<commit_message>
Correct industry-landscape facts against primary sources
KLEE's 56 serious bugs span coreutils/busybox/Minix (three coreutils
bugs hid for 15 years), not 56 in coreutils alone (OSDI 2008). SAGE
found ~1/3 of Win7 file-fuzzing bugs, running last (ACM Queue 2012).
Astrée's runtime-error proof was the A340 (132k LOC, 2003), then
applied to the A380. CompCert claim scoped to its verified core
(PLDI 2011). Quiz answer key and delivery plan updated to match.
</commit_message>
<xml_diff>
--- a/slides/session1/01-session1-fundamentals.pptx
+++ b/slides/session1/01-session1-fundamentals.pptx
@@ -10415,7 +10415,7 @@
                   <a:srgbClr val="212121"/>
                 </a:solidFill>
               </a:rPr>
-              <a:t>KLEE found 56 bugs in GNU coreutils — code tested for 15 years</a:t>
+              <a:t>KLEE found 56 serious bugs in coreutils, busybox and Minix — including three in coreutils that had survived 15 years of testing</a:t>
             </a:r>
           </a:p>
           <a:p>
@@ -10430,7 +10430,7 @@
                   <a:srgbClr val="212121"/>
                 </a:solidFill>
               </a:rPr>
-              <a:t>Microsoft SAGE fuzzed Windows file parsers with symbolic execution; credited with finding 1/3 of all Win7 file-parsing bugs</a:t>
+              <a:t>Microsoft SAGE fuzzed Windows file parsers with symbolic execution; it found ~1/3 of all bugs caught by file fuzzing during Windows 7 development — running last, after every other tool</a:t>
             </a:r>
           </a:p>
           <a:p>
@@ -10549,7 +10549,7 @@
                   <a:srgbClr val="212121"/>
                 </a:solidFill>
               </a:rPr>
-              <a:t>Astrée (abstract interpretation) proved absence of runtime errors in Airbus A380 fly-by-wire control code</a:t>
+              <a:t>Astrée (abstract interpretation) proved absence of runtime errors in the Airbus A340 fly-by-wire code — 132,000 lines of C — and was then applied to the A380</a:t>
             </a:r>
           </a:p>
           <a:p>
@@ -10579,7 +10579,7 @@
                   <a:srgbClr val="212121"/>
                 </a:solidFill>
               </a:rPr>
-              <a:t>CompCert — a C compiler with a proof that compilation preserves semantics; fuzzers find zero wrong-code bugs in it</a:t>
+              <a:t>CompCert — a C compiler with a proof that compilation preserves semantics; six CPU-years of fuzzing found no wrong-code bugs in its verified core, while every other compiler tested failed</a:t>
             </a:r>
           </a:p>
         </p:txBody>
@@ -10832,7 +10832,7 @@
                   <a:srgbClr val="212121"/>
                 </a:solidFill>
               </a:rPr>
-              <a:t>4. Which technique proved the A380 flight-control code free of runtime errors?</a:t>
+              <a:t>4. Which technique proved the A340 flight-control code free of runtime errors?</a:t>
             </a:r>
           </a:p>
           <a:p>

</xml_diff>

<commit_message>
Add CrowdStrike 2024 to the "when software fails" slide
Add the Channel File 291 out-of-bounds read (21 vs 20 input fields,
8.5M Windows hosts, 78-minute window) as a third real-world failure
alongside Ariane 5 and Therac-25, verified against CrowdStrike's
remediation hub and Microsoft's outage blog. Also normalise the two
existing entries to colon-led lead-ins.
</commit_message>
<xml_diff>
--- a/slides/session1/01-session1-fundamentals.pptx
+++ b/slides/session1/01-session1-fundamentals.pptx
@@ -10095,7 +10095,7 @@
                   <a:srgbClr val="5A0A7A"/>
                 </a:solidFill>
               </a:rPr>
-              <a:t>When software fails: two classics</a:t>
+              <a:t>When software fails: two classics and a fresh one</a:t>
             </a:r>
           </a:p>
         </p:txBody>
@@ -10133,7 +10133,7 @@
                   <a:srgbClr val="212121"/>
                 </a:solidFill>
               </a:rPr>
-              <a:t>Ariane 5, 1996 — a 64-bit float squeezed into a 16-bit integer. The conversion overflowed; the rocket self-destructed 40 seconds after lift-off.</a:t>
+              <a:t>Ariane 5, 1996: a 64-bit float squeezed into a 16-bit integer. The conversion overflowed; the rocket self-destructed 40 seconds after lift-off.</a:t>
             </a:r>
           </a:p>
           <a:p>
@@ -10163,7 +10163,7 @@
                   <a:srgbClr val="212121"/>
                 </a:solidFill>
               </a:rPr>
-              <a:t>Therac-25, 1985–87 — a race condition between operator keystrokes and the radiation beam controller. Six massive overdoses, several fatal.</a:t>
+              <a:t>Therac-25, 1985–87: a race condition between operator keystrokes and the radiation beam controller. Six massive overdoses, several fatal.</a:t>
             </a:r>
           </a:p>
           <a:p>
@@ -10193,6 +10193,36 @@
                   <a:srgbClr val="212121"/>
                 </a:solidFill>
               </a:rPr>
+              <a:t>CrowdStrike, 2024: a security update supplied 21 input fields to sensor code expecting 20. The out-of-bounds read blue-screened 8.5 million Windows machines; the bad file was live for just 78 minutes.</a:t>
+            </a:r>
+          </a:p>
+          <a:p>
+            <a:pPr lvl="1">
+              <a:spcAft>
+                <a:spcPts val="800"/>
+              </a:spcAft>
+            </a:pPr>
+            <a:r>
+              <a:rPr sz="2000">
+                <a:solidFill>
+                  <a:srgbClr val="212121"/>
+                </a:solidFill>
+              </a:rPr>
+              <a:t>It passed the release tooling: the content validator itself had a bug, and no test ever read the 21st field.</a:t>
+            </a:r>
+          </a:p>
+          <a:p>
+            <a:pPr>
+              <a:spcAft>
+                <a:spcPts val="800"/>
+              </a:spcAft>
+            </a:pPr>
+            <a:r>
+              <a:rPr sz="2200">
+                <a:solidFill>
+                  <a:srgbClr val="212121"/>
+                </a:solidFill>
+              </a:rPr>
               <a:t/>
             </a:r>
           </a:p>
@@ -10208,7 +10238,7 @@
                   <a:srgbClr val="212121"/>
                 </a:solidFill>
               </a:rPr>
-              <a:t>An integer overflow and a race condition. Hold that thought — you will hunt both bug classes yourself in Session 2.</a:t>
+              <a:t>An integer overflow, a race condition, and an out-of-bounds read. Hold that thought — you will hunt all three bug classes yourself in Session 2.</a:t>
             </a:r>
           </a:p>
         </p:txBody>

</xml_diff>

<commit_message>
Fix ctest-gen demo to search for an access-control bypass
The previous getpassword.c asserted access is never granted (assert(!granted)),
which reads as a backwards unit test failing on the password. Reframe it as a
reachability search: claim the access-granted branch is unreachable (assert(0)),
and let ESBMC find the input that reaches it. The generated test now prints the
bypassing input it found. Update the slide and demo README to match.
</commit_message>
<xml_diff>
--- a/slides/session1/01-session1-fundamentals.pptx
+++ b/slides/session1/01-session1-fundamentals.pptx
@@ -12049,7 +12049,7 @@
                   <a:srgbClr val="212121"/>
                 </a:solidFill>
               </a:rPr>
-              <a:t>Ask the same tool the opposite question — "can anyone ever be let in?" — and it hands back the exact password, as a test you can run.</a:t>
+              <a:t>Ask the same tool the opposite question — "can any input get past the check?" — and it hands back one that does, as a test you can run.</a:t>
             </a:r>
           </a:p>
           <a:p>
@@ -12065,7 +12065,7 @@
                 </a:solidFill>
                 <a:latin typeface="Courier New"/>
               </a:rPr>
-              <a:t>  char buf[4];</a:t>
+              <a:t>  char buf[4];                          /* input ESBMC chooses */</a:t>
             </a:r>
           </a:p>
           <a:p>
@@ -12081,7 +12081,7 @@
                 </a:solidFill>
                 <a:latin typeface="Courier New"/>
               </a:rPr>
-              <a:t>  for (int i = 0; i &lt; 4; i++) buf[i] = nondet_char();</a:t>
+              <a:t>  for (int i = 0; i &lt; 3; i++) buf[i] = nondet_char();</a:t>
             </a:r>
           </a:p>
           <a:p>
@@ -12097,7 +12097,7 @@
                 </a:solidFill>
                 <a:latin typeface="Courier New"/>
               </a:rPr>
-              <a:t>  assert(strcmp(buf, "SMT") != 0);  /* claim: never granted */</a:t>
+              <a:t>  buf[3] = '\0';</a:t>
             </a:r>
           </a:p>
           <a:p>
@@ -12113,6 +12113,38 @@
                 </a:solidFill>
                 <a:latin typeface="Courier New"/>
               </a:rPr>
+              <a:t>  if (strcmp(buf, "SMT") == 0)</a:t>
+            </a:r>
+          </a:p>
+          <a:p>
+            <a:pPr>
+              <a:spcAft>
+                <a:spcPts val="0"/>
+              </a:spcAft>
+            </a:pPr>
+            <a:r>
+              <a:rPr sz="1600">
+                <a:solidFill>
+                  <a:srgbClr val="212121"/>
+                </a:solidFill>
+                <a:latin typeface="Courier New"/>
+              </a:rPr>
+              <a:t>    assert(0);             /* claim: this is unreachable */</a:t>
+            </a:r>
+          </a:p>
+          <a:p>
+            <a:pPr>
+              <a:spcAft>
+                <a:spcPts val="0"/>
+              </a:spcAft>
+            </a:pPr>
+            <a:r>
+              <a:rPr sz="1600">
+                <a:solidFill>
+                  <a:srgbClr val="212121"/>
+                </a:solidFill>
+                <a:latin typeface="Courier New"/>
+              </a:rPr>
               <a:t/>
             </a:r>
           </a:p>
@@ -12193,7 +12225,7 @@
                 </a:solidFill>
                 <a:latin typeface="Courier New"/>
               </a:rPr>
-              <a:t>  static const char v[] = { 83, 77, 84, 0 };  /* "SMT" */</a:t>
+              <a:t>  static const char v[] = { 83, 77, 84 };  /* "SMT" */</a:t>
             </a:r>
           </a:p>
           <a:p>
@@ -12255,7 +12287,7 @@
                   <a:srgbClr val="212121"/>
                 </a:solidFill>
               </a:rPr>
-              <a:t>ESBMC derived the password from the program's own logic. The test compiles, runs, and prints "Access Granted" — no one had to guess the right input.</a:t>
+              <a:t>ESBMC found the input that reaches the protected branch. The test compiles, runs, and prints "Access Granted with input SMT" — no one had to guess it.</a:t>
             </a:r>
           </a:p>
         </p:txBody>

</xml_diff>

<commit_message>
Clarify ESBMC's role on the gets() overflow slide and demo
Add a note to slide 6 ("What gets() does to the stack") and the getpassword
talking points: ESBMC finds the overflow itself (CWE-787); the strcmp check is
otherwise sound (only "SMT" passes, provable), and a non-password bypass is
the strncmp logic-flaw demo, not a stack-smash exploit ESBMC synthesises.
</commit_message>
<xml_diff>
--- a/slides/session1/01-session1-fundamentals.pptx
+++ b/slides/session1/01-session1-fundamentals.pptx
@@ -12024,6 +12024,21 @@
                 </a:solidFill>
               </a:rPr>
               <a:t>Could a test suite find this? Only if someone thinks to type the right garbage.</a:t>
+            </a:r>
+          </a:p>
+          <a:p>
+            <a:pPr>
+              <a:spcAft>
+                <a:spcPts val="800"/>
+              </a:spcAft>
+            </a:pPr>
+            <a:r>
+              <a:rPr sz="2200">
+                <a:solidFill>
+                  <a:srgbClr val="212121"/>
+                </a:solidFill>
+              </a:rPr>
+              <a:t>ESBMC finds the overflow itself (CWE-787) — the door. The check is otherwise sound: no input but "SMT" passes it (provable). A non-password input that still gets in is the strncmp logic-flaw demo.</a:t>
             </a:r>
           </a:p>
         </p:txBody>

</xml_diff>

<commit_message>
Correct the static-analyser soundness claim on the S&C slide
"Most static analysers are sound" is inaccurate — most deployed bug-finders
are deliberately unsound. Scope the sound-but-incomplete claim to abstract
interpretation (matching the technique grid) and note that everyday
bug-finders are unsound, trading missed bugs for fewer false alarms.
</commit_message>
<xml_diff>
--- a/slides/session1/01-session1-fundamentals.pptx
+++ b/slides/session1/01-session1-fundamentals.pptx
@@ -5330,7 +5330,22 @@
                   <a:srgbClr val="212121"/>
                 </a:solidFill>
               </a:rPr>
-              <a:t>Most static analysers are sound but not complete (no missed bugs, but false alarms).</a:t>
+              <a:t>Sound static analysers — e.g. abstract interpretation — are sound but not complete by design (no missed bugs, but false alarms).</a:t>
+            </a:r>
+          </a:p>
+          <a:p>
+            <a:pPr>
+              <a:spcAft>
+                <a:spcPts val="800"/>
+              </a:spcAft>
+            </a:pPr>
+            <a:r>
+              <a:rPr sz="2400">
+                <a:solidFill>
+                  <a:srgbClr val="212121"/>
+                </a:solidFill>
+              </a:rPr>
+              <a:t>Most everyday bug-finders, by contrast, are unsound: they miss bugs to keep false alarms low.</a:t>
             </a:r>
           </a:p>
         </p:txBody>

</xml_diff>

<commit_message>
Add 'techniques as real tools' slide mapping tools to methods
New slide after Soundness and completeness: a table pairing each technique with
representative tools — testing/fuzzing (AFL++, libFuzzer, OSS-Fuzz), symbolic
execution (KLEE, SAGE, angr), unsound bug-finders (Coverity, Clang SA, CodeQL,
Cppcheck), abstract interpretation (Astree, Polyspace, Frama-C Eva), bounded
model checking (CBMC, ESBMC), deductive verification (Dafny, SPARK, Frama-C WP).
Deck is now 48 slides; update the README run order.
</commit_message>
<xml_diff>
--- a/slides/session1/01-session1-fundamentals.pptx
+++ b/slides/session1/01-session1-fundamentals.pptx
@@ -52,6 +52,7 @@
     <p:sldId id="300" r:id="rId51"/>
     <p:sldId id="301" r:id="rId52"/>
     <p:sldId id="302" r:id="rId53"/>
+    <p:sldId id="303" r:id="rId54"/>
   </p:sldIdLst>
   <p:sldSz cx="12191695" cy="6858000" type="screen4x3"/>
   <p:notesSz cx="6858000" cy="9144000"/>
@@ -5753,6 +5754,409 @@
                   <a:srgbClr val="5A0A7A"/>
                 </a:solidFill>
               </a:rPr>
+              <a:t>The techniques as real tools</a:t>
+            </a:r>
+          </a:p>
+        </p:txBody>
+      </p:sp>
+      <p:graphicFrame>
+        <p:nvGraphicFramePr>
+          <p:cNvPr id="3" name="Table 2"/>
+          <p:cNvGraphicFramePr>
+            <a:graphicFrameLocks noGrp="1"/>
+          </p:cNvGraphicFramePr>
+          <p:nvPr/>
+        </p:nvGraphicFramePr>
+        <p:xfrm>
+          <a:off x="731520" y="1280160"/>
+          <a:ext cx="10698480" cy="2560320"/>
+        </p:xfrm>
+        <a:graphic>
+          <a:graphicData uri="http://schemas.openxmlformats.org/drawingml/2006/table">
+            <a:tbl>
+              <a:tblPr firstRow="1" bandRow="1">
+                <a:tableStyleId>{5C22544A-7EE6-4342-B048-85BDC9FD1C3A}</a:tableStyleId>
+              </a:tblPr>
+              <a:tblGrid>
+                <a:gridCol w="2468880"/>
+                <a:gridCol w="4206240"/>
+                <a:gridCol w="4023360"/>
+              </a:tblGrid>
+              <a:tr h="365760">
+                <a:tc>
+                  <a:txBody>
+                    <a:bodyPr/>
+                    <a:lstStyle/>
+                    <a:p>
+                      <a:r>
+                        <a:rPr sz="1500" b="1"/>
+                        <a:t>Technique</a:t>
+                      </a:r>
+                    </a:p>
+                  </a:txBody>
+                  <a:tcPr/>
+                </a:tc>
+                <a:tc>
+                  <a:txBody>
+                    <a:bodyPr/>
+                    <a:lstStyle/>
+                    <a:p>
+                      <a:r>
+                        <a:rPr sz="1500" b="1"/>
+                        <a:t>In one line</a:t>
+                      </a:r>
+                    </a:p>
+                  </a:txBody>
+                  <a:tcPr/>
+                </a:tc>
+                <a:tc>
+                  <a:txBody>
+                    <a:bodyPr/>
+                    <a:lstStyle/>
+                    <a:p>
+                      <a:r>
+                        <a:rPr sz="1500" b="1"/>
+                        <a:t>Example tools</a:t>
+                      </a:r>
+                    </a:p>
+                  </a:txBody>
+                  <a:tcPr/>
+                </a:tc>
+              </a:tr>
+              <a:tr h="365760">
+                <a:tc>
+                  <a:txBody>
+                    <a:bodyPr/>
+                    <a:lstStyle/>
+                    <a:p>
+                      <a:r>
+                        <a:rPr sz="1500"/>
+                        <a:t>Testing &amp; fuzzing</a:t>
+                      </a:r>
+                    </a:p>
+                  </a:txBody>
+                  <a:tcPr/>
+                </a:tc>
+                <a:tc>
+                  <a:txBody>
+                    <a:bodyPr/>
+                    <a:lstStyle/>
+                    <a:p>
+                      <a:r>
+                        <a:rPr sz="1500"/>
+                        <a:t>run the code on many inputs</a:t>
+                      </a:r>
+                    </a:p>
+                  </a:txBody>
+                  <a:tcPr/>
+                </a:tc>
+                <a:tc>
+                  <a:txBody>
+                    <a:bodyPr/>
+                    <a:lstStyle/>
+                    <a:p>
+                      <a:r>
+                        <a:rPr sz="1500"/>
+                        <a:t>AFL++, libFuzzer, OSS-Fuzz</a:t>
+                      </a:r>
+                    </a:p>
+                  </a:txBody>
+                  <a:tcPr/>
+                </a:tc>
+              </a:tr>
+              <a:tr h="365760">
+                <a:tc>
+                  <a:txBody>
+                    <a:bodyPr/>
+                    <a:lstStyle/>
+                    <a:p>
+                      <a:r>
+                        <a:rPr sz="1500"/>
+                        <a:t>Symbolic execution</a:t>
+                      </a:r>
+                    </a:p>
+                  </a:txBody>
+                  <a:tcPr/>
+                </a:tc>
+                <a:tc>
+                  <a:txBody>
+                    <a:bodyPr/>
+                    <a:lstStyle/>
+                    <a:p>
+                      <a:r>
+                        <a:rPr sz="1500"/>
+                        <a:t>explore paths with a solver; each bug comes with an input</a:t>
+                      </a:r>
+                    </a:p>
+                  </a:txBody>
+                  <a:tcPr/>
+                </a:tc>
+                <a:tc>
+                  <a:txBody>
+                    <a:bodyPr/>
+                    <a:lstStyle/>
+                    <a:p>
+                      <a:r>
+                        <a:rPr sz="1500"/>
+                        <a:t>KLEE, SAGE, angr</a:t>
+                      </a:r>
+                    </a:p>
+                  </a:txBody>
+                  <a:tcPr/>
+                </a:tc>
+              </a:tr>
+              <a:tr h="365760">
+                <a:tc>
+                  <a:txBody>
+                    <a:bodyPr/>
+                    <a:lstStyle/>
+                    <a:p>
+                      <a:r>
+                        <a:rPr sz="1500"/>
+                        <a:t>Bug-finding static analysis</a:t>
+                      </a:r>
+                    </a:p>
+                  </a:txBody>
+                  <a:tcPr/>
+                </a:tc>
+                <a:tc>
+                  <a:txBody>
+                    <a:bodyPr/>
+                    <a:lstStyle/>
+                    <a:p>
+                      <a:r>
+                        <a:rPr sz="1500"/>
+                        <a:t>scan for suspicious patterns (unsound — misses bugs)</a:t>
+                      </a:r>
+                    </a:p>
+                  </a:txBody>
+                  <a:tcPr/>
+                </a:tc>
+                <a:tc>
+                  <a:txBody>
+                    <a:bodyPr/>
+                    <a:lstStyle/>
+                    <a:p>
+                      <a:r>
+                        <a:rPr sz="1500"/>
+                        <a:t>Coverity, Clang Static Analyzer, CodeQL, Cppcheck</a:t>
+                      </a:r>
+                    </a:p>
+                  </a:txBody>
+                  <a:tcPr/>
+                </a:tc>
+              </a:tr>
+              <a:tr h="365760">
+                <a:tc>
+                  <a:txBody>
+                    <a:bodyPr/>
+                    <a:lstStyle/>
+                    <a:p>
+                      <a:r>
+                        <a:rPr sz="1500"/>
+                        <a:t>Abstract interpretation</a:t>
+                      </a:r>
+                    </a:p>
+                  </a:txBody>
+                  <a:tcPr/>
+                </a:tc>
+                <a:tc>
+                  <a:txBody>
+                    <a:bodyPr/>
+                    <a:lstStyle/>
+                    <a:p>
+                      <a:r>
+                        <a:rPr sz="1500"/>
+                        <a:t>over-approximate every run (sound — but false alarms)</a:t>
+                      </a:r>
+                    </a:p>
+                  </a:txBody>
+                  <a:tcPr/>
+                </a:tc>
+                <a:tc>
+                  <a:txBody>
+                    <a:bodyPr/>
+                    <a:lstStyle/>
+                    <a:p>
+                      <a:r>
+                        <a:rPr sz="1500"/>
+                        <a:t>Astrée, Polyspace, Frama-C (Eva)</a:t>
+                      </a:r>
+                    </a:p>
+                  </a:txBody>
+                  <a:tcPr/>
+                </a:tc>
+              </a:tr>
+              <a:tr h="365760">
+                <a:tc>
+                  <a:txBody>
+                    <a:bodyPr/>
+                    <a:lstStyle/>
+                    <a:p>
+                      <a:r>
+                        <a:rPr sz="1500"/>
+                        <a:t>Bounded model checking</a:t>
+                      </a:r>
+                    </a:p>
+                  </a:txBody>
+                  <a:tcPr/>
+                </a:tc>
+                <a:tc>
+                  <a:txBody>
+                    <a:bodyPr/>
+                    <a:lstStyle/>
+                    <a:p>
+                      <a:r>
+                        <a:rPr sz="1500"/>
+                        <a:t>prove properties up to a depth bound</a:t>
+                      </a:r>
+                    </a:p>
+                  </a:txBody>
+                  <a:tcPr/>
+                </a:tc>
+                <a:tc>
+                  <a:txBody>
+                    <a:bodyPr/>
+                    <a:lstStyle/>
+                    <a:p>
+                      <a:r>
+                        <a:rPr sz="1500"/>
+                        <a:t>CBMC, ESBMC</a:t>
+                      </a:r>
+                    </a:p>
+                  </a:txBody>
+                  <a:tcPr/>
+                </a:tc>
+              </a:tr>
+              <a:tr h="365760">
+                <a:tc>
+                  <a:txBody>
+                    <a:bodyPr/>
+                    <a:lstStyle/>
+                    <a:p>
+                      <a:r>
+                        <a:rPr sz="1500"/>
+                        <a:t>Deductive verification</a:t>
+                      </a:r>
+                    </a:p>
+                  </a:txBody>
+                  <a:tcPr/>
+                </a:tc>
+                <a:tc>
+                  <a:txBody>
+                    <a:bodyPr/>
+                    <a:lstStyle/>
+                    <a:p>
+                      <a:r>
+                        <a:rPr sz="1500"/>
+                        <a:t>prove code against a spec (needs effort)</a:t>
+                      </a:r>
+                    </a:p>
+                  </a:txBody>
+                  <a:tcPr/>
+                </a:tc>
+                <a:tc>
+                  <a:txBody>
+                    <a:bodyPr/>
+                    <a:lstStyle/>
+                    <a:p>
+                      <a:r>
+                        <a:rPr sz="1500"/>
+                        <a:t>Dafny, SPARK (GNATprove), Frama-C (WP)</a:t>
+                      </a:r>
+                    </a:p>
+                  </a:txBody>
+                  <a:tcPr/>
+                </a:tc>
+              </a:tr>
+            </a:tbl>
+          </a:graphicData>
+        </a:graphic>
+      </p:graphicFrame>
+      <p:sp>
+        <p:nvSpPr>
+          <p:cNvPr id="4" name="TextBox 3"/>
+          <p:cNvSpPr txBox="1"/>
+          <p:nvPr/>
+        </p:nvSpPr>
+        <p:spPr>
+          <a:xfrm>
+            <a:off x="731520" y="6126480"/>
+            <a:ext cx="10789920" cy="457199"/>
+          </a:xfrm>
+          <a:prstGeom prst="rect">
+            <a:avLst/>
+          </a:prstGeom>
+          <a:noFill/>
+        </p:spPr>
+        <p:txBody>
+          <a:bodyPr wrap="square">
+            <a:spAutoFit/>
+          </a:bodyPr>
+          <a:lstStyle/>
+          <a:p>
+            <a:pPr>
+              <a:spcAft>
+                <a:spcPts val="800"/>
+              </a:spcAft>
+            </a:pPr>
+            <a:r>
+              <a:rPr sz="1600">
+                <a:solidFill>
+                  <a:srgbClr val="212121"/>
+                </a:solidFill>
+              </a:rPr>
+              <a:t>Tonight's tool, ESBMC, is bounded model checking — and BMC and deductive verifiers both run on the SAT/SMT solvers we meet after the break.</a:t>
+            </a:r>
+          </a:p>
+        </p:txBody>
+      </p:sp>
+    </p:spTree>
+  </p:cSld>
+  <p:clrMapOvr>
+    <a:masterClrMapping/>
+  </p:clrMapOvr>
+</p:sld>
+</file>
+
+<file path=ppt/slides/slide21.xml><?xml version="1.0" encoding="utf-8"?>
+<p:sld xmlns:a="http://schemas.openxmlformats.org/drawingml/2006/main" xmlns:p="http://schemas.openxmlformats.org/presentationml/2006/main" xmlns:r="http://schemas.openxmlformats.org/officeDocument/2006/relationships">
+  <p:cSld>
+    <p:spTree>
+      <p:nvGrpSpPr>
+        <p:cNvPr id="1" name=""/>
+        <p:cNvGrpSpPr/>
+        <p:nvPr/>
+      </p:nvGrpSpPr>
+      <p:grpSpPr/>
+      <p:sp>
+        <p:nvSpPr>
+          <p:cNvPr id="2" name="TextBox 1"/>
+          <p:cNvSpPr txBox="1"/>
+          <p:nvPr/>
+        </p:nvSpPr>
+        <p:spPr>
+          <a:xfrm>
+            <a:off x="548640" y="365760"/>
+            <a:ext cx="11064240" cy="1005840"/>
+          </a:xfrm>
+          <a:prstGeom prst="rect">
+            <a:avLst/>
+          </a:prstGeom>
+          <a:noFill/>
+        </p:spPr>
+        <p:txBody>
+          <a:bodyPr wrap="square">
+            <a:spAutoFit/>
+          </a:bodyPr>
+          <a:lstStyle/>
+          <a:p>
+            <a:r>
+              <a:rPr sz="3600" b="1">
+                <a:solidFill>
+                  <a:srgbClr val="5A0A7A"/>
+                </a:solidFill>
+              </a:rPr>
               <a:t>Where does your technique sit?</a:t>
             </a:r>
           </a:p>
@@ -5964,7 +6368,7 @@
 </p:sld>
 </file>
 
-<file path=ppt/slides/slide21.xml><?xml version="1.0" encoding="utf-8"?>
+<file path=ppt/slides/slide22.xml><?xml version="1.0" encoding="utf-8"?>
 <p:sld xmlns:a="http://schemas.openxmlformats.org/drawingml/2006/main" xmlns:p="http://schemas.openxmlformats.org/presentationml/2006/main" xmlns:r="http://schemas.openxmlformats.org/officeDocument/2006/relationships">
   <p:cSld>
     <p:spTree>
@@ -6326,7 +6730,7 @@
 </p:sld>
 </file>
 
-<file path=ppt/slides/slide22.xml><?xml version="1.0" encoding="utf-8"?>
+<file path=ppt/slides/slide23.xml><?xml version="1.0" encoding="utf-8"?>
 <p:sld xmlns:a="http://schemas.openxmlformats.org/drawingml/2006/main" xmlns:p="http://schemas.openxmlformats.org/presentationml/2006/main" xmlns:r="http://schemas.openxmlformats.org/officeDocument/2006/relationships">
   <p:cSld>
     <p:spTree>
@@ -6493,57 +6897,6 @@
                 </a:solidFill>
               </a:rPr>
               <a:t>So we need an oracle for “is this formula satisfiable?” — it exists, it is free, and it is absurdly good. After the break.</a:t>
-            </a:r>
-          </a:p>
-        </p:txBody>
-      </p:sp>
-    </p:spTree>
-  </p:cSld>
-  <p:clrMapOvr>
-    <a:masterClrMapping/>
-  </p:clrMapOvr>
-</p:sld>
-</file>
-
-<file path=ppt/slides/slide23.xml><?xml version="1.0" encoding="utf-8"?>
-<p:sld xmlns:a="http://schemas.openxmlformats.org/drawingml/2006/main" xmlns:p="http://schemas.openxmlformats.org/presentationml/2006/main" xmlns:r="http://schemas.openxmlformats.org/officeDocument/2006/relationships">
-  <p:cSld>
-    <p:spTree>
-      <p:nvGrpSpPr>
-        <p:cNvPr id="1" name=""/>
-        <p:cNvGrpSpPr/>
-        <p:nvPr/>
-      </p:nvGrpSpPr>
-      <p:grpSpPr/>
-      <p:sp>
-        <p:nvSpPr>
-          <p:cNvPr id="2" name="TextBox 1"/>
-          <p:cNvSpPr txBox="1"/>
-          <p:nvPr/>
-        </p:nvSpPr>
-        <p:spPr>
-          <a:xfrm>
-            <a:off x="548640" y="2377440"/>
-            <a:ext cx="11064240" cy="1005840"/>
-          </a:xfrm>
-          <a:prstGeom prst="rect">
-            <a:avLst/>
-          </a:prstGeom>
-          <a:noFill/>
-        </p:spPr>
-        <p:txBody>
-          <a:bodyPr wrap="square">
-            <a:spAutoFit/>
-          </a:bodyPr>
-          <a:lstStyle/>
-          <a:p>
-            <a:r>
-              <a:rPr sz="4400" b="1">
-                <a:solidFill>
-                  <a:srgbClr val="5A0A7A"/>
-                </a:solidFill>
-              </a:rPr>
-              <a:t>Break — back at 19:25</a:t>
             </a:r>
           </a:p>
         </p:txBody>
@@ -6574,7 +6927,7 @@
         </p:nvSpPr>
         <p:spPr>
           <a:xfrm>
-            <a:off x="548640" y="365760"/>
+            <a:off x="548640" y="2377440"/>
             <a:ext cx="11064240" cy="1005840"/>
           </a:xfrm>
           <a:prstGeom prst="rect">
@@ -6589,126 +6942,12 @@
           <a:lstStyle/>
           <a:p>
             <a:r>
-              <a:rPr sz="3600" b="1">
+              <a:rPr sz="4400" b="1">
                 <a:solidFill>
                   <a:srgbClr val="5A0A7A"/>
                 </a:solidFill>
               </a:rPr>
-              <a:t>SAT: the original hard problem</a:t>
-            </a:r>
-          </a:p>
-        </p:txBody>
-      </p:sp>
-      <p:sp>
-        <p:nvSpPr>
-          <p:cNvPr id="3" name="TextBox 2"/>
-          <p:cNvSpPr txBox="1"/>
-          <p:nvPr/>
-        </p:nvSpPr>
-        <p:spPr>
-          <a:xfrm>
-            <a:off x="731520" y="1554480"/>
-            <a:ext cx="10789920" cy="5029200"/>
-          </a:xfrm>
-          <a:prstGeom prst="rect">
-            <a:avLst/>
-          </a:prstGeom>
-          <a:noFill/>
-        </p:spPr>
-        <p:txBody>
-          <a:bodyPr wrap="square">
-            <a:spAutoFit/>
-          </a:bodyPr>
-          <a:lstStyle/>
-          <a:p>
-            <a:pPr>
-              <a:spcAft>
-                <a:spcPts val="0"/>
-              </a:spcAft>
-            </a:pPr>
-            <a:r>
-              <a:rPr sz="2000">
-                <a:solidFill>
-                  <a:srgbClr val="212121"/>
-                </a:solidFill>
-                <a:latin typeface="Courier New"/>
-              </a:rPr>
-              <a:t>(a ∨ ¬b) ∧ (b ∨ c) ∧ (¬a ∨ ¬c)</a:t>
-            </a:r>
-          </a:p>
-          <a:p>
-            <a:pPr>
-              <a:spcAft>
-                <a:spcPts val="800"/>
-              </a:spcAft>
-            </a:pPr>
-            <a:r>
-              <a:rPr sz="2400">
-                <a:solidFill>
-                  <a:srgbClr val="212121"/>
-                </a:solidFill>
-              </a:rPr>
-              <a:t/>
-            </a:r>
-          </a:p>
-          <a:p>
-            <a:pPr>
-              <a:spcAft>
-                <a:spcPts val="800"/>
-              </a:spcAft>
-            </a:pPr>
-            <a:r>
-              <a:rPr sz="2400">
-                <a:solidFill>
-                  <a:srgbClr val="212121"/>
-                </a:solidFill>
-              </a:rPr>
-              <a:t>Is there a true/false assignment that makes the whole formula true?</a:t>
-            </a:r>
-          </a:p>
-          <a:p>
-            <a:pPr>
-              <a:spcAft>
-                <a:spcPts val="800"/>
-              </a:spcAft>
-            </a:pPr>
-            <a:r>
-              <a:rPr sz="2400">
-                <a:solidFill>
-                  <a:srgbClr val="212121"/>
-                </a:solidFill>
-              </a:rPr>
-              <a:t/>
-            </a:r>
-          </a:p>
-          <a:p>
-            <a:pPr>
-              <a:spcAft>
-                <a:spcPts val="800"/>
-              </a:spcAft>
-            </a:pPr>
-            <a:r>
-              <a:rPr sz="2400">
-                <a:solidFill>
-                  <a:srgbClr val="212121"/>
-                </a:solidFill>
-              </a:rPr>
-              <a:t>The first problem ever proved NP-complete (Cook, 1971) — in theory, hopeless.</a:t>
-            </a:r>
-          </a:p>
-          <a:p>
-            <a:pPr>
-              <a:spcAft>
-                <a:spcPts val="800"/>
-              </a:spcAft>
-            </a:pPr>
-            <a:r>
-              <a:rPr sz="2400">
-                <a:solidFill>
-                  <a:srgbClr val="212121"/>
-                </a:solidFill>
-              </a:rPr>
-              <a:t>In practice: modern solvers eat formulas with millions of clauses for breakfast. Industrial SAT solving is the closest thing CS has to a superpower.</a:t>
+              <a:t>Break — back at 19:25</a:t>
             </a:r>
           </a:p>
         </p:txBody>
@@ -6759,6 +6998,171 @@
                   <a:srgbClr val="5A0A7A"/>
                 </a:solidFill>
               </a:rPr>
+              <a:t>SAT: the original hard problem</a:t>
+            </a:r>
+          </a:p>
+        </p:txBody>
+      </p:sp>
+      <p:sp>
+        <p:nvSpPr>
+          <p:cNvPr id="3" name="TextBox 2"/>
+          <p:cNvSpPr txBox="1"/>
+          <p:nvPr/>
+        </p:nvSpPr>
+        <p:spPr>
+          <a:xfrm>
+            <a:off x="731520" y="1554480"/>
+            <a:ext cx="10789920" cy="5029200"/>
+          </a:xfrm>
+          <a:prstGeom prst="rect">
+            <a:avLst/>
+          </a:prstGeom>
+          <a:noFill/>
+        </p:spPr>
+        <p:txBody>
+          <a:bodyPr wrap="square">
+            <a:spAutoFit/>
+          </a:bodyPr>
+          <a:lstStyle/>
+          <a:p>
+            <a:pPr>
+              <a:spcAft>
+                <a:spcPts val="0"/>
+              </a:spcAft>
+            </a:pPr>
+            <a:r>
+              <a:rPr sz="2000">
+                <a:solidFill>
+                  <a:srgbClr val="212121"/>
+                </a:solidFill>
+                <a:latin typeface="Courier New"/>
+              </a:rPr>
+              <a:t>(a ∨ ¬b) ∧ (b ∨ c) ∧ (¬a ∨ ¬c)</a:t>
+            </a:r>
+          </a:p>
+          <a:p>
+            <a:pPr>
+              <a:spcAft>
+                <a:spcPts val="800"/>
+              </a:spcAft>
+            </a:pPr>
+            <a:r>
+              <a:rPr sz="2400">
+                <a:solidFill>
+                  <a:srgbClr val="212121"/>
+                </a:solidFill>
+              </a:rPr>
+              <a:t/>
+            </a:r>
+          </a:p>
+          <a:p>
+            <a:pPr>
+              <a:spcAft>
+                <a:spcPts val="800"/>
+              </a:spcAft>
+            </a:pPr>
+            <a:r>
+              <a:rPr sz="2400">
+                <a:solidFill>
+                  <a:srgbClr val="212121"/>
+                </a:solidFill>
+              </a:rPr>
+              <a:t>Is there a true/false assignment that makes the whole formula true?</a:t>
+            </a:r>
+          </a:p>
+          <a:p>
+            <a:pPr>
+              <a:spcAft>
+                <a:spcPts val="800"/>
+              </a:spcAft>
+            </a:pPr>
+            <a:r>
+              <a:rPr sz="2400">
+                <a:solidFill>
+                  <a:srgbClr val="212121"/>
+                </a:solidFill>
+              </a:rPr>
+              <a:t/>
+            </a:r>
+          </a:p>
+          <a:p>
+            <a:pPr>
+              <a:spcAft>
+                <a:spcPts val="800"/>
+              </a:spcAft>
+            </a:pPr>
+            <a:r>
+              <a:rPr sz="2400">
+                <a:solidFill>
+                  <a:srgbClr val="212121"/>
+                </a:solidFill>
+              </a:rPr>
+              <a:t>The first problem ever proved NP-complete (Cook, 1971) — in theory, hopeless.</a:t>
+            </a:r>
+          </a:p>
+          <a:p>
+            <a:pPr>
+              <a:spcAft>
+                <a:spcPts val="800"/>
+              </a:spcAft>
+            </a:pPr>
+            <a:r>
+              <a:rPr sz="2400">
+                <a:solidFill>
+                  <a:srgbClr val="212121"/>
+                </a:solidFill>
+              </a:rPr>
+              <a:t>In practice: modern solvers eat formulas with millions of clauses for breakfast. Industrial SAT solving is the closest thing CS has to a superpower.</a:t>
+            </a:r>
+          </a:p>
+        </p:txBody>
+      </p:sp>
+    </p:spTree>
+  </p:cSld>
+  <p:clrMapOvr>
+    <a:masterClrMapping/>
+  </p:clrMapOvr>
+</p:sld>
+</file>
+
+<file path=ppt/slides/slide26.xml><?xml version="1.0" encoding="utf-8"?>
+<p:sld xmlns:a="http://schemas.openxmlformats.org/drawingml/2006/main" xmlns:p="http://schemas.openxmlformats.org/presentationml/2006/main" xmlns:r="http://schemas.openxmlformats.org/officeDocument/2006/relationships">
+  <p:cSld>
+    <p:spTree>
+      <p:nvGrpSpPr>
+        <p:cNvPr id="1" name=""/>
+        <p:cNvGrpSpPr/>
+        <p:nvPr/>
+      </p:nvGrpSpPr>
+      <p:grpSpPr/>
+      <p:sp>
+        <p:nvSpPr>
+          <p:cNvPr id="2" name="TextBox 1"/>
+          <p:cNvSpPr txBox="1"/>
+          <p:nvPr/>
+        </p:nvSpPr>
+        <p:spPr>
+          <a:xfrm>
+            <a:off x="548640" y="365760"/>
+            <a:ext cx="11064240" cy="1005840"/>
+          </a:xfrm>
+          <a:prstGeom prst="rect">
+            <a:avLst/>
+          </a:prstGeom>
+          <a:noFill/>
+        </p:spPr>
+        <p:txBody>
+          <a:bodyPr wrap="square">
+            <a:spAutoFit/>
+          </a:bodyPr>
+          <a:lstStyle/>
+          <a:p>
+            <a:r>
+              <a:rPr sz="3600" b="1">
+                <a:solidFill>
+                  <a:srgbClr val="5A0A7A"/>
+                </a:solidFill>
+              </a:rPr>
               <a:t>The two answers a solver can give</a:t>
             </a:r>
           </a:p>
@@ -6915,7 +7319,7 @@
 </p:sld>
 </file>
 
-<file path=ppt/slides/slide26.xml><?xml version="1.0" encoding="utf-8"?>
+<file path=ppt/slides/slide27.xml><?xml version="1.0" encoding="utf-8"?>
 <p:sld xmlns:a="http://schemas.openxmlformats.org/drawingml/2006/main" xmlns:p="http://schemas.openxmlformats.org/presentationml/2006/main" xmlns:r="http://schemas.openxmlformats.org/officeDocument/2006/relationships">
   <p:cSld>
     <p:spTree>
@@ -7170,7 +7574,7 @@
 </p:sld>
 </file>
 
-<file path=ppt/slides/slide27.xml><?xml version="1.0" encoding="utf-8"?>
+<file path=ppt/slides/slide28.xml><?xml version="1.0" encoding="utf-8"?>
 <p:sld xmlns:a="http://schemas.openxmlformats.org/drawingml/2006/main" xmlns:p="http://schemas.openxmlformats.org/presentationml/2006/main" xmlns:r="http://schemas.openxmlformats.org/officeDocument/2006/relationships">
   <p:cSld>
     <p:spTree>
@@ -7339,222 +7743,6 @@
                 </a:solidFill>
               </a:rPr>
               <a:t>unsat  →  the access is safe on every path</a:t>
-            </a:r>
-          </a:p>
-        </p:txBody>
-      </p:sp>
-    </p:spTree>
-  </p:cSld>
-  <p:clrMapOvr>
-    <a:masterClrMapping/>
-  </p:clrMapOvr>
-</p:sld>
-</file>
-
-<file path=ppt/slides/slide28.xml><?xml version="1.0" encoding="utf-8"?>
-<p:sld xmlns:a="http://schemas.openxmlformats.org/drawingml/2006/main" xmlns:p="http://schemas.openxmlformats.org/presentationml/2006/main" xmlns:r="http://schemas.openxmlformats.org/officeDocument/2006/relationships">
-  <p:cSld>
-    <p:spTree>
-      <p:nvGrpSpPr>
-        <p:cNvPr id="1" name=""/>
-        <p:cNvGrpSpPr/>
-        <p:nvPr/>
-      </p:nvGrpSpPr>
-      <p:grpSpPr/>
-      <p:sp>
-        <p:nvSpPr>
-          <p:cNvPr id="2" name="TextBox 1"/>
-          <p:cNvSpPr txBox="1"/>
-          <p:nvPr/>
-        </p:nvSpPr>
-        <p:spPr>
-          <a:xfrm>
-            <a:off x="548640" y="365760"/>
-            <a:ext cx="11064240" cy="1005840"/>
-          </a:xfrm>
-          <a:prstGeom prst="rect">
-            <a:avLst/>
-          </a:prstGeom>
-          <a:noFill/>
-        </p:spPr>
-        <p:txBody>
-          <a:bodyPr wrap="square">
-            <a:spAutoFit/>
-          </a:bodyPr>
-          <a:lstStyle/>
-          <a:p>
-            <a:r>
-              <a:rPr sz="3600" b="1">
-                <a:solidFill>
-                  <a:srgbClr val="5A0A7A"/>
-                </a:solidFill>
-              </a:rPr>
-              <a:t>Live: a solver in two queries</a:t>
-            </a:r>
-          </a:p>
-        </p:txBody>
-      </p:sp>
-      <p:sp>
-        <p:nvSpPr>
-          <p:cNvPr id="3" name="TextBox 2"/>
-          <p:cNvSpPr txBox="1"/>
-          <p:nvPr/>
-        </p:nvSpPr>
-        <p:spPr>
-          <a:xfrm>
-            <a:off x="731520" y="1463040"/>
-            <a:ext cx="10789920" cy="5120640"/>
-          </a:xfrm>
-          <a:prstGeom prst="rect">
-            <a:avLst/>
-          </a:prstGeom>
-          <a:noFill/>
-        </p:spPr>
-        <p:txBody>
-          <a:bodyPr wrap="square">
-            <a:spAutoFit/>
-          </a:bodyPr>
-          <a:lstStyle/>
-          <a:p>
-            <a:pPr>
-              <a:spcAft>
-                <a:spcPts val="0"/>
-              </a:spcAft>
-            </a:pPr>
-            <a:r>
-              <a:rPr sz="1800">
-                <a:solidFill>
-                  <a:srgbClr val="212121"/>
-                </a:solidFill>
-                <a:latin typeface="Courier New"/>
-              </a:rPr>
-              <a:t>$ python3 z3_demo.py</a:t>
-            </a:r>
-          </a:p>
-          <a:p>
-            <a:pPr>
-              <a:spcAft>
-                <a:spcPts val="0"/>
-              </a:spcAft>
-            </a:pPr>
-            <a:r>
-              <a:rPr sz="1800">
-                <a:solidFill>
-                  <a:srgbClr val="212121"/>
-                </a:solidFill>
-                <a:latin typeface="Courier New"/>
-              </a:rPr>
-              <a:t/>
-            </a:r>
-          </a:p>
-          <a:p>
-            <a:pPr>
-              <a:spcAft>
-                <a:spcPts val="0"/>
-              </a:spcAft>
-            </a:pPr>
-            <a:r>
-              <a:rPr sz="1800">
-                <a:solidFill>
-                  <a:srgbClr val="212121"/>
-                </a:solidFill>
-                <a:latin typeface="Courier New"/>
-              </a:rPr>
-              <a:t>Query 1: x + y == 42 and x &gt; 100</a:t>
-            </a:r>
-          </a:p>
-          <a:p>
-            <a:pPr>
-              <a:spcAft>
-                <a:spcPts val="0"/>
-              </a:spcAft>
-            </a:pPr>
-            <a:r>
-              <a:rPr sz="1800">
-                <a:solidFill>
-                  <a:srgbClr val="212121"/>
-                </a:solidFill>
-                <a:latin typeface="Courier New"/>
-              </a:rPr>
-              <a:t>[y = -59, x = 101]            ← a model, in milliseconds</a:t>
-            </a:r>
-          </a:p>
-          <a:p>
-            <a:pPr>
-              <a:spcAft>
-                <a:spcPts val="0"/>
-              </a:spcAft>
-            </a:pPr>
-            <a:r>
-              <a:rPr sz="1800">
-                <a:solidFill>
-                  <a:srgbClr val="212121"/>
-                </a:solidFill>
-                <a:latin typeface="Courier New"/>
-              </a:rPr>
-              <a:t/>
-            </a:r>
-          </a:p>
-          <a:p>
-            <a:pPr>
-              <a:spcAft>
-                <a:spcPts val="0"/>
-              </a:spcAft>
-            </a:pPr>
-            <a:r>
-              <a:rPr sz="1800">
-                <a:solidFill>
-                  <a:srgbClr val="212121"/>
-                </a:solidFill>
-                <a:latin typeface="Courier New"/>
-              </a:rPr>
-              <a:t>Query 2: x*x == 2*y*y, x &gt; 0, y &gt; 0 (no overflow)</a:t>
-            </a:r>
-          </a:p>
-          <a:p>
-            <a:pPr>
-              <a:spcAft>
-                <a:spcPts val="0"/>
-              </a:spcAft>
-            </a:pPr>
-            <a:r>
-              <a:rPr sz="1800">
-                <a:solidFill>
-                  <a:srgbClr val="212121"/>
-                </a:solidFill>
-                <a:latin typeface="Courier New"/>
-              </a:rPr>
-              <a:t>unsat                          ← a proof</a:t>
-            </a:r>
-          </a:p>
-          <a:p>
-            <a:pPr>
-              <a:spcAft>
-                <a:spcPts val="800"/>
-              </a:spcAft>
-            </a:pPr>
-            <a:r>
-              <a:rPr sz="2200">
-                <a:solidFill>
-                  <a:srgbClr val="212121"/>
-                </a:solidFill>
-              </a:rPr>
-              <a:t/>
-            </a:r>
-          </a:p>
-          <a:p>
-            <a:pPr>
-              <a:spcAft>
-                <a:spcPts val="800"/>
-              </a:spcAft>
-            </a:pPr>
-            <a:r>
-              <a:rPr sz="2200">
-                <a:solidFill>
-                  <a:srgbClr val="212121"/>
-                </a:solidFill>
-              </a:rPr>
-              <a:t>Query 2 just proved that √2 is irrational — 32-bit bit-vector edition. unsat is a theorem, not a shrug.</a:t>
             </a:r>
           </a:p>
         </p:txBody>
@@ -7605,7 +7793,7 @@
                   <a:srgbClr val="5A0A7A"/>
                 </a:solidFill>
               </a:rPr>
-              <a:t>Machine arithmetic is not mathematics</a:t>
+              <a:t>Live: a solver in two queries</a:t>
             </a:r>
           </a:p>
         </p:txBody>
@@ -7644,7 +7832,7 @@
                 </a:solidFill>
                 <a:latin typeface="Courier New"/>
               </a:rPr>
-              <a:t>INT_MAX     =  2147483647</a:t>
+              <a:t>$ python3 z3_demo.py</a:t>
             </a:r>
           </a:p>
           <a:p>
@@ -7660,7 +7848,7 @@
                 </a:solidFill>
                 <a:latin typeface="Courier New"/>
               </a:rPr>
-              <a:t>INT_MAX + 1 =  ?            /* C: undefined behaviour */</a:t>
+              <a:t/>
             </a:r>
           </a:p>
           <a:p>
@@ -7676,7 +7864,71 @@
                 </a:solidFill>
                 <a:latin typeface="Courier New"/>
               </a:rPr>
-              <a:t>                            /* bit-vectors: wraps negative */</a:t>
+              <a:t>Query 1: x + y == 42 and x &gt; 100</a:t>
+            </a:r>
+          </a:p>
+          <a:p>
+            <a:pPr>
+              <a:spcAft>
+                <a:spcPts val="0"/>
+              </a:spcAft>
+            </a:pPr>
+            <a:r>
+              <a:rPr sz="1800">
+                <a:solidFill>
+                  <a:srgbClr val="212121"/>
+                </a:solidFill>
+                <a:latin typeface="Courier New"/>
+              </a:rPr>
+              <a:t>[y = -59, x = 101]            ← a model, in milliseconds</a:t>
+            </a:r>
+          </a:p>
+          <a:p>
+            <a:pPr>
+              <a:spcAft>
+                <a:spcPts val="0"/>
+              </a:spcAft>
+            </a:pPr>
+            <a:r>
+              <a:rPr sz="1800">
+                <a:solidFill>
+                  <a:srgbClr val="212121"/>
+                </a:solidFill>
+                <a:latin typeface="Courier New"/>
+              </a:rPr>
+              <a:t/>
+            </a:r>
+          </a:p>
+          <a:p>
+            <a:pPr>
+              <a:spcAft>
+                <a:spcPts val="0"/>
+              </a:spcAft>
+            </a:pPr>
+            <a:r>
+              <a:rPr sz="1800">
+                <a:solidFill>
+                  <a:srgbClr val="212121"/>
+                </a:solidFill>
+                <a:latin typeface="Courier New"/>
+              </a:rPr>
+              <a:t>Query 2: x*x == 2*y*y, x &gt; 0, y &gt; 0 (no overflow)</a:t>
+            </a:r>
+          </a:p>
+          <a:p>
+            <a:pPr>
+              <a:spcAft>
+                <a:spcPts val="0"/>
+              </a:spcAft>
+            </a:pPr>
+            <a:r>
+              <a:rPr sz="1800">
+                <a:solidFill>
+                  <a:srgbClr val="212121"/>
+                </a:solidFill>
+                <a:latin typeface="Courier New"/>
+              </a:rPr>
+              <a:t>unsat                          ← a proof</a:t>
             </a:r>
           </a:p>
           <a:p>
@@ -7697,54 +7949,6 @@
           <a:p>
             <a:pPr>
               <a:spcAft>
-                <a:spcPts val="0"/>
-              </a:spcAft>
-            </a:pPr>
-            <a:r>
-              <a:rPr sz="1800">
-                <a:solidFill>
-                  <a:srgbClr val="212121"/>
-                </a:solidFill>
-                <a:latin typeface="Courier New"/>
-              </a:rPr>
-              <a:t>int y = x + 1;</a:t>
-            </a:r>
-          </a:p>
-          <a:p>
-            <a:pPr>
-              <a:spcAft>
-                <a:spcPts val="0"/>
-              </a:spcAft>
-            </a:pPr>
-            <a:r>
-              <a:rPr sz="1800">
-                <a:solidFill>
-                  <a:srgbClr val="212121"/>
-                </a:solidFill>
-                <a:latin typeface="Courier New"/>
-              </a:rPr>
-              <a:t>int z = y * 2;</a:t>
-            </a:r>
-          </a:p>
-          <a:p>
-            <a:pPr>
-              <a:spcAft>
-                <a:spcPts val="0"/>
-              </a:spcAft>
-            </a:pPr>
-            <a:r>
-              <a:rPr sz="1800">
-                <a:solidFill>
-                  <a:srgbClr val="212121"/>
-                </a:solidFill>
-                <a:latin typeface="Courier New"/>
-              </a:rPr>
-              <a:t>assert(z &gt;= 2);   /* surely true for x &gt;= 0 … ? */</a:t>
-            </a:r>
-          </a:p>
-          <a:p>
-            <a:pPr>
-              <a:spcAft>
                 <a:spcPts val="800"/>
               </a:spcAft>
             </a:pPr>
@@ -7754,22 +7958,7 @@
                   <a:srgbClr val="212121"/>
                 </a:solidFill>
               </a:rPr>
-              <a:t/>
-            </a:r>
-          </a:p>
-          <a:p>
-            <a:pPr>
-              <a:spcAft>
-                <a:spcPts val="800"/>
-              </a:spcAft>
-            </a:pPr>
-            <a:r>
-              <a:rPr sz="2200">
-                <a:solidFill>
-                  <a:srgbClr val="212121"/>
-                </a:solidFill>
-              </a:rPr>
-              <a:t>A solver finds the x that breaks this in milliseconds. In Lab 1 you will encode these three lines yourself and watch it happen.</a:t>
+              <a:t>Query 2 just proved that √2 is irrational — 32-bit bit-vector edition. unsat is a theorem, not a shrug.</a:t>
             </a:r>
           </a:p>
         </p:txBody>
@@ -7924,7 +8113,7 @@
                   <a:srgbClr val="5A0A7A"/>
                 </a:solidFill>
               </a:rPr>
-              <a:t>Solvers as search engines: SEND + MORE = MONEY</a:t>
+              <a:t>Machine arithmetic is not mathematics</a:t>
             </a:r>
           </a:p>
         </p:txBody>
@@ -7963,7 +8152,7 @@
                 </a:solidFill>
                 <a:latin typeface="Courier New"/>
               </a:rPr>
-              <a:t>  S E N D</a:t>
+              <a:t>INT_MAX     =  2147483647</a:t>
             </a:r>
           </a:p>
           <a:p>
@@ -7979,7 +8168,7 @@
                 </a:solidFill>
                 <a:latin typeface="Courier New"/>
               </a:rPr>
-              <a:t>+ M O R E</a:t>
+              <a:t>INT_MAX + 1 =  ?            /* C: undefined behaviour */</a:t>
             </a:r>
           </a:p>
           <a:p>
@@ -7995,7 +8184,22 @@
                 </a:solidFill>
                 <a:latin typeface="Courier New"/>
               </a:rPr>
-              <a:t>---------</a:t>
+              <a:t>                            /* bit-vectors: wraps negative */</a:t>
+            </a:r>
+          </a:p>
+          <a:p>
+            <a:pPr>
+              <a:spcAft>
+                <a:spcPts val="800"/>
+              </a:spcAft>
+            </a:pPr>
+            <a:r>
+              <a:rPr sz="2200">
+                <a:solidFill>
+                  <a:srgbClr val="212121"/>
+                </a:solidFill>
+              </a:rPr>
+              <a:t/>
             </a:r>
           </a:p>
           <a:p>
@@ -8011,7 +8215,39 @@
                 </a:solidFill>
                 <a:latin typeface="Courier New"/>
               </a:rPr>
-              <a:t>M O N E Y</a:t>
+              <a:t>int y = x + 1;</a:t>
+            </a:r>
+          </a:p>
+          <a:p>
+            <a:pPr>
+              <a:spcAft>
+                <a:spcPts val="0"/>
+              </a:spcAft>
+            </a:pPr>
+            <a:r>
+              <a:rPr sz="1800">
+                <a:solidFill>
+                  <a:srgbClr val="212121"/>
+                </a:solidFill>
+                <a:latin typeface="Courier New"/>
+              </a:rPr>
+              <a:t>int z = y * 2;</a:t>
+            </a:r>
+          </a:p>
+          <a:p>
+            <a:pPr>
+              <a:spcAft>
+                <a:spcPts val="0"/>
+              </a:spcAft>
+            </a:pPr>
+            <a:r>
+              <a:rPr sz="1800">
+                <a:solidFill>
+                  <a:srgbClr val="212121"/>
+                </a:solidFill>
+                <a:latin typeface="Courier New"/>
+              </a:rPr>
+              <a:t>assert(z &gt;= 2);   /* surely true for x &gt;= 0 … ? */</a:t>
             </a:r>
           </a:p>
           <a:p>
@@ -8041,52 +8277,7 @@
                   <a:srgbClr val="212121"/>
                 </a:solidFill>
               </a:rPr>
-              <a:t>Eight letters, all different digits, S ≠ 0, M ≠ 0 — about 10⁸ candidate assignments.</a:t>
-            </a:r>
-          </a:p>
-          <a:p>
-            <a:pPr>
-              <a:spcAft>
-                <a:spcPts val="800"/>
-              </a:spcAft>
-            </a:pPr>
-            <a:r>
-              <a:rPr sz="2200">
-                <a:solidFill>
-                  <a:srgbClr val="212121"/>
-                </a:solidFill>
-              </a:rPr>
-              <a:t>Z3 finds the unique solution in well under a second.</a:t>
-            </a:r>
-          </a:p>
-          <a:p>
-            <a:pPr>
-              <a:spcAft>
-                <a:spcPts val="800"/>
-              </a:spcAft>
-            </a:pPr>
-            <a:r>
-              <a:rPr sz="2200">
-                <a:solidFill>
-                  <a:srgbClr val="212121"/>
-                </a:solidFill>
-              </a:rPr>
-              <a:t>The same engine that solves puzzles finds your bugs: a counterexample is just a solution to “break my program”.</a:t>
-            </a:r>
-          </a:p>
-          <a:p>
-            <a:pPr>
-              <a:spcAft>
-                <a:spcPts val="800"/>
-              </a:spcAft>
-            </a:pPr>
-            <a:r>
-              <a:rPr sz="2200">
-                <a:solidFill>
-                  <a:srgbClr val="212121"/>
-                </a:solidFill>
-              </a:rPr>
-              <a:t>Lab 1, Stage 2: you run this yourself.</a:t>
+              <a:t>A solver finds the x that breaks this in milliseconds. In Lab 1 you will encode these three lines yourself and watch it happen.</a:t>
             </a:r>
           </a:p>
         </p:txBody>
@@ -8100,6 +8291,219 @@
 </file>
 
 <file path=ppt/slides/slide31.xml><?xml version="1.0" encoding="utf-8"?>
+<p:sld xmlns:a="http://schemas.openxmlformats.org/drawingml/2006/main" xmlns:p="http://schemas.openxmlformats.org/presentationml/2006/main" xmlns:r="http://schemas.openxmlformats.org/officeDocument/2006/relationships">
+  <p:cSld>
+    <p:spTree>
+      <p:nvGrpSpPr>
+        <p:cNvPr id="1" name=""/>
+        <p:cNvGrpSpPr/>
+        <p:nvPr/>
+      </p:nvGrpSpPr>
+      <p:grpSpPr/>
+      <p:sp>
+        <p:nvSpPr>
+          <p:cNvPr id="2" name="TextBox 1"/>
+          <p:cNvSpPr txBox="1"/>
+          <p:nvPr/>
+        </p:nvSpPr>
+        <p:spPr>
+          <a:xfrm>
+            <a:off x="548640" y="365760"/>
+            <a:ext cx="11064240" cy="1005840"/>
+          </a:xfrm>
+          <a:prstGeom prst="rect">
+            <a:avLst/>
+          </a:prstGeom>
+          <a:noFill/>
+        </p:spPr>
+        <p:txBody>
+          <a:bodyPr wrap="square">
+            <a:spAutoFit/>
+          </a:bodyPr>
+          <a:lstStyle/>
+          <a:p>
+            <a:r>
+              <a:rPr sz="3600" b="1">
+                <a:solidFill>
+                  <a:srgbClr val="5A0A7A"/>
+                </a:solidFill>
+              </a:rPr>
+              <a:t>Solvers as search engines: SEND + MORE = MONEY</a:t>
+            </a:r>
+          </a:p>
+        </p:txBody>
+      </p:sp>
+      <p:sp>
+        <p:nvSpPr>
+          <p:cNvPr id="3" name="TextBox 2"/>
+          <p:cNvSpPr txBox="1"/>
+          <p:nvPr/>
+        </p:nvSpPr>
+        <p:spPr>
+          <a:xfrm>
+            <a:off x="731520" y="1463040"/>
+            <a:ext cx="10789920" cy="5120640"/>
+          </a:xfrm>
+          <a:prstGeom prst="rect">
+            <a:avLst/>
+          </a:prstGeom>
+          <a:noFill/>
+        </p:spPr>
+        <p:txBody>
+          <a:bodyPr wrap="square">
+            <a:spAutoFit/>
+          </a:bodyPr>
+          <a:lstStyle/>
+          <a:p>
+            <a:pPr>
+              <a:spcAft>
+                <a:spcPts val="0"/>
+              </a:spcAft>
+            </a:pPr>
+            <a:r>
+              <a:rPr sz="1800">
+                <a:solidFill>
+                  <a:srgbClr val="212121"/>
+                </a:solidFill>
+                <a:latin typeface="Courier New"/>
+              </a:rPr>
+              <a:t>  S E N D</a:t>
+            </a:r>
+          </a:p>
+          <a:p>
+            <a:pPr>
+              <a:spcAft>
+                <a:spcPts val="0"/>
+              </a:spcAft>
+            </a:pPr>
+            <a:r>
+              <a:rPr sz="1800">
+                <a:solidFill>
+                  <a:srgbClr val="212121"/>
+                </a:solidFill>
+                <a:latin typeface="Courier New"/>
+              </a:rPr>
+              <a:t>+ M O R E</a:t>
+            </a:r>
+          </a:p>
+          <a:p>
+            <a:pPr>
+              <a:spcAft>
+                <a:spcPts val="0"/>
+              </a:spcAft>
+            </a:pPr>
+            <a:r>
+              <a:rPr sz="1800">
+                <a:solidFill>
+                  <a:srgbClr val="212121"/>
+                </a:solidFill>
+                <a:latin typeface="Courier New"/>
+              </a:rPr>
+              <a:t>---------</a:t>
+            </a:r>
+          </a:p>
+          <a:p>
+            <a:pPr>
+              <a:spcAft>
+                <a:spcPts val="0"/>
+              </a:spcAft>
+            </a:pPr>
+            <a:r>
+              <a:rPr sz="1800">
+                <a:solidFill>
+                  <a:srgbClr val="212121"/>
+                </a:solidFill>
+                <a:latin typeface="Courier New"/>
+              </a:rPr>
+              <a:t>M O N E Y</a:t>
+            </a:r>
+          </a:p>
+          <a:p>
+            <a:pPr>
+              <a:spcAft>
+                <a:spcPts val="800"/>
+              </a:spcAft>
+            </a:pPr>
+            <a:r>
+              <a:rPr sz="2200">
+                <a:solidFill>
+                  <a:srgbClr val="212121"/>
+                </a:solidFill>
+              </a:rPr>
+              <a:t/>
+            </a:r>
+          </a:p>
+          <a:p>
+            <a:pPr>
+              <a:spcAft>
+                <a:spcPts val="800"/>
+              </a:spcAft>
+            </a:pPr>
+            <a:r>
+              <a:rPr sz="2200">
+                <a:solidFill>
+                  <a:srgbClr val="212121"/>
+                </a:solidFill>
+              </a:rPr>
+              <a:t>Eight letters, all different digits, S ≠ 0, M ≠ 0 — about 10⁸ candidate assignments.</a:t>
+            </a:r>
+          </a:p>
+          <a:p>
+            <a:pPr>
+              <a:spcAft>
+                <a:spcPts val="800"/>
+              </a:spcAft>
+            </a:pPr>
+            <a:r>
+              <a:rPr sz="2200">
+                <a:solidFill>
+                  <a:srgbClr val="212121"/>
+                </a:solidFill>
+              </a:rPr>
+              <a:t>Z3 finds the unique solution in well under a second.</a:t>
+            </a:r>
+          </a:p>
+          <a:p>
+            <a:pPr>
+              <a:spcAft>
+                <a:spcPts val="800"/>
+              </a:spcAft>
+            </a:pPr>
+            <a:r>
+              <a:rPr sz="2200">
+                <a:solidFill>
+                  <a:srgbClr val="212121"/>
+                </a:solidFill>
+              </a:rPr>
+              <a:t>The same engine that solves puzzles finds your bugs: a counterexample is just a solution to “break my program”.</a:t>
+            </a:r>
+          </a:p>
+          <a:p>
+            <a:pPr>
+              <a:spcAft>
+                <a:spcPts val="800"/>
+              </a:spcAft>
+            </a:pPr>
+            <a:r>
+              <a:rPr sz="2200">
+                <a:solidFill>
+                  <a:srgbClr val="212121"/>
+                </a:solidFill>
+              </a:rPr>
+              <a:t>Lab 1, Stage 2: you run this yourself.</a:t>
+            </a:r>
+          </a:p>
+        </p:txBody>
+      </p:sp>
+    </p:spTree>
+  </p:cSld>
+  <p:clrMapOvr>
+    <a:masterClrMapping/>
+  </p:clrMapOvr>
+</p:sld>
+</file>
+
+<file path=ppt/slides/slide32.xml><?xml version="1.0" encoding="utf-8"?>
 <p:sld xmlns:a="http://schemas.openxmlformats.org/drawingml/2006/main" xmlns:p="http://schemas.openxmlformats.org/presentationml/2006/main" xmlns:r="http://schemas.openxmlformats.org/officeDocument/2006/relationships">
   <p:cSld>
     <p:spTree>
@@ -8671,7 +9075,7 @@
 </p:sld>
 </file>
 
-<file path=ppt/slides/slide32.xml><?xml version="1.0" encoding="utf-8"?>
+<file path=ppt/slides/slide33.xml><?xml version="1.0" encoding="utf-8"?>
 <p:sld xmlns:a="http://schemas.openxmlformats.org/drawingml/2006/main" xmlns:p="http://schemas.openxmlformats.org/presentationml/2006/main" xmlns:r="http://schemas.openxmlformats.org/officeDocument/2006/relationships">
   <p:cSld>
     <p:spTree>
@@ -8851,7 +9255,7 @@
 </p:sld>
 </file>
 
-<file path=ppt/slides/slide33.xml><?xml version="1.0" encoding="utf-8"?>
+<file path=ppt/slides/slide34.xml><?xml version="1.0" encoding="utf-8"?>
 <p:sld xmlns:a="http://schemas.openxmlformats.org/drawingml/2006/main" xmlns:p="http://schemas.openxmlformats.org/presentationml/2006/main" xmlns:r="http://schemas.openxmlformats.org/officeDocument/2006/relationships">
   <p:cSld>
     <p:spTree>
@@ -9093,7 +9497,7 @@
 </p:sld>
 </file>
 
-<file path=ppt/slides/slide34.xml><?xml version="1.0" encoding="utf-8"?>
+<file path=ppt/slides/slide35.xml><?xml version="1.0" encoding="utf-8"?>
 <p:sld xmlns:a="http://schemas.openxmlformats.org/drawingml/2006/main" xmlns:p="http://schemas.openxmlformats.org/presentationml/2006/main" xmlns:r="http://schemas.openxmlformats.org/officeDocument/2006/relationships">
   <p:cSld>
     <p:spTree>
@@ -9248,171 +9652,6 @@
                 </a:solidFill>
               </a:rPr>
               <a:t>Recognise the three lines? In Lab 1, Stage 3 you translate exactly this function by hand and hand it to Z3. You will be doing ESBMC's job yourself.</a:t>
-            </a:r>
-          </a:p>
-        </p:txBody>
-      </p:sp>
-    </p:spTree>
-  </p:cSld>
-  <p:clrMapOvr>
-    <a:masterClrMapping/>
-  </p:clrMapOvr>
-</p:sld>
-</file>
-
-<file path=ppt/slides/slide35.xml><?xml version="1.0" encoding="utf-8"?>
-<p:sld xmlns:a="http://schemas.openxmlformats.org/drawingml/2006/main" xmlns:p="http://schemas.openxmlformats.org/presentationml/2006/main" xmlns:r="http://schemas.openxmlformats.org/officeDocument/2006/relationships">
-  <p:cSld>
-    <p:spTree>
-      <p:nvGrpSpPr>
-        <p:cNvPr id="1" name=""/>
-        <p:cNvGrpSpPr/>
-        <p:nvPr/>
-      </p:nvGrpSpPr>
-      <p:grpSpPr/>
-      <p:sp>
-        <p:nvSpPr>
-          <p:cNvPr id="2" name="TextBox 1"/>
-          <p:cNvSpPr txBox="1"/>
-          <p:nvPr/>
-        </p:nvSpPr>
-        <p:spPr>
-          <a:xfrm>
-            <a:off x="548640" y="365760"/>
-            <a:ext cx="11064240" cy="1005840"/>
-          </a:xfrm>
-          <a:prstGeom prst="rect">
-            <a:avLst/>
-          </a:prstGeom>
-          <a:noFill/>
-        </p:spPr>
-        <p:txBody>
-          <a:bodyPr wrap="square">
-            <a:spAutoFit/>
-          </a:bodyPr>
-          <a:lstStyle/>
-          <a:p>
-            <a:r>
-              <a:rPr sz="3600" b="1">
-                <a:solidFill>
-                  <a:srgbClr val="5A0A7A"/>
-                </a:solidFill>
-              </a:rPr>
-              <a:t>Putting it together</a:t>
-            </a:r>
-          </a:p>
-        </p:txBody>
-      </p:sp>
-      <p:sp>
-        <p:nvSpPr>
-          <p:cNvPr id="3" name="TextBox 2"/>
-          <p:cNvSpPr txBox="1"/>
-          <p:nvPr/>
-        </p:nvSpPr>
-        <p:spPr>
-          <a:xfrm>
-            <a:off x="731520" y="1737360"/>
-            <a:ext cx="10789920" cy="4846320"/>
-          </a:xfrm>
-          <a:prstGeom prst="rect">
-            <a:avLst/>
-          </a:prstGeom>
-          <a:noFill/>
-        </p:spPr>
-        <p:txBody>
-          <a:bodyPr wrap="square">
-            <a:spAutoFit/>
-          </a:bodyPr>
-          <a:lstStyle/>
-          <a:p>
-            <a:pPr>
-              <a:spcAft>
-                <a:spcPts val="0"/>
-              </a:spcAft>
-            </a:pPr>
-            <a:r>
-              <a:rPr sz="2200">
-                <a:solidFill>
-                  <a:srgbClr val="212121"/>
-                </a:solidFill>
-                <a:latin typeface="Courier New"/>
-              </a:rPr>
-              <a:t>⟦program⟧  ∧  ¬P      →  SMT solver</a:t>
-            </a:r>
-          </a:p>
-          <a:p>
-            <a:pPr>
-              <a:spcAft>
-                <a:spcPts val="800"/>
-              </a:spcAft>
-            </a:pPr>
-            <a:r>
-              <a:rPr sz="2600">
-                <a:solidFill>
-                  <a:srgbClr val="212121"/>
-                </a:solidFill>
-              </a:rPr>
-              <a:t/>
-            </a:r>
-          </a:p>
-          <a:p>
-            <a:pPr>
-              <a:spcAft>
-                <a:spcPts val="800"/>
-              </a:spcAft>
-            </a:pPr>
-            <a:r>
-              <a:rPr sz="2600">
-                <a:solidFill>
-                  <a:srgbClr val="212121"/>
-                </a:solidFill>
-              </a:rPr>
-              <a:t>sat — the model assigns every input and every choice: replayed in program order, that is the counterexample trace.</a:t>
-            </a:r>
-          </a:p>
-          <a:p>
-            <a:pPr>
-              <a:spcAft>
-                <a:spcPts val="800"/>
-              </a:spcAft>
-            </a:pPr>
-            <a:r>
-              <a:rPr sz="2600">
-                <a:solidFill>
-                  <a:srgbClr val="212121"/>
-                </a:solidFill>
-              </a:rPr>
-              <a:t>unsat — no execution within the bound violates P.</a:t>
-            </a:r>
-          </a:p>
-          <a:p>
-            <a:pPr>
-              <a:spcAft>
-                <a:spcPts val="800"/>
-              </a:spcAft>
-            </a:pPr>
-            <a:r>
-              <a:rPr sz="2600">
-                <a:solidFill>
-                  <a:srgbClr val="212121"/>
-                </a:solidFill>
-              </a:rPr>
-              <a:t/>
-            </a:r>
-          </a:p>
-          <a:p>
-            <a:pPr>
-              <a:spcAft>
-                <a:spcPts val="800"/>
-              </a:spcAft>
-            </a:pPr>
-            <a:r>
-              <a:rPr sz="2600">
-                <a:solidFill>
-                  <a:srgbClr val="212121"/>
-                </a:solidFill>
-              </a:rPr>
-              <a:t>One formula, every path at once. That is why nobody has to enumerate 2⁶⁴ test cases.</a:t>
             </a:r>
           </a:p>
         </p:txBody>
@@ -9463,7 +9702,7 @@
                   <a:srgbClr val="5A0A7A"/>
                 </a:solidFill>
               </a:rPr>
-              <a:t>Anatomy of a counterexample</a:t>
+              <a:t>Putting it together</a:t>
             </a:r>
           </a:p>
         </p:txBody>
@@ -9476,8 +9715,8 @@
         </p:nvSpPr>
         <p:spPr>
           <a:xfrm>
-            <a:off x="731520" y="1463040"/>
-            <a:ext cx="10789920" cy="5120640"/>
+            <a:off x="731520" y="1737360"/>
+            <a:ext cx="10789920" cy="4846320"/>
           </a:xfrm>
           <a:prstGeom prst="rect">
             <a:avLst/>
@@ -9496,103 +9735,23 @@
               </a:spcAft>
             </a:pPr>
             <a:r>
-              <a:rPr sz="1800">
+              <a:rPr sz="2200">
                 <a:solidFill>
                   <a:srgbClr val="212121"/>
                 </a:solidFill>
                 <a:latin typeface="Courier New"/>
               </a:rPr>
-              <a:t>State 3  file offbyone.c  line 15</a:t>
-            </a:r>
-          </a:p>
-          <a:p>
-            <a:pPr>
-              <a:spcAft>
-                <a:spcPts val="0"/>
-              </a:spcAft>
-            </a:pPr>
-            <a:r>
-              <a:rPr sz="1800">
-                <a:solidFill>
-                  <a:srgbClr val="212121"/>
-                </a:solidFill>
-                <a:latin typeface="Courier New"/>
-              </a:rPr>
-              <a:t>  i = 5 (00000000 ... 101)      ← the value the solver chose</a:t>
-            </a:r>
-          </a:p>
-          <a:p>
-            <a:pPr>
-              <a:spcAft>
-                <a:spcPts val="0"/>
-              </a:spcAft>
-            </a:pPr>
-            <a:r>
-              <a:rPr sz="1800">
-                <a:solidFill>
-                  <a:srgbClr val="212121"/>
-                </a:solidFill>
-                <a:latin typeface="Courier New"/>
-              </a:rPr>
-              <a:t>...</a:t>
-            </a:r>
-          </a:p>
-          <a:p>
-            <a:pPr>
-              <a:spcAft>
-                <a:spcPts val="0"/>
-              </a:spcAft>
-            </a:pPr>
-            <a:r>
-              <a:rPr sz="1800">
-                <a:solidFill>
-                  <a:srgbClr val="212121"/>
-                </a:solidFill>
-                <a:latin typeface="Courier New"/>
-              </a:rPr>
-              <a:t>Violated property:</a:t>
-            </a:r>
-          </a:p>
-          <a:p>
-            <a:pPr>
-              <a:spcAft>
-                <a:spcPts val="0"/>
-              </a:spcAft>
-            </a:pPr>
-            <a:r>
-              <a:rPr sz="1800">
-                <a:solidFill>
-                  <a:srgbClr val="212121"/>
-                </a:solidFill>
-                <a:latin typeface="Courier New"/>
-              </a:rPr>
-              <a:t>  array bounds violated: a[i]   ← what broke</a:t>
-            </a:r>
-          </a:p>
-          <a:p>
-            <a:pPr>
-              <a:spcAft>
-                <a:spcPts val="0"/>
-              </a:spcAft>
-            </a:pPr>
-            <a:r>
-              <a:rPr sz="1800">
-                <a:solidFill>
-                  <a:srgbClr val="212121"/>
-                </a:solidFill>
-                <a:latin typeface="Courier New"/>
-              </a:rPr>
-              <a:t>  CWE: CWE-787                   ← the vulnerability class</a:t>
-            </a:r>
-          </a:p>
-          <a:p>
-            <a:pPr>
-              <a:spcAft>
-                <a:spcPts val="800"/>
-              </a:spcAft>
-            </a:pPr>
-            <a:r>
-              <a:rPr sz="2200">
+              <a:t>⟦program⟧  ∧  ¬P      →  SMT solver</a:t>
+            </a:r>
+          </a:p>
+          <a:p>
+            <a:pPr>
+              <a:spcAft>
+                <a:spcPts val="800"/>
+              </a:spcAft>
+            </a:pPr>
+            <a:r>
+              <a:rPr sz="2600">
                 <a:solidFill>
                   <a:srgbClr val="212121"/>
                 </a:solidFill>
@@ -9607,27 +9766,57 @@
               </a:spcAft>
             </a:pPr>
             <a:r>
-              <a:rPr sz="2200">
-                <a:solidFill>
-                  <a:srgbClr val="212121"/>
-                </a:solidFill>
-              </a:rPr>
-              <a:t>Read it bottom-up: first what was violated, then scroll up for the values that caused it.</a:t>
-            </a:r>
-          </a:p>
-          <a:p>
-            <a:pPr>
-              <a:spcAft>
-                <a:spcPts val="800"/>
-              </a:spcAft>
-            </a:pPr>
-            <a:r>
-              <a:rPr sz="2200">
-                <a:solidFill>
-                  <a:srgbClr val="212121"/>
-                </a:solidFill>
-              </a:rPr>
-              <a:t>Those values are a ready-made failing test case — keep them.</a:t>
+              <a:rPr sz="2600">
+                <a:solidFill>
+                  <a:srgbClr val="212121"/>
+                </a:solidFill>
+              </a:rPr>
+              <a:t>sat — the model assigns every input and every choice: replayed in program order, that is the counterexample trace.</a:t>
+            </a:r>
+          </a:p>
+          <a:p>
+            <a:pPr>
+              <a:spcAft>
+                <a:spcPts val="800"/>
+              </a:spcAft>
+            </a:pPr>
+            <a:r>
+              <a:rPr sz="2600">
+                <a:solidFill>
+                  <a:srgbClr val="212121"/>
+                </a:solidFill>
+              </a:rPr>
+              <a:t>unsat — no execution within the bound violates P.</a:t>
+            </a:r>
+          </a:p>
+          <a:p>
+            <a:pPr>
+              <a:spcAft>
+                <a:spcPts val="800"/>
+              </a:spcAft>
+            </a:pPr>
+            <a:r>
+              <a:rPr sz="2600">
+                <a:solidFill>
+                  <a:srgbClr val="212121"/>
+                </a:solidFill>
+              </a:rPr>
+              <a:t/>
+            </a:r>
+          </a:p>
+          <a:p>
+            <a:pPr>
+              <a:spcAft>
+                <a:spcPts val="800"/>
+              </a:spcAft>
+            </a:pPr>
+            <a:r>
+              <a:rPr sz="2600">
+                <a:solidFill>
+                  <a:srgbClr val="212121"/>
+                </a:solidFill>
+              </a:rPr>
+              <a:t>One formula, every path at once. That is why nobody has to enumerate 2⁶⁴ test cases.</a:t>
             </a:r>
           </a:p>
         </p:txBody>
@@ -9678,7 +9867,7 @@
                   <a:srgbClr val="5A0A7A"/>
                 </a:solidFill>
               </a:rPr>
-              <a:t>Live: the whole pipeline on five lines</a:t>
+              <a:t>Anatomy of a counterexample</a:t>
             </a:r>
           </a:p>
         </p:txBody>
@@ -9717,7 +9906,7 @@
                 </a:solidFill>
                 <a:latin typeface="Courier New"/>
               </a:rPr>
-              <a:t>int main(void)</a:t>
+              <a:t>State 3  file offbyone.c  line 15</a:t>
             </a:r>
           </a:p>
           <a:p>
@@ -9733,7 +9922,7 @@
                 </a:solidFill>
                 <a:latin typeface="Courier New"/>
               </a:rPr>
-              <a:t>{</a:t>
+              <a:t>  i = 5 (00000000 ... 101)      ← the value the solver chose</a:t>
             </a:r>
           </a:p>
           <a:p>
@@ -9749,7 +9938,7 @@
                 </a:solidFill>
                 <a:latin typeface="Courier New"/>
               </a:rPr>
-              <a:t>  int a[5];</a:t>
+              <a:t>...</a:t>
             </a:r>
           </a:p>
           <a:p>
@@ -9765,7 +9954,7 @@
                 </a:solidFill>
                 <a:latin typeface="Courier New"/>
               </a:rPr>
-              <a:t>  for (int i = 0; i &lt;= 5; i++)</a:t>
+              <a:t>Violated property:</a:t>
             </a:r>
           </a:p>
           <a:p>
@@ -9781,7 +9970,7 @@
                 </a:solidFill>
                 <a:latin typeface="Courier New"/>
               </a:rPr>
-              <a:t>    a[i] = i;</a:t>
+              <a:t>  array bounds violated: a[i]   ← what broke</a:t>
             </a:r>
           </a:p>
           <a:p>
@@ -9797,21 +9986,20 @@
                 </a:solidFill>
                 <a:latin typeface="Courier New"/>
               </a:rPr>
-              <a:t>}</a:t>
-            </a:r>
-          </a:p>
-          <a:p>
-            <a:pPr>
-              <a:spcAft>
-                <a:spcPts val="0"/>
-              </a:spcAft>
-            </a:pPr>
-            <a:r>
-              <a:rPr sz="1800">
-                <a:solidFill>
-                  <a:srgbClr val="212121"/>
-                </a:solidFill>
-                <a:latin typeface="Courier New"/>
+              <a:t>  CWE: CWE-787                   ← the vulnerability class</a:t>
+            </a:r>
+          </a:p>
+          <a:p>
+            <a:pPr>
+              <a:spcAft>
+                <a:spcPts val="800"/>
+              </a:spcAft>
+            </a:pPr>
+            <a:r>
+              <a:rPr sz="2200">
+                <a:solidFill>
+                  <a:srgbClr val="212121"/>
+                </a:solidFill>
               </a:rPr>
               <a:t/>
             </a:r>
@@ -9819,22 +10007,6 @@
           <a:p>
             <a:pPr>
               <a:spcAft>
-                <a:spcPts val="0"/>
-              </a:spcAft>
-            </a:pPr>
-            <a:r>
-              <a:rPr sz="1800">
-                <a:solidFill>
-                  <a:srgbClr val="212121"/>
-                </a:solidFill>
-                <a:latin typeface="Courier New"/>
-              </a:rPr>
-              <a:t>$ esbmc offbyone.c --unwind 7</a:t>
-            </a:r>
-          </a:p>
-          <a:p>
-            <a:pPr>
-              <a:spcAft>
                 <a:spcPts val="800"/>
               </a:spcAft>
             </a:pPr>
@@ -9844,7 +10016,7 @@
                   <a:srgbClr val="212121"/>
                 </a:solidFill>
               </a:rPr>
-              <a:t/>
+              <a:t>Read it bottom-up: first what was violated, then scroll up for the values that caused it.</a:t>
             </a:r>
           </a:p>
           <a:p>
@@ -9859,22 +10031,7 @@
                   <a:srgbClr val="212121"/>
                 </a:solidFill>
               </a:rPr>
-              <a:t>Predict first: FAILED or SUCCESSFUL? If FAILED — at which i?</a:t>
-            </a:r>
-          </a:p>
-          <a:p>
-            <a:pPr>
-              <a:spcAft>
-                <a:spcPts val="800"/>
-              </a:spcAft>
-            </a:pPr>
-            <a:r>
-              <a:rPr sz="2200">
-                <a:solidFill>
-                  <a:srgbClr val="212121"/>
-                </a:solidFill>
-              </a:rPr>
-              <a:t>Then we read the trace together, bottom-up.</a:t>
+              <a:t>Those values are a ready-made failing test case — keep them.</a:t>
             </a:r>
           </a:p>
         </p:txBody>
@@ -9925,7 +10082,7 @@
                   <a:srgbClr val="5A0A7A"/>
                 </a:solidFill>
               </a:rPr>
-              <a:t>Modelling the environment: a preview</a:t>
+              <a:t>Live: the whole pipeline on five lines</a:t>
             </a:r>
           </a:p>
         </p:txBody>
@@ -9964,7 +10121,7 @@
                 </a:solidFill>
                 <a:latin typeface="Courier New"/>
               </a:rPr>
-              <a:t>int x = nondet_int();              /* every value at once */</a:t>
+              <a:t>int main(void)</a:t>
             </a:r>
           </a:p>
           <a:p>
@@ -9980,7 +10137,7 @@
                 </a:solidFill>
                 <a:latin typeface="Courier New"/>
               </a:rPr>
-              <a:t>__ESBMC_assume(x &gt; 0 &amp;&amp; x &lt; 100);  /* now: every value in 1..99 */</a:t>
+              <a:t>{</a:t>
             </a:r>
           </a:p>
           <a:p>
@@ -9996,7 +10153,87 @@
                 </a:solidFill>
                 <a:latin typeface="Courier New"/>
               </a:rPr>
-              <a:t>assert(property(x));               /* must hold for ALL of them */</a:t>
+              <a:t>  int a[5];</a:t>
+            </a:r>
+          </a:p>
+          <a:p>
+            <a:pPr>
+              <a:spcAft>
+                <a:spcPts val="0"/>
+              </a:spcAft>
+            </a:pPr>
+            <a:r>
+              <a:rPr sz="1800">
+                <a:solidFill>
+                  <a:srgbClr val="212121"/>
+                </a:solidFill>
+                <a:latin typeface="Courier New"/>
+              </a:rPr>
+              <a:t>  for (int i = 0; i &lt;= 5; i++)</a:t>
+            </a:r>
+          </a:p>
+          <a:p>
+            <a:pPr>
+              <a:spcAft>
+                <a:spcPts val="0"/>
+              </a:spcAft>
+            </a:pPr>
+            <a:r>
+              <a:rPr sz="1800">
+                <a:solidFill>
+                  <a:srgbClr val="212121"/>
+                </a:solidFill>
+                <a:latin typeface="Courier New"/>
+              </a:rPr>
+              <a:t>    a[i] = i;</a:t>
+            </a:r>
+          </a:p>
+          <a:p>
+            <a:pPr>
+              <a:spcAft>
+                <a:spcPts val="0"/>
+              </a:spcAft>
+            </a:pPr>
+            <a:r>
+              <a:rPr sz="1800">
+                <a:solidFill>
+                  <a:srgbClr val="212121"/>
+                </a:solidFill>
+                <a:latin typeface="Courier New"/>
+              </a:rPr>
+              <a:t>}</a:t>
+            </a:r>
+          </a:p>
+          <a:p>
+            <a:pPr>
+              <a:spcAft>
+                <a:spcPts val="0"/>
+              </a:spcAft>
+            </a:pPr>
+            <a:r>
+              <a:rPr sz="1800">
+                <a:solidFill>
+                  <a:srgbClr val="212121"/>
+                </a:solidFill>
+                <a:latin typeface="Courier New"/>
+              </a:rPr>
+              <a:t/>
+            </a:r>
+          </a:p>
+          <a:p>
+            <a:pPr>
+              <a:spcAft>
+                <a:spcPts val="0"/>
+              </a:spcAft>
+            </a:pPr>
+            <a:r>
+              <a:rPr sz="1800">
+                <a:solidFill>
+                  <a:srgbClr val="212121"/>
+                </a:solidFill>
+                <a:latin typeface="Courier New"/>
+              </a:rPr>
+              <a:t>$ esbmc offbyone.c --unwind 7</a:t>
             </a:r>
           </a:p>
           <a:p>
@@ -10026,7 +10263,7 @@
                   <a:srgbClr val="212121"/>
                 </a:solidFill>
               </a:rPr>
-              <a:t>One nondeterministic input = all tests of that input at once.</a:t>
+              <a:t>Predict first: FAILED or SUCCESSFUL? If FAILED — at which i?</a:t>
             </a:r>
           </a:p>
           <a:p>
@@ -10041,7 +10278,7 @@
                   <a:srgbClr val="212121"/>
                 </a:solidFill>
               </a:rPr>
-              <a:t>In Session 2 you will use these three lines to expose a bug in a program that verifies green as shipped — the tool only checks what you specify.</a:t>
+              <a:t>Then we read the trace together, bottom-up.</a:t>
             </a:r>
           </a:p>
         </p:txBody>
@@ -10092,7 +10329,7 @@
                   <a:srgbClr val="5A0A7A"/>
                 </a:solidFill>
               </a:rPr>
-              <a:t>Beyond one thread</a:t>
+              <a:t>Modelling the environment: a preview</a:t>
             </a:r>
           </a:p>
         </p:txBody>
@@ -10105,8 +10342,8 @@
         </p:nvSpPr>
         <p:spPr>
           <a:xfrm>
-            <a:off x="731520" y="1645920"/>
-            <a:ext cx="10789920" cy="4937760"/>
+            <a:off x="731520" y="1463040"/>
+            <a:ext cx="10789920" cy="5120640"/>
           </a:xfrm>
           <a:prstGeom prst="rect">
             <a:avLst/>
@@ -10121,56 +10358,59 @@
           <a:p>
             <a:pPr>
               <a:spcAft>
-                <a:spcPts val="800"/>
-              </a:spcAft>
-            </a:pPr>
-            <a:r>
-              <a:rPr sz="2400">
-                <a:solidFill>
-                  <a:srgbClr val="212121"/>
-                </a:solidFill>
-              </a:rPr>
-              <a:t>Two threads of two and one statements already have three interleavings. Real code has billions.</a:t>
-            </a:r>
-          </a:p>
-          <a:p>
-            <a:pPr>
-              <a:spcAft>
-                <a:spcPts val="800"/>
-              </a:spcAft>
-            </a:pPr>
-            <a:r>
-              <a:rPr sz="2400">
-                <a:solidFill>
-                  <a:srgbClr val="212121"/>
-                </a:solidFill>
-              </a:rPr>
-              <a:t>Run the program a million times and the bad interleaving may never show up — Therac-25's bug hid exactly this way.</a:t>
-            </a:r>
-          </a:p>
-          <a:p>
-            <a:pPr>
-              <a:spcAft>
-                <a:spcPts val="800"/>
-              </a:spcAft>
-            </a:pPr>
-            <a:r>
-              <a:rPr sz="2400">
-                <a:solidFill>
-                  <a:srgbClr val="212121"/>
-                </a:solidFill>
-              </a:rPr>
-              <a:t>A model checker enumerates every interleaving up to a bound, including the one that kills your assertion.</a:t>
-            </a:r>
-          </a:p>
-          <a:p>
-            <a:pPr>
-              <a:spcAft>
-                <a:spcPts val="800"/>
-              </a:spcAft>
-            </a:pPr>
-            <a:r>
-              <a:rPr sz="2400">
+                <a:spcPts val="0"/>
+              </a:spcAft>
+            </a:pPr>
+            <a:r>
+              <a:rPr sz="1800">
+                <a:solidFill>
+                  <a:srgbClr val="212121"/>
+                </a:solidFill>
+                <a:latin typeface="Courier New"/>
+              </a:rPr>
+              <a:t>int x = nondet_int();              /* every value at once */</a:t>
+            </a:r>
+          </a:p>
+          <a:p>
+            <a:pPr>
+              <a:spcAft>
+                <a:spcPts val="0"/>
+              </a:spcAft>
+            </a:pPr>
+            <a:r>
+              <a:rPr sz="1800">
+                <a:solidFill>
+                  <a:srgbClr val="212121"/>
+                </a:solidFill>
+                <a:latin typeface="Courier New"/>
+              </a:rPr>
+              <a:t>__ESBMC_assume(x &gt; 0 &amp;&amp; x &lt; 100);  /* now: every value in 1..99 */</a:t>
+            </a:r>
+          </a:p>
+          <a:p>
+            <a:pPr>
+              <a:spcAft>
+                <a:spcPts val="0"/>
+              </a:spcAft>
+            </a:pPr>
+            <a:r>
+              <a:rPr sz="1800">
+                <a:solidFill>
+                  <a:srgbClr val="212121"/>
+                </a:solidFill>
+                <a:latin typeface="Courier New"/>
+              </a:rPr>
+              <a:t>assert(property(x));               /* must hold for ALL of them */</a:t>
+            </a:r>
+          </a:p>
+          <a:p>
+            <a:pPr>
+              <a:spcAft>
+                <a:spcPts val="800"/>
+              </a:spcAft>
+            </a:pPr>
+            <a:r>
+              <a:rPr sz="2200">
                 <a:solidFill>
                   <a:srgbClr val="212121"/>
                 </a:solidFill>
@@ -10185,12 +10425,27 @@
               </a:spcAft>
             </a:pPr>
             <a:r>
-              <a:rPr sz="2400">
-                <a:solidFill>
-                  <a:srgbClr val="212121"/>
-                </a:solidFill>
-              </a:rPr>
-              <a:t>Session 2, Lab 4: you write down the killer interleaving before the tool finds it.</a:t>
+              <a:rPr sz="2200">
+                <a:solidFill>
+                  <a:srgbClr val="212121"/>
+                </a:solidFill>
+              </a:rPr>
+              <a:t>One nondeterministic input = all tests of that input at once.</a:t>
+            </a:r>
+          </a:p>
+          <a:p>
+            <a:pPr>
+              <a:spcAft>
+                <a:spcPts val="800"/>
+              </a:spcAft>
+            </a:pPr>
+            <a:r>
+              <a:rPr sz="2200">
+                <a:solidFill>
+                  <a:srgbClr val="212121"/>
+                </a:solidFill>
+              </a:rPr>
+              <a:t>In Session 2 you will use these three lines to expose a bug in a program that verifies green as shipped — the tool only checks what you specify.</a:t>
             </a:r>
           </a:p>
         </p:txBody>
@@ -10435,7 +10690,7 @@
                   <a:srgbClr val="5A0A7A"/>
                 </a:solidFill>
               </a:rPr>
-              <a:t>Homework for your intuition</a:t>
+              <a:t>Beyond one thread</a:t>
             </a:r>
           </a:p>
         </p:txBody>
@@ -10448,8 +10703,8 @@
         </p:nvSpPr>
         <p:spPr>
           <a:xfrm>
-            <a:off x="731520" y="1828800"/>
-            <a:ext cx="10789920" cy="4754880"/>
+            <a:off x="731520" y="1645920"/>
+            <a:ext cx="10789920" cy="4937760"/>
           </a:xfrm>
           <a:prstGeom prst="rect">
             <a:avLst/>
@@ -10464,43 +10719,56 @@
           <a:p>
             <a:pPr>
               <a:spcAft>
-                <a:spcPts val="0"/>
-              </a:spcAft>
-            </a:pPr>
-            <a:r>
-              <a:rPr sz="2200">
-                <a:solidFill>
-                  <a:srgbClr val="212121"/>
-                </a:solidFill>
-                <a:latin typeface="Courier New"/>
-              </a:rPr>
-              <a:t>double w = 0.1 + 0.2;</a:t>
-            </a:r>
-          </a:p>
-          <a:p>
-            <a:pPr>
-              <a:spcAft>
-                <a:spcPts val="0"/>
-              </a:spcAft>
-            </a:pPr>
-            <a:r>
-              <a:rPr sz="2200">
-                <a:solidFill>
-                  <a:srgbClr val="212121"/>
-                </a:solidFill>
-                <a:latin typeface="Courier New"/>
-              </a:rPr>
-              <a:t>assert(w == 0.3);</a:t>
-            </a:r>
-          </a:p>
-          <a:p>
-            <a:pPr>
-              <a:spcAft>
-                <a:spcPts val="800"/>
-              </a:spcAft>
-            </a:pPr>
-            <a:r>
-              <a:rPr sz="2600">
+                <a:spcPts val="800"/>
+              </a:spcAft>
+            </a:pPr>
+            <a:r>
+              <a:rPr sz="2400">
+                <a:solidFill>
+                  <a:srgbClr val="212121"/>
+                </a:solidFill>
+              </a:rPr>
+              <a:t>Two threads of two and one statements already have three interleavings. Real code has billions.</a:t>
+            </a:r>
+          </a:p>
+          <a:p>
+            <a:pPr>
+              <a:spcAft>
+                <a:spcPts val="800"/>
+              </a:spcAft>
+            </a:pPr>
+            <a:r>
+              <a:rPr sz="2400">
+                <a:solidFill>
+                  <a:srgbClr val="212121"/>
+                </a:solidFill>
+              </a:rPr>
+              <a:t>Run the program a million times and the bad interleaving may never show up — Therac-25's bug hid exactly this way.</a:t>
+            </a:r>
+          </a:p>
+          <a:p>
+            <a:pPr>
+              <a:spcAft>
+                <a:spcPts val="800"/>
+              </a:spcAft>
+            </a:pPr>
+            <a:r>
+              <a:rPr sz="2400">
+                <a:solidFill>
+                  <a:srgbClr val="212121"/>
+                </a:solidFill>
+              </a:rPr>
+              <a:t>A model checker enumerates every interleaving up to a bound, including the one that kills your assertion.</a:t>
+            </a:r>
+          </a:p>
+          <a:p>
+            <a:pPr>
+              <a:spcAft>
+                <a:spcPts val="800"/>
+              </a:spcAft>
+            </a:pPr>
+            <a:r>
+              <a:rPr sz="2400">
                 <a:solidFill>
                   <a:srgbClr val="212121"/>
                 </a:solidFill>
@@ -10515,57 +10783,12 @@
               </a:spcAft>
             </a:pPr>
             <a:r>
-              <a:rPr sz="2600">
-                <a:solidFill>
-                  <a:srgbClr val="212121"/>
-                </a:solidFill>
-              </a:rPr>
-              <a:t>FAILED or SUCCESSFUL?</a:t>
-            </a:r>
-          </a:p>
-          <a:p>
-            <a:pPr>
-              <a:spcAft>
-                <a:spcPts val="800"/>
-              </a:spcAft>
-            </a:pPr>
-            <a:r>
-              <a:rPr sz="2600">
-                <a:solidFill>
-                  <a:srgbClr val="212121"/>
-                </a:solidFill>
-              </a:rPr>
-              <a:t/>
-            </a:r>
-          </a:p>
-          <a:p>
-            <a:pPr>
-              <a:spcAft>
-                <a:spcPts val="800"/>
-              </a:spcAft>
-            </a:pPr>
-            <a:r>
-              <a:rPr sz="2600">
-                <a:solidFill>
-                  <a:srgbClr val="212121"/>
-                </a:solidFill>
-              </a:rPr>
-              <a:t>Bring your answer to Session 2 — Lab 4 settles it with a solver that does exact IEEE-754 arithmetic.</a:t>
-            </a:r>
-          </a:p>
-          <a:p>
-            <a:pPr lvl="1">
-              <a:spcAft>
-                <a:spcPts val="800"/>
-              </a:spcAft>
-            </a:pPr>
-            <a:r>
               <a:rPr sz="2400">
                 <a:solidFill>
                   <a:srgbClr val="212121"/>
                 </a:solidFill>
               </a:rPr>
-              <a:t>Hint: 0.1 in binary is like 1/3 in decimal.</a:t>
+              <a:t>Session 2, Lab 4: you write down the killer interleaving before the tool finds it.</a:t>
             </a:r>
           </a:p>
         </p:txBody>
@@ -10616,7 +10839,7 @@
                   <a:srgbClr val="5A0A7A"/>
                 </a:solidFill>
               </a:rPr>
-              <a:t>Exercise 2 — Predict the Verdict (15 min)</a:t>
+              <a:t>Homework for your intuition</a:t>
             </a:r>
           </a:p>
         </p:txBody>
@@ -10629,8 +10852,8 @@
         </p:nvSpPr>
         <p:spPr>
           <a:xfrm>
-            <a:off x="731520" y="1463040"/>
-            <a:ext cx="10789920" cy="5120640"/>
+            <a:off x="731520" y="1828800"/>
+            <a:ext cx="10789920" cy="4754880"/>
           </a:xfrm>
           <a:prstGeom prst="rect">
             <a:avLst/>
@@ -10645,7 +10868,7 @@
           <a:p>
             <a:pPr>
               <a:spcAft>
-                <a:spcPts val="800"/>
+                <a:spcPts val="0"/>
               </a:spcAft>
             </a:pPr>
             <a:r>
@@ -10653,14 +10876,15 @@
                 <a:solidFill>
                   <a:srgbClr val="212121"/>
                 </a:solidFill>
-              </a:rPr>
-              <a:t>Groups of 3–4. Three short C programs on the handout (predict1.c, predict2.c, predict3.c).</a:t>
-            </a:r>
-          </a:p>
-          <a:p>
-            <a:pPr>
-              <a:spcAft>
-                <a:spcPts val="800"/>
+                <a:latin typeface="Courier New"/>
+              </a:rPr>
+              <a:t>double w = 0.1 + 0.2;</a:t>
+            </a:r>
+          </a:p>
+          <a:p>
+            <a:pPr>
+              <a:spcAft>
+                <a:spcPts val="0"/>
               </a:spcAft>
             </a:pPr>
             <a:r>
@@ -10668,8 +10892,69 @@
                 <a:solidFill>
                   <a:srgbClr val="212121"/>
                 </a:solidFill>
-              </a:rPr>
-              <a:t>For each program, write down BEFORE we run anything:</a:t>
+                <a:latin typeface="Courier New"/>
+              </a:rPr>
+              <a:t>assert(w == 0.3);</a:t>
+            </a:r>
+          </a:p>
+          <a:p>
+            <a:pPr>
+              <a:spcAft>
+                <a:spcPts val="800"/>
+              </a:spcAft>
+            </a:pPr>
+            <a:r>
+              <a:rPr sz="2600">
+                <a:solidFill>
+                  <a:srgbClr val="212121"/>
+                </a:solidFill>
+              </a:rPr>
+              <a:t/>
+            </a:r>
+          </a:p>
+          <a:p>
+            <a:pPr>
+              <a:spcAft>
+                <a:spcPts val="800"/>
+              </a:spcAft>
+            </a:pPr>
+            <a:r>
+              <a:rPr sz="2600">
+                <a:solidFill>
+                  <a:srgbClr val="212121"/>
+                </a:solidFill>
+              </a:rPr>
+              <a:t>FAILED or SUCCESSFUL?</a:t>
+            </a:r>
+          </a:p>
+          <a:p>
+            <a:pPr>
+              <a:spcAft>
+                <a:spcPts val="800"/>
+              </a:spcAft>
+            </a:pPr>
+            <a:r>
+              <a:rPr sz="2600">
+                <a:solidFill>
+                  <a:srgbClr val="212121"/>
+                </a:solidFill>
+              </a:rPr>
+              <a:t/>
+            </a:r>
+          </a:p>
+          <a:p>
+            <a:pPr>
+              <a:spcAft>
+                <a:spcPts val="800"/>
+              </a:spcAft>
+            </a:pPr>
+            <a:r>
+              <a:rPr sz="2600">
+                <a:solidFill>
+                  <a:srgbClr val="212121"/>
+                </a:solidFill>
+              </a:rPr>
+              <a:t>Bring your answer to Session 2 — Lab 4 settles it with a solver that does exact IEEE-754 arithmetic.</a:t>
             </a:r>
           </a:p>
           <a:p>
@@ -10679,42 +10964,12 @@
               </a:spcAft>
             </a:pPr>
             <a:r>
-              <a:rPr sz="2000">
-                <a:solidFill>
-                  <a:srgbClr val="212121"/>
-                </a:solidFill>
-              </a:rPr>
-              <a:t>Will the model checker say VERIFICATION FAILED or SUCCESSFUL?</a:t>
-            </a:r>
-          </a:p>
-          <a:p>
-            <a:pPr lvl="1">
-              <a:spcAft>
-                <a:spcPts val="800"/>
-              </a:spcAft>
-            </a:pPr>
-            <a:r>
-              <a:rPr sz="2000">
-                <a:solidFill>
-                  <a:srgbClr val="212121"/>
-                </a:solidFill>
-              </a:rPr>
-              <a:t>If FAILED — which line is the culprit?</a:t>
-            </a:r>
-          </a:p>
-          <a:p>
-            <a:pPr>
-              <a:spcAft>
-                <a:spcPts val="800"/>
-              </a:spcAft>
-            </a:pPr>
-            <a:r>
-              <a:rPr sz="2200">
-                <a:solidFill>
-                  <a:srgbClr val="212121"/>
-                </a:solidFill>
-              </a:rPr>
-              <a:t>Then we run ESBMC live and settle every bet.</a:t>
+              <a:rPr sz="2400">
+                <a:solidFill>
+                  <a:srgbClr val="212121"/>
+                </a:solidFill>
+              </a:rPr>
+              <a:t>Hint: 0.1 in binary is like 1/3 in decimal.</a:t>
             </a:r>
           </a:p>
         </p:txBody>
@@ -10765,7 +11020,7 @@
                   <a:srgbClr val="5A0A7A"/>
                 </a:solidFill>
               </a:rPr>
-              <a:t>Who uses this? — Model checking</a:t>
+              <a:t>Exercise 2 — Predict the Verdict (15 min)</a:t>
             </a:r>
           </a:p>
         </p:txBody>
@@ -10803,7 +11058,7 @@
                   <a:srgbClr val="212121"/>
                 </a:solidFill>
               </a:rPr>
-              <a:t>Amazon Web Services — CBMC proves memory safety of the TLS library s2n; bounded proofs run in CI on every commit</a:t>
+              <a:t>Groups of 3–4. Three short C programs on the handout (predict1.c, predict2.c, predict3.c).</a:t>
             </a:r>
           </a:p>
           <a:p>
@@ -10818,7 +11073,37 @@
                   <a:srgbClr val="212121"/>
                 </a:solidFill>
               </a:rPr>
-              <a:t>ESBMC / CBMC — the tools from tonight's demos; compete yearly in SV-COMP on tens of thousands of benchmarks</a:t>
+              <a:t>For each program, write down BEFORE we run anything:</a:t>
+            </a:r>
+          </a:p>
+          <a:p>
+            <a:pPr lvl="1">
+              <a:spcAft>
+                <a:spcPts val="800"/>
+              </a:spcAft>
+            </a:pPr>
+            <a:r>
+              <a:rPr sz="2000">
+                <a:solidFill>
+                  <a:srgbClr val="212121"/>
+                </a:solidFill>
+              </a:rPr>
+              <a:t>Will the model checker say VERIFICATION FAILED or SUCCESSFUL?</a:t>
+            </a:r>
+          </a:p>
+          <a:p>
+            <a:pPr lvl="1">
+              <a:spcAft>
+                <a:spcPts val="800"/>
+              </a:spcAft>
+            </a:pPr>
+            <a:r>
+              <a:rPr sz="2000">
+                <a:solidFill>
+                  <a:srgbClr val="212121"/>
+                </a:solidFill>
+              </a:rPr>
+              <a:t>If FAILED — which line is the culprit?</a:t>
             </a:r>
           </a:p>
           <a:p>
@@ -10833,7 +11118,7 @@
                   <a:srgbClr val="212121"/>
                 </a:solidFill>
               </a:rPr>
-              <a:t>The counterexample you saw for getpassword.c is the same artefact AWS engineers read when a proof fails</a:t>
+              <a:t>Then we run ESBMC live and settle every bet.</a:t>
             </a:r>
           </a:p>
         </p:txBody>
@@ -10884,7 +11169,7 @@
                   <a:srgbClr val="5A0A7A"/>
                 </a:solidFill>
               </a:rPr>
-              <a:t>Who uses this? — Symbolic execution &amp; fuzzing</a:t>
+              <a:t>Who uses this? — Model checking</a:t>
             </a:r>
           </a:p>
         </p:txBody>
@@ -10922,7 +11207,7 @@
                   <a:srgbClr val="212121"/>
                 </a:solidFill>
               </a:rPr>
-              <a:t>KLEE found 56 serious bugs in coreutils, busybox and Minix — including three in coreutils that had survived 15 years of testing</a:t>
+              <a:t>Amazon Web Services — CBMC proves memory safety of the TLS library s2n; bounded proofs run in CI on every commit</a:t>
             </a:r>
           </a:p>
           <a:p>
@@ -10937,7 +11222,7 @@
                   <a:srgbClr val="212121"/>
                 </a:solidFill>
               </a:rPr>
-              <a:t>Microsoft SAGE fuzzed Windows file parsers with symbolic execution; it found ~1/3 of all bugs caught by file fuzzing during Windows 7 development — running last, after every other tool</a:t>
+              <a:t>ESBMC / CBMC — the tools from tonight's demos; compete yearly in SV-COMP on tens of thousands of benchmarks</a:t>
             </a:r>
           </a:p>
           <a:p>
@@ -10952,22 +11237,7 @@
                   <a:srgbClr val="212121"/>
                 </a:solidFill>
               </a:rPr>
-              <a:t>AFL / OSS-Fuzz — Google fuzzes ~1,000 open-source projects continuously; tens of thousands of bugs found</a:t>
-            </a:r>
-          </a:p>
-          <a:p>
-            <a:pPr>
-              <a:spcAft>
-                <a:spcPts val="800"/>
-              </a:spcAft>
-            </a:pPr>
-            <a:r>
-              <a:rPr sz="2200">
-                <a:solidFill>
-                  <a:srgbClr val="212121"/>
-                </a:solidFill>
-              </a:rPr>
-              <a:t>The pragmatic cousin of verification: no proofs, ruthless effectiveness</a:t>
+              <a:t>The counterexample you saw for getpassword.c is the same artefact AWS engineers read when a proof fails</a:t>
             </a:r>
           </a:p>
         </p:txBody>
@@ -11018,7 +11288,7 @@
                   <a:srgbClr val="5A0A7A"/>
                 </a:solidFill>
               </a:rPr>
-              <a:t>Who uses this? — Proofs all the way up</a:t>
+              <a:t>Who uses this? — Symbolic execution &amp; fuzzing</a:t>
             </a:r>
           </a:p>
         </p:txBody>
@@ -11056,7 +11326,7 @@
                   <a:srgbClr val="212121"/>
                 </a:solidFill>
               </a:rPr>
-              <a:t>Astrée (abstract interpretation) proved absence of runtime errors in the Airbus A340 fly-by-wire code — 132,000 lines of C — and was then applied to the A380</a:t>
+              <a:t>KLEE found 56 serious bugs in coreutils, busybox and Minix — including three in coreutils that had survived 15 years of testing</a:t>
             </a:r>
           </a:p>
           <a:p>
@@ -11071,7 +11341,7 @@
                   <a:srgbClr val="212121"/>
                 </a:solidFill>
               </a:rPr>
-              <a:t>seL4 — an OS microkernel with a machine-checked proof of functional correctness</a:t>
+              <a:t>Microsoft SAGE fuzzed Windows file parsers with symbolic execution; it found ~1/3 of all bugs caught by file fuzzing during Windows 7 development — running last, after every other tool</a:t>
             </a:r>
           </a:p>
           <a:p>
@@ -11086,7 +11356,22 @@
                   <a:srgbClr val="212121"/>
                 </a:solidFill>
               </a:rPr>
-              <a:t>CompCert — a C compiler with a proof that compilation preserves semantics; six CPU-years of fuzzing found no wrong-code bugs in its verified core, while every other compiler tested failed</a:t>
+              <a:t>AFL / OSS-Fuzz — Google fuzzes ~1,000 open-source projects continuously; tens of thousands of bugs found</a:t>
+            </a:r>
+          </a:p>
+          <a:p>
+            <a:pPr>
+              <a:spcAft>
+                <a:spcPts val="800"/>
+              </a:spcAft>
+            </a:pPr>
+            <a:r>
+              <a:rPr sz="2200">
+                <a:solidFill>
+                  <a:srgbClr val="212121"/>
+                </a:solidFill>
+              </a:rPr>
+              <a:t>The pragmatic cousin of verification: no proofs, ruthless effectiveness</a:t>
             </a:r>
           </a:p>
         </p:txBody>
@@ -11137,7 +11422,7 @@
                   <a:srgbClr val="5A0A7A"/>
                 </a:solidFill>
               </a:rPr>
-              <a:t>Discussion</a:t>
+              <a:t>Who uses this? — Proofs all the way up</a:t>
             </a:r>
           </a:p>
         </p:txBody>
@@ -11150,8 +11435,8 @@
         </p:nvSpPr>
         <p:spPr>
           <a:xfrm>
-            <a:off x="731520" y="2194560"/>
-            <a:ext cx="10789920" cy="4389120"/>
+            <a:off x="731520" y="1463040"/>
+            <a:ext cx="10789920" cy="5120640"/>
           </a:xfrm>
           <a:prstGeom prst="rect">
             <a:avLst/>
@@ -11170,42 +11455,42 @@
               </a:spcAft>
             </a:pPr>
             <a:r>
-              <a:rPr sz="2800">
-                <a:solidFill>
-                  <a:srgbClr val="212121"/>
-                </a:solidFill>
-              </a:rPr>
-              <a:t>If verification can prove the absence of bugs…</a:t>
-            </a:r>
-          </a:p>
-          <a:p>
-            <a:pPr>
-              <a:spcAft>
-                <a:spcPts val="800"/>
-              </a:spcAft>
-            </a:pPr>
-            <a:r>
-              <a:rPr sz="2800">
-                <a:solidFill>
-                  <a:srgbClr val="212121"/>
-                </a:solidFill>
-              </a:rPr>
-              <a:t>why isn't all software verified?</a:t>
-            </a:r>
-          </a:p>
-          <a:p>
-            <a:pPr>
-              <a:spcAft>
-                <a:spcPts val="800"/>
-              </a:spcAft>
-            </a:pPr>
-            <a:r>
-              <a:rPr sz="2800">
-                <a:solidFill>
-                  <a:srgbClr val="212121"/>
-                </a:solidFill>
-              </a:rPr>
-              <a:t>(Let's collect reasons — then I'll tell you which ones the industry actually cites.)</a:t>
+              <a:rPr sz="2200">
+                <a:solidFill>
+                  <a:srgbClr val="212121"/>
+                </a:solidFill>
+              </a:rPr>
+              <a:t>Astrée (abstract interpretation) proved absence of runtime errors in the Airbus A340 fly-by-wire code — 132,000 lines of C — and was then applied to the A380</a:t>
+            </a:r>
+          </a:p>
+          <a:p>
+            <a:pPr>
+              <a:spcAft>
+                <a:spcPts val="800"/>
+              </a:spcAft>
+            </a:pPr>
+            <a:r>
+              <a:rPr sz="2200">
+                <a:solidFill>
+                  <a:srgbClr val="212121"/>
+                </a:solidFill>
+              </a:rPr>
+              <a:t>seL4 — an OS microkernel with a machine-checked proof of functional correctness</a:t>
+            </a:r>
+          </a:p>
+          <a:p>
+            <a:pPr>
+              <a:spcAft>
+                <a:spcPts val="800"/>
+              </a:spcAft>
+            </a:pPr>
+            <a:r>
+              <a:rPr sz="2200">
+                <a:solidFill>
+                  <a:srgbClr val="212121"/>
+                </a:solidFill>
+              </a:rPr>
+              <a:t>CompCert — a C compiler with a proof that compilation preserves semantics; six CPU-years of fuzzing found no wrong-code bugs in its verified core, while every other compiler tested failed</a:t>
             </a:r>
           </a:p>
         </p:txBody>
@@ -11256,6 +11541,125 @@
                   <a:srgbClr val="5A0A7A"/>
                 </a:solidFill>
               </a:rPr>
+              <a:t>Discussion</a:t>
+            </a:r>
+          </a:p>
+        </p:txBody>
+      </p:sp>
+      <p:sp>
+        <p:nvSpPr>
+          <p:cNvPr id="3" name="TextBox 2"/>
+          <p:cNvSpPr txBox="1"/>
+          <p:nvPr/>
+        </p:nvSpPr>
+        <p:spPr>
+          <a:xfrm>
+            <a:off x="731520" y="2194560"/>
+            <a:ext cx="10789920" cy="4389120"/>
+          </a:xfrm>
+          <a:prstGeom prst="rect">
+            <a:avLst/>
+          </a:prstGeom>
+          <a:noFill/>
+        </p:spPr>
+        <p:txBody>
+          <a:bodyPr wrap="square">
+            <a:spAutoFit/>
+          </a:bodyPr>
+          <a:lstStyle/>
+          <a:p>
+            <a:pPr>
+              <a:spcAft>
+                <a:spcPts val="800"/>
+              </a:spcAft>
+            </a:pPr>
+            <a:r>
+              <a:rPr sz="2800">
+                <a:solidFill>
+                  <a:srgbClr val="212121"/>
+                </a:solidFill>
+              </a:rPr>
+              <a:t>If verification can prove the absence of bugs…</a:t>
+            </a:r>
+          </a:p>
+          <a:p>
+            <a:pPr>
+              <a:spcAft>
+                <a:spcPts val="800"/>
+              </a:spcAft>
+            </a:pPr>
+            <a:r>
+              <a:rPr sz="2800">
+                <a:solidFill>
+                  <a:srgbClr val="212121"/>
+                </a:solidFill>
+              </a:rPr>
+              <a:t>why isn't all software verified?</a:t>
+            </a:r>
+          </a:p>
+          <a:p>
+            <a:pPr>
+              <a:spcAft>
+                <a:spcPts val="800"/>
+              </a:spcAft>
+            </a:pPr>
+            <a:r>
+              <a:rPr sz="2800">
+                <a:solidFill>
+                  <a:srgbClr val="212121"/>
+                </a:solidFill>
+              </a:rPr>
+              <a:t>(Let's collect reasons — then I'll tell you which ones the industry actually cites.)</a:t>
+            </a:r>
+          </a:p>
+        </p:txBody>
+      </p:sp>
+    </p:spTree>
+  </p:cSld>
+  <p:clrMapOvr>
+    <a:masterClrMapping/>
+  </p:clrMapOvr>
+</p:sld>
+</file>
+
+<file path=ppt/slides/slide47.xml><?xml version="1.0" encoding="utf-8"?>
+<p:sld xmlns:a="http://schemas.openxmlformats.org/drawingml/2006/main" xmlns:p="http://schemas.openxmlformats.org/presentationml/2006/main" xmlns:r="http://schemas.openxmlformats.org/officeDocument/2006/relationships">
+  <p:cSld>
+    <p:spTree>
+      <p:nvGrpSpPr>
+        <p:cNvPr id="1" name=""/>
+        <p:cNvGrpSpPr/>
+        <p:nvPr/>
+      </p:nvGrpSpPr>
+      <p:grpSpPr/>
+      <p:sp>
+        <p:nvSpPr>
+          <p:cNvPr id="2" name="TextBox 1"/>
+          <p:cNvSpPr txBox="1"/>
+          <p:nvPr/>
+        </p:nvSpPr>
+        <p:spPr>
+          <a:xfrm>
+            <a:off x="548640" y="365760"/>
+            <a:ext cx="11064240" cy="1005840"/>
+          </a:xfrm>
+          <a:prstGeom prst="rect">
+            <a:avLst/>
+          </a:prstGeom>
+          <a:noFill/>
+        </p:spPr>
+        <p:txBody>
+          <a:bodyPr wrap="square">
+            <a:spAutoFit/>
+          </a:bodyPr>
+          <a:lstStyle/>
+          <a:p>
+            <a:r>
+              <a:rPr sz="3600" b="1">
+                <a:solidFill>
+                  <a:srgbClr val="5A0A7A"/>
+                </a:solidFill>
+              </a:rPr>
               <a:t>Closing quiz</a:t>
             </a:r>
           </a:p>
@@ -11367,7 +11771,7 @@
 </p:sld>
 </file>
 
-<file path=ppt/slides/slide47.xml><?xml version="1.0" encoding="utf-8"?>
+<file path=ppt/slides/slide48.xml><?xml version="1.0" encoding="utf-8"?>
 <p:sld xmlns:a="http://schemas.openxmlformats.org/drawingml/2006/main" xmlns:p="http://schemas.openxmlformats.org/presentationml/2006/main" xmlns:r="http://schemas.openxmlformats.org/officeDocument/2006/relationships">
   <p:cSld>
     <p:spTree>

</xml_diff>

<commit_message>
Reconcile testing placement and fold k-induction into the grid
Move 'testing' to the Unsound x Complete cell (failures are real → complete),
matching the soundness slide's 'testing is complete but not sound'; leave code
review in Incomplete. Extend the asterisk footnote so k-induction is what lifts
BMC into the Sound row — an unbounded proof when the induction converges,
foreshadowing the Session 2 k-induction deck.
</commit_message>
<xml_diff>
--- a/slides/session1/01-session1-fundamentals.pptx
+++ b/slides/session1/01-session1-fundamentals.pptx
@@ -6283,7 +6283,7 @@
                     <a:p>
                       <a:r>
                         <a:rPr sz="2000"/>
-                        <a:t>bounded model checking*</a:t>
+                        <a:t>bounded model checking*, testing</a:t>
                       </a:r>
                     </a:p>
                   </a:txBody>
@@ -6296,7 +6296,7 @@
                     <a:p>
                       <a:r>
                         <a:rPr sz="2000"/>
-                        <a:t>testing, code review</a:t>
+                        <a:t>code review</a:t>
                       </a:r>
                     </a:p>
                   </a:txBody>
@@ -6335,22 +6335,22 @@
               </a:spcAft>
             </a:pPr>
             <a:r>
-              <a:rPr sz="2200">
-                <a:solidFill>
-                  <a:srgbClr val="212121"/>
-                </a:solidFill>
-              </a:rPr>
-              <a:t>* sound up to its bound — tonight's central fine print</a:t>
-            </a:r>
-          </a:p>
-          <a:p>
-            <a:pPr>
-              <a:spcAft>
-                <a:spcPts val="800"/>
-              </a:spcAft>
-            </a:pPr>
-            <a:r>
-              <a:rPr sz="2200">
+              <a:rPr sz="2000">
+                <a:solidFill>
+                  <a:srgbClr val="212121"/>
+                </a:solidFill>
+              </a:rPr>
+              <a:t>* sound only up to its bound. k-induction removes it: prove the inductive step — not just unwind to depth k — and BMC climbs into the Sound row (an unbounded proof when the induction converges; Session 2).</a:t>
+            </a:r>
+          </a:p>
+          <a:p>
+            <a:pPr>
+              <a:spcAft>
+                <a:spcPts val="800"/>
+              </a:spcAft>
+            </a:pPr>
+            <a:r>
+              <a:rPr sz="2000">
                 <a:solidFill>
                   <a:srgbClr val="212121"/>
                 </a:solidFill>

</xml_diff>

<commit_message>
Add slide on LLMs as bug-finders and the LLM+verifier synergy
New slide after the technique landscape: LLMs (Copilot/Claude/Cursor, Google
Big Sleep on SQLite) find bugs but are unsound and hallucinate, so they sit
with code review. The payoff is pairing them with a sound checker — the LLM
proposes, the verifier disposes — as in ESBMC-AI. Deck is now 49 slides;
update the README run order.
</commit_message>
<xml_diff>
--- a/slides/session1/01-session1-fundamentals.pptx
+++ b/slides/session1/01-session1-fundamentals.pptx
@@ -53,6 +53,7 @@
     <p:sldId id="301" r:id="rId52"/>
     <p:sldId id="302" r:id="rId53"/>
     <p:sldId id="303" r:id="rId54"/>
+    <p:sldId id="304" r:id="rId55"/>
   </p:sldIdLst>
   <p:sldSz cx="12191695" cy="6858000" type="screen4x3"/>
   <p:notesSz cx="6858000" cy="9144000"/>
@@ -6768,7 +6769,7 @@
                   <a:srgbClr val="5A0A7A"/>
                 </a:solidFill>
               </a:rPr>
-              <a:t>The one trick to remember</a:t>
+              <a:t>LLMs find bugs too — but who checks the LLM?</a:t>
             </a:r>
           </a:p>
         </p:txBody>
@@ -6781,8 +6782,8 @@
         </p:nvSpPr>
         <p:spPr>
           <a:xfrm>
-            <a:off x="731520" y="1737360"/>
-            <a:ext cx="10789920" cy="4846320"/>
+            <a:off x="731520" y="1463040"/>
+            <a:ext cx="10789920" cy="5120640"/>
           </a:xfrm>
           <a:prstGeom prst="rect">
             <a:avLst/>
@@ -6801,12 +6802,42 @@
               </a:spcAft>
             </a:pPr>
             <a:r>
-              <a:rPr sz="2600">
-                <a:solidFill>
-                  <a:srgbClr val="212121"/>
-                </a:solidFill>
-              </a:rPr>
-              <a:t>To prove a property P, ask whether ¬P is satisfiable.</a:t>
+              <a:rPr sz="2000">
+                <a:solidFill>
+                  <a:srgbClr val="212121"/>
+                </a:solidFill>
+              </a:rPr>
+              <a:t>LLMs (Copilot, Claude, Cursor) read code and flag bugs — fast, broad, cheap. They even find real zero-days: Google's Big Sleep found an exploitable buffer underflow in SQLite (2024).</a:t>
+            </a:r>
+          </a:p>
+          <a:p>
+            <a:pPr>
+              <a:spcAft>
+                <a:spcPts val="800"/>
+              </a:spcAft>
+            </a:pPr>
+            <a:r>
+              <a:rPr sz="2000">
+                <a:solidFill>
+                  <a:srgbClr val="212121"/>
+                </a:solidFill>
+              </a:rPr>
+              <a:t>But an LLM is unsound and incomplete: it misses real bugs and hallucinates ones that aren't there — no guarantees. Same corner of the grid as code review.</a:t>
+            </a:r>
+          </a:p>
+          <a:p>
+            <a:pPr>
+              <a:spcAft>
+                <a:spcPts val="800"/>
+              </a:spcAft>
+            </a:pPr>
+            <a:r>
+              <a:rPr sz="2000">
+                <a:solidFill>
+                  <a:srgbClr val="212121"/>
+                </a:solidFill>
+              </a:rPr>
+              <a:t>The win is pairing them — the LLM proposes, a sound checker disposes:</a:t>
             </a:r>
           </a:p>
           <a:p>
@@ -6816,12 +6847,12 @@
               </a:spcAft>
             </a:pPr>
             <a:r>
-              <a:rPr sz="2400">
-                <a:solidFill>
-                  <a:srgbClr val="212121"/>
-                </a:solidFill>
-              </a:rPr>
-              <a:t>unsat  ⇒  no way to violate P exists — a proof</a:t>
+              <a:rPr sz="1800">
+                <a:solidFill>
+                  <a:srgbClr val="212121"/>
+                </a:solidFill>
+              </a:rPr>
+              <a:t>the LLM suggests bugs, fixes, specs, or inductive invariants;</a:t>
             </a:r>
           </a:p>
           <a:p>
@@ -6831,72 +6862,65 @@
               </a:spcAft>
             </a:pPr>
             <a:r>
-              <a:rPr sz="2400">
-                <a:solidFill>
-                  <a:srgbClr val="212121"/>
-                </a:solidFill>
-              </a:rPr>
-              <a:t>satisfiable, with a model  ⇒  a concrete counterexample to P</a:t>
-            </a:r>
-          </a:p>
-          <a:p>
-            <a:pPr>
-              <a:spcAft>
-                <a:spcPts val="800"/>
-              </a:spcAft>
-            </a:pPr>
-            <a:r>
-              <a:rPr sz="2600">
-                <a:solidFill>
-                  <a:srgbClr val="212121"/>
-                </a:solidFill>
-              </a:rPr>
-              <a:t/>
-            </a:r>
-          </a:p>
-          <a:p>
-            <a:pPr>
-              <a:spcAft>
-                <a:spcPts val="800"/>
-              </a:spcAft>
-            </a:pPr>
-            <a:r>
-              <a:rPr sz="2600">
-                <a:solidFill>
-                  <a:srgbClr val="212121"/>
-                </a:solidFill>
-              </a:rPr>
-              <a:t>Every tool tonight, and every lab in Session 2, is this one move in different costumes.</a:t>
-            </a:r>
-          </a:p>
-          <a:p>
-            <a:pPr>
-              <a:spcAft>
-                <a:spcPts val="800"/>
-              </a:spcAft>
-            </a:pPr>
-            <a:r>
-              <a:rPr sz="2600">
-                <a:solidFill>
-                  <a:srgbClr val="212121"/>
-                </a:solidFill>
-              </a:rPr>
-              <a:t/>
-            </a:r>
-          </a:p>
-          <a:p>
-            <a:pPr>
-              <a:spcAft>
-                <a:spcPts val="800"/>
-              </a:spcAft>
-            </a:pPr>
-            <a:r>
-              <a:rPr sz="2600">
-                <a:solidFill>
-                  <a:srgbClr val="212121"/>
-                </a:solidFill>
-              </a:rPr>
-              <a:t>So we need an oracle for “is this formula satisfiable?” — it exists, it is free, and it is absurdly good. After the break.</a:t>
+              <a:rPr sz="1800">
+                <a:solidFill>
+                  <a:srgbClr val="212121"/>
+                </a:solidFill>
+              </a:rPr>
+              <a:t>the verifier returns a concrete counterexample or a proof — and catches the hallucinations.</a:t>
+            </a:r>
+          </a:p>
+          <a:p>
+            <a:pPr>
+              <a:spcAft>
+                <a:spcPts val="800"/>
+              </a:spcAft>
+            </a:pPr>
+            <a:r>
+              <a:rPr sz="2000">
+                <a:solidFill>
+                  <a:srgbClr val="212121"/>
+                </a:solidFill>
+              </a:rPr>
+              <a:t>ESBMC-AI does exactly this: ESBMC verifies → counterexample + code → LLM proposes a fix → re-verify, loop until proven.</a:t>
+            </a:r>
+          </a:p>
+        </p:txBody>
+      </p:sp>
+      <p:sp>
+        <p:nvSpPr>
+          <p:cNvPr id="4" name="TextBox 3"/>
+          <p:cNvSpPr txBox="1"/>
+          <p:nvPr/>
+        </p:nvSpPr>
+        <p:spPr>
+          <a:xfrm>
+            <a:off x="731520" y="6400800"/>
+            <a:ext cx="10789920" cy="182880"/>
+          </a:xfrm>
+          <a:prstGeom prst="rect">
+            <a:avLst/>
+          </a:prstGeom>
+          <a:noFill/>
+        </p:spPr>
+        <p:txBody>
+          <a:bodyPr wrap="square">
+            <a:spAutoFit/>
+          </a:bodyPr>
+          <a:lstStyle/>
+          <a:p>
+            <a:pPr>
+              <a:spcAft>
+                <a:spcPts val="800"/>
+              </a:spcAft>
+            </a:pPr>
+            <a:r>
+              <a:rPr sz="1400">
+                <a:solidFill>
+                  <a:srgbClr val="212121"/>
+                </a:solidFill>
+              </a:rPr>
+              <a:t>Sources: Google Big Sleep (Project Zero × DeepMind, 2024) · ESBMC-AI — esbmc.github.io/esbmc-ai</a:t>
             </a:r>
           </a:p>
         </p:txBody>
@@ -6927,7 +6951,7 @@
         </p:nvSpPr>
         <p:spPr>
           <a:xfrm>
-            <a:off x="548640" y="2377440"/>
+            <a:off x="548640" y="365760"/>
             <a:ext cx="11064240" cy="1005840"/>
           </a:xfrm>
           <a:prstGeom prst="rect">
@@ -6942,12 +6966,140 @@
           <a:lstStyle/>
           <a:p>
             <a:r>
-              <a:rPr sz="4400" b="1">
+              <a:rPr sz="3600" b="1">
                 <a:solidFill>
                   <a:srgbClr val="5A0A7A"/>
                 </a:solidFill>
               </a:rPr>
-              <a:t>Break — back at 19:25</a:t>
+              <a:t>The one trick to remember</a:t>
+            </a:r>
+          </a:p>
+        </p:txBody>
+      </p:sp>
+      <p:sp>
+        <p:nvSpPr>
+          <p:cNvPr id="3" name="TextBox 2"/>
+          <p:cNvSpPr txBox="1"/>
+          <p:nvPr/>
+        </p:nvSpPr>
+        <p:spPr>
+          <a:xfrm>
+            <a:off x="731520" y="1737360"/>
+            <a:ext cx="10789920" cy="4846320"/>
+          </a:xfrm>
+          <a:prstGeom prst="rect">
+            <a:avLst/>
+          </a:prstGeom>
+          <a:noFill/>
+        </p:spPr>
+        <p:txBody>
+          <a:bodyPr wrap="square">
+            <a:spAutoFit/>
+          </a:bodyPr>
+          <a:lstStyle/>
+          <a:p>
+            <a:pPr>
+              <a:spcAft>
+                <a:spcPts val="800"/>
+              </a:spcAft>
+            </a:pPr>
+            <a:r>
+              <a:rPr sz="2600">
+                <a:solidFill>
+                  <a:srgbClr val="212121"/>
+                </a:solidFill>
+              </a:rPr>
+              <a:t>To prove a property P, ask whether ¬P is satisfiable.</a:t>
+            </a:r>
+          </a:p>
+          <a:p>
+            <a:pPr lvl="1">
+              <a:spcAft>
+                <a:spcPts val="800"/>
+              </a:spcAft>
+            </a:pPr>
+            <a:r>
+              <a:rPr sz="2400">
+                <a:solidFill>
+                  <a:srgbClr val="212121"/>
+                </a:solidFill>
+              </a:rPr>
+              <a:t>unsat  ⇒  no way to violate P exists — a proof</a:t>
+            </a:r>
+          </a:p>
+          <a:p>
+            <a:pPr lvl="1">
+              <a:spcAft>
+                <a:spcPts val="800"/>
+              </a:spcAft>
+            </a:pPr>
+            <a:r>
+              <a:rPr sz="2400">
+                <a:solidFill>
+                  <a:srgbClr val="212121"/>
+                </a:solidFill>
+              </a:rPr>
+              <a:t>satisfiable, with a model  ⇒  a concrete counterexample to P</a:t>
+            </a:r>
+          </a:p>
+          <a:p>
+            <a:pPr>
+              <a:spcAft>
+                <a:spcPts val="800"/>
+              </a:spcAft>
+            </a:pPr>
+            <a:r>
+              <a:rPr sz="2600">
+                <a:solidFill>
+                  <a:srgbClr val="212121"/>
+                </a:solidFill>
+              </a:rPr>
+              <a:t/>
+            </a:r>
+          </a:p>
+          <a:p>
+            <a:pPr>
+              <a:spcAft>
+                <a:spcPts val="800"/>
+              </a:spcAft>
+            </a:pPr>
+            <a:r>
+              <a:rPr sz="2600">
+                <a:solidFill>
+                  <a:srgbClr val="212121"/>
+                </a:solidFill>
+              </a:rPr>
+              <a:t>Every tool tonight, and every lab in Session 2, is this one move in different costumes.</a:t>
+            </a:r>
+          </a:p>
+          <a:p>
+            <a:pPr>
+              <a:spcAft>
+                <a:spcPts val="800"/>
+              </a:spcAft>
+            </a:pPr>
+            <a:r>
+              <a:rPr sz="2600">
+                <a:solidFill>
+                  <a:srgbClr val="212121"/>
+                </a:solidFill>
+              </a:rPr>
+              <a:t/>
+            </a:r>
+          </a:p>
+          <a:p>
+            <a:pPr>
+              <a:spcAft>
+                <a:spcPts val="800"/>
+              </a:spcAft>
+            </a:pPr>
+            <a:r>
+              <a:rPr sz="2600">
+                <a:solidFill>
+                  <a:srgbClr val="212121"/>
+                </a:solidFill>
+              </a:rPr>
+              <a:t>So we need an oracle for “is this formula satisfiable?” — it exists, it is free, and it is absurdly good. After the break.</a:t>
             </a:r>
           </a:p>
         </p:txBody>
@@ -6978,7 +7130,7 @@
         </p:nvSpPr>
         <p:spPr>
           <a:xfrm>
-            <a:off x="548640" y="365760"/>
+            <a:off x="548640" y="2377440"/>
             <a:ext cx="11064240" cy="1005840"/>
           </a:xfrm>
           <a:prstGeom prst="rect">
@@ -6993,126 +7145,12 @@
           <a:lstStyle/>
           <a:p>
             <a:r>
-              <a:rPr sz="3600" b="1">
+              <a:rPr sz="4400" b="1">
                 <a:solidFill>
                   <a:srgbClr val="5A0A7A"/>
                 </a:solidFill>
               </a:rPr>
-              <a:t>SAT: the original hard problem</a:t>
-            </a:r>
-          </a:p>
-        </p:txBody>
-      </p:sp>
-      <p:sp>
-        <p:nvSpPr>
-          <p:cNvPr id="3" name="TextBox 2"/>
-          <p:cNvSpPr txBox="1"/>
-          <p:nvPr/>
-        </p:nvSpPr>
-        <p:spPr>
-          <a:xfrm>
-            <a:off x="731520" y="1554480"/>
-            <a:ext cx="10789920" cy="5029200"/>
-          </a:xfrm>
-          <a:prstGeom prst="rect">
-            <a:avLst/>
-          </a:prstGeom>
-          <a:noFill/>
-        </p:spPr>
-        <p:txBody>
-          <a:bodyPr wrap="square">
-            <a:spAutoFit/>
-          </a:bodyPr>
-          <a:lstStyle/>
-          <a:p>
-            <a:pPr>
-              <a:spcAft>
-                <a:spcPts val="0"/>
-              </a:spcAft>
-            </a:pPr>
-            <a:r>
-              <a:rPr sz="2000">
-                <a:solidFill>
-                  <a:srgbClr val="212121"/>
-                </a:solidFill>
-                <a:latin typeface="Courier New"/>
-              </a:rPr>
-              <a:t>(a ∨ ¬b) ∧ (b ∨ c) ∧ (¬a ∨ ¬c)</a:t>
-            </a:r>
-          </a:p>
-          <a:p>
-            <a:pPr>
-              <a:spcAft>
-                <a:spcPts val="800"/>
-              </a:spcAft>
-            </a:pPr>
-            <a:r>
-              <a:rPr sz="2400">
-                <a:solidFill>
-                  <a:srgbClr val="212121"/>
-                </a:solidFill>
-              </a:rPr>
-              <a:t/>
-            </a:r>
-          </a:p>
-          <a:p>
-            <a:pPr>
-              <a:spcAft>
-                <a:spcPts val="800"/>
-              </a:spcAft>
-            </a:pPr>
-            <a:r>
-              <a:rPr sz="2400">
-                <a:solidFill>
-                  <a:srgbClr val="212121"/>
-                </a:solidFill>
-              </a:rPr>
-              <a:t>Is there a true/false assignment that makes the whole formula true?</a:t>
-            </a:r>
-          </a:p>
-          <a:p>
-            <a:pPr>
-              <a:spcAft>
-                <a:spcPts val="800"/>
-              </a:spcAft>
-            </a:pPr>
-            <a:r>
-              <a:rPr sz="2400">
-                <a:solidFill>
-                  <a:srgbClr val="212121"/>
-                </a:solidFill>
-              </a:rPr>
-              <a:t/>
-            </a:r>
-          </a:p>
-          <a:p>
-            <a:pPr>
-              <a:spcAft>
-                <a:spcPts val="800"/>
-              </a:spcAft>
-            </a:pPr>
-            <a:r>
-              <a:rPr sz="2400">
-                <a:solidFill>
-                  <a:srgbClr val="212121"/>
-                </a:solidFill>
-              </a:rPr>
-              <a:t>The first problem ever proved NP-complete (Cook, 1971) — in theory, hopeless.</a:t>
-            </a:r>
-          </a:p>
-          <a:p>
-            <a:pPr>
-              <a:spcAft>
-                <a:spcPts val="800"/>
-              </a:spcAft>
-            </a:pPr>
-            <a:r>
-              <a:rPr sz="2400">
-                <a:solidFill>
-                  <a:srgbClr val="212121"/>
-                </a:solidFill>
-              </a:rPr>
-              <a:t>In practice: modern solvers eat formulas with millions of clauses for breakfast. Industrial SAT solving is the closest thing CS has to a superpower.</a:t>
+              <a:t>Break — back at 19:25</a:t>
             </a:r>
           </a:p>
         </p:txBody>
@@ -7163,6 +7201,171 @@
                   <a:srgbClr val="5A0A7A"/>
                 </a:solidFill>
               </a:rPr>
+              <a:t>SAT: the original hard problem</a:t>
+            </a:r>
+          </a:p>
+        </p:txBody>
+      </p:sp>
+      <p:sp>
+        <p:nvSpPr>
+          <p:cNvPr id="3" name="TextBox 2"/>
+          <p:cNvSpPr txBox="1"/>
+          <p:nvPr/>
+        </p:nvSpPr>
+        <p:spPr>
+          <a:xfrm>
+            <a:off x="731520" y="1554480"/>
+            <a:ext cx="10789920" cy="5029200"/>
+          </a:xfrm>
+          <a:prstGeom prst="rect">
+            <a:avLst/>
+          </a:prstGeom>
+          <a:noFill/>
+        </p:spPr>
+        <p:txBody>
+          <a:bodyPr wrap="square">
+            <a:spAutoFit/>
+          </a:bodyPr>
+          <a:lstStyle/>
+          <a:p>
+            <a:pPr>
+              <a:spcAft>
+                <a:spcPts val="0"/>
+              </a:spcAft>
+            </a:pPr>
+            <a:r>
+              <a:rPr sz="2000">
+                <a:solidFill>
+                  <a:srgbClr val="212121"/>
+                </a:solidFill>
+                <a:latin typeface="Courier New"/>
+              </a:rPr>
+              <a:t>(a ∨ ¬b) ∧ (b ∨ c) ∧ (¬a ∨ ¬c)</a:t>
+            </a:r>
+          </a:p>
+          <a:p>
+            <a:pPr>
+              <a:spcAft>
+                <a:spcPts val="800"/>
+              </a:spcAft>
+            </a:pPr>
+            <a:r>
+              <a:rPr sz="2400">
+                <a:solidFill>
+                  <a:srgbClr val="212121"/>
+                </a:solidFill>
+              </a:rPr>
+              <a:t/>
+            </a:r>
+          </a:p>
+          <a:p>
+            <a:pPr>
+              <a:spcAft>
+                <a:spcPts val="800"/>
+              </a:spcAft>
+            </a:pPr>
+            <a:r>
+              <a:rPr sz="2400">
+                <a:solidFill>
+                  <a:srgbClr val="212121"/>
+                </a:solidFill>
+              </a:rPr>
+              <a:t>Is there a true/false assignment that makes the whole formula true?</a:t>
+            </a:r>
+          </a:p>
+          <a:p>
+            <a:pPr>
+              <a:spcAft>
+                <a:spcPts val="800"/>
+              </a:spcAft>
+            </a:pPr>
+            <a:r>
+              <a:rPr sz="2400">
+                <a:solidFill>
+                  <a:srgbClr val="212121"/>
+                </a:solidFill>
+              </a:rPr>
+              <a:t/>
+            </a:r>
+          </a:p>
+          <a:p>
+            <a:pPr>
+              <a:spcAft>
+                <a:spcPts val="800"/>
+              </a:spcAft>
+            </a:pPr>
+            <a:r>
+              <a:rPr sz="2400">
+                <a:solidFill>
+                  <a:srgbClr val="212121"/>
+                </a:solidFill>
+              </a:rPr>
+              <a:t>The first problem ever proved NP-complete (Cook, 1971) — in theory, hopeless.</a:t>
+            </a:r>
+          </a:p>
+          <a:p>
+            <a:pPr>
+              <a:spcAft>
+                <a:spcPts val="800"/>
+              </a:spcAft>
+            </a:pPr>
+            <a:r>
+              <a:rPr sz="2400">
+                <a:solidFill>
+                  <a:srgbClr val="212121"/>
+                </a:solidFill>
+              </a:rPr>
+              <a:t>In practice: modern solvers eat formulas with millions of clauses for breakfast. Industrial SAT solving is the closest thing CS has to a superpower.</a:t>
+            </a:r>
+          </a:p>
+        </p:txBody>
+      </p:sp>
+    </p:spTree>
+  </p:cSld>
+  <p:clrMapOvr>
+    <a:masterClrMapping/>
+  </p:clrMapOvr>
+</p:sld>
+</file>
+
+<file path=ppt/slides/slide27.xml><?xml version="1.0" encoding="utf-8"?>
+<p:sld xmlns:a="http://schemas.openxmlformats.org/drawingml/2006/main" xmlns:p="http://schemas.openxmlformats.org/presentationml/2006/main" xmlns:r="http://schemas.openxmlformats.org/officeDocument/2006/relationships">
+  <p:cSld>
+    <p:spTree>
+      <p:nvGrpSpPr>
+        <p:cNvPr id="1" name=""/>
+        <p:cNvGrpSpPr/>
+        <p:nvPr/>
+      </p:nvGrpSpPr>
+      <p:grpSpPr/>
+      <p:sp>
+        <p:nvSpPr>
+          <p:cNvPr id="2" name="TextBox 1"/>
+          <p:cNvSpPr txBox="1"/>
+          <p:nvPr/>
+        </p:nvSpPr>
+        <p:spPr>
+          <a:xfrm>
+            <a:off x="548640" y="365760"/>
+            <a:ext cx="11064240" cy="1005840"/>
+          </a:xfrm>
+          <a:prstGeom prst="rect">
+            <a:avLst/>
+          </a:prstGeom>
+          <a:noFill/>
+        </p:spPr>
+        <p:txBody>
+          <a:bodyPr wrap="square">
+            <a:spAutoFit/>
+          </a:bodyPr>
+          <a:lstStyle/>
+          <a:p>
+            <a:r>
+              <a:rPr sz="3600" b="1">
+                <a:solidFill>
+                  <a:srgbClr val="5A0A7A"/>
+                </a:solidFill>
+              </a:rPr>
               <a:t>The two answers a solver can give</a:t>
             </a:r>
           </a:p>
@@ -7319,7 +7522,7 @@
 </p:sld>
 </file>
 
-<file path=ppt/slides/slide27.xml><?xml version="1.0" encoding="utf-8"?>
+<file path=ppt/slides/slide28.xml><?xml version="1.0" encoding="utf-8"?>
 <p:sld xmlns:a="http://schemas.openxmlformats.org/drawingml/2006/main" xmlns:p="http://schemas.openxmlformats.org/presentationml/2006/main" xmlns:r="http://schemas.openxmlformats.org/officeDocument/2006/relationships">
   <p:cSld>
     <p:spTree>
@@ -7574,7 +7777,7 @@
 </p:sld>
 </file>
 
-<file path=ppt/slides/slide28.xml><?xml version="1.0" encoding="utf-8"?>
+<file path=ppt/slides/slide29.xml><?xml version="1.0" encoding="utf-8"?>
 <p:sld xmlns:a="http://schemas.openxmlformats.org/drawingml/2006/main" xmlns:p="http://schemas.openxmlformats.org/presentationml/2006/main" xmlns:r="http://schemas.openxmlformats.org/officeDocument/2006/relationships">
   <p:cSld>
     <p:spTree>
@@ -7743,222 +7946,6 @@
                 </a:solidFill>
               </a:rPr>
               <a:t>unsat  →  the access is safe on every path</a:t>
-            </a:r>
-          </a:p>
-        </p:txBody>
-      </p:sp>
-    </p:spTree>
-  </p:cSld>
-  <p:clrMapOvr>
-    <a:masterClrMapping/>
-  </p:clrMapOvr>
-</p:sld>
-</file>
-
-<file path=ppt/slides/slide29.xml><?xml version="1.0" encoding="utf-8"?>
-<p:sld xmlns:a="http://schemas.openxmlformats.org/drawingml/2006/main" xmlns:p="http://schemas.openxmlformats.org/presentationml/2006/main" xmlns:r="http://schemas.openxmlformats.org/officeDocument/2006/relationships">
-  <p:cSld>
-    <p:spTree>
-      <p:nvGrpSpPr>
-        <p:cNvPr id="1" name=""/>
-        <p:cNvGrpSpPr/>
-        <p:nvPr/>
-      </p:nvGrpSpPr>
-      <p:grpSpPr/>
-      <p:sp>
-        <p:nvSpPr>
-          <p:cNvPr id="2" name="TextBox 1"/>
-          <p:cNvSpPr txBox="1"/>
-          <p:nvPr/>
-        </p:nvSpPr>
-        <p:spPr>
-          <a:xfrm>
-            <a:off x="548640" y="365760"/>
-            <a:ext cx="11064240" cy="1005840"/>
-          </a:xfrm>
-          <a:prstGeom prst="rect">
-            <a:avLst/>
-          </a:prstGeom>
-          <a:noFill/>
-        </p:spPr>
-        <p:txBody>
-          <a:bodyPr wrap="square">
-            <a:spAutoFit/>
-          </a:bodyPr>
-          <a:lstStyle/>
-          <a:p>
-            <a:r>
-              <a:rPr sz="3600" b="1">
-                <a:solidFill>
-                  <a:srgbClr val="5A0A7A"/>
-                </a:solidFill>
-              </a:rPr>
-              <a:t>Live: a solver in two queries</a:t>
-            </a:r>
-          </a:p>
-        </p:txBody>
-      </p:sp>
-      <p:sp>
-        <p:nvSpPr>
-          <p:cNvPr id="3" name="TextBox 2"/>
-          <p:cNvSpPr txBox="1"/>
-          <p:nvPr/>
-        </p:nvSpPr>
-        <p:spPr>
-          <a:xfrm>
-            <a:off x="731520" y="1463040"/>
-            <a:ext cx="10789920" cy="5120640"/>
-          </a:xfrm>
-          <a:prstGeom prst="rect">
-            <a:avLst/>
-          </a:prstGeom>
-          <a:noFill/>
-        </p:spPr>
-        <p:txBody>
-          <a:bodyPr wrap="square">
-            <a:spAutoFit/>
-          </a:bodyPr>
-          <a:lstStyle/>
-          <a:p>
-            <a:pPr>
-              <a:spcAft>
-                <a:spcPts val="0"/>
-              </a:spcAft>
-            </a:pPr>
-            <a:r>
-              <a:rPr sz="1800">
-                <a:solidFill>
-                  <a:srgbClr val="212121"/>
-                </a:solidFill>
-                <a:latin typeface="Courier New"/>
-              </a:rPr>
-              <a:t>$ python3 z3_demo.py</a:t>
-            </a:r>
-          </a:p>
-          <a:p>
-            <a:pPr>
-              <a:spcAft>
-                <a:spcPts val="0"/>
-              </a:spcAft>
-            </a:pPr>
-            <a:r>
-              <a:rPr sz="1800">
-                <a:solidFill>
-                  <a:srgbClr val="212121"/>
-                </a:solidFill>
-                <a:latin typeface="Courier New"/>
-              </a:rPr>
-              <a:t/>
-            </a:r>
-          </a:p>
-          <a:p>
-            <a:pPr>
-              <a:spcAft>
-                <a:spcPts val="0"/>
-              </a:spcAft>
-            </a:pPr>
-            <a:r>
-              <a:rPr sz="1800">
-                <a:solidFill>
-                  <a:srgbClr val="212121"/>
-                </a:solidFill>
-                <a:latin typeface="Courier New"/>
-              </a:rPr>
-              <a:t>Query 1: x + y == 42 and x &gt; 100</a:t>
-            </a:r>
-          </a:p>
-          <a:p>
-            <a:pPr>
-              <a:spcAft>
-                <a:spcPts val="0"/>
-              </a:spcAft>
-            </a:pPr>
-            <a:r>
-              <a:rPr sz="1800">
-                <a:solidFill>
-                  <a:srgbClr val="212121"/>
-                </a:solidFill>
-                <a:latin typeface="Courier New"/>
-              </a:rPr>
-              <a:t>[y = -59, x = 101]            ← a model, in milliseconds</a:t>
-            </a:r>
-          </a:p>
-          <a:p>
-            <a:pPr>
-              <a:spcAft>
-                <a:spcPts val="0"/>
-              </a:spcAft>
-            </a:pPr>
-            <a:r>
-              <a:rPr sz="1800">
-                <a:solidFill>
-                  <a:srgbClr val="212121"/>
-                </a:solidFill>
-                <a:latin typeface="Courier New"/>
-              </a:rPr>
-              <a:t/>
-            </a:r>
-          </a:p>
-          <a:p>
-            <a:pPr>
-              <a:spcAft>
-                <a:spcPts val="0"/>
-              </a:spcAft>
-            </a:pPr>
-            <a:r>
-              <a:rPr sz="1800">
-                <a:solidFill>
-                  <a:srgbClr val="212121"/>
-                </a:solidFill>
-                <a:latin typeface="Courier New"/>
-              </a:rPr>
-              <a:t>Query 2: x*x == 2*y*y, x &gt; 0, y &gt; 0 (no overflow)</a:t>
-            </a:r>
-          </a:p>
-          <a:p>
-            <a:pPr>
-              <a:spcAft>
-                <a:spcPts val="0"/>
-              </a:spcAft>
-            </a:pPr>
-            <a:r>
-              <a:rPr sz="1800">
-                <a:solidFill>
-                  <a:srgbClr val="212121"/>
-                </a:solidFill>
-                <a:latin typeface="Courier New"/>
-              </a:rPr>
-              <a:t>unsat                          ← a proof</a:t>
-            </a:r>
-          </a:p>
-          <a:p>
-            <a:pPr>
-              <a:spcAft>
-                <a:spcPts val="800"/>
-              </a:spcAft>
-            </a:pPr>
-            <a:r>
-              <a:rPr sz="2200">
-                <a:solidFill>
-                  <a:srgbClr val="212121"/>
-                </a:solidFill>
-              </a:rPr>
-              <a:t/>
-            </a:r>
-          </a:p>
-          <a:p>
-            <a:pPr>
-              <a:spcAft>
-                <a:spcPts val="800"/>
-              </a:spcAft>
-            </a:pPr>
-            <a:r>
-              <a:rPr sz="2200">
-                <a:solidFill>
-                  <a:srgbClr val="212121"/>
-                </a:solidFill>
-              </a:rPr>
-              <a:t>Query 2 just proved that √2 is irrational — 32-bit bit-vector edition. unsat is a theorem, not a shrug.</a:t>
             </a:r>
           </a:p>
         </p:txBody>
@@ -8113,7 +8100,7 @@
                   <a:srgbClr val="5A0A7A"/>
                 </a:solidFill>
               </a:rPr>
-              <a:t>Machine arithmetic is not mathematics</a:t>
+              <a:t>Live: a solver in two queries</a:t>
             </a:r>
           </a:p>
         </p:txBody>
@@ -8152,7 +8139,7 @@
                 </a:solidFill>
                 <a:latin typeface="Courier New"/>
               </a:rPr>
-              <a:t>INT_MAX     =  2147483647</a:t>
+              <a:t>$ python3 z3_demo.py</a:t>
             </a:r>
           </a:p>
           <a:p>
@@ -8168,7 +8155,7 @@
                 </a:solidFill>
                 <a:latin typeface="Courier New"/>
               </a:rPr>
-              <a:t>INT_MAX + 1 =  ?            /* C: undefined behaviour */</a:t>
+              <a:t/>
             </a:r>
           </a:p>
           <a:p>
@@ -8184,7 +8171,71 @@
                 </a:solidFill>
                 <a:latin typeface="Courier New"/>
               </a:rPr>
-              <a:t>                            /* bit-vectors: wraps negative */</a:t>
+              <a:t>Query 1: x + y == 42 and x &gt; 100</a:t>
+            </a:r>
+          </a:p>
+          <a:p>
+            <a:pPr>
+              <a:spcAft>
+                <a:spcPts val="0"/>
+              </a:spcAft>
+            </a:pPr>
+            <a:r>
+              <a:rPr sz="1800">
+                <a:solidFill>
+                  <a:srgbClr val="212121"/>
+                </a:solidFill>
+                <a:latin typeface="Courier New"/>
+              </a:rPr>
+              <a:t>[y = -59, x = 101]            ← a model, in milliseconds</a:t>
+            </a:r>
+          </a:p>
+          <a:p>
+            <a:pPr>
+              <a:spcAft>
+                <a:spcPts val="0"/>
+              </a:spcAft>
+            </a:pPr>
+            <a:r>
+              <a:rPr sz="1800">
+                <a:solidFill>
+                  <a:srgbClr val="212121"/>
+                </a:solidFill>
+                <a:latin typeface="Courier New"/>
+              </a:rPr>
+              <a:t/>
+            </a:r>
+          </a:p>
+          <a:p>
+            <a:pPr>
+              <a:spcAft>
+                <a:spcPts val="0"/>
+              </a:spcAft>
+            </a:pPr>
+            <a:r>
+              <a:rPr sz="1800">
+                <a:solidFill>
+                  <a:srgbClr val="212121"/>
+                </a:solidFill>
+                <a:latin typeface="Courier New"/>
+              </a:rPr>
+              <a:t>Query 2: x*x == 2*y*y, x &gt; 0, y &gt; 0 (no overflow)</a:t>
+            </a:r>
+          </a:p>
+          <a:p>
+            <a:pPr>
+              <a:spcAft>
+                <a:spcPts val="0"/>
+              </a:spcAft>
+            </a:pPr>
+            <a:r>
+              <a:rPr sz="1800">
+                <a:solidFill>
+                  <a:srgbClr val="212121"/>
+                </a:solidFill>
+                <a:latin typeface="Courier New"/>
+              </a:rPr>
+              <a:t>unsat                          ← a proof</a:t>
             </a:r>
           </a:p>
           <a:p>
@@ -8205,54 +8256,6 @@
           <a:p>
             <a:pPr>
               <a:spcAft>
-                <a:spcPts val="0"/>
-              </a:spcAft>
-            </a:pPr>
-            <a:r>
-              <a:rPr sz="1800">
-                <a:solidFill>
-                  <a:srgbClr val="212121"/>
-                </a:solidFill>
-                <a:latin typeface="Courier New"/>
-              </a:rPr>
-              <a:t>int y = x + 1;</a:t>
-            </a:r>
-          </a:p>
-          <a:p>
-            <a:pPr>
-              <a:spcAft>
-                <a:spcPts val="0"/>
-              </a:spcAft>
-            </a:pPr>
-            <a:r>
-              <a:rPr sz="1800">
-                <a:solidFill>
-                  <a:srgbClr val="212121"/>
-                </a:solidFill>
-                <a:latin typeface="Courier New"/>
-              </a:rPr>
-              <a:t>int z = y * 2;</a:t>
-            </a:r>
-          </a:p>
-          <a:p>
-            <a:pPr>
-              <a:spcAft>
-                <a:spcPts val="0"/>
-              </a:spcAft>
-            </a:pPr>
-            <a:r>
-              <a:rPr sz="1800">
-                <a:solidFill>
-                  <a:srgbClr val="212121"/>
-                </a:solidFill>
-                <a:latin typeface="Courier New"/>
-              </a:rPr>
-              <a:t>assert(z &gt;= 2);   /* surely true for x &gt;= 0 … ? */</a:t>
-            </a:r>
-          </a:p>
-          <a:p>
-            <a:pPr>
-              <a:spcAft>
                 <a:spcPts val="800"/>
               </a:spcAft>
             </a:pPr>
@@ -8262,22 +8265,7 @@
                   <a:srgbClr val="212121"/>
                 </a:solidFill>
               </a:rPr>
-              <a:t/>
-            </a:r>
-          </a:p>
-          <a:p>
-            <a:pPr>
-              <a:spcAft>
-                <a:spcPts val="800"/>
-              </a:spcAft>
-            </a:pPr>
-            <a:r>
-              <a:rPr sz="2200">
-                <a:solidFill>
-                  <a:srgbClr val="212121"/>
-                </a:solidFill>
-              </a:rPr>
-              <a:t>A solver finds the x that breaks this in milliseconds. In Lab 1 you will encode these three lines yourself and watch it happen.</a:t>
+              <a:t>Query 2 just proved that √2 is irrational — 32-bit bit-vector edition. unsat is a theorem, not a shrug.</a:t>
             </a:r>
           </a:p>
         </p:txBody>
@@ -8328,7 +8316,7 @@
                   <a:srgbClr val="5A0A7A"/>
                 </a:solidFill>
               </a:rPr>
-              <a:t>Solvers as search engines: SEND + MORE = MONEY</a:t>
+              <a:t>Machine arithmetic is not mathematics</a:t>
             </a:r>
           </a:p>
         </p:txBody>
@@ -8367,7 +8355,7 @@
                 </a:solidFill>
                 <a:latin typeface="Courier New"/>
               </a:rPr>
-              <a:t>  S E N D</a:t>
+              <a:t>INT_MAX     =  2147483647</a:t>
             </a:r>
           </a:p>
           <a:p>
@@ -8383,7 +8371,7 @@
                 </a:solidFill>
                 <a:latin typeface="Courier New"/>
               </a:rPr>
-              <a:t>+ M O R E</a:t>
+              <a:t>INT_MAX + 1 =  ?            /* C: undefined behaviour */</a:t>
             </a:r>
           </a:p>
           <a:p>
@@ -8399,7 +8387,22 @@
                 </a:solidFill>
                 <a:latin typeface="Courier New"/>
               </a:rPr>
-              <a:t>---------</a:t>
+              <a:t>                            /* bit-vectors: wraps negative */</a:t>
+            </a:r>
+          </a:p>
+          <a:p>
+            <a:pPr>
+              <a:spcAft>
+                <a:spcPts val="800"/>
+              </a:spcAft>
+            </a:pPr>
+            <a:r>
+              <a:rPr sz="2200">
+                <a:solidFill>
+                  <a:srgbClr val="212121"/>
+                </a:solidFill>
+              </a:rPr>
+              <a:t/>
             </a:r>
           </a:p>
           <a:p>
@@ -8415,7 +8418,39 @@
                 </a:solidFill>
                 <a:latin typeface="Courier New"/>
               </a:rPr>
-              <a:t>M O N E Y</a:t>
+              <a:t>int y = x + 1;</a:t>
+            </a:r>
+          </a:p>
+          <a:p>
+            <a:pPr>
+              <a:spcAft>
+                <a:spcPts val="0"/>
+              </a:spcAft>
+            </a:pPr>
+            <a:r>
+              <a:rPr sz="1800">
+                <a:solidFill>
+                  <a:srgbClr val="212121"/>
+                </a:solidFill>
+                <a:latin typeface="Courier New"/>
+              </a:rPr>
+              <a:t>int z = y * 2;</a:t>
+            </a:r>
+          </a:p>
+          <a:p>
+            <a:pPr>
+              <a:spcAft>
+                <a:spcPts val="0"/>
+              </a:spcAft>
+            </a:pPr>
+            <a:r>
+              <a:rPr sz="1800">
+                <a:solidFill>
+                  <a:srgbClr val="212121"/>
+                </a:solidFill>
+                <a:latin typeface="Courier New"/>
+              </a:rPr>
+              <a:t>assert(z &gt;= 2);   /* surely true for x &gt;= 0 … ? */</a:t>
             </a:r>
           </a:p>
           <a:p>
@@ -8445,52 +8480,7 @@
                   <a:srgbClr val="212121"/>
                 </a:solidFill>
               </a:rPr>
-              <a:t>Eight letters, all different digits, S ≠ 0, M ≠ 0 — about 10⁸ candidate assignments.</a:t>
-            </a:r>
-          </a:p>
-          <a:p>
-            <a:pPr>
-              <a:spcAft>
-                <a:spcPts val="800"/>
-              </a:spcAft>
-            </a:pPr>
-            <a:r>
-              <a:rPr sz="2200">
-                <a:solidFill>
-                  <a:srgbClr val="212121"/>
-                </a:solidFill>
-              </a:rPr>
-              <a:t>Z3 finds the unique solution in well under a second.</a:t>
-            </a:r>
-          </a:p>
-          <a:p>
-            <a:pPr>
-              <a:spcAft>
-                <a:spcPts val="800"/>
-              </a:spcAft>
-            </a:pPr>
-            <a:r>
-              <a:rPr sz="2200">
-                <a:solidFill>
-                  <a:srgbClr val="212121"/>
-                </a:solidFill>
-              </a:rPr>
-              <a:t>The same engine that solves puzzles finds your bugs: a counterexample is just a solution to “break my program”.</a:t>
-            </a:r>
-          </a:p>
-          <a:p>
-            <a:pPr>
-              <a:spcAft>
-                <a:spcPts val="800"/>
-              </a:spcAft>
-            </a:pPr>
-            <a:r>
-              <a:rPr sz="2200">
-                <a:solidFill>
-                  <a:srgbClr val="212121"/>
-                </a:solidFill>
-              </a:rPr>
-              <a:t>Lab 1, Stage 2: you run this yourself.</a:t>
+              <a:t>A solver finds the x that breaks this in milliseconds. In Lab 1 you will encode these three lines yourself and watch it happen.</a:t>
             </a:r>
           </a:p>
         </p:txBody>
@@ -8504,6 +8494,219 @@
 </file>
 
 <file path=ppt/slides/slide32.xml><?xml version="1.0" encoding="utf-8"?>
+<p:sld xmlns:a="http://schemas.openxmlformats.org/drawingml/2006/main" xmlns:p="http://schemas.openxmlformats.org/presentationml/2006/main" xmlns:r="http://schemas.openxmlformats.org/officeDocument/2006/relationships">
+  <p:cSld>
+    <p:spTree>
+      <p:nvGrpSpPr>
+        <p:cNvPr id="1" name=""/>
+        <p:cNvGrpSpPr/>
+        <p:nvPr/>
+      </p:nvGrpSpPr>
+      <p:grpSpPr/>
+      <p:sp>
+        <p:nvSpPr>
+          <p:cNvPr id="2" name="TextBox 1"/>
+          <p:cNvSpPr txBox="1"/>
+          <p:nvPr/>
+        </p:nvSpPr>
+        <p:spPr>
+          <a:xfrm>
+            <a:off x="548640" y="365760"/>
+            <a:ext cx="11064240" cy="1005840"/>
+          </a:xfrm>
+          <a:prstGeom prst="rect">
+            <a:avLst/>
+          </a:prstGeom>
+          <a:noFill/>
+        </p:spPr>
+        <p:txBody>
+          <a:bodyPr wrap="square">
+            <a:spAutoFit/>
+          </a:bodyPr>
+          <a:lstStyle/>
+          <a:p>
+            <a:r>
+              <a:rPr sz="3600" b="1">
+                <a:solidFill>
+                  <a:srgbClr val="5A0A7A"/>
+                </a:solidFill>
+              </a:rPr>
+              <a:t>Solvers as search engines: SEND + MORE = MONEY</a:t>
+            </a:r>
+          </a:p>
+        </p:txBody>
+      </p:sp>
+      <p:sp>
+        <p:nvSpPr>
+          <p:cNvPr id="3" name="TextBox 2"/>
+          <p:cNvSpPr txBox="1"/>
+          <p:nvPr/>
+        </p:nvSpPr>
+        <p:spPr>
+          <a:xfrm>
+            <a:off x="731520" y="1463040"/>
+            <a:ext cx="10789920" cy="5120640"/>
+          </a:xfrm>
+          <a:prstGeom prst="rect">
+            <a:avLst/>
+          </a:prstGeom>
+          <a:noFill/>
+        </p:spPr>
+        <p:txBody>
+          <a:bodyPr wrap="square">
+            <a:spAutoFit/>
+          </a:bodyPr>
+          <a:lstStyle/>
+          <a:p>
+            <a:pPr>
+              <a:spcAft>
+                <a:spcPts val="0"/>
+              </a:spcAft>
+            </a:pPr>
+            <a:r>
+              <a:rPr sz="1800">
+                <a:solidFill>
+                  <a:srgbClr val="212121"/>
+                </a:solidFill>
+                <a:latin typeface="Courier New"/>
+              </a:rPr>
+              <a:t>  S E N D</a:t>
+            </a:r>
+          </a:p>
+          <a:p>
+            <a:pPr>
+              <a:spcAft>
+                <a:spcPts val="0"/>
+              </a:spcAft>
+            </a:pPr>
+            <a:r>
+              <a:rPr sz="1800">
+                <a:solidFill>
+                  <a:srgbClr val="212121"/>
+                </a:solidFill>
+                <a:latin typeface="Courier New"/>
+              </a:rPr>
+              <a:t>+ M O R E</a:t>
+            </a:r>
+          </a:p>
+          <a:p>
+            <a:pPr>
+              <a:spcAft>
+                <a:spcPts val="0"/>
+              </a:spcAft>
+            </a:pPr>
+            <a:r>
+              <a:rPr sz="1800">
+                <a:solidFill>
+                  <a:srgbClr val="212121"/>
+                </a:solidFill>
+                <a:latin typeface="Courier New"/>
+              </a:rPr>
+              <a:t>---------</a:t>
+            </a:r>
+          </a:p>
+          <a:p>
+            <a:pPr>
+              <a:spcAft>
+                <a:spcPts val="0"/>
+              </a:spcAft>
+            </a:pPr>
+            <a:r>
+              <a:rPr sz="1800">
+                <a:solidFill>
+                  <a:srgbClr val="212121"/>
+                </a:solidFill>
+                <a:latin typeface="Courier New"/>
+              </a:rPr>
+              <a:t>M O N E Y</a:t>
+            </a:r>
+          </a:p>
+          <a:p>
+            <a:pPr>
+              <a:spcAft>
+                <a:spcPts val="800"/>
+              </a:spcAft>
+            </a:pPr>
+            <a:r>
+              <a:rPr sz="2200">
+                <a:solidFill>
+                  <a:srgbClr val="212121"/>
+                </a:solidFill>
+              </a:rPr>
+              <a:t/>
+            </a:r>
+          </a:p>
+          <a:p>
+            <a:pPr>
+              <a:spcAft>
+                <a:spcPts val="800"/>
+              </a:spcAft>
+            </a:pPr>
+            <a:r>
+              <a:rPr sz="2200">
+                <a:solidFill>
+                  <a:srgbClr val="212121"/>
+                </a:solidFill>
+              </a:rPr>
+              <a:t>Eight letters, all different digits, S ≠ 0, M ≠ 0 — about 10⁸ candidate assignments.</a:t>
+            </a:r>
+          </a:p>
+          <a:p>
+            <a:pPr>
+              <a:spcAft>
+                <a:spcPts val="800"/>
+              </a:spcAft>
+            </a:pPr>
+            <a:r>
+              <a:rPr sz="2200">
+                <a:solidFill>
+                  <a:srgbClr val="212121"/>
+                </a:solidFill>
+              </a:rPr>
+              <a:t>Z3 finds the unique solution in well under a second.</a:t>
+            </a:r>
+          </a:p>
+          <a:p>
+            <a:pPr>
+              <a:spcAft>
+                <a:spcPts val="800"/>
+              </a:spcAft>
+            </a:pPr>
+            <a:r>
+              <a:rPr sz="2200">
+                <a:solidFill>
+                  <a:srgbClr val="212121"/>
+                </a:solidFill>
+              </a:rPr>
+              <a:t>The same engine that solves puzzles finds your bugs: a counterexample is just a solution to “break my program”.</a:t>
+            </a:r>
+          </a:p>
+          <a:p>
+            <a:pPr>
+              <a:spcAft>
+                <a:spcPts val="800"/>
+              </a:spcAft>
+            </a:pPr>
+            <a:r>
+              <a:rPr sz="2200">
+                <a:solidFill>
+                  <a:srgbClr val="212121"/>
+                </a:solidFill>
+              </a:rPr>
+              <a:t>Lab 1, Stage 2: you run this yourself.</a:t>
+            </a:r>
+          </a:p>
+        </p:txBody>
+      </p:sp>
+    </p:spTree>
+  </p:cSld>
+  <p:clrMapOvr>
+    <a:masterClrMapping/>
+  </p:clrMapOvr>
+</p:sld>
+</file>
+
+<file path=ppt/slides/slide33.xml><?xml version="1.0" encoding="utf-8"?>
 <p:sld xmlns:a="http://schemas.openxmlformats.org/drawingml/2006/main" xmlns:p="http://schemas.openxmlformats.org/presentationml/2006/main" xmlns:r="http://schemas.openxmlformats.org/officeDocument/2006/relationships">
   <p:cSld>
     <p:spTree>
@@ -9075,7 +9278,7 @@
 </p:sld>
 </file>
 
-<file path=ppt/slides/slide33.xml><?xml version="1.0" encoding="utf-8"?>
+<file path=ppt/slides/slide34.xml><?xml version="1.0" encoding="utf-8"?>
 <p:sld xmlns:a="http://schemas.openxmlformats.org/drawingml/2006/main" xmlns:p="http://schemas.openxmlformats.org/presentationml/2006/main" xmlns:r="http://schemas.openxmlformats.org/officeDocument/2006/relationships">
   <p:cSld>
     <p:spTree>
@@ -9255,7 +9458,7 @@
 </p:sld>
 </file>
 
-<file path=ppt/slides/slide34.xml><?xml version="1.0" encoding="utf-8"?>
+<file path=ppt/slides/slide35.xml><?xml version="1.0" encoding="utf-8"?>
 <p:sld xmlns:a="http://schemas.openxmlformats.org/drawingml/2006/main" xmlns:p="http://schemas.openxmlformats.org/presentationml/2006/main" xmlns:r="http://schemas.openxmlformats.org/officeDocument/2006/relationships">
   <p:cSld>
     <p:spTree>
@@ -9497,7 +9700,7 @@
 </p:sld>
 </file>
 
-<file path=ppt/slides/slide35.xml><?xml version="1.0" encoding="utf-8"?>
+<file path=ppt/slides/slide36.xml><?xml version="1.0" encoding="utf-8"?>
 <p:sld xmlns:a="http://schemas.openxmlformats.org/drawingml/2006/main" xmlns:p="http://schemas.openxmlformats.org/presentationml/2006/main" xmlns:r="http://schemas.openxmlformats.org/officeDocument/2006/relationships">
   <p:cSld>
     <p:spTree>
@@ -9652,171 +9855,6 @@
                 </a:solidFill>
               </a:rPr>
               <a:t>Recognise the three lines? In Lab 1, Stage 3 you translate exactly this function by hand and hand it to Z3. You will be doing ESBMC's job yourself.</a:t>
-            </a:r>
-          </a:p>
-        </p:txBody>
-      </p:sp>
-    </p:spTree>
-  </p:cSld>
-  <p:clrMapOvr>
-    <a:masterClrMapping/>
-  </p:clrMapOvr>
-</p:sld>
-</file>
-
-<file path=ppt/slides/slide36.xml><?xml version="1.0" encoding="utf-8"?>
-<p:sld xmlns:a="http://schemas.openxmlformats.org/drawingml/2006/main" xmlns:p="http://schemas.openxmlformats.org/presentationml/2006/main" xmlns:r="http://schemas.openxmlformats.org/officeDocument/2006/relationships">
-  <p:cSld>
-    <p:spTree>
-      <p:nvGrpSpPr>
-        <p:cNvPr id="1" name=""/>
-        <p:cNvGrpSpPr/>
-        <p:nvPr/>
-      </p:nvGrpSpPr>
-      <p:grpSpPr/>
-      <p:sp>
-        <p:nvSpPr>
-          <p:cNvPr id="2" name="TextBox 1"/>
-          <p:cNvSpPr txBox="1"/>
-          <p:nvPr/>
-        </p:nvSpPr>
-        <p:spPr>
-          <a:xfrm>
-            <a:off x="548640" y="365760"/>
-            <a:ext cx="11064240" cy="1005840"/>
-          </a:xfrm>
-          <a:prstGeom prst="rect">
-            <a:avLst/>
-          </a:prstGeom>
-          <a:noFill/>
-        </p:spPr>
-        <p:txBody>
-          <a:bodyPr wrap="square">
-            <a:spAutoFit/>
-          </a:bodyPr>
-          <a:lstStyle/>
-          <a:p>
-            <a:r>
-              <a:rPr sz="3600" b="1">
-                <a:solidFill>
-                  <a:srgbClr val="5A0A7A"/>
-                </a:solidFill>
-              </a:rPr>
-              <a:t>Putting it together</a:t>
-            </a:r>
-          </a:p>
-        </p:txBody>
-      </p:sp>
-      <p:sp>
-        <p:nvSpPr>
-          <p:cNvPr id="3" name="TextBox 2"/>
-          <p:cNvSpPr txBox="1"/>
-          <p:nvPr/>
-        </p:nvSpPr>
-        <p:spPr>
-          <a:xfrm>
-            <a:off x="731520" y="1737360"/>
-            <a:ext cx="10789920" cy="4846320"/>
-          </a:xfrm>
-          <a:prstGeom prst="rect">
-            <a:avLst/>
-          </a:prstGeom>
-          <a:noFill/>
-        </p:spPr>
-        <p:txBody>
-          <a:bodyPr wrap="square">
-            <a:spAutoFit/>
-          </a:bodyPr>
-          <a:lstStyle/>
-          <a:p>
-            <a:pPr>
-              <a:spcAft>
-                <a:spcPts val="0"/>
-              </a:spcAft>
-            </a:pPr>
-            <a:r>
-              <a:rPr sz="2200">
-                <a:solidFill>
-                  <a:srgbClr val="212121"/>
-                </a:solidFill>
-                <a:latin typeface="Courier New"/>
-              </a:rPr>
-              <a:t>⟦program⟧  ∧  ¬P      →  SMT solver</a:t>
-            </a:r>
-          </a:p>
-          <a:p>
-            <a:pPr>
-              <a:spcAft>
-                <a:spcPts val="800"/>
-              </a:spcAft>
-            </a:pPr>
-            <a:r>
-              <a:rPr sz="2600">
-                <a:solidFill>
-                  <a:srgbClr val="212121"/>
-                </a:solidFill>
-              </a:rPr>
-              <a:t/>
-            </a:r>
-          </a:p>
-          <a:p>
-            <a:pPr>
-              <a:spcAft>
-                <a:spcPts val="800"/>
-              </a:spcAft>
-            </a:pPr>
-            <a:r>
-              <a:rPr sz="2600">
-                <a:solidFill>
-                  <a:srgbClr val="212121"/>
-                </a:solidFill>
-              </a:rPr>
-              <a:t>sat — the model assigns every input and every choice: replayed in program order, that is the counterexample trace.</a:t>
-            </a:r>
-          </a:p>
-          <a:p>
-            <a:pPr>
-              <a:spcAft>
-                <a:spcPts val="800"/>
-              </a:spcAft>
-            </a:pPr>
-            <a:r>
-              <a:rPr sz="2600">
-                <a:solidFill>
-                  <a:srgbClr val="212121"/>
-                </a:solidFill>
-              </a:rPr>
-              <a:t>unsat — no execution within the bound violates P.</a:t>
-            </a:r>
-          </a:p>
-          <a:p>
-            <a:pPr>
-              <a:spcAft>
-                <a:spcPts val="800"/>
-              </a:spcAft>
-            </a:pPr>
-            <a:r>
-              <a:rPr sz="2600">
-                <a:solidFill>
-                  <a:srgbClr val="212121"/>
-                </a:solidFill>
-              </a:rPr>
-              <a:t/>
-            </a:r>
-          </a:p>
-          <a:p>
-            <a:pPr>
-              <a:spcAft>
-                <a:spcPts val="800"/>
-              </a:spcAft>
-            </a:pPr>
-            <a:r>
-              <a:rPr sz="2600">
-                <a:solidFill>
-                  <a:srgbClr val="212121"/>
-                </a:solidFill>
-              </a:rPr>
-              <a:t>One formula, every path at once. That is why nobody has to enumerate 2⁶⁴ test cases.</a:t>
             </a:r>
           </a:p>
         </p:txBody>
@@ -9867,7 +9905,7 @@
                   <a:srgbClr val="5A0A7A"/>
                 </a:solidFill>
               </a:rPr>
-              <a:t>Anatomy of a counterexample</a:t>
+              <a:t>Putting it together</a:t>
             </a:r>
           </a:p>
         </p:txBody>
@@ -9880,8 +9918,8 @@
         </p:nvSpPr>
         <p:spPr>
           <a:xfrm>
-            <a:off x="731520" y="1463040"/>
-            <a:ext cx="10789920" cy="5120640"/>
+            <a:off x="731520" y="1737360"/>
+            <a:ext cx="10789920" cy="4846320"/>
           </a:xfrm>
           <a:prstGeom prst="rect">
             <a:avLst/>
@@ -9900,103 +9938,23 @@
               </a:spcAft>
             </a:pPr>
             <a:r>
-              <a:rPr sz="1800">
+              <a:rPr sz="2200">
                 <a:solidFill>
                   <a:srgbClr val="212121"/>
                 </a:solidFill>
                 <a:latin typeface="Courier New"/>
               </a:rPr>
-              <a:t>State 3  file offbyone.c  line 15</a:t>
-            </a:r>
-          </a:p>
-          <a:p>
-            <a:pPr>
-              <a:spcAft>
-                <a:spcPts val="0"/>
-              </a:spcAft>
-            </a:pPr>
-            <a:r>
-              <a:rPr sz="1800">
-                <a:solidFill>
-                  <a:srgbClr val="212121"/>
-                </a:solidFill>
-                <a:latin typeface="Courier New"/>
-              </a:rPr>
-              <a:t>  i = 5 (00000000 ... 101)      ← the value the solver chose</a:t>
-            </a:r>
-          </a:p>
-          <a:p>
-            <a:pPr>
-              <a:spcAft>
-                <a:spcPts val="0"/>
-              </a:spcAft>
-            </a:pPr>
-            <a:r>
-              <a:rPr sz="1800">
-                <a:solidFill>
-                  <a:srgbClr val="212121"/>
-                </a:solidFill>
-                <a:latin typeface="Courier New"/>
-              </a:rPr>
-              <a:t>...</a:t>
-            </a:r>
-          </a:p>
-          <a:p>
-            <a:pPr>
-              <a:spcAft>
-                <a:spcPts val="0"/>
-              </a:spcAft>
-            </a:pPr>
-            <a:r>
-              <a:rPr sz="1800">
-                <a:solidFill>
-                  <a:srgbClr val="212121"/>
-                </a:solidFill>
-                <a:latin typeface="Courier New"/>
-              </a:rPr>
-              <a:t>Violated property:</a:t>
-            </a:r>
-          </a:p>
-          <a:p>
-            <a:pPr>
-              <a:spcAft>
-                <a:spcPts val="0"/>
-              </a:spcAft>
-            </a:pPr>
-            <a:r>
-              <a:rPr sz="1800">
-                <a:solidFill>
-                  <a:srgbClr val="212121"/>
-                </a:solidFill>
-                <a:latin typeface="Courier New"/>
-              </a:rPr>
-              <a:t>  array bounds violated: a[i]   ← what broke</a:t>
-            </a:r>
-          </a:p>
-          <a:p>
-            <a:pPr>
-              <a:spcAft>
-                <a:spcPts val="0"/>
-              </a:spcAft>
-            </a:pPr>
-            <a:r>
-              <a:rPr sz="1800">
-                <a:solidFill>
-                  <a:srgbClr val="212121"/>
-                </a:solidFill>
-                <a:latin typeface="Courier New"/>
-              </a:rPr>
-              <a:t>  CWE: CWE-787                   ← the vulnerability class</a:t>
-            </a:r>
-          </a:p>
-          <a:p>
-            <a:pPr>
-              <a:spcAft>
-                <a:spcPts val="800"/>
-              </a:spcAft>
-            </a:pPr>
-            <a:r>
-              <a:rPr sz="2200">
+              <a:t>⟦program⟧  ∧  ¬P      →  SMT solver</a:t>
+            </a:r>
+          </a:p>
+          <a:p>
+            <a:pPr>
+              <a:spcAft>
+                <a:spcPts val="800"/>
+              </a:spcAft>
+            </a:pPr>
+            <a:r>
+              <a:rPr sz="2600">
                 <a:solidFill>
                   <a:srgbClr val="212121"/>
                 </a:solidFill>
@@ -10011,27 +9969,57 @@
               </a:spcAft>
             </a:pPr>
             <a:r>
-              <a:rPr sz="2200">
-                <a:solidFill>
-                  <a:srgbClr val="212121"/>
-                </a:solidFill>
-              </a:rPr>
-              <a:t>Read it bottom-up: first what was violated, then scroll up for the values that caused it.</a:t>
-            </a:r>
-          </a:p>
-          <a:p>
-            <a:pPr>
-              <a:spcAft>
-                <a:spcPts val="800"/>
-              </a:spcAft>
-            </a:pPr>
-            <a:r>
-              <a:rPr sz="2200">
-                <a:solidFill>
-                  <a:srgbClr val="212121"/>
-                </a:solidFill>
-              </a:rPr>
-              <a:t>Those values are a ready-made failing test case — keep them.</a:t>
+              <a:rPr sz="2600">
+                <a:solidFill>
+                  <a:srgbClr val="212121"/>
+                </a:solidFill>
+              </a:rPr>
+              <a:t>sat — the model assigns every input and every choice: replayed in program order, that is the counterexample trace.</a:t>
+            </a:r>
+          </a:p>
+          <a:p>
+            <a:pPr>
+              <a:spcAft>
+                <a:spcPts val="800"/>
+              </a:spcAft>
+            </a:pPr>
+            <a:r>
+              <a:rPr sz="2600">
+                <a:solidFill>
+                  <a:srgbClr val="212121"/>
+                </a:solidFill>
+              </a:rPr>
+              <a:t>unsat — no execution within the bound violates P.</a:t>
+            </a:r>
+          </a:p>
+          <a:p>
+            <a:pPr>
+              <a:spcAft>
+                <a:spcPts val="800"/>
+              </a:spcAft>
+            </a:pPr>
+            <a:r>
+              <a:rPr sz="2600">
+                <a:solidFill>
+                  <a:srgbClr val="212121"/>
+                </a:solidFill>
+              </a:rPr>
+              <a:t/>
+            </a:r>
+          </a:p>
+          <a:p>
+            <a:pPr>
+              <a:spcAft>
+                <a:spcPts val="800"/>
+              </a:spcAft>
+            </a:pPr>
+            <a:r>
+              <a:rPr sz="2600">
+                <a:solidFill>
+                  <a:srgbClr val="212121"/>
+                </a:solidFill>
+              </a:rPr>
+              <a:t>One formula, every path at once. That is why nobody has to enumerate 2⁶⁴ test cases.</a:t>
             </a:r>
           </a:p>
         </p:txBody>
@@ -10082,7 +10070,7 @@
                   <a:srgbClr val="5A0A7A"/>
                 </a:solidFill>
               </a:rPr>
-              <a:t>Live: the whole pipeline on five lines</a:t>
+              <a:t>Anatomy of a counterexample</a:t>
             </a:r>
           </a:p>
         </p:txBody>
@@ -10121,7 +10109,7 @@
                 </a:solidFill>
                 <a:latin typeface="Courier New"/>
               </a:rPr>
-              <a:t>int main(void)</a:t>
+              <a:t>State 3  file offbyone.c  line 15</a:t>
             </a:r>
           </a:p>
           <a:p>
@@ -10137,7 +10125,7 @@
                 </a:solidFill>
                 <a:latin typeface="Courier New"/>
               </a:rPr>
-              <a:t>{</a:t>
+              <a:t>  i = 5 (00000000 ... 101)      ← the value the solver chose</a:t>
             </a:r>
           </a:p>
           <a:p>
@@ -10153,7 +10141,7 @@
                 </a:solidFill>
                 <a:latin typeface="Courier New"/>
               </a:rPr>
-              <a:t>  int a[5];</a:t>
+              <a:t>...</a:t>
             </a:r>
           </a:p>
           <a:p>
@@ -10169,7 +10157,7 @@
                 </a:solidFill>
                 <a:latin typeface="Courier New"/>
               </a:rPr>
-              <a:t>  for (int i = 0; i &lt;= 5; i++)</a:t>
+              <a:t>Violated property:</a:t>
             </a:r>
           </a:p>
           <a:p>
@@ -10185,7 +10173,7 @@
                 </a:solidFill>
                 <a:latin typeface="Courier New"/>
               </a:rPr>
-              <a:t>    a[i] = i;</a:t>
+              <a:t>  array bounds violated: a[i]   ← what broke</a:t>
             </a:r>
           </a:p>
           <a:p>
@@ -10201,21 +10189,20 @@
                 </a:solidFill>
                 <a:latin typeface="Courier New"/>
               </a:rPr>
-              <a:t>}</a:t>
-            </a:r>
-          </a:p>
-          <a:p>
-            <a:pPr>
-              <a:spcAft>
-                <a:spcPts val="0"/>
-              </a:spcAft>
-            </a:pPr>
-            <a:r>
-              <a:rPr sz="1800">
-                <a:solidFill>
-                  <a:srgbClr val="212121"/>
-                </a:solidFill>
-                <a:latin typeface="Courier New"/>
+              <a:t>  CWE: CWE-787                   ← the vulnerability class</a:t>
+            </a:r>
+          </a:p>
+          <a:p>
+            <a:pPr>
+              <a:spcAft>
+                <a:spcPts val="800"/>
+              </a:spcAft>
+            </a:pPr>
+            <a:r>
+              <a:rPr sz="2200">
+                <a:solidFill>
+                  <a:srgbClr val="212121"/>
+                </a:solidFill>
               </a:rPr>
               <a:t/>
             </a:r>
@@ -10223,22 +10210,6 @@
           <a:p>
             <a:pPr>
               <a:spcAft>
-                <a:spcPts val="0"/>
-              </a:spcAft>
-            </a:pPr>
-            <a:r>
-              <a:rPr sz="1800">
-                <a:solidFill>
-                  <a:srgbClr val="212121"/>
-                </a:solidFill>
-                <a:latin typeface="Courier New"/>
-              </a:rPr>
-              <a:t>$ esbmc offbyone.c --unwind 7</a:t>
-            </a:r>
-          </a:p>
-          <a:p>
-            <a:pPr>
-              <a:spcAft>
                 <a:spcPts val="800"/>
               </a:spcAft>
             </a:pPr>
@@ -10248,7 +10219,7 @@
                   <a:srgbClr val="212121"/>
                 </a:solidFill>
               </a:rPr>
-              <a:t/>
+              <a:t>Read it bottom-up: first what was violated, then scroll up for the values that caused it.</a:t>
             </a:r>
           </a:p>
           <a:p>
@@ -10263,22 +10234,7 @@
                   <a:srgbClr val="212121"/>
                 </a:solidFill>
               </a:rPr>
-              <a:t>Predict first: FAILED or SUCCESSFUL? If FAILED — at which i?</a:t>
-            </a:r>
-          </a:p>
-          <a:p>
-            <a:pPr>
-              <a:spcAft>
-                <a:spcPts val="800"/>
-              </a:spcAft>
-            </a:pPr>
-            <a:r>
-              <a:rPr sz="2200">
-                <a:solidFill>
-                  <a:srgbClr val="212121"/>
-                </a:solidFill>
-              </a:rPr>
-              <a:t>Then we read the trace together, bottom-up.</a:t>
+              <a:t>Those values are a ready-made failing test case — keep them.</a:t>
             </a:r>
           </a:p>
         </p:txBody>
@@ -10329,7 +10285,7 @@
                   <a:srgbClr val="5A0A7A"/>
                 </a:solidFill>
               </a:rPr>
-              <a:t>Modelling the environment: a preview</a:t>
+              <a:t>Live: the whole pipeline on five lines</a:t>
             </a:r>
           </a:p>
         </p:txBody>
@@ -10368,7 +10324,7 @@
                 </a:solidFill>
                 <a:latin typeface="Courier New"/>
               </a:rPr>
-              <a:t>int x = nondet_int();              /* every value at once */</a:t>
+              <a:t>int main(void)</a:t>
             </a:r>
           </a:p>
           <a:p>
@@ -10384,7 +10340,7 @@
                 </a:solidFill>
                 <a:latin typeface="Courier New"/>
               </a:rPr>
-              <a:t>__ESBMC_assume(x &gt; 0 &amp;&amp; x &lt; 100);  /* now: every value in 1..99 */</a:t>
+              <a:t>{</a:t>
             </a:r>
           </a:p>
           <a:p>
@@ -10400,7 +10356,87 @@
                 </a:solidFill>
                 <a:latin typeface="Courier New"/>
               </a:rPr>
-              <a:t>assert(property(x));               /* must hold for ALL of them */</a:t>
+              <a:t>  int a[5];</a:t>
+            </a:r>
+          </a:p>
+          <a:p>
+            <a:pPr>
+              <a:spcAft>
+                <a:spcPts val="0"/>
+              </a:spcAft>
+            </a:pPr>
+            <a:r>
+              <a:rPr sz="1800">
+                <a:solidFill>
+                  <a:srgbClr val="212121"/>
+                </a:solidFill>
+                <a:latin typeface="Courier New"/>
+              </a:rPr>
+              <a:t>  for (int i = 0; i &lt;= 5; i++)</a:t>
+            </a:r>
+          </a:p>
+          <a:p>
+            <a:pPr>
+              <a:spcAft>
+                <a:spcPts val="0"/>
+              </a:spcAft>
+            </a:pPr>
+            <a:r>
+              <a:rPr sz="1800">
+                <a:solidFill>
+                  <a:srgbClr val="212121"/>
+                </a:solidFill>
+                <a:latin typeface="Courier New"/>
+              </a:rPr>
+              <a:t>    a[i] = i;</a:t>
+            </a:r>
+          </a:p>
+          <a:p>
+            <a:pPr>
+              <a:spcAft>
+                <a:spcPts val="0"/>
+              </a:spcAft>
+            </a:pPr>
+            <a:r>
+              <a:rPr sz="1800">
+                <a:solidFill>
+                  <a:srgbClr val="212121"/>
+                </a:solidFill>
+                <a:latin typeface="Courier New"/>
+              </a:rPr>
+              <a:t>}</a:t>
+            </a:r>
+          </a:p>
+          <a:p>
+            <a:pPr>
+              <a:spcAft>
+                <a:spcPts val="0"/>
+              </a:spcAft>
+            </a:pPr>
+            <a:r>
+              <a:rPr sz="1800">
+                <a:solidFill>
+                  <a:srgbClr val="212121"/>
+                </a:solidFill>
+                <a:latin typeface="Courier New"/>
+              </a:rPr>
+              <a:t/>
+            </a:r>
+          </a:p>
+          <a:p>
+            <a:pPr>
+              <a:spcAft>
+                <a:spcPts val="0"/>
+              </a:spcAft>
+            </a:pPr>
+            <a:r>
+              <a:rPr sz="1800">
+                <a:solidFill>
+                  <a:srgbClr val="212121"/>
+                </a:solidFill>
+                <a:latin typeface="Courier New"/>
+              </a:rPr>
+              <a:t>$ esbmc offbyone.c --unwind 7</a:t>
             </a:r>
           </a:p>
           <a:p>
@@ -10430,7 +10466,7 @@
                   <a:srgbClr val="212121"/>
                 </a:solidFill>
               </a:rPr>
-              <a:t>One nondeterministic input = all tests of that input at once.</a:t>
+              <a:t>Predict first: FAILED or SUCCESSFUL? If FAILED — at which i?</a:t>
             </a:r>
           </a:p>
           <a:p>
@@ -10445,7 +10481,7 @@
                   <a:srgbClr val="212121"/>
                 </a:solidFill>
               </a:rPr>
-              <a:t>In Session 2 you will use these three lines to expose a bug in a program that verifies green as shipped — the tool only checks what you specify.</a:t>
+              <a:t>Then we read the trace together, bottom-up.</a:t>
             </a:r>
           </a:p>
         </p:txBody>
@@ -10690,7 +10726,7 @@
                   <a:srgbClr val="5A0A7A"/>
                 </a:solidFill>
               </a:rPr>
-              <a:t>Beyond one thread</a:t>
+              <a:t>Modelling the environment: a preview</a:t>
             </a:r>
           </a:p>
         </p:txBody>
@@ -10703,8 +10739,8 @@
         </p:nvSpPr>
         <p:spPr>
           <a:xfrm>
-            <a:off x="731520" y="1645920"/>
-            <a:ext cx="10789920" cy="4937760"/>
+            <a:off x="731520" y="1463040"/>
+            <a:ext cx="10789920" cy="5120640"/>
           </a:xfrm>
           <a:prstGeom prst="rect">
             <a:avLst/>
@@ -10719,56 +10755,59 @@
           <a:p>
             <a:pPr>
               <a:spcAft>
-                <a:spcPts val="800"/>
-              </a:spcAft>
-            </a:pPr>
-            <a:r>
-              <a:rPr sz="2400">
-                <a:solidFill>
-                  <a:srgbClr val="212121"/>
-                </a:solidFill>
-              </a:rPr>
-              <a:t>Two threads of two and one statements already have three interleavings. Real code has billions.</a:t>
-            </a:r>
-          </a:p>
-          <a:p>
-            <a:pPr>
-              <a:spcAft>
-                <a:spcPts val="800"/>
-              </a:spcAft>
-            </a:pPr>
-            <a:r>
-              <a:rPr sz="2400">
-                <a:solidFill>
-                  <a:srgbClr val="212121"/>
-                </a:solidFill>
-              </a:rPr>
-              <a:t>Run the program a million times and the bad interleaving may never show up — Therac-25's bug hid exactly this way.</a:t>
-            </a:r>
-          </a:p>
-          <a:p>
-            <a:pPr>
-              <a:spcAft>
-                <a:spcPts val="800"/>
-              </a:spcAft>
-            </a:pPr>
-            <a:r>
-              <a:rPr sz="2400">
-                <a:solidFill>
-                  <a:srgbClr val="212121"/>
-                </a:solidFill>
-              </a:rPr>
-              <a:t>A model checker enumerates every interleaving up to a bound, including the one that kills your assertion.</a:t>
-            </a:r>
-          </a:p>
-          <a:p>
-            <a:pPr>
-              <a:spcAft>
-                <a:spcPts val="800"/>
-              </a:spcAft>
-            </a:pPr>
-            <a:r>
-              <a:rPr sz="2400">
+                <a:spcPts val="0"/>
+              </a:spcAft>
+            </a:pPr>
+            <a:r>
+              <a:rPr sz="1800">
+                <a:solidFill>
+                  <a:srgbClr val="212121"/>
+                </a:solidFill>
+                <a:latin typeface="Courier New"/>
+              </a:rPr>
+              <a:t>int x = nondet_int();              /* every value at once */</a:t>
+            </a:r>
+          </a:p>
+          <a:p>
+            <a:pPr>
+              <a:spcAft>
+                <a:spcPts val="0"/>
+              </a:spcAft>
+            </a:pPr>
+            <a:r>
+              <a:rPr sz="1800">
+                <a:solidFill>
+                  <a:srgbClr val="212121"/>
+                </a:solidFill>
+                <a:latin typeface="Courier New"/>
+              </a:rPr>
+              <a:t>__ESBMC_assume(x &gt; 0 &amp;&amp; x &lt; 100);  /* now: every value in 1..99 */</a:t>
+            </a:r>
+          </a:p>
+          <a:p>
+            <a:pPr>
+              <a:spcAft>
+                <a:spcPts val="0"/>
+              </a:spcAft>
+            </a:pPr>
+            <a:r>
+              <a:rPr sz="1800">
+                <a:solidFill>
+                  <a:srgbClr val="212121"/>
+                </a:solidFill>
+                <a:latin typeface="Courier New"/>
+              </a:rPr>
+              <a:t>assert(property(x));               /* must hold for ALL of them */</a:t>
+            </a:r>
+          </a:p>
+          <a:p>
+            <a:pPr>
+              <a:spcAft>
+                <a:spcPts val="800"/>
+              </a:spcAft>
+            </a:pPr>
+            <a:r>
+              <a:rPr sz="2200">
                 <a:solidFill>
                   <a:srgbClr val="212121"/>
                 </a:solidFill>
@@ -10783,12 +10822,27 @@
               </a:spcAft>
             </a:pPr>
             <a:r>
-              <a:rPr sz="2400">
-                <a:solidFill>
-                  <a:srgbClr val="212121"/>
-                </a:solidFill>
-              </a:rPr>
-              <a:t>Session 2, Lab 4: you write down the killer interleaving before the tool finds it.</a:t>
+              <a:rPr sz="2200">
+                <a:solidFill>
+                  <a:srgbClr val="212121"/>
+                </a:solidFill>
+              </a:rPr>
+              <a:t>One nondeterministic input = all tests of that input at once.</a:t>
+            </a:r>
+          </a:p>
+          <a:p>
+            <a:pPr>
+              <a:spcAft>
+                <a:spcPts val="800"/>
+              </a:spcAft>
+            </a:pPr>
+            <a:r>
+              <a:rPr sz="2200">
+                <a:solidFill>
+                  <a:srgbClr val="212121"/>
+                </a:solidFill>
+              </a:rPr>
+              <a:t>In Session 2 you will use these three lines to expose a bug in a program that verifies green as shipped — the tool only checks what you specify.</a:t>
             </a:r>
           </a:p>
         </p:txBody>
@@ -10839,7 +10893,7 @@
                   <a:srgbClr val="5A0A7A"/>
                 </a:solidFill>
               </a:rPr>
-              <a:t>Homework for your intuition</a:t>
+              <a:t>Beyond one thread</a:t>
             </a:r>
           </a:p>
         </p:txBody>
@@ -10852,8 +10906,8 @@
         </p:nvSpPr>
         <p:spPr>
           <a:xfrm>
-            <a:off x="731520" y="1828800"/>
-            <a:ext cx="10789920" cy="4754880"/>
+            <a:off x="731520" y="1645920"/>
+            <a:ext cx="10789920" cy="4937760"/>
           </a:xfrm>
           <a:prstGeom prst="rect">
             <a:avLst/>
@@ -10868,43 +10922,56 @@
           <a:p>
             <a:pPr>
               <a:spcAft>
-                <a:spcPts val="0"/>
-              </a:spcAft>
-            </a:pPr>
-            <a:r>
-              <a:rPr sz="2200">
-                <a:solidFill>
-                  <a:srgbClr val="212121"/>
-                </a:solidFill>
-                <a:latin typeface="Courier New"/>
-              </a:rPr>
-              <a:t>double w = 0.1 + 0.2;</a:t>
-            </a:r>
-          </a:p>
-          <a:p>
-            <a:pPr>
-              <a:spcAft>
-                <a:spcPts val="0"/>
-              </a:spcAft>
-            </a:pPr>
-            <a:r>
-              <a:rPr sz="2200">
-                <a:solidFill>
-                  <a:srgbClr val="212121"/>
-                </a:solidFill>
-                <a:latin typeface="Courier New"/>
-              </a:rPr>
-              <a:t>assert(w == 0.3);</a:t>
-            </a:r>
-          </a:p>
-          <a:p>
-            <a:pPr>
-              <a:spcAft>
-                <a:spcPts val="800"/>
-              </a:spcAft>
-            </a:pPr>
-            <a:r>
-              <a:rPr sz="2600">
+                <a:spcPts val="800"/>
+              </a:spcAft>
+            </a:pPr>
+            <a:r>
+              <a:rPr sz="2400">
+                <a:solidFill>
+                  <a:srgbClr val="212121"/>
+                </a:solidFill>
+              </a:rPr>
+              <a:t>Two threads of two and one statements already have three interleavings. Real code has billions.</a:t>
+            </a:r>
+          </a:p>
+          <a:p>
+            <a:pPr>
+              <a:spcAft>
+                <a:spcPts val="800"/>
+              </a:spcAft>
+            </a:pPr>
+            <a:r>
+              <a:rPr sz="2400">
+                <a:solidFill>
+                  <a:srgbClr val="212121"/>
+                </a:solidFill>
+              </a:rPr>
+              <a:t>Run the program a million times and the bad interleaving may never show up — Therac-25's bug hid exactly this way.</a:t>
+            </a:r>
+          </a:p>
+          <a:p>
+            <a:pPr>
+              <a:spcAft>
+                <a:spcPts val="800"/>
+              </a:spcAft>
+            </a:pPr>
+            <a:r>
+              <a:rPr sz="2400">
+                <a:solidFill>
+                  <a:srgbClr val="212121"/>
+                </a:solidFill>
+              </a:rPr>
+              <a:t>A model checker enumerates every interleaving up to a bound, including the one that kills your assertion.</a:t>
+            </a:r>
+          </a:p>
+          <a:p>
+            <a:pPr>
+              <a:spcAft>
+                <a:spcPts val="800"/>
+              </a:spcAft>
+            </a:pPr>
+            <a:r>
+              <a:rPr sz="2400">
                 <a:solidFill>
                   <a:srgbClr val="212121"/>
                 </a:solidFill>
@@ -10919,57 +10986,12 @@
               </a:spcAft>
             </a:pPr>
             <a:r>
-              <a:rPr sz="2600">
-                <a:solidFill>
-                  <a:srgbClr val="212121"/>
-                </a:solidFill>
-              </a:rPr>
-              <a:t>FAILED or SUCCESSFUL?</a:t>
-            </a:r>
-          </a:p>
-          <a:p>
-            <a:pPr>
-              <a:spcAft>
-                <a:spcPts val="800"/>
-              </a:spcAft>
-            </a:pPr>
-            <a:r>
-              <a:rPr sz="2600">
-                <a:solidFill>
-                  <a:srgbClr val="212121"/>
-                </a:solidFill>
-              </a:rPr>
-              <a:t/>
-            </a:r>
-          </a:p>
-          <a:p>
-            <a:pPr>
-              <a:spcAft>
-                <a:spcPts val="800"/>
-              </a:spcAft>
-            </a:pPr>
-            <a:r>
-              <a:rPr sz="2600">
-                <a:solidFill>
-                  <a:srgbClr val="212121"/>
-                </a:solidFill>
-              </a:rPr>
-              <a:t>Bring your answer to Session 2 — Lab 4 settles it with a solver that does exact IEEE-754 arithmetic.</a:t>
-            </a:r>
-          </a:p>
-          <a:p>
-            <a:pPr lvl="1">
-              <a:spcAft>
-                <a:spcPts val="800"/>
-              </a:spcAft>
-            </a:pPr>
-            <a:r>
               <a:rPr sz="2400">
                 <a:solidFill>
                   <a:srgbClr val="212121"/>
                 </a:solidFill>
               </a:rPr>
-              <a:t>Hint: 0.1 in binary is like 1/3 in decimal.</a:t>
+              <a:t>Session 2, Lab 4: you write down the killer interleaving before the tool finds it.</a:t>
             </a:r>
           </a:p>
         </p:txBody>
@@ -11020,7 +11042,7 @@
                   <a:srgbClr val="5A0A7A"/>
                 </a:solidFill>
               </a:rPr>
-              <a:t>Exercise 2 — Predict the Verdict (15 min)</a:t>
+              <a:t>Homework for your intuition</a:t>
             </a:r>
           </a:p>
         </p:txBody>
@@ -11033,8 +11055,8 @@
         </p:nvSpPr>
         <p:spPr>
           <a:xfrm>
-            <a:off x="731520" y="1463040"/>
-            <a:ext cx="10789920" cy="5120640"/>
+            <a:off x="731520" y="1828800"/>
+            <a:ext cx="10789920" cy="4754880"/>
           </a:xfrm>
           <a:prstGeom prst="rect">
             <a:avLst/>
@@ -11049,7 +11071,7 @@
           <a:p>
             <a:pPr>
               <a:spcAft>
-                <a:spcPts val="800"/>
+                <a:spcPts val="0"/>
               </a:spcAft>
             </a:pPr>
             <a:r>
@@ -11057,14 +11079,15 @@
                 <a:solidFill>
                   <a:srgbClr val="212121"/>
                 </a:solidFill>
-              </a:rPr>
-              <a:t>Groups of 3–4. Three short C programs on the handout (predict1.c, predict2.c, predict3.c).</a:t>
-            </a:r>
-          </a:p>
-          <a:p>
-            <a:pPr>
-              <a:spcAft>
-                <a:spcPts val="800"/>
+                <a:latin typeface="Courier New"/>
+              </a:rPr>
+              <a:t>double w = 0.1 + 0.2;</a:t>
+            </a:r>
+          </a:p>
+          <a:p>
+            <a:pPr>
+              <a:spcAft>
+                <a:spcPts val="0"/>
               </a:spcAft>
             </a:pPr>
             <a:r>
@@ -11072,8 +11095,69 @@
                 <a:solidFill>
                   <a:srgbClr val="212121"/>
                 </a:solidFill>
-              </a:rPr>
-              <a:t>For each program, write down BEFORE we run anything:</a:t>
+                <a:latin typeface="Courier New"/>
+              </a:rPr>
+              <a:t>assert(w == 0.3);</a:t>
+            </a:r>
+          </a:p>
+          <a:p>
+            <a:pPr>
+              <a:spcAft>
+                <a:spcPts val="800"/>
+              </a:spcAft>
+            </a:pPr>
+            <a:r>
+              <a:rPr sz="2600">
+                <a:solidFill>
+                  <a:srgbClr val="212121"/>
+                </a:solidFill>
+              </a:rPr>
+              <a:t/>
+            </a:r>
+          </a:p>
+          <a:p>
+            <a:pPr>
+              <a:spcAft>
+                <a:spcPts val="800"/>
+              </a:spcAft>
+            </a:pPr>
+            <a:r>
+              <a:rPr sz="2600">
+                <a:solidFill>
+                  <a:srgbClr val="212121"/>
+                </a:solidFill>
+              </a:rPr>
+              <a:t>FAILED or SUCCESSFUL?</a:t>
+            </a:r>
+          </a:p>
+          <a:p>
+            <a:pPr>
+              <a:spcAft>
+                <a:spcPts val="800"/>
+              </a:spcAft>
+            </a:pPr>
+            <a:r>
+              <a:rPr sz="2600">
+                <a:solidFill>
+                  <a:srgbClr val="212121"/>
+                </a:solidFill>
+              </a:rPr>
+              <a:t/>
+            </a:r>
+          </a:p>
+          <a:p>
+            <a:pPr>
+              <a:spcAft>
+                <a:spcPts val="800"/>
+              </a:spcAft>
+            </a:pPr>
+            <a:r>
+              <a:rPr sz="2600">
+                <a:solidFill>
+                  <a:srgbClr val="212121"/>
+                </a:solidFill>
+              </a:rPr>
+              <a:t>Bring your answer to Session 2 — Lab 4 settles it with a solver that does exact IEEE-754 arithmetic.</a:t>
             </a:r>
           </a:p>
           <a:p>
@@ -11083,42 +11167,12 @@
               </a:spcAft>
             </a:pPr>
             <a:r>
-              <a:rPr sz="2000">
-                <a:solidFill>
-                  <a:srgbClr val="212121"/>
-                </a:solidFill>
-              </a:rPr>
-              <a:t>Will the model checker say VERIFICATION FAILED or SUCCESSFUL?</a:t>
-            </a:r>
-          </a:p>
-          <a:p>
-            <a:pPr lvl="1">
-              <a:spcAft>
-                <a:spcPts val="800"/>
-              </a:spcAft>
-            </a:pPr>
-            <a:r>
-              <a:rPr sz="2000">
-                <a:solidFill>
-                  <a:srgbClr val="212121"/>
-                </a:solidFill>
-              </a:rPr>
-              <a:t>If FAILED — which line is the culprit?</a:t>
-            </a:r>
-          </a:p>
-          <a:p>
-            <a:pPr>
-              <a:spcAft>
-                <a:spcPts val="800"/>
-              </a:spcAft>
-            </a:pPr>
-            <a:r>
-              <a:rPr sz="2200">
-                <a:solidFill>
-                  <a:srgbClr val="212121"/>
-                </a:solidFill>
-              </a:rPr>
-              <a:t>Then we run ESBMC live and settle every bet.</a:t>
+              <a:rPr sz="2400">
+                <a:solidFill>
+                  <a:srgbClr val="212121"/>
+                </a:solidFill>
+              </a:rPr>
+              <a:t>Hint: 0.1 in binary is like 1/3 in decimal.</a:t>
             </a:r>
           </a:p>
         </p:txBody>
@@ -11169,7 +11223,7 @@
                   <a:srgbClr val="5A0A7A"/>
                 </a:solidFill>
               </a:rPr>
-              <a:t>Who uses this? — Model checking</a:t>
+              <a:t>Exercise 2 — Predict the Verdict (15 min)</a:t>
             </a:r>
           </a:p>
         </p:txBody>
@@ -11207,7 +11261,7 @@
                   <a:srgbClr val="212121"/>
                 </a:solidFill>
               </a:rPr>
-              <a:t>Amazon Web Services — CBMC proves memory safety of the TLS library s2n; bounded proofs run in CI on every commit</a:t>
+              <a:t>Groups of 3–4. Three short C programs on the handout (predict1.c, predict2.c, predict3.c).</a:t>
             </a:r>
           </a:p>
           <a:p>
@@ -11222,7 +11276,37 @@
                   <a:srgbClr val="212121"/>
                 </a:solidFill>
               </a:rPr>
-              <a:t>ESBMC / CBMC — the tools from tonight's demos; compete yearly in SV-COMP on tens of thousands of benchmarks</a:t>
+              <a:t>For each program, write down BEFORE we run anything:</a:t>
+            </a:r>
+          </a:p>
+          <a:p>
+            <a:pPr lvl="1">
+              <a:spcAft>
+                <a:spcPts val="800"/>
+              </a:spcAft>
+            </a:pPr>
+            <a:r>
+              <a:rPr sz="2000">
+                <a:solidFill>
+                  <a:srgbClr val="212121"/>
+                </a:solidFill>
+              </a:rPr>
+              <a:t>Will the model checker say VERIFICATION FAILED or SUCCESSFUL?</a:t>
+            </a:r>
+          </a:p>
+          <a:p>
+            <a:pPr lvl="1">
+              <a:spcAft>
+                <a:spcPts val="800"/>
+              </a:spcAft>
+            </a:pPr>
+            <a:r>
+              <a:rPr sz="2000">
+                <a:solidFill>
+                  <a:srgbClr val="212121"/>
+                </a:solidFill>
+              </a:rPr>
+              <a:t>If FAILED — which line is the culprit?</a:t>
             </a:r>
           </a:p>
           <a:p>
@@ -11237,7 +11321,7 @@
                   <a:srgbClr val="212121"/>
                 </a:solidFill>
               </a:rPr>
-              <a:t>The counterexample you saw for getpassword.c is the same artefact AWS engineers read when a proof fails</a:t>
+              <a:t>Then we run ESBMC live and settle every bet.</a:t>
             </a:r>
           </a:p>
         </p:txBody>
@@ -11288,7 +11372,7 @@
                   <a:srgbClr val="5A0A7A"/>
                 </a:solidFill>
               </a:rPr>
-              <a:t>Who uses this? — Symbolic execution &amp; fuzzing</a:t>
+              <a:t>Who uses this? — Model checking</a:t>
             </a:r>
           </a:p>
         </p:txBody>
@@ -11326,7 +11410,7 @@
                   <a:srgbClr val="212121"/>
                 </a:solidFill>
               </a:rPr>
-              <a:t>KLEE found 56 serious bugs in coreutils, busybox and Minix — including three in coreutils that had survived 15 years of testing</a:t>
+              <a:t>Amazon Web Services — CBMC proves memory safety of the TLS library s2n; bounded proofs run in CI on every commit</a:t>
             </a:r>
           </a:p>
           <a:p>
@@ -11341,7 +11425,7 @@
                   <a:srgbClr val="212121"/>
                 </a:solidFill>
               </a:rPr>
-              <a:t>Microsoft SAGE fuzzed Windows file parsers with symbolic execution; it found ~1/3 of all bugs caught by file fuzzing during Windows 7 development — running last, after every other tool</a:t>
+              <a:t>ESBMC / CBMC — the tools from tonight's demos; compete yearly in SV-COMP on tens of thousands of benchmarks</a:t>
             </a:r>
           </a:p>
           <a:p>
@@ -11356,22 +11440,7 @@
                   <a:srgbClr val="212121"/>
                 </a:solidFill>
               </a:rPr>
-              <a:t>AFL / OSS-Fuzz — Google fuzzes ~1,000 open-source projects continuously; tens of thousands of bugs found</a:t>
-            </a:r>
-          </a:p>
-          <a:p>
-            <a:pPr>
-              <a:spcAft>
-                <a:spcPts val="800"/>
-              </a:spcAft>
-            </a:pPr>
-            <a:r>
-              <a:rPr sz="2200">
-                <a:solidFill>
-                  <a:srgbClr val="212121"/>
-                </a:solidFill>
-              </a:rPr>
-              <a:t>The pragmatic cousin of verification: no proofs, ruthless effectiveness</a:t>
+              <a:t>The counterexample you saw for getpassword.c is the same artefact AWS engineers read when a proof fails</a:t>
             </a:r>
           </a:p>
         </p:txBody>
@@ -11422,7 +11491,7 @@
                   <a:srgbClr val="5A0A7A"/>
                 </a:solidFill>
               </a:rPr>
-              <a:t>Who uses this? — Proofs all the way up</a:t>
+              <a:t>Who uses this? — Symbolic execution &amp; fuzzing</a:t>
             </a:r>
           </a:p>
         </p:txBody>
@@ -11460,7 +11529,7 @@
                   <a:srgbClr val="212121"/>
                 </a:solidFill>
               </a:rPr>
-              <a:t>Astrée (abstract interpretation) proved absence of runtime errors in the Airbus A340 fly-by-wire code — 132,000 lines of C — and was then applied to the A380</a:t>
+              <a:t>KLEE found 56 serious bugs in coreutils, busybox and Minix — including three in coreutils that had survived 15 years of testing</a:t>
             </a:r>
           </a:p>
           <a:p>
@@ -11475,7 +11544,7 @@
                   <a:srgbClr val="212121"/>
                 </a:solidFill>
               </a:rPr>
-              <a:t>seL4 — an OS microkernel with a machine-checked proof of functional correctness</a:t>
+              <a:t>Microsoft SAGE fuzzed Windows file parsers with symbolic execution; it found ~1/3 of all bugs caught by file fuzzing during Windows 7 development — running last, after every other tool</a:t>
             </a:r>
           </a:p>
           <a:p>
@@ -11490,7 +11559,22 @@
                   <a:srgbClr val="212121"/>
                 </a:solidFill>
               </a:rPr>
-              <a:t>CompCert — a C compiler with a proof that compilation preserves semantics; six CPU-years of fuzzing found no wrong-code bugs in its verified core, while every other compiler tested failed</a:t>
+              <a:t>AFL / OSS-Fuzz — Google fuzzes ~1,000 open-source projects continuously; tens of thousands of bugs found</a:t>
+            </a:r>
+          </a:p>
+          <a:p>
+            <a:pPr>
+              <a:spcAft>
+                <a:spcPts val="800"/>
+              </a:spcAft>
+            </a:pPr>
+            <a:r>
+              <a:rPr sz="2200">
+                <a:solidFill>
+                  <a:srgbClr val="212121"/>
+                </a:solidFill>
+              </a:rPr>
+              <a:t>The pragmatic cousin of verification: no proofs, ruthless effectiveness</a:t>
             </a:r>
           </a:p>
         </p:txBody>
@@ -11541,7 +11625,7 @@
                   <a:srgbClr val="5A0A7A"/>
                 </a:solidFill>
               </a:rPr>
-              <a:t>Discussion</a:t>
+              <a:t>Who uses this? — Proofs all the way up</a:t>
             </a:r>
           </a:p>
         </p:txBody>
@@ -11554,8 +11638,8 @@
         </p:nvSpPr>
         <p:spPr>
           <a:xfrm>
-            <a:off x="731520" y="2194560"/>
-            <a:ext cx="10789920" cy="4389120"/>
+            <a:off x="731520" y="1463040"/>
+            <a:ext cx="10789920" cy="5120640"/>
           </a:xfrm>
           <a:prstGeom prst="rect">
             <a:avLst/>
@@ -11574,42 +11658,42 @@
               </a:spcAft>
             </a:pPr>
             <a:r>
-              <a:rPr sz="2800">
-                <a:solidFill>
-                  <a:srgbClr val="212121"/>
-                </a:solidFill>
-              </a:rPr>
-              <a:t>If verification can prove the absence of bugs…</a:t>
-            </a:r>
-          </a:p>
-          <a:p>
-            <a:pPr>
-              <a:spcAft>
-                <a:spcPts val="800"/>
-              </a:spcAft>
-            </a:pPr>
-            <a:r>
-              <a:rPr sz="2800">
-                <a:solidFill>
-                  <a:srgbClr val="212121"/>
-                </a:solidFill>
-              </a:rPr>
-              <a:t>why isn't all software verified?</a:t>
-            </a:r>
-          </a:p>
-          <a:p>
-            <a:pPr>
-              <a:spcAft>
-                <a:spcPts val="800"/>
-              </a:spcAft>
-            </a:pPr>
-            <a:r>
-              <a:rPr sz="2800">
-                <a:solidFill>
-                  <a:srgbClr val="212121"/>
-                </a:solidFill>
-              </a:rPr>
-              <a:t>(Let's collect reasons — then I'll tell you which ones the industry actually cites.)</a:t>
+              <a:rPr sz="2200">
+                <a:solidFill>
+                  <a:srgbClr val="212121"/>
+                </a:solidFill>
+              </a:rPr>
+              <a:t>Astrée (abstract interpretation) proved absence of runtime errors in the Airbus A340 fly-by-wire code — 132,000 lines of C — and was then applied to the A380</a:t>
+            </a:r>
+          </a:p>
+          <a:p>
+            <a:pPr>
+              <a:spcAft>
+                <a:spcPts val="800"/>
+              </a:spcAft>
+            </a:pPr>
+            <a:r>
+              <a:rPr sz="2200">
+                <a:solidFill>
+                  <a:srgbClr val="212121"/>
+                </a:solidFill>
+              </a:rPr>
+              <a:t>seL4 — an OS microkernel with a machine-checked proof of functional correctness</a:t>
+            </a:r>
+          </a:p>
+          <a:p>
+            <a:pPr>
+              <a:spcAft>
+                <a:spcPts val="800"/>
+              </a:spcAft>
+            </a:pPr>
+            <a:r>
+              <a:rPr sz="2200">
+                <a:solidFill>
+                  <a:srgbClr val="212121"/>
+                </a:solidFill>
+              </a:rPr>
+              <a:t>CompCert — a C compiler with a proof that compilation preserves semantics; six CPU-years of fuzzing found no wrong-code bugs in its verified core, while every other compiler tested failed</a:t>
             </a:r>
           </a:p>
         </p:txBody>
@@ -11660,6 +11744,125 @@
                   <a:srgbClr val="5A0A7A"/>
                 </a:solidFill>
               </a:rPr>
+              <a:t>Discussion</a:t>
+            </a:r>
+          </a:p>
+        </p:txBody>
+      </p:sp>
+      <p:sp>
+        <p:nvSpPr>
+          <p:cNvPr id="3" name="TextBox 2"/>
+          <p:cNvSpPr txBox="1"/>
+          <p:nvPr/>
+        </p:nvSpPr>
+        <p:spPr>
+          <a:xfrm>
+            <a:off x="731520" y="2194560"/>
+            <a:ext cx="10789920" cy="4389120"/>
+          </a:xfrm>
+          <a:prstGeom prst="rect">
+            <a:avLst/>
+          </a:prstGeom>
+          <a:noFill/>
+        </p:spPr>
+        <p:txBody>
+          <a:bodyPr wrap="square">
+            <a:spAutoFit/>
+          </a:bodyPr>
+          <a:lstStyle/>
+          <a:p>
+            <a:pPr>
+              <a:spcAft>
+                <a:spcPts val="800"/>
+              </a:spcAft>
+            </a:pPr>
+            <a:r>
+              <a:rPr sz="2800">
+                <a:solidFill>
+                  <a:srgbClr val="212121"/>
+                </a:solidFill>
+              </a:rPr>
+              <a:t>If verification can prove the absence of bugs…</a:t>
+            </a:r>
+          </a:p>
+          <a:p>
+            <a:pPr>
+              <a:spcAft>
+                <a:spcPts val="800"/>
+              </a:spcAft>
+            </a:pPr>
+            <a:r>
+              <a:rPr sz="2800">
+                <a:solidFill>
+                  <a:srgbClr val="212121"/>
+                </a:solidFill>
+              </a:rPr>
+              <a:t>why isn't all software verified?</a:t>
+            </a:r>
+          </a:p>
+          <a:p>
+            <a:pPr>
+              <a:spcAft>
+                <a:spcPts val="800"/>
+              </a:spcAft>
+            </a:pPr>
+            <a:r>
+              <a:rPr sz="2800">
+                <a:solidFill>
+                  <a:srgbClr val="212121"/>
+                </a:solidFill>
+              </a:rPr>
+              <a:t>(Let's collect reasons — then I'll tell you which ones the industry actually cites.)</a:t>
+            </a:r>
+          </a:p>
+        </p:txBody>
+      </p:sp>
+    </p:spTree>
+  </p:cSld>
+  <p:clrMapOvr>
+    <a:masterClrMapping/>
+  </p:clrMapOvr>
+</p:sld>
+</file>
+
+<file path=ppt/slides/slide48.xml><?xml version="1.0" encoding="utf-8"?>
+<p:sld xmlns:a="http://schemas.openxmlformats.org/drawingml/2006/main" xmlns:p="http://schemas.openxmlformats.org/presentationml/2006/main" xmlns:r="http://schemas.openxmlformats.org/officeDocument/2006/relationships">
+  <p:cSld>
+    <p:spTree>
+      <p:nvGrpSpPr>
+        <p:cNvPr id="1" name=""/>
+        <p:cNvGrpSpPr/>
+        <p:nvPr/>
+      </p:nvGrpSpPr>
+      <p:grpSpPr/>
+      <p:sp>
+        <p:nvSpPr>
+          <p:cNvPr id="2" name="TextBox 1"/>
+          <p:cNvSpPr txBox="1"/>
+          <p:nvPr/>
+        </p:nvSpPr>
+        <p:spPr>
+          <a:xfrm>
+            <a:off x="548640" y="365760"/>
+            <a:ext cx="11064240" cy="1005840"/>
+          </a:xfrm>
+          <a:prstGeom prst="rect">
+            <a:avLst/>
+          </a:prstGeom>
+          <a:noFill/>
+        </p:spPr>
+        <p:txBody>
+          <a:bodyPr wrap="square">
+            <a:spAutoFit/>
+          </a:bodyPr>
+          <a:lstStyle/>
+          <a:p>
+            <a:r>
+              <a:rPr sz="3600" b="1">
+                <a:solidFill>
+                  <a:srgbClr val="5A0A7A"/>
+                </a:solidFill>
+              </a:rPr>
               <a:t>Closing quiz</a:t>
             </a:r>
           </a:p>
@@ -11771,7 +11974,7 @@
 </p:sld>
 </file>
 
-<file path=ppt/slides/slide48.xml><?xml version="1.0" encoding="utf-8"?>
+<file path=ppt/slides/slide49.xml><?xml version="1.0" encoding="utf-8"?>
 <p:sld xmlns:a="http://schemas.openxmlformats.org/drawingml/2006/main" xmlns:p="http://schemas.openxmlformats.org/presentationml/2006/main" xmlns:r="http://schemas.openxmlformats.org/officeDocument/2006/relationships">
   <p:cSld>
     <p:spTree>

</xml_diff>

<commit_message>
Fix the SEND+MORE=MONEY search-space count
The old line listed 'all different digits' next to 10^8, which is the count
*without* distinctness (8 letters x 10 digits with repetition) — a ~70x
overcount. Reframe 10^8 as the naive count, then show the constraints cut it
to ~1.5 million (10x9x8x7x6x5x4x3 minus leading zeros), and name the unique
solution 9567+1085=10652.
</commit_message>
<xml_diff>
--- a/slides/session1/01-session1-fundamentals.pptx
+++ b/slides/session1/01-session1-fundamentals.pptx
@@ -8648,7 +8648,7 @@
                   <a:srgbClr val="212121"/>
                 </a:solidFill>
               </a:rPr>
-              <a:t>Eight letters, all different digits, S ≠ 0, M ≠ 0 — about 10⁸ candidate assignments.</a:t>
+              <a:t>Eight letters, ten digits — naïvely 10⁸ ways to fill them in. “All different, S ≠ 0, M ≠ 0” cuts that to about 1.5 million — still far too many to eyeball.</a:t>
             </a:r>
           </a:p>
           <a:p>
@@ -8663,7 +8663,7 @@
                   <a:srgbClr val="212121"/>
                 </a:solidFill>
               </a:rPr>
-              <a:t>Z3 finds the unique solution in well under a second.</a:t>
+              <a:t>Z3 finds the unique solution (9567 + 1085 = 10652) in well under a second.</a:t>
             </a:r>
           </a:p>
           <a:p>

</xml_diff>

<commit_message>
Expand SEND+MORE=MONEY into a three-slide step-by-step build
Split the dense single slide into: the substitution puzzle (what's unknown is
the digit per letter), 'Turn the puzzle into arithmetic' (place-value encoding,
distinctness, no leading zero, why M=1), and 'Let the solver search' (search
space, constraint propagation + backtracking, the unique answer, bug-finding
analogy). Avoid clashing with the BMC pipeline's Step 1/Step 2 by giving the
puzzle slides plain titles. Deck is now 51 slides; update the README run order.
</commit_message>
<xml_diff>
--- a/slides/session1/01-session1-fundamentals.pptx
+++ b/slides/session1/01-session1-fundamentals.pptx
@@ -54,6 +54,8 @@
     <p:sldId id="302" r:id="rId53"/>
     <p:sldId id="303" r:id="rId54"/>
     <p:sldId id="304" r:id="rId55"/>
+    <p:sldId id="305" r:id="rId56"/>
+    <p:sldId id="306" r:id="rId57"/>
   </p:sldIdLst>
   <p:sldSz cx="12191695" cy="6858000" type="screen4x3"/>
   <p:notesSz cx="6858000" cy="9144000"/>
@@ -8648,7 +8650,7 @@
                   <a:srgbClr val="212121"/>
                 </a:solidFill>
               </a:rPr>
-              <a:t>Eight letters, ten digits — naïvely 10⁸ ways to fill them in. “All different, S ≠ 0, M ≠ 0” cuts that to about 1.5 million — still far too many to eyeball.</a:t>
+              <a:t>A substitution puzzle: replace each letter with a digit. Same letter → same digit; different letters → different digits.</a:t>
             </a:r>
           </a:p>
           <a:p>
@@ -8663,7 +8665,7 @@
                   <a:srgbClr val="212121"/>
                 </a:solidFill>
               </a:rPr>
-              <a:t>Z3 finds the unique solution (9567 + 1085 = 10652) in well under a second.</a:t>
+              <a:t>Eight distinct letters — S E N D M O R Y. The words are fixed; what we solve for is the digit hiding behind each letter.</a:t>
             </a:r>
           </a:p>
           <a:p>
@@ -8678,22 +8680,7 @@
                   <a:srgbClr val="212121"/>
                 </a:solidFill>
               </a:rPr>
-              <a:t>The same engine that solves puzzles finds your bugs: a counterexample is just a solution to “break my program”.</a:t>
-            </a:r>
-          </a:p>
-          <a:p>
-            <a:pPr>
-              <a:spcAft>
-                <a:spcPts val="800"/>
-              </a:spcAft>
-            </a:pPr>
-            <a:r>
-              <a:rPr sz="2200">
-                <a:solidFill>
-                  <a:srgbClr val="212121"/>
-                </a:solidFill>
-              </a:rPr>
-              <a:t>Lab 1, Stage 2: you run this yourself.</a:t>
+              <a:t>Goal: find the assignment that makes the addition come out true.</a:t>
             </a:r>
           </a:p>
         </p:txBody>
@@ -8707,6 +8694,383 @@
 </file>
 
 <file path=ppt/slides/slide33.xml><?xml version="1.0" encoding="utf-8"?>
+<p:sld xmlns:a="http://schemas.openxmlformats.org/drawingml/2006/main" xmlns:p="http://schemas.openxmlformats.org/presentationml/2006/main" xmlns:r="http://schemas.openxmlformats.org/officeDocument/2006/relationships">
+  <p:cSld>
+    <p:spTree>
+      <p:nvGrpSpPr>
+        <p:cNvPr id="1" name=""/>
+        <p:cNvGrpSpPr/>
+        <p:nvPr/>
+      </p:nvGrpSpPr>
+      <p:grpSpPr/>
+      <p:sp>
+        <p:nvSpPr>
+          <p:cNvPr id="2" name="TextBox 1"/>
+          <p:cNvSpPr txBox="1"/>
+          <p:nvPr/>
+        </p:nvSpPr>
+        <p:spPr>
+          <a:xfrm>
+            <a:off x="548640" y="365760"/>
+            <a:ext cx="11064240" cy="1005840"/>
+          </a:xfrm>
+          <a:prstGeom prst="rect">
+            <a:avLst/>
+          </a:prstGeom>
+          <a:noFill/>
+        </p:spPr>
+        <p:txBody>
+          <a:bodyPr wrap="square">
+            <a:spAutoFit/>
+          </a:bodyPr>
+          <a:lstStyle/>
+          <a:p>
+            <a:r>
+              <a:rPr sz="3600" b="1">
+                <a:solidFill>
+                  <a:srgbClr val="5A0A7A"/>
+                </a:solidFill>
+              </a:rPr>
+              <a:t>Turn the puzzle into arithmetic</a:t>
+            </a:r>
+          </a:p>
+        </p:txBody>
+      </p:sp>
+      <p:sp>
+        <p:nvSpPr>
+          <p:cNvPr id="3" name="TextBox 2"/>
+          <p:cNvSpPr txBox="1"/>
+          <p:nvPr/>
+        </p:nvSpPr>
+        <p:spPr>
+          <a:xfrm>
+            <a:off x="731520" y="1463040"/>
+            <a:ext cx="10789920" cy="5120640"/>
+          </a:xfrm>
+          <a:prstGeom prst="rect">
+            <a:avLst/>
+          </a:prstGeom>
+          <a:noFill/>
+        </p:spPr>
+        <p:txBody>
+          <a:bodyPr wrap="square">
+            <a:spAutoFit/>
+          </a:bodyPr>
+          <a:lstStyle/>
+          <a:p>
+            <a:pPr>
+              <a:spcAft>
+                <a:spcPts val="800"/>
+              </a:spcAft>
+            </a:pPr>
+            <a:r>
+              <a:rPr sz="2200">
+                <a:solidFill>
+                  <a:srgbClr val="212121"/>
+                </a:solidFill>
+              </a:rPr>
+              <a:t>A word is just its digits times their place value:</a:t>
+            </a:r>
+          </a:p>
+          <a:p>
+            <a:pPr lvl="1">
+              <a:spcAft>
+                <a:spcPts val="0"/>
+              </a:spcAft>
+            </a:pPr>
+            <a:r>
+              <a:rPr sz="1800">
+                <a:solidFill>
+                  <a:srgbClr val="212121"/>
+                </a:solidFill>
+                <a:latin typeface="Courier New"/>
+              </a:rPr>
+              <a:t>SEND  = 1000·S + 100·E + 10·N + D</a:t>
+            </a:r>
+          </a:p>
+          <a:p>
+            <a:pPr lvl="1">
+              <a:spcAft>
+                <a:spcPts val="0"/>
+              </a:spcAft>
+            </a:pPr>
+            <a:r>
+              <a:rPr sz="1800">
+                <a:solidFill>
+                  <a:srgbClr val="212121"/>
+                </a:solidFill>
+                <a:latin typeface="Courier New"/>
+              </a:rPr>
+              <a:t>MORE  = 1000·M + 100·O + 10·R + E</a:t>
+            </a:r>
+          </a:p>
+          <a:p>
+            <a:pPr lvl="1">
+              <a:spcAft>
+                <a:spcPts val="0"/>
+              </a:spcAft>
+            </a:pPr>
+            <a:r>
+              <a:rPr sz="1800">
+                <a:solidFill>
+                  <a:srgbClr val="212121"/>
+                </a:solidFill>
+                <a:latin typeface="Courier New"/>
+              </a:rPr>
+              <a:t>MONEY = 10000·M + 1000·O + 100·N + 10·E + Y</a:t>
+            </a:r>
+          </a:p>
+          <a:p>
+            <a:pPr>
+              <a:spcAft>
+                <a:spcPts val="800"/>
+              </a:spcAft>
+            </a:pPr>
+            <a:r>
+              <a:rPr sz="2200">
+                <a:solidFill>
+                  <a:srgbClr val="212121"/>
+                </a:solidFill>
+              </a:rPr>
+              <a:t/>
+            </a:r>
+          </a:p>
+          <a:p>
+            <a:pPr>
+              <a:spcAft>
+                <a:spcPts val="800"/>
+              </a:spcAft>
+            </a:pPr>
+            <a:r>
+              <a:rPr sz="2200">
+                <a:solidFill>
+                  <a:srgbClr val="212121"/>
+                </a:solidFill>
+              </a:rPr>
+              <a:t>So the whole puzzle becomes one equation:  SEND + MORE = MONEY.</a:t>
+            </a:r>
+          </a:p>
+          <a:p>
+            <a:pPr>
+              <a:spcAft>
+                <a:spcPts val="800"/>
+              </a:spcAft>
+            </a:pPr>
+            <a:r>
+              <a:rPr sz="2200">
+                <a:solidFill>
+                  <a:srgbClr val="212121"/>
+                </a:solidFill>
+              </a:rPr>
+              <a:t>Plus the rules: every letter is a digit 0–9; all eight are different; S ≠ 0 and M ≠ 0 (no number starts with 0).</a:t>
+            </a:r>
+          </a:p>
+          <a:p>
+            <a:pPr>
+              <a:spcAft>
+                <a:spcPts val="800"/>
+              </a:spcAft>
+            </a:pPr>
+            <a:r>
+              <a:rPr sz="2200">
+                <a:solidFill>
+                  <a:srgbClr val="212121"/>
+                </a:solidFill>
+              </a:rPr>
+              <a:t>Why is MONEY five digits? Two 4-digit numbers can carry into a fifth place — and that carry is at most 1, so M = 1 before we even start.</a:t>
+            </a:r>
+          </a:p>
+        </p:txBody>
+      </p:sp>
+    </p:spTree>
+  </p:cSld>
+  <p:clrMapOvr>
+    <a:masterClrMapping/>
+  </p:clrMapOvr>
+</p:sld>
+</file>
+
+<file path=ppt/slides/slide34.xml><?xml version="1.0" encoding="utf-8"?>
+<p:sld xmlns:a="http://schemas.openxmlformats.org/drawingml/2006/main" xmlns:p="http://schemas.openxmlformats.org/presentationml/2006/main" xmlns:r="http://schemas.openxmlformats.org/officeDocument/2006/relationships">
+  <p:cSld>
+    <p:spTree>
+      <p:nvGrpSpPr>
+        <p:cNvPr id="1" name=""/>
+        <p:cNvGrpSpPr/>
+        <p:nvPr/>
+      </p:nvGrpSpPr>
+      <p:grpSpPr/>
+      <p:sp>
+        <p:nvSpPr>
+          <p:cNvPr id="2" name="TextBox 1"/>
+          <p:cNvSpPr txBox="1"/>
+          <p:nvPr/>
+        </p:nvSpPr>
+        <p:spPr>
+          <a:xfrm>
+            <a:off x="548640" y="365760"/>
+            <a:ext cx="11064240" cy="1005840"/>
+          </a:xfrm>
+          <a:prstGeom prst="rect">
+            <a:avLst/>
+          </a:prstGeom>
+          <a:noFill/>
+        </p:spPr>
+        <p:txBody>
+          <a:bodyPr wrap="square">
+            <a:spAutoFit/>
+          </a:bodyPr>
+          <a:lstStyle/>
+          <a:p>
+            <a:r>
+              <a:rPr sz="3600" b="1">
+                <a:solidFill>
+                  <a:srgbClr val="5A0A7A"/>
+                </a:solidFill>
+              </a:rPr>
+              <a:t>Let the solver search</a:t>
+            </a:r>
+          </a:p>
+        </p:txBody>
+      </p:sp>
+      <p:sp>
+        <p:nvSpPr>
+          <p:cNvPr id="3" name="TextBox 2"/>
+          <p:cNvSpPr txBox="1"/>
+          <p:nvPr/>
+        </p:nvSpPr>
+        <p:spPr>
+          <a:xfrm>
+            <a:off x="731520" y="1463040"/>
+            <a:ext cx="10789920" cy="5120640"/>
+          </a:xfrm>
+          <a:prstGeom prst="rect">
+            <a:avLst/>
+          </a:prstGeom>
+          <a:noFill/>
+        </p:spPr>
+        <p:txBody>
+          <a:bodyPr wrap="square">
+            <a:spAutoFit/>
+          </a:bodyPr>
+          <a:lstStyle/>
+          <a:p>
+            <a:pPr>
+              <a:spcAft>
+                <a:spcPts val="800"/>
+              </a:spcAft>
+            </a:pPr>
+            <a:r>
+              <a:rPr sz="2200">
+                <a:solidFill>
+                  <a:srgbClr val="212121"/>
+                </a:solidFill>
+              </a:rPr>
+              <a:t>Naïvely 10⁸ ways to fill in eight letters; “all different, S ≠ 0, M ≠ 0” cuts it to about 1.5 million — still far too many to eyeball.</a:t>
+            </a:r>
+          </a:p>
+          <a:p>
+            <a:pPr>
+              <a:spcAft>
+                <a:spcPts val="800"/>
+              </a:spcAft>
+            </a:pPr>
+            <a:r>
+              <a:rPr sz="2200">
+                <a:solidFill>
+                  <a:srgbClr val="212121"/>
+                </a:solidFill>
+              </a:rPr>
+              <a:t>The solver does not guess blindly: it fixes M = 1, then propagates each column's carry, backtracking when a choice clashes — the way you solve Sudoku.</a:t>
+            </a:r>
+          </a:p>
+          <a:p>
+            <a:pPr>
+              <a:spcAft>
+                <a:spcPts val="800"/>
+              </a:spcAft>
+            </a:pPr>
+            <a:r>
+              <a:rPr sz="2200">
+                <a:solidFill>
+                  <a:srgbClr val="212121"/>
+                </a:solidFill>
+              </a:rPr>
+              <a:t>Z3 returns the unique solution in well under a second:</a:t>
+            </a:r>
+          </a:p>
+          <a:p>
+            <a:pPr lvl="1">
+              <a:spcAft>
+                <a:spcPts val="0"/>
+              </a:spcAft>
+            </a:pPr>
+            <a:r>
+              <a:rPr sz="1800">
+                <a:solidFill>
+                  <a:srgbClr val="212121"/>
+                </a:solidFill>
+                <a:latin typeface="Courier New"/>
+              </a:rPr>
+              <a:t>9567 + 1085 = 10652   (S=9 E=5 N=6 D=7 M=1 O=0 R=8 Y=2)</a:t>
+            </a:r>
+          </a:p>
+          <a:p>
+            <a:pPr>
+              <a:spcAft>
+                <a:spcPts val="800"/>
+              </a:spcAft>
+            </a:pPr>
+            <a:r>
+              <a:rPr sz="2200">
+                <a:solidFill>
+                  <a:srgbClr val="212121"/>
+                </a:solidFill>
+              </a:rPr>
+              <a:t/>
+            </a:r>
+          </a:p>
+          <a:p>
+            <a:pPr>
+              <a:spcAft>
+                <a:spcPts val="800"/>
+              </a:spcAft>
+            </a:pPr>
+            <a:r>
+              <a:rPr sz="2200">
+                <a:solidFill>
+                  <a:srgbClr val="212121"/>
+                </a:solidFill>
+              </a:rPr>
+              <a:t>The same engine that solves this finds your bugs: a counterexample is just a satisfying assignment to “break my program”.</a:t>
+            </a:r>
+          </a:p>
+          <a:p>
+            <a:pPr>
+              <a:spcAft>
+                <a:spcPts val="800"/>
+              </a:spcAft>
+            </a:pPr>
+            <a:r>
+              <a:rPr sz="2200">
+                <a:solidFill>
+                  <a:srgbClr val="212121"/>
+                </a:solidFill>
+              </a:rPr>
+              <a:t>Lab 1, Stage 2: you run this yourself.</a:t>
+            </a:r>
+          </a:p>
+        </p:txBody>
+      </p:sp>
+    </p:spTree>
+  </p:cSld>
+  <p:clrMapOvr>
+    <a:masterClrMapping/>
+  </p:clrMapOvr>
+</p:sld>
+</file>
+
+<file path=ppt/slides/slide35.xml><?xml version="1.0" encoding="utf-8"?>
 <p:sld xmlns:a="http://schemas.openxmlformats.org/drawingml/2006/main" xmlns:p="http://schemas.openxmlformats.org/presentationml/2006/main" xmlns:r="http://schemas.openxmlformats.org/officeDocument/2006/relationships">
   <p:cSld>
     <p:spTree>
@@ -9278,7 +9642,7 @@
 </p:sld>
 </file>
 
-<file path=ppt/slides/slide34.xml><?xml version="1.0" encoding="utf-8"?>
+<file path=ppt/slides/slide36.xml><?xml version="1.0" encoding="utf-8"?>
 <p:sld xmlns:a="http://schemas.openxmlformats.org/drawingml/2006/main" xmlns:p="http://schemas.openxmlformats.org/presentationml/2006/main" xmlns:r="http://schemas.openxmlformats.org/officeDocument/2006/relationships">
   <p:cSld>
     <p:spTree>
@@ -9458,7 +9822,7 @@
 </p:sld>
 </file>
 
-<file path=ppt/slides/slide35.xml><?xml version="1.0" encoding="utf-8"?>
+<file path=ppt/slides/slide37.xml><?xml version="1.0" encoding="utf-8"?>
 <p:sld xmlns:a="http://schemas.openxmlformats.org/drawingml/2006/main" xmlns:p="http://schemas.openxmlformats.org/presentationml/2006/main" xmlns:r="http://schemas.openxmlformats.org/officeDocument/2006/relationships">
   <p:cSld>
     <p:spTree>
@@ -9700,7 +10064,7 @@
 </p:sld>
 </file>
 
-<file path=ppt/slides/slide36.xml><?xml version="1.0" encoding="utf-8"?>
+<file path=ppt/slides/slide38.xml><?xml version="1.0" encoding="utf-8"?>
 <p:sld xmlns:a="http://schemas.openxmlformats.org/drawingml/2006/main" xmlns:p="http://schemas.openxmlformats.org/presentationml/2006/main" xmlns:r="http://schemas.openxmlformats.org/officeDocument/2006/relationships">
   <p:cSld>
     <p:spTree>
@@ -9855,386 +10219,6 @@
                 </a:solidFill>
               </a:rPr>
               <a:t>Recognise the three lines? In Lab 1, Stage 3 you translate exactly this function by hand and hand it to Z3. You will be doing ESBMC's job yourself.</a:t>
-            </a:r>
-          </a:p>
-        </p:txBody>
-      </p:sp>
-    </p:spTree>
-  </p:cSld>
-  <p:clrMapOvr>
-    <a:masterClrMapping/>
-  </p:clrMapOvr>
-</p:sld>
-</file>
-
-<file path=ppt/slides/slide37.xml><?xml version="1.0" encoding="utf-8"?>
-<p:sld xmlns:a="http://schemas.openxmlformats.org/drawingml/2006/main" xmlns:p="http://schemas.openxmlformats.org/presentationml/2006/main" xmlns:r="http://schemas.openxmlformats.org/officeDocument/2006/relationships">
-  <p:cSld>
-    <p:spTree>
-      <p:nvGrpSpPr>
-        <p:cNvPr id="1" name=""/>
-        <p:cNvGrpSpPr/>
-        <p:nvPr/>
-      </p:nvGrpSpPr>
-      <p:grpSpPr/>
-      <p:sp>
-        <p:nvSpPr>
-          <p:cNvPr id="2" name="TextBox 1"/>
-          <p:cNvSpPr txBox="1"/>
-          <p:nvPr/>
-        </p:nvSpPr>
-        <p:spPr>
-          <a:xfrm>
-            <a:off x="548640" y="365760"/>
-            <a:ext cx="11064240" cy="1005840"/>
-          </a:xfrm>
-          <a:prstGeom prst="rect">
-            <a:avLst/>
-          </a:prstGeom>
-          <a:noFill/>
-        </p:spPr>
-        <p:txBody>
-          <a:bodyPr wrap="square">
-            <a:spAutoFit/>
-          </a:bodyPr>
-          <a:lstStyle/>
-          <a:p>
-            <a:r>
-              <a:rPr sz="3600" b="1">
-                <a:solidFill>
-                  <a:srgbClr val="5A0A7A"/>
-                </a:solidFill>
-              </a:rPr>
-              <a:t>Putting it together</a:t>
-            </a:r>
-          </a:p>
-        </p:txBody>
-      </p:sp>
-      <p:sp>
-        <p:nvSpPr>
-          <p:cNvPr id="3" name="TextBox 2"/>
-          <p:cNvSpPr txBox="1"/>
-          <p:nvPr/>
-        </p:nvSpPr>
-        <p:spPr>
-          <a:xfrm>
-            <a:off x="731520" y="1737360"/>
-            <a:ext cx="10789920" cy="4846320"/>
-          </a:xfrm>
-          <a:prstGeom prst="rect">
-            <a:avLst/>
-          </a:prstGeom>
-          <a:noFill/>
-        </p:spPr>
-        <p:txBody>
-          <a:bodyPr wrap="square">
-            <a:spAutoFit/>
-          </a:bodyPr>
-          <a:lstStyle/>
-          <a:p>
-            <a:pPr>
-              <a:spcAft>
-                <a:spcPts val="0"/>
-              </a:spcAft>
-            </a:pPr>
-            <a:r>
-              <a:rPr sz="2200">
-                <a:solidFill>
-                  <a:srgbClr val="212121"/>
-                </a:solidFill>
-                <a:latin typeface="Courier New"/>
-              </a:rPr>
-              <a:t>⟦program⟧  ∧  ¬P      →  SMT solver</a:t>
-            </a:r>
-          </a:p>
-          <a:p>
-            <a:pPr>
-              <a:spcAft>
-                <a:spcPts val="800"/>
-              </a:spcAft>
-            </a:pPr>
-            <a:r>
-              <a:rPr sz="2600">
-                <a:solidFill>
-                  <a:srgbClr val="212121"/>
-                </a:solidFill>
-              </a:rPr>
-              <a:t/>
-            </a:r>
-          </a:p>
-          <a:p>
-            <a:pPr>
-              <a:spcAft>
-                <a:spcPts val="800"/>
-              </a:spcAft>
-            </a:pPr>
-            <a:r>
-              <a:rPr sz="2600">
-                <a:solidFill>
-                  <a:srgbClr val="212121"/>
-                </a:solidFill>
-              </a:rPr>
-              <a:t>sat — the model assigns every input and every choice: replayed in program order, that is the counterexample trace.</a:t>
-            </a:r>
-          </a:p>
-          <a:p>
-            <a:pPr>
-              <a:spcAft>
-                <a:spcPts val="800"/>
-              </a:spcAft>
-            </a:pPr>
-            <a:r>
-              <a:rPr sz="2600">
-                <a:solidFill>
-                  <a:srgbClr val="212121"/>
-                </a:solidFill>
-              </a:rPr>
-              <a:t>unsat — no execution within the bound violates P.</a:t>
-            </a:r>
-          </a:p>
-          <a:p>
-            <a:pPr>
-              <a:spcAft>
-                <a:spcPts val="800"/>
-              </a:spcAft>
-            </a:pPr>
-            <a:r>
-              <a:rPr sz="2600">
-                <a:solidFill>
-                  <a:srgbClr val="212121"/>
-                </a:solidFill>
-              </a:rPr>
-              <a:t/>
-            </a:r>
-          </a:p>
-          <a:p>
-            <a:pPr>
-              <a:spcAft>
-                <a:spcPts val="800"/>
-              </a:spcAft>
-            </a:pPr>
-            <a:r>
-              <a:rPr sz="2600">
-                <a:solidFill>
-                  <a:srgbClr val="212121"/>
-                </a:solidFill>
-              </a:rPr>
-              <a:t>One formula, every path at once. That is why nobody has to enumerate 2⁶⁴ test cases.</a:t>
-            </a:r>
-          </a:p>
-        </p:txBody>
-      </p:sp>
-    </p:spTree>
-  </p:cSld>
-  <p:clrMapOvr>
-    <a:masterClrMapping/>
-  </p:clrMapOvr>
-</p:sld>
-</file>
-
-<file path=ppt/slides/slide38.xml><?xml version="1.0" encoding="utf-8"?>
-<p:sld xmlns:a="http://schemas.openxmlformats.org/drawingml/2006/main" xmlns:p="http://schemas.openxmlformats.org/presentationml/2006/main" xmlns:r="http://schemas.openxmlformats.org/officeDocument/2006/relationships">
-  <p:cSld>
-    <p:spTree>
-      <p:nvGrpSpPr>
-        <p:cNvPr id="1" name=""/>
-        <p:cNvGrpSpPr/>
-        <p:nvPr/>
-      </p:nvGrpSpPr>
-      <p:grpSpPr/>
-      <p:sp>
-        <p:nvSpPr>
-          <p:cNvPr id="2" name="TextBox 1"/>
-          <p:cNvSpPr txBox="1"/>
-          <p:nvPr/>
-        </p:nvSpPr>
-        <p:spPr>
-          <a:xfrm>
-            <a:off x="548640" y="365760"/>
-            <a:ext cx="11064240" cy="1005840"/>
-          </a:xfrm>
-          <a:prstGeom prst="rect">
-            <a:avLst/>
-          </a:prstGeom>
-          <a:noFill/>
-        </p:spPr>
-        <p:txBody>
-          <a:bodyPr wrap="square">
-            <a:spAutoFit/>
-          </a:bodyPr>
-          <a:lstStyle/>
-          <a:p>
-            <a:r>
-              <a:rPr sz="3600" b="1">
-                <a:solidFill>
-                  <a:srgbClr val="5A0A7A"/>
-                </a:solidFill>
-              </a:rPr>
-              <a:t>Anatomy of a counterexample</a:t>
-            </a:r>
-          </a:p>
-        </p:txBody>
-      </p:sp>
-      <p:sp>
-        <p:nvSpPr>
-          <p:cNvPr id="3" name="TextBox 2"/>
-          <p:cNvSpPr txBox="1"/>
-          <p:nvPr/>
-        </p:nvSpPr>
-        <p:spPr>
-          <a:xfrm>
-            <a:off x="731520" y="1463040"/>
-            <a:ext cx="10789920" cy="5120640"/>
-          </a:xfrm>
-          <a:prstGeom prst="rect">
-            <a:avLst/>
-          </a:prstGeom>
-          <a:noFill/>
-        </p:spPr>
-        <p:txBody>
-          <a:bodyPr wrap="square">
-            <a:spAutoFit/>
-          </a:bodyPr>
-          <a:lstStyle/>
-          <a:p>
-            <a:pPr>
-              <a:spcAft>
-                <a:spcPts val="0"/>
-              </a:spcAft>
-            </a:pPr>
-            <a:r>
-              <a:rPr sz="1800">
-                <a:solidFill>
-                  <a:srgbClr val="212121"/>
-                </a:solidFill>
-                <a:latin typeface="Courier New"/>
-              </a:rPr>
-              <a:t>State 3  file offbyone.c  line 15</a:t>
-            </a:r>
-          </a:p>
-          <a:p>
-            <a:pPr>
-              <a:spcAft>
-                <a:spcPts val="0"/>
-              </a:spcAft>
-            </a:pPr>
-            <a:r>
-              <a:rPr sz="1800">
-                <a:solidFill>
-                  <a:srgbClr val="212121"/>
-                </a:solidFill>
-                <a:latin typeface="Courier New"/>
-              </a:rPr>
-              <a:t>  i = 5 (00000000 ... 101)      ← the value the solver chose</a:t>
-            </a:r>
-          </a:p>
-          <a:p>
-            <a:pPr>
-              <a:spcAft>
-                <a:spcPts val="0"/>
-              </a:spcAft>
-            </a:pPr>
-            <a:r>
-              <a:rPr sz="1800">
-                <a:solidFill>
-                  <a:srgbClr val="212121"/>
-                </a:solidFill>
-                <a:latin typeface="Courier New"/>
-              </a:rPr>
-              <a:t>...</a:t>
-            </a:r>
-          </a:p>
-          <a:p>
-            <a:pPr>
-              <a:spcAft>
-                <a:spcPts val="0"/>
-              </a:spcAft>
-            </a:pPr>
-            <a:r>
-              <a:rPr sz="1800">
-                <a:solidFill>
-                  <a:srgbClr val="212121"/>
-                </a:solidFill>
-                <a:latin typeface="Courier New"/>
-              </a:rPr>
-              <a:t>Violated property:</a:t>
-            </a:r>
-          </a:p>
-          <a:p>
-            <a:pPr>
-              <a:spcAft>
-                <a:spcPts val="0"/>
-              </a:spcAft>
-            </a:pPr>
-            <a:r>
-              <a:rPr sz="1800">
-                <a:solidFill>
-                  <a:srgbClr val="212121"/>
-                </a:solidFill>
-                <a:latin typeface="Courier New"/>
-              </a:rPr>
-              <a:t>  array bounds violated: a[i]   ← what broke</a:t>
-            </a:r>
-          </a:p>
-          <a:p>
-            <a:pPr>
-              <a:spcAft>
-                <a:spcPts val="0"/>
-              </a:spcAft>
-            </a:pPr>
-            <a:r>
-              <a:rPr sz="1800">
-                <a:solidFill>
-                  <a:srgbClr val="212121"/>
-                </a:solidFill>
-                <a:latin typeface="Courier New"/>
-              </a:rPr>
-              <a:t>  CWE: CWE-787                   ← the vulnerability class</a:t>
-            </a:r>
-          </a:p>
-          <a:p>
-            <a:pPr>
-              <a:spcAft>
-                <a:spcPts val="800"/>
-              </a:spcAft>
-            </a:pPr>
-            <a:r>
-              <a:rPr sz="2200">
-                <a:solidFill>
-                  <a:srgbClr val="212121"/>
-                </a:solidFill>
-              </a:rPr>
-              <a:t/>
-            </a:r>
-          </a:p>
-          <a:p>
-            <a:pPr>
-              <a:spcAft>
-                <a:spcPts val="800"/>
-              </a:spcAft>
-            </a:pPr>
-            <a:r>
-              <a:rPr sz="2200">
-                <a:solidFill>
-                  <a:srgbClr val="212121"/>
-                </a:solidFill>
-              </a:rPr>
-              <a:t>Read it bottom-up: first what was violated, then scroll up for the values that caused it.</a:t>
-            </a:r>
-          </a:p>
-          <a:p>
-            <a:pPr>
-              <a:spcAft>
-                <a:spcPts val="800"/>
-              </a:spcAft>
-            </a:pPr>
-            <a:r>
-              <a:rPr sz="2200">
-                <a:solidFill>
-                  <a:srgbClr val="212121"/>
-                </a:solidFill>
-              </a:rPr>
-              <a:t>Those values are a ready-made failing test case — keep them.</a:t>
             </a:r>
           </a:p>
         </p:txBody>
@@ -10285,7 +10269,7 @@
                   <a:srgbClr val="5A0A7A"/>
                 </a:solidFill>
               </a:rPr>
-              <a:t>Live: the whole pipeline on five lines</a:t>
+              <a:t>Putting it together</a:t>
             </a:r>
           </a:p>
         </p:txBody>
@@ -10298,8 +10282,8 @@
         </p:nvSpPr>
         <p:spPr>
           <a:xfrm>
-            <a:off x="731520" y="1463040"/>
-            <a:ext cx="10789920" cy="5120640"/>
+            <a:off x="731520" y="1737360"/>
+            <a:ext cx="10789920" cy="4846320"/>
           </a:xfrm>
           <a:prstGeom prst="rect">
             <a:avLst/>
@@ -10318,107 +10302,26 @@
               </a:spcAft>
             </a:pPr>
             <a:r>
-              <a:rPr sz="1800">
+              <a:rPr sz="2200">
                 <a:solidFill>
                   <a:srgbClr val="212121"/>
                 </a:solidFill>
                 <a:latin typeface="Courier New"/>
               </a:rPr>
-              <a:t>int main(void)</a:t>
-            </a:r>
-          </a:p>
-          <a:p>
-            <a:pPr>
-              <a:spcAft>
-                <a:spcPts val="0"/>
-              </a:spcAft>
-            </a:pPr>
-            <a:r>
-              <a:rPr sz="1800">
-                <a:solidFill>
-                  <a:srgbClr val="212121"/>
-                </a:solidFill>
-                <a:latin typeface="Courier New"/>
-              </a:rPr>
-              <a:t>{</a:t>
-            </a:r>
-          </a:p>
-          <a:p>
-            <a:pPr>
-              <a:spcAft>
-                <a:spcPts val="0"/>
-              </a:spcAft>
-            </a:pPr>
-            <a:r>
-              <a:rPr sz="1800">
-                <a:solidFill>
-                  <a:srgbClr val="212121"/>
-                </a:solidFill>
-                <a:latin typeface="Courier New"/>
-              </a:rPr>
-              <a:t>  int a[5];</a:t>
-            </a:r>
-          </a:p>
-          <a:p>
-            <a:pPr>
-              <a:spcAft>
-                <a:spcPts val="0"/>
-              </a:spcAft>
-            </a:pPr>
-            <a:r>
-              <a:rPr sz="1800">
-                <a:solidFill>
-                  <a:srgbClr val="212121"/>
-                </a:solidFill>
-                <a:latin typeface="Courier New"/>
-              </a:rPr>
-              <a:t>  for (int i = 0; i &lt;= 5; i++)</a:t>
-            </a:r>
-          </a:p>
-          <a:p>
-            <a:pPr>
-              <a:spcAft>
-                <a:spcPts val="0"/>
-              </a:spcAft>
-            </a:pPr>
-            <a:r>
-              <a:rPr sz="1800">
-                <a:solidFill>
-                  <a:srgbClr val="212121"/>
-                </a:solidFill>
-                <a:latin typeface="Courier New"/>
-              </a:rPr>
-              <a:t>    a[i] = i;</a:t>
-            </a:r>
-          </a:p>
-          <a:p>
-            <a:pPr>
-              <a:spcAft>
-                <a:spcPts val="0"/>
-              </a:spcAft>
-            </a:pPr>
-            <a:r>
-              <a:rPr sz="1800">
-                <a:solidFill>
-                  <a:srgbClr val="212121"/>
-                </a:solidFill>
-                <a:latin typeface="Courier New"/>
-              </a:rPr>
-              <a:t>}</a:t>
-            </a:r>
-          </a:p>
-          <a:p>
-            <a:pPr>
-              <a:spcAft>
-                <a:spcPts val="0"/>
-              </a:spcAft>
-            </a:pPr>
-            <a:r>
-              <a:rPr sz="1800">
-                <a:solidFill>
-                  <a:srgbClr val="212121"/>
-                </a:solidFill>
-                <a:latin typeface="Courier New"/>
+              <a:t>⟦program⟧  ∧  ¬P      →  SMT solver</a:t>
+            </a:r>
+          </a:p>
+          <a:p>
+            <a:pPr>
+              <a:spcAft>
+                <a:spcPts val="800"/>
+              </a:spcAft>
+            </a:pPr>
+            <a:r>
+              <a:rPr sz="2600">
+                <a:solidFill>
+                  <a:srgbClr val="212121"/>
+                </a:solidFill>
               </a:rPr>
               <a:t/>
             </a:r>
@@ -10426,27 +10329,41 @@
           <a:p>
             <a:pPr>
               <a:spcAft>
-                <a:spcPts val="0"/>
-              </a:spcAft>
-            </a:pPr>
-            <a:r>
-              <a:rPr sz="1800">
-                <a:solidFill>
-                  <a:srgbClr val="212121"/>
-                </a:solidFill>
-                <a:latin typeface="Courier New"/>
-              </a:rPr>
-              <a:t>$ esbmc offbyone.c --unwind 7</a:t>
-            </a:r>
-          </a:p>
-          <a:p>
-            <a:pPr>
-              <a:spcAft>
-                <a:spcPts val="800"/>
-              </a:spcAft>
-            </a:pPr>
-            <a:r>
-              <a:rPr sz="2200">
+                <a:spcPts val="800"/>
+              </a:spcAft>
+            </a:pPr>
+            <a:r>
+              <a:rPr sz="2600">
+                <a:solidFill>
+                  <a:srgbClr val="212121"/>
+                </a:solidFill>
+              </a:rPr>
+              <a:t>sat — the model assigns every input and every choice: replayed in program order, that is the counterexample trace.</a:t>
+            </a:r>
+          </a:p>
+          <a:p>
+            <a:pPr>
+              <a:spcAft>
+                <a:spcPts val="800"/>
+              </a:spcAft>
+            </a:pPr>
+            <a:r>
+              <a:rPr sz="2600">
+                <a:solidFill>
+                  <a:srgbClr val="212121"/>
+                </a:solidFill>
+              </a:rPr>
+              <a:t>unsat — no execution within the bound violates P.</a:t>
+            </a:r>
+          </a:p>
+          <a:p>
+            <a:pPr>
+              <a:spcAft>
+                <a:spcPts val="800"/>
+              </a:spcAft>
+            </a:pPr>
+            <a:r>
+              <a:rPr sz="2600">
                 <a:solidFill>
                   <a:srgbClr val="212121"/>
                 </a:solidFill>
@@ -10461,27 +10378,12 @@
               </a:spcAft>
             </a:pPr>
             <a:r>
-              <a:rPr sz="2200">
-                <a:solidFill>
-                  <a:srgbClr val="212121"/>
-                </a:solidFill>
-              </a:rPr>
-              <a:t>Predict first: FAILED or SUCCESSFUL? If FAILED — at which i?</a:t>
-            </a:r>
-          </a:p>
-          <a:p>
-            <a:pPr>
-              <a:spcAft>
-                <a:spcPts val="800"/>
-              </a:spcAft>
-            </a:pPr>
-            <a:r>
-              <a:rPr sz="2200">
-                <a:solidFill>
-                  <a:srgbClr val="212121"/>
-                </a:solidFill>
-              </a:rPr>
-              <a:t>Then we read the trace together, bottom-up.</a:t>
+              <a:rPr sz="2600">
+                <a:solidFill>
+                  <a:srgbClr val="212121"/>
+                </a:solidFill>
+              </a:rPr>
+              <a:t>One formula, every path at once. That is why nobody has to enumerate 2⁶⁴ test cases.</a:t>
             </a:r>
           </a:p>
         </p:txBody>
@@ -10726,7 +10628,7 @@
                   <a:srgbClr val="5A0A7A"/>
                 </a:solidFill>
               </a:rPr>
-              <a:t>Modelling the environment: a preview</a:t>
+              <a:t>Anatomy of a counterexample</a:t>
             </a:r>
           </a:p>
         </p:txBody>
@@ -10765,7 +10667,7 @@
                 </a:solidFill>
                 <a:latin typeface="Courier New"/>
               </a:rPr>
-              <a:t>int x = nondet_int();              /* every value at once */</a:t>
+              <a:t>State 3  file offbyone.c  line 15</a:t>
             </a:r>
           </a:p>
           <a:p>
@@ -10781,7 +10683,7 @@
                 </a:solidFill>
                 <a:latin typeface="Courier New"/>
               </a:rPr>
-              <a:t>__ESBMC_assume(x &gt; 0 &amp;&amp; x &lt; 100);  /* now: every value in 1..99 */</a:t>
+              <a:t>  i = 5 (00000000 ... 101)      ← the value the solver chose</a:t>
             </a:r>
           </a:p>
           <a:p>
@@ -10797,7 +10699,55 @@
                 </a:solidFill>
                 <a:latin typeface="Courier New"/>
               </a:rPr>
-              <a:t>assert(property(x));               /* must hold for ALL of them */</a:t>
+              <a:t>...</a:t>
+            </a:r>
+          </a:p>
+          <a:p>
+            <a:pPr>
+              <a:spcAft>
+                <a:spcPts val="0"/>
+              </a:spcAft>
+            </a:pPr>
+            <a:r>
+              <a:rPr sz="1800">
+                <a:solidFill>
+                  <a:srgbClr val="212121"/>
+                </a:solidFill>
+                <a:latin typeface="Courier New"/>
+              </a:rPr>
+              <a:t>Violated property:</a:t>
+            </a:r>
+          </a:p>
+          <a:p>
+            <a:pPr>
+              <a:spcAft>
+                <a:spcPts val="0"/>
+              </a:spcAft>
+            </a:pPr>
+            <a:r>
+              <a:rPr sz="1800">
+                <a:solidFill>
+                  <a:srgbClr val="212121"/>
+                </a:solidFill>
+                <a:latin typeface="Courier New"/>
+              </a:rPr>
+              <a:t>  array bounds violated: a[i]   ← what broke</a:t>
+            </a:r>
+          </a:p>
+          <a:p>
+            <a:pPr>
+              <a:spcAft>
+                <a:spcPts val="0"/>
+              </a:spcAft>
+            </a:pPr>
+            <a:r>
+              <a:rPr sz="1800">
+                <a:solidFill>
+                  <a:srgbClr val="212121"/>
+                </a:solidFill>
+                <a:latin typeface="Courier New"/>
+              </a:rPr>
+              <a:t>  CWE: CWE-787                   ← the vulnerability class</a:t>
             </a:r>
           </a:p>
           <a:p>
@@ -10827,7 +10777,7 @@
                   <a:srgbClr val="212121"/>
                 </a:solidFill>
               </a:rPr>
-              <a:t>One nondeterministic input = all tests of that input at once.</a:t>
+              <a:t>Read it bottom-up: first what was violated, then scroll up for the values that caused it.</a:t>
             </a:r>
           </a:p>
           <a:p>
@@ -10842,7 +10792,7 @@
                   <a:srgbClr val="212121"/>
                 </a:solidFill>
               </a:rPr>
-              <a:t>In Session 2 you will use these three lines to expose a bug in a program that verifies green as shipped — the tool only checks what you specify.</a:t>
+              <a:t>Those values are a ready-made failing test case — keep them.</a:t>
             </a:r>
           </a:p>
         </p:txBody>
@@ -10893,7 +10843,7 @@
                   <a:srgbClr val="5A0A7A"/>
                 </a:solidFill>
               </a:rPr>
-              <a:t>Beyond one thread</a:t>
+              <a:t>Live: the whole pipeline on five lines</a:t>
             </a:r>
           </a:p>
         </p:txBody>
@@ -10906,8 +10856,8 @@
         </p:nvSpPr>
         <p:spPr>
           <a:xfrm>
-            <a:off x="731520" y="1645920"/>
-            <a:ext cx="10789920" cy="4937760"/>
+            <a:off x="731520" y="1463040"/>
+            <a:ext cx="10789920" cy="5120640"/>
           </a:xfrm>
           <a:prstGeom prst="rect">
             <a:avLst/>
@@ -10922,59 +10872,111 @@
           <a:p>
             <a:pPr>
               <a:spcAft>
-                <a:spcPts val="800"/>
-              </a:spcAft>
-            </a:pPr>
-            <a:r>
-              <a:rPr sz="2400">
-                <a:solidFill>
-                  <a:srgbClr val="212121"/>
-                </a:solidFill>
-              </a:rPr>
-              <a:t>Two threads of two and one statements already have three interleavings. Real code has billions.</a:t>
-            </a:r>
-          </a:p>
-          <a:p>
-            <a:pPr>
-              <a:spcAft>
-                <a:spcPts val="800"/>
-              </a:spcAft>
-            </a:pPr>
-            <a:r>
-              <a:rPr sz="2400">
-                <a:solidFill>
-                  <a:srgbClr val="212121"/>
-                </a:solidFill>
-              </a:rPr>
-              <a:t>Run the program a million times and the bad interleaving may never show up — Therac-25's bug hid exactly this way.</a:t>
-            </a:r>
-          </a:p>
-          <a:p>
-            <a:pPr>
-              <a:spcAft>
-                <a:spcPts val="800"/>
-              </a:spcAft>
-            </a:pPr>
-            <a:r>
-              <a:rPr sz="2400">
-                <a:solidFill>
-                  <a:srgbClr val="212121"/>
-                </a:solidFill>
-              </a:rPr>
-              <a:t>A model checker enumerates every interleaving up to a bound, including the one that kills your assertion.</a:t>
-            </a:r>
-          </a:p>
-          <a:p>
-            <a:pPr>
-              <a:spcAft>
-                <a:spcPts val="800"/>
-              </a:spcAft>
-            </a:pPr>
-            <a:r>
-              <a:rPr sz="2400">
-                <a:solidFill>
-                  <a:srgbClr val="212121"/>
-                </a:solidFill>
+                <a:spcPts val="0"/>
+              </a:spcAft>
+            </a:pPr>
+            <a:r>
+              <a:rPr sz="1800">
+                <a:solidFill>
+                  <a:srgbClr val="212121"/>
+                </a:solidFill>
+                <a:latin typeface="Courier New"/>
+              </a:rPr>
+              <a:t>int main(void)</a:t>
+            </a:r>
+          </a:p>
+          <a:p>
+            <a:pPr>
+              <a:spcAft>
+                <a:spcPts val="0"/>
+              </a:spcAft>
+            </a:pPr>
+            <a:r>
+              <a:rPr sz="1800">
+                <a:solidFill>
+                  <a:srgbClr val="212121"/>
+                </a:solidFill>
+                <a:latin typeface="Courier New"/>
+              </a:rPr>
+              <a:t>{</a:t>
+            </a:r>
+          </a:p>
+          <a:p>
+            <a:pPr>
+              <a:spcAft>
+                <a:spcPts val="0"/>
+              </a:spcAft>
+            </a:pPr>
+            <a:r>
+              <a:rPr sz="1800">
+                <a:solidFill>
+                  <a:srgbClr val="212121"/>
+                </a:solidFill>
+                <a:latin typeface="Courier New"/>
+              </a:rPr>
+              <a:t>  int a[5];</a:t>
+            </a:r>
+          </a:p>
+          <a:p>
+            <a:pPr>
+              <a:spcAft>
+                <a:spcPts val="0"/>
+              </a:spcAft>
+            </a:pPr>
+            <a:r>
+              <a:rPr sz="1800">
+                <a:solidFill>
+                  <a:srgbClr val="212121"/>
+                </a:solidFill>
+                <a:latin typeface="Courier New"/>
+              </a:rPr>
+              <a:t>  for (int i = 0; i &lt;= 5; i++)</a:t>
+            </a:r>
+          </a:p>
+          <a:p>
+            <a:pPr>
+              <a:spcAft>
+                <a:spcPts val="0"/>
+              </a:spcAft>
+            </a:pPr>
+            <a:r>
+              <a:rPr sz="1800">
+                <a:solidFill>
+                  <a:srgbClr val="212121"/>
+                </a:solidFill>
+                <a:latin typeface="Courier New"/>
+              </a:rPr>
+              <a:t>    a[i] = i;</a:t>
+            </a:r>
+          </a:p>
+          <a:p>
+            <a:pPr>
+              <a:spcAft>
+                <a:spcPts val="0"/>
+              </a:spcAft>
+            </a:pPr>
+            <a:r>
+              <a:rPr sz="1800">
+                <a:solidFill>
+                  <a:srgbClr val="212121"/>
+                </a:solidFill>
+                <a:latin typeface="Courier New"/>
+              </a:rPr>
+              <a:t>}</a:t>
+            </a:r>
+          </a:p>
+          <a:p>
+            <a:pPr>
+              <a:spcAft>
+                <a:spcPts val="0"/>
+              </a:spcAft>
+            </a:pPr>
+            <a:r>
+              <a:rPr sz="1800">
+                <a:solidFill>
+                  <a:srgbClr val="212121"/>
+                </a:solidFill>
+                <a:latin typeface="Courier New"/>
               </a:rPr>
               <a:t/>
             </a:r>
@@ -10982,16 +10984,62 @@
           <a:p>
             <a:pPr>
               <a:spcAft>
-                <a:spcPts val="800"/>
-              </a:spcAft>
-            </a:pPr>
-            <a:r>
-              <a:rPr sz="2400">
-                <a:solidFill>
-                  <a:srgbClr val="212121"/>
-                </a:solidFill>
-              </a:rPr>
-              <a:t>Session 2, Lab 4: you write down the killer interleaving before the tool finds it.</a:t>
+                <a:spcPts val="0"/>
+              </a:spcAft>
+            </a:pPr>
+            <a:r>
+              <a:rPr sz="1800">
+                <a:solidFill>
+                  <a:srgbClr val="212121"/>
+                </a:solidFill>
+                <a:latin typeface="Courier New"/>
+              </a:rPr>
+              <a:t>$ esbmc offbyone.c --unwind 7</a:t>
+            </a:r>
+          </a:p>
+          <a:p>
+            <a:pPr>
+              <a:spcAft>
+                <a:spcPts val="800"/>
+              </a:spcAft>
+            </a:pPr>
+            <a:r>
+              <a:rPr sz="2200">
+                <a:solidFill>
+                  <a:srgbClr val="212121"/>
+                </a:solidFill>
+              </a:rPr>
+              <a:t/>
+            </a:r>
+          </a:p>
+          <a:p>
+            <a:pPr>
+              <a:spcAft>
+                <a:spcPts val="800"/>
+              </a:spcAft>
+            </a:pPr>
+            <a:r>
+              <a:rPr sz="2200">
+                <a:solidFill>
+                  <a:srgbClr val="212121"/>
+                </a:solidFill>
+              </a:rPr>
+              <a:t>Predict first: FAILED or SUCCESSFUL? If FAILED — at which i?</a:t>
+            </a:r>
+          </a:p>
+          <a:p>
+            <a:pPr>
+              <a:spcAft>
+                <a:spcPts val="800"/>
+              </a:spcAft>
+            </a:pPr>
+            <a:r>
+              <a:rPr sz="2200">
+                <a:solidFill>
+                  <a:srgbClr val="212121"/>
+                </a:solidFill>
+              </a:rPr>
+              <a:t>Then we read the trace together, bottom-up.</a:t>
             </a:r>
           </a:p>
         </p:txBody>
@@ -11042,7 +11090,7 @@
                   <a:srgbClr val="5A0A7A"/>
                 </a:solidFill>
               </a:rPr>
-              <a:t>Homework for your intuition</a:t>
+              <a:t>Modelling the environment: a preview</a:t>
             </a:r>
           </a:p>
         </p:txBody>
@@ -11055,8 +11103,8 @@
         </p:nvSpPr>
         <p:spPr>
           <a:xfrm>
-            <a:off x="731520" y="1828800"/>
-            <a:ext cx="10789920" cy="4754880"/>
+            <a:off x="731520" y="1463040"/>
+            <a:ext cx="10789920" cy="5120640"/>
           </a:xfrm>
           <a:prstGeom prst="rect">
             <a:avLst/>
@@ -11075,19 +11123,66 @@
               </a:spcAft>
             </a:pPr>
             <a:r>
+              <a:rPr sz="1800">
+                <a:solidFill>
+                  <a:srgbClr val="212121"/>
+                </a:solidFill>
+                <a:latin typeface="Courier New"/>
+              </a:rPr>
+              <a:t>int x = nondet_int();              /* every value at once */</a:t>
+            </a:r>
+          </a:p>
+          <a:p>
+            <a:pPr>
+              <a:spcAft>
+                <a:spcPts val="0"/>
+              </a:spcAft>
+            </a:pPr>
+            <a:r>
+              <a:rPr sz="1800">
+                <a:solidFill>
+                  <a:srgbClr val="212121"/>
+                </a:solidFill>
+                <a:latin typeface="Courier New"/>
+              </a:rPr>
+              <a:t>__ESBMC_assume(x &gt; 0 &amp;&amp; x &lt; 100);  /* now: every value in 1..99 */</a:t>
+            </a:r>
+          </a:p>
+          <a:p>
+            <a:pPr>
+              <a:spcAft>
+                <a:spcPts val="0"/>
+              </a:spcAft>
+            </a:pPr>
+            <a:r>
+              <a:rPr sz="1800">
+                <a:solidFill>
+                  <a:srgbClr val="212121"/>
+                </a:solidFill>
+                <a:latin typeface="Courier New"/>
+              </a:rPr>
+              <a:t>assert(property(x));               /* must hold for ALL of them */</a:t>
+            </a:r>
+          </a:p>
+          <a:p>
+            <a:pPr>
+              <a:spcAft>
+                <a:spcPts val="800"/>
+              </a:spcAft>
+            </a:pPr>
+            <a:r>
               <a:rPr sz="2200">
                 <a:solidFill>
                   <a:srgbClr val="212121"/>
                 </a:solidFill>
-                <a:latin typeface="Courier New"/>
-              </a:rPr>
-              <a:t>double w = 0.1 + 0.2;</a:t>
-            </a:r>
-          </a:p>
-          <a:p>
-            <a:pPr>
-              <a:spcAft>
-                <a:spcPts val="0"/>
+              </a:rPr>
+              <a:t/>
+            </a:r>
+          </a:p>
+          <a:p>
+            <a:pPr>
+              <a:spcAft>
+                <a:spcPts val="800"/>
               </a:spcAft>
             </a:pPr>
             <a:r>
@@ -11095,84 +11190,23 @@
                 <a:solidFill>
                   <a:srgbClr val="212121"/>
                 </a:solidFill>
-                <a:latin typeface="Courier New"/>
-              </a:rPr>
-              <a:t>assert(w == 0.3);</a:t>
-            </a:r>
-          </a:p>
-          <a:p>
-            <a:pPr>
-              <a:spcAft>
-                <a:spcPts val="800"/>
-              </a:spcAft>
-            </a:pPr>
-            <a:r>
-              <a:rPr sz="2600">
-                <a:solidFill>
-                  <a:srgbClr val="212121"/>
-                </a:solidFill>
-              </a:rPr>
-              <a:t/>
-            </a:r>
-          </a:p>
-          <a:p>
-            <a:pPr>
-              <a:spcAft>
-                <a:spcPts val="800"/>
-              </a:spcAft>
-            </a:pPr>
-            <a:r>
-              <a:rPr sz="2600">
-                <a:solidFill>
-                  <a:srgbClr val="212121"/>
-                </a:solidFill>
-              </a:rPr>
-              <a:t>FAILED or SUCCESSFUL?</a:t>
-            </a:r>
-          </a:p>
-          <a:p>
-            <a:pPr>
-              <a:spcAft>
-                <a:spcPts val="800"/>
-              </a:spcAft>
-            </a:pPr>
-            <a:r>
-              <a:rPr sz="2600">
-                <a:solidFill>
-                  <a:srgbClr val="212121"/>
-                </a:solidFill>
-              </a:rPr>
-              <a:t/>
-            </a:r>
-          </a:p>
-          <a:p>
-            <a:pPr>
-              <a:spcAft>
-                <a:spcPts val="800"/>
-              </a:spcAft>
-            </a:pPr>
-            <a:r>
-              <a:rPr sz="2600">
-                <a:solidFill>
-                  <a:srgbClr val="212121"/>
-                </a:solidFill>
-              </a:rPr>
-              <a:t>Bring your answer to Session 2 — Lab 4 settles it with a solver that does exact IEEE-754 arithmetic.</a:t>
-            </a:r>
-          </a:p>
-          <a:p>
-            <a:pPr lvl="1">
-              <a:spcAft>
-                <a:spcPts val="800"/>
-              </a:spcAft>
-            </a:pPr>
-            <a:r>
-              <a:rPr sz="2400">
-                <a:solidFill>
-                  <a:srgbClr val="212121"/>
-                </a:solidFill>
-              </a:rPr>
-              <a:t>Hint: 0.1 in binary is like 1/3 in decimal.</a:t>
+              </a:rPr>
+              <a:t>One nondeterministic input = all tests of that input at once.</a:t>
+            </a:r>
+          </a:p>
+          <a:p>
+            <a:pPr>
+              <a:spcAft>
+                <a:spcPts val="800"/>
+              </a:spcAft>
+            </a:pPr>
+            <a:r>
+              <a:rPr sz="2200">
+                <a:solidFill>
+                  <a:srgbClr val="212121"/>
+                </a:solidFill>
+              </a:rPr>
+              <a:t>In Session 2 you will use these three lines to expose a bug in a program that verifies green as shipped — the tool only checks what you specify.</a:t>
             </a:r>
           </a:p>
         </p:txBody>
@@ -11223,7 +11257,7 @@
                   <a:srgbClr val="5A0A7A"/>
                 </a:solidFill>
               </a:rPr>
-              <a:t>Exercise 2 — Predict the Verdict (15 min)</a:t>
+              <a:t>Beyond one thread</a:t>
             </a:r>
           </a:p>
         </p:txBody>
@@ -11236,8 +11270,8 @@
         </p:nvSpPr>
         <p:spPr>
           <a:xfrm>
-            <a:off x="731520" y="1463040"/>
-            <a:ext cx="10789920" cy="5120640"/>
+            <a:off x="731520" y="1645920"/>
+            <a:ext cx="10789920" cy="4937760"/>
           </a:xfrm>
           <a:prstGeom prst="rect">
             <a:avLst/>
@@ -11256,72 +11290,72 @@
               </a:spcAft>
             </a:pPr>
             <a:r>
-              <a:rPr sz="2200">
-                <a:solidFill>
-                  <a:srgbClr val="212121"/>
-                </a:solidFill>
-              </a:rPr>
-              <a:t>Groups of 3–4. Three short C programs on the handout (predict1.c, predict2.c, predict3.c).</a:t>
-            </a:r>
-          </a:p>
-          <a:p>
-            <a:pPr>
-              <a:spcAft>
-                <a:spcPts val="800"/>
-              </a:spcAft>
-            </a:pPr>
-            <a:r>
-              <a:rPr sz="2200">
-                <a:solidFill>
-                  <a:srgbClr val="212121"/>
-                </a:solidFill>
-              </a:rPr>
-              <a:t>For each program, write down BEFORE we run anything:</a:t>
-            </a:r>
-          </a:p>
-          <a:p>
-            <a:pPr lvl="1">
-              <a:spcAft>
-                <a:spcPts val="800"/>
-              </a:spcAft>
-            </a:pPr>
-            <a:r>
-              <a:rPr sz="2000">
-                <a:solidFill>
-                  <a:srgbClr val="212121"/>
-                </a:solidFill>
-              </a:rPr>
-              <a:t>Will the model checker say VERIFICATION FAILED or SUCCESSFUL?</a:t>
-            </a:r>
-          </a:p>
-          <a:p>
-            <a:pPr lvl="1">
-              <a:spcAft>
-                <a:spcPts val="800"/>
-              </a:spcAft>
-            </a:pPr>
-            <a:r>
-              <a:rPr sz="2000">
-                <a:solidFill>
-                  <a:srgbClr val="212121"/>
-                </a:solidFill>
-              </a:rPr>
-              <a:t>If FAILED — which line is the culprit?</a:t>
-            </a:r>
-          </a:p>
-          <a:p>
-            <a:pPr>
-              <a:spcAft>
-                <a:spcPts val="800"/>
-              </a:spcAft>
-            </a:pPr>
-            <a:r>
-              <a:rPr sz="2200">
-                <a:solidFill>
-                  <a:srgbClr val="212121"/>
-                </a:solidFill>
-              </a:rPr>
-              <a:t>Then we run ESBMC live and settle every bet.</a:t>
+              <a:rPr sz="2400">
+                <a:solidFill>
+                  <a:srgbClr val="212121"/>
+                </a:solidFill>
+              </a:rPr>
+              <a:t>Two threads of two and one statements already have three interleavings. Real code has billions.</a:t>
+            </a:r>
+          </a:p>
+          <a:p>
+            <a:pPr>
+              <a:spcAft>
+                <a:spcPts val="800"/>
+              </a:spcAft>
+            </a:pPr>
+            <a:r>
+              <a:rPr sz="2400">
+                <a:solidFill>
+                  <a:srgbClr val="212121"/>
+                </a:solidFill>
+              </a:rPr>
+              <a:t>Run the program a million times and the bad interleaving may never show up — Therac-25's bug hid exactly this way.</a:t>
+            </a:r>
+          </a:p>
+          <a:p>
+            <a:pPr>
+              <a:spcAft>
+                <a:spcPts val="800"/>
+              </a:spcAft>
+            </a:pPr>
+            <a:r>
+              <a:rPr sz="2400">
+                <a:solidFill>
+                  <a:srgbClr val="212121"/>
+                </a:solidFill>
+              </a:rPr>
+              <a:t>A model checker enumerates every interleaving up to a bound, including the one that kills your assertion.</a:t>
+            </a:r>
+          </a:p>
+          <a:p>
+            <a:pPr>
+              <a:spcAft>
+                <a:spcPts val="800"/>
+              </a:spcAft>
+            </a:pPr>
+            <a:r>
+              <a:rPr sz="2400">
+                <a:solidFill>
+                  <a:srgbClr val="212121"/>
+                </a:solidFill>
+              </a:rPr>
+              <a:t/>
+            </a:r>
+          </a:p>
+          <a:p>
+            <a:pPr>
+              <a:spcAft>
+                <a:spcPts val="800"/>
+              </a:spcAft>
+            </a:pPr>
+            <a:r>
+              <a:rPr sz="2400">
+                <a:solidFill>
+                  <a:srgbClr val="212121"/>
+                </a:solidFill>
+              </a:rPr>
+              <a:t>Session 2, Lab 4: you write down the killer interleaving before the tool finds it.</a:t>
             </a:r>
           </a:p>
         </p:txBody>
@@ -11372,7 +11406,7 @@
                   <a:srgbClr val="5A0A7A"/>
                 </a:solidFill>
               </a:rPr>
-              <a:t>Who uses this? — Model checking</a:t>
+              <a:t>Homework for your intuition</a:t>
             </a:r>
           </a:p>
         </p:txBody>
@@ -11385,8 +11419,8 @@
         </p:nvSpPr>
         <p:spPr>
           <a:xfrm>
-            <a:off x="731520" y="1463040"/>
-            <a:ext cx="10789920" cy="5120640"/>
+            <a:off x="731520" y="1828800"/>
+            <a:ext cx="10789920" cy="4754880"/>
           </a:xfrm>
           <a:prstGeom prst="rect">
             <a:avLst/>
@@ -11401,7 +11435,7 @@
           <a:p>
             <a:pPr>
               <a:spcAft>
-                <a:spcPts val="800"/>
+                <a:spcPts val="0"/>
               </a:spcAft>
             </a:pPr>
             <a:r>
@@ -11409,14 +11443,15 @@
                 <a:solidFill>
                   <a:srgbClr val="212121"/>
                 </a:solidFill>
-              </a:rPr>
-              <a:t>Amazon Web Services — CBMC proves memory safety of the TLS library s2n; bounded proofs run in CI on every commit</a:t>
-            </a:r>
-          </a:p>
-          <a:p>
-            <a:pPr>
-              <a:spcAft>
-                <a:spcPts val="800"/>
+                <a:latin typeface="Courier New"/>
+              </a:rPr>
+              <a:t>double w = 0.1 + 0.2;</a:t>
+            </a:r>
+          </a:p>
+          <a:p>
+            <a:pPr>
+              <a:spcAft>
+                <a:spcPts val="0"/>
               </a:spcAft>
             </a:pPr>
             <a:r>
@@ -11424,23 +11459,84 @@
                 <a:solidFill>
                   <a:srgbClr val="212121"/>
                 </a:solidFill>
-              </a:rPr>
-              <a:t>ESBMC / CBMC — the tools from tonight's demos; compete yearly in SV-COMP on tens of thousands of benchmarks</a:t>
-            </a:r>
-          </a:p>
-          <a:p>
-            <a:pPr>
-              <a:spcAft>
-                <a:spcPts val="800"/>
-              </a:spcAft>
-            </a:pPr>
-            <a:r>
-              <a:rPr sz="2200">
-                <a:solidFill>
-                  <a:srgbClr val="212121"/>
-                </a:solidFill>
-              </a:rPr>
-              <a:t>The counterexample you saw for getpassword.c is the same artefact AWS engineers read when a proof fails</a:t>
+                <a:latin typeface="Courier New"/>
+              </a:rPr>
+              <a:t>assert(w == 0.3);</a:t>
+            </a:r>
+          </a:p>
+          <a:p>
+            <a:pPr>
+              <a:spcAft>
+                <a:spcPts val="800"/>
+              </a:spcAft>
+            </a:pPr>
+            <a:r>
+              <a:rPr sz="2600">
+                <a:solidFill>
+                  <a:srgbClr val="212121"/>
+                </a:solidFill>
+              </a:rPr>
+              <a:t/>
+            </a:r>
+          </a:p>
+          <a:p>
+            <a:pPr>
+              <a:spcAft>
+                <a:spcPts val="800"/>
+              </a:spcAft>
+            </a:pPr>
+            <a:r>
+              <a:rPr sz="2600">
+                <a:solidFill>
+                  <a:srgbClr val="212121"/>
+                </a:solidFill>
+              </a:rPr>
+              <a:t>FAILED or SUCCESSFUL?</a:t>
+            </a:r>
+          </a:p>
+          <a:p>
+            <a:pPr>
+              <a:spcAft>
+                <a:spcPts val="800"/>
+              </a:spcAft>
+            </a:pPr>
+            <a:r>
+              <a:rPr sz="2600">
+                <a:solidFill>
+                  <a:srgbClr val="212121"/>
+                </a:solidFill>
+              </a:rPr>
+              <a:t/>
+            </a:r>
+          </a:p>
+          <a:p>
+            <a:pPr>
+              <a:spcAft>
+                <a:spcPts val="800"/>
+              </a:spcAft>
+            </a:pPr>
+            <a:r>
+              <a:rPr sz="2600">
+                <a:solidFill>
+                  <a:srgbClr val="212121"/>
+                </a:solidFill>
+              </a:rPr>
+              <a:t>Bring your answer to Session 2 — Lab 4 settles it with a solver that does exact IEEE-754 arithmetic.</a:t>
+            </a:r>
+          </a:p>
+          <a:p>
+            <a:pPr lvl="1">
+              <a:spcAft>
+                <a:spcPts val="800"/>
+              </a:spcAft>
+            </a:pPr>
+            <a:r>
+              <a:rPr sz="2400">
+                <a:solidFill>
+                  <a:srgbClr val="212121"/>
+                </a:solidFill>
+              </a:rPr>
+              <a:t>Hint: 0.1 in binary is like 1/3 in decimal.</a:t>
             </a:r>
           </a:p>
         </p:txBody>
@@ -11491,7 +11587,7 @@
                   <a:srgbClr val="5A0A7A"/>
                 </a:solidFill>
               </a:rPr>
-              <a:t>Who uses this? — Symbolic execution &amp; fuzzing</a:t>
+              <a:t>Exercise 2 — Predict the Verdict (15 min)</a:t>
             </a:r>
           </a:p>
         </p:txBody>
@@ -11529,7 +11625,7 @@
                   <a:srgbClr val="212121"/>
                 </a:solidFill>
               </a:rPr>
-              <a:t>KLEE found 56 serious bugs in coreutils, busybox and Minix — including three in coreutils that had survived 15 years of testing</a:t>
+              <a:t>Groups of 3–4. Three short C programs on the handout (predict1.c, predict2.c, predict3.c).</a:t>
             </a:r>
           </a:p>
           <a:p>
@@ -11544,7 +11640,37 @@
                   <a:srgbClr val="212121"/>
                 </a:solidFill>
               </a:rPr>
-              <a:t>Microsoft SAGE fuzzed Windows file parsers with symbolic execution; it found ~1/3 of all bugs caught by file fuzzing during Windows 7 development — running last, after every other tool</a:t>
+              <a:t>For each program, write down BEFORE we run anything:</a:t>
+            </a:r>
+          </a:p>
+          <a:p>
+            <a:pPr lvl="1">
+              <a:spcAft>
+                <a:spcPts val="800"/>
+              </a:spcAft>
+            </a:pPr>
+            <a:r>
+              <a:rPr sz="2000">
+                <a:solidFill>
+                  <a:srgbClr val="212121"/>
+                </a:solidFill>
+              </a:rPr>
+              <a:t>Will the model checker say VERIFICATION FAILED or SUCCESSFUL?</a:t>
+            </a:r>
+          </a:p>
+          <a:p>
+            <a:pPr lvl="1">
+              <a:spcAft>
+                <a:spcPts val="800"/>
+              </a:spcAft>
+            </a:pPr>
+            <a:r>
+              <a:rPr sz="2000">
+                <a:solidFill>
+                  <a:srgbClr val="212121"/>
+                </a:solidFill>
+              </a:rPr>
+              <a:t>If FAILED — which line is the culprit?</a:t>
             </a:r>
           </a:p>
           <a:p>
@@ -11559,22 +11685,7 @@
                   <a:srgbClr val="212121"/>
                 </a:solidFill>
               </a:rPr>
-              <a:t>AFL / OSS-Fuzz — Google fuzzes ~1,000 open-source projects continuously; tens of thousands of bugs found</a:t>
-            </a:r>
-          </a:p>
-          <a:p>
-            <a:pPr>
-              <a:spcAft>
-                <a:spcPts val="800"/>
-              </a:spcAft>
-            </a:pPr>
-            <a:r>
-              <a:rPr sz="2200">
-                <a:solidFill>
-                  <a:srgbClr val="212121"/>
-                </a:solidFill>
-              </a:rPr>
-              <a:t>The pragmatic cousin of verification: no proofs, ruthless effectiveness</a:t>
+              <a:t>Then we run ESBMC live and settle every bet.</a:t>
             </a:r>
           </a:p>
         </p:txBody>
@@ -11625,7 +11736,7 @@
                   <a:srgbClr val="5A0A7A"/>
                 </a:solidFill>
               </a:rPr>
-              <a:t>Who uses this? — Proofs all the way up</a:t>
+              <a:t>Who uses this? — Model checking</a:t>
             </a:r>
           </a:p>
         </p:txBody>
@@ -11663,7 +11774,7 @@
                   <a:srgbClr val="212121"/>
                 </a:solidFill>
               </a:rPr>
-              <a:t>Astrée (abstract interpretation) proved absence of runtime errors in the Airbus A340 fly-by-wire code — 132,000 lines of C — and was then applied to the A380</a:t>
+              <a:t>Amazon Web Services — CBMC proves memory safety of the TLS library s2n; bounded proofs run in CI on every commit</a:t>
             </a:r>
           </a:p>
           <a:p>
@@ -11678,7 +11789,7 @@
                   <a:srgbClr val="212121"/>
                 </a:solidFill>
               </a:rPr>
-              <a:t>seL4 — an OS microkernel with a machine-checked proof of functional correctness</a:t>
+              <a:t>ESBMC / CBMC — the tools from tonight's demos; compete yearly in SV-COMP on tens of thousands of benchmarks</a:t>
             </a:r>
           </a:p>
           <a:p>
@@ -11693,7 +11804,7 @@
                   <a:srgbClr val="212121"/>
                 </a:solidFill>
               </a:rPr>
-              <a:t>CompCert — a C compiler with a proof that compilation preserves semantics; six CPU-years of fuzzing found no wrong-code bugs in its verified core, while every other compiler tested failed</a:t>
+              <a:t>The counterexample you saw for getpassword.c is the same artefact AWS engineers read when a proof fails</a:t>
             </a:r>
           </a:p>
         </p:txBody>
@@ -11744,7 +11855,7 @@
                   <a:srgbClr val="5A0A7A"/>
                 </a:solidFill>
               </a:rPr>
-              <a:t>Discussion</a:t>
+              <a:t>Who uses this? — Symbolic execution &amp; fuzzing</a:t>
             </a:r>
           </a:p>
         </p:txBody>
@@ -11757,8 +11868,8 @@
         </p:nvSpPr>
         <p:spPr>
           <a:xfrm>
-            <a:off x="731520" y="2194560"/>
-            <a:ext cx="10789920" cy="4389120"/>
+            <a:off x="731520" y="1463040"/>
+            <a:ext cx="10789920" cy="5120640"/>
           </a:xfrm>
           <a:prstGeom prst="rect">
             <a:avLst/>
@@ -11777,42 +11888,57 @@
               </a:spcAft>
             </a:pPr>
             <a:r>
-              <a:rPr sz="2800">
-                <a:solidFill>
-                  <a:srgbClr val="212121"/>
-                </a:solidFill>
-              </a:rPr>
-              <a:t>If verification can prove the absence of bugs…</a:t>
-            </a:r>
-          </a:p>
-          <a:p>
-            <a:pPr>
-              <a:spcAft>
-                <a:spcPts val="800"/>
-              </a:spcAft>
-            </a:pPr>
-            <a:r>
-              <a:rPr sz="2800">
-                <a:solidFill>
-                  <a:srgbClr val="212121"/>
-                </a:solidFill>
-              </a:rPr>
-              <a:t>why isn't all software verified?</a:t>
-            </a:r>
-          </a:p>
-          <a:p>
-            <a:pPr>
-              <a:spcAft>
-                <a:spcPts val="800"/>
-              </a:spcAft>
-            </a:pPr>
-            <a:r>
-              <a:rPr sz="2800">
-                <a:solidFill>
-                  <a:srgbClr val="212121"/>
-                </a:solidFill>
-              </a:rPr>
-              <a:t>(Let's collect reasons — then I'll tell you which ones the industry actually cites.)</a:t>
+              <a:rPr sz="2200">
+                <a:solidFill>
+                  <a:srgbClr val="212121"/>
+                </a:solidFill>
+              </a:rPr>
+              <a:t>KLEE found 56 serious bugs in coreutils, busybox and Minix — including three in coreutils that had survived 15 years of testing</a:t>
+            </a:r>
+          </a:p>
+          <a:p>
+            <a:pPr>
+              <a:spcAft>
+                <a:spcPts val="800"/>
+              </a:spcAft>
+            </a:pPr>
+            <a:r>
+              <a:rPr sz="2200">
+                <a:solidFill>
+                  <a:srgbClr val="212121"/>
+                </a:solidFill>
+              </a:rPr>
+              <a:t>Microsoft SAGE fuzzed Windows file parsers with symbolic execution; it found ~1/3 of all bugs caught by file fuzzing during Windows 7 development — running last, after every other tool</a:t>
+            </a:r>
+          </a:p>
+          <a:p>
+            <a:pPr>
+              <a:spcAft>
+                <a:spcPts val="800"/>
+              </a:spcAft>
+            </a:pPr>
+            <a:r>
+              <a:rPr sz="2200">
+                <a:solidFill>
+                  <a:srgbClr val="212121"/>
+                </a:solidFill>
+              </a:rPr>
+              <a:t>AFL / OSS-Fuzz — Google fuzzes ~1,000 open-source projects continuously; tens of thousands of bugs found</a:t>
+            </a:r>
+          </a:p>
+          <a:p>
+            <a:pPr>
+              <a:spcAft>
+                <a:spcPts val="800"/>
+              </a:spcAft>
+            </a:pPr>
+            <a:r>
+              <a:rPr sz="2200">
+                <a:solidFill>
+                  <a:srgbClr val="212121"/>
+                </a:solidFill>
+              </a:rPr>
+              <a:t>The pragmatic cousin of verification: no proofs, ruthless effectiveness</a:t>
             </a:r>
           </a:p>
         </p:txBody>
@@ -11863,7 +11989,7 @@
                   <a:srgbClr val="5A0A7A"/>
                 </a:solidFill>
               </a:rPr>
-              <a:t>Closing quiz</a:t>
+              <a:t>Who uses this? — Proofs all the way up</a:t>
             </a:r>
           </a:p>
         </p:txBody>
@@ -11896,72 +12022,42 @@
               </a:spcAft>
             </a:pPr>
             <a:r>
-              <a:rPr sz="2400">
-                <a:solidFill>
-                  <a:srgbClr val="212121"/>
-                </a:solidFill>
-              </a:rPr>
-              <a:t>1. A tool that never raises a false alarm is called …?</a:t>
-            </a:r>
-          </a:p>
-          <a:p>
-            <a:pPr>
-              <a:spcAft>
-                <a:spcPts val="800"/>
-              </a:spcAft>
-            </a:pPr>
-            <a:r>
-              <a:rPr sz="2400">
-                <a:solidFill>
-                  <a:srgbClr val="212121"/>
-                </a:solidFill>
-              </a:rPr>
-              <a:t>2. ESBMC returns UNSAT for C ∧ ¬P at --unwind 10. What do we know?</a:t>
-            </a:r>
-          </a:p>
-          <a:p>
-            <a:pPr>
-              <a:spcAft>
-                <a:spcPts val="800"/>
-              </a:spcAft>
-            </a:pPr>
-            <a:r>
-              <a:rPr sz="2400">
-                <a:solidFill>
-                  <a:srgbClr val="212121"/>
-                </a:solidFill>
-              </a:rPr>
-              <a:t>3. What's inside a counterexample?</a:t>
-            </a:r>
-          </a:p>
-          <a:p>
-            <a:pPr>
-              <a:spcAft>
-                <a:spcPts val="800"/>
-              </a:spcAft>
-            </a:pPr>
-            <a:r>
-              <a:rPr sz="2400">
-                <a:solidFill>
-                  <a:srgbClr val="212121"/>
-                </a:solidFill>
-              </a:rPr>
-              <a:t>4. Which technique proved the A340 flight-control code free of runtime errors?</a:t>
-            </a:r>
-          </a:p>
-          <a:p>
-            <a:pPr>
-              <a:spcAft>
-                <a:spcPts val="800"/>
-              </a:spcAft>
-            </a:pPr>
-            <a:r>
-              <a:rPr sz="2400">
-                <a:solidFill>
-                  <a:srgbClr val="212121"/>
-                </a:solidFill>
-              </a:rPr>
-              <a:t>5. Why can't testing prove the getPassword program safe?</a:t>
+              <a:rPr sz="2200">
+                <a:solidFill>
+                  <a:srgbClr val="212121"/>
+                </a:solidFill>
+              </a:rPr>
+              <a:t>Astrée (abstract interpretation) proved absence of runtime errors in the Airbus A340 fly-by-wire code — 132,000 lines of C — and was then applied to the A380</a:t>
+            </a:r>
+          </a:p>
+          <a:p>
+            <a:pPr>
+              <a:spcAft>
+                <a:spcPts val="800"/>
+              </a:spcAft>
+            </a:pPr>
+            <a:r>
+              <a:rPr sz="2200">
+                <a:solidFill>
+                  <a:srgbClr val="212121"/>
+                </a:solidFill>
+              </a:rPr>
+              <a:t>seL4 — an OS microkernel with a machine-checked proof of functional correctness</a:t>
+            </a:r>
+          </a:p>
+          <a:p>
+            <a:pPr>
+              <a:spcAft>
+                <a:spcPts val="800"/>
+              </a:spcAft>
+            </a:pPr>
+            <a:r>
+              <a:rPr sz="2200">
+                <a:solidFill>
+                  <a:srgbClr val="212121"/>
+                </a:solidFill>
+              </a:rPr>
+              <a:t>CompCert — a C compiler with a proof that compilation preserves semantics; six CPU-years of fuzzing found no wrong-code bugs in its verified core, while every other compiler tested failed</a:t>
             </a:r>
           </a:p>
         </p:txBody>
@@ -12012,7 +12108,7 @@
                   <a:srgbClr val="5A0A7A"/>
                 </a:solidFill>
               </a:rPr>
-              <a:t>Before Session 2 — 10 minutes of homework</a:t>
+              <a:t>Discussion</a:t>
             </a:r>
           </a:p>
         </p:txBody>
@@ -12025,8 +12121,8 @@
         </p:nvSpPr>
         <p:spPr>
           <a:xfrm>
-            <a:off x="731520" y="1463040"/>
-            <a:ext cx="10789920" cy="5120640"/>
+            <a:off x="731520" y="2194560"/>
+            <a:ext cx="10789920" cy="4389120"/>
           </a:xfrm>
           <a:prstGeom prst="rect">
             <a:avLst/>
@@ -12045,91 +12141,42 @@
               </a:spcAft>
             </a:pPr>
             <a:r>
-              <a:rPr sz="2200">
-                <a:solidFill>
-                  <a:srgbClr val="212121"/>
-                </a:solidFill>
-              </a:rPr>
-              <a:t>Follow handouts/setup.md in the repo:</a:t>
-            </a:r>
-          </a:p>
-          <a:p>
-            <a:pPr>
-              <a:spcAft>
-                <a:spcPts val="0"/>
-              </a:spcAft>
-            </a:pPr>
-            <a:r>
-              <a:rPr sz="1800">
-                <a:solidFill>
-                  <a:srgbClr val="212121"/>
-                </a:solidFill>
-                <a:latin typeface="Courier New"/>
-              </a:rPr>
-              <a:t>1.  pip install z3-solver</a:t>
-            </a:r>
-          </a:p>
-          <a:p>
-            <a:pPr>
-              <a:spcAft>
-                <a:spcPts val="0"/>
-              </a:spcAft>
-            </a:pPr>
-            <a:r>
-              <a:rPr sz="1800">
-                <a:solidFill>
-                  <a:srgbClr val="212121"/>
-                </a:solidFill>
-                <a:latin typeface="Courier New"/>
-              </a:rPr>
-              <a:t>2.  download ESBMC: github.com/esbmc/esbmc/releases</a:t>
-            </a:r>
-          </a:p>
-          <a:p>
-            <a:pPr>
-              <a:spcAft>
-                <a:spcPts val="0"/>
-              </a:spcAft>
-            </a:pPr>
-            <a:r>
-              <a:rPr sz="1800">
-                <a:solidFill>
-                  <a:srgbClr val="212121"/>
-                </a:solidFill>
-                <a:latin typeface="Courier New"/>
-              </a:rPr>
-              <a:t>3.  smoke test:  esbmc labs/lab4/float.c</a:t>
-            </a:r>
-          </a:p>
-          <a:p>
-            <a:pPr>
-              <a:spcAft>
-                <a:spcPts val="0"/>
-              </a:spcAft>
-            </a:pPr>
-            <a:r>
-              <a:rPr sz="1800">
-                <a:solidFill>
-                  <a:srgbClr val="212121"/>
-                </a:solidFill>
-                <a:latin typeface="Courier New"/>
-              </a:rPr>
-              <a:t>    → should print VERIFICATION FAILED (yes, failed — that's the point)</a:t>
-            </a:r>
-          </a:p>
-          <a:p>
-            <a:pPr>
-              <a:spcAft>
-                <a:spcPts val="800"/>
-              </a:spcAft>
-            </a:pPr>
-            <a:r>
-              <a:rPr sz="2200">
-                <a:solidFill>
-                  <a:srgbClr val="212121"/>
-                </a:solidFill>
-              </a:rPr>
-              <a:t>Can't make it work? Come at 17:45 — we'll fix it together.</a:t>
+              <a:rPr sz="2800">
+                <a:solidFill>
+                  <a:srgbClr val="212121"/>
+                </a:solidFill>
+              </a:rPr>
+              <a:t>If verification can prove the absence of bugs…</a:t>
+            </a:r>
+          </a:p>
+          <a:p>
+            <a:pPr>
+              <a:spcAft>
+                <a:spcPts val="800"/>
+              </a:spcAft>
+            </a:pPr>
+            <a:r>
+              <a:rPr sz="2800">
+                <a:solidFill>
+                  <a:srgbClr val="212121"/>
+                </a:solidFill>
+              </a:rPr>
+              <a:t>why isn't all software verified?</a:t>
+            </a:r>
+          </a:p>
+          <a:p>
+            <a:pPr>
+              <a:spcAft>
+                <a:spcPts val="800"/>
+              </a:spcAft>
+            </a:pPr>
+            <a:r>
+              <a:rPr sz="2800">
+                <a:solidFill>
+                  <a:srgbClr val="212121"/>
+                </a:solidFill>
+              </a:rPr>
+              <a:t>(Let's collect reasons — then I'll tell you which ones the industry actually cites.)</a:t>
             </a:r>
           </a:p>
         </p:txBody>
@@ -12394,6 +12441,323 @@
                 </a:solidFill>
               </a:rPr>
               <a:t>session1-demos/getpassword.c — what happens if you type more than three characters?</a:t>
+            </a:r>
+          </a:p>
+        </p:txBody>
+      </p:sp>
+    </p:spTree>
+  </p:cSld>
+  <p:clrMapOvr>
+    <a:masterClrMapping/>
+  </p:clrMapOvr>
+</p:sld>
+</file>
+
+<file path=ppt/slides/slide50.xml><?xml version="1.0" encoding="utf-8"?>
+<p:sld xmlns:a="http://schemas.openxmlformats.org/drawingml/2006/main" xmlns:p="http://schemas.openxmlformats.org/presentationml/2006/main" xmlns:r="http://schemas.openxmlformats.org/officeDocument/2006/relationships">
+  <p:cSld>
+    <p:spTree>
+      <p:nvGrpSpPr>
+        <p:cNvPr id="1" name=""/>
+        <p:cNvGrpSpPr/>
+        <p:nvPr/>
+      </p:nvGrpSpPr>
+      <p:grpSpPr/>
+      <p:sp>
+        <p:nvSpPr>
+          <p:cNvPr id="2" name="TextBox 1"/>
+          <p:cNvSpPr txBox="1"/>
+          <p:nvPr/>
+        </p:nvSpPr>
+        <p:spPr>
+          <a:xfrm>
+            <a:off x="548640" y="365760"/>
+            <a:ext cx="11064240" cy="1005840"/>
+          </a:xfrm>
+          <a:prstGeom prst="rect">
+            <a:avLst/>
+          </a:prstGeom>
+          <a:noFill/>
+        </p:spPr>
+        <p:txBody>
+          <a:bodyPr wrap="square">
+            <a:spAutoFit/>
+          </a:bodyPr>
+          <a:lstStyle/>
+          <a:p>
+            <a:r>
+              <a:rPr sz="3600" b="1">
+                <a:solidFill>
+                  <a:srgbClr val="5A0A7A"/>
+                </a:solidFill>
+              </a:rPr>
+              <a:t>Closing quiz</a:t>
+            </a:r>
+          </a:p>
+        </p:txBody>
+      </p:sp>
+      <p:sp>
+        <p:nvSpPr>
+          <p:cNvPr id="3" name="TextBox 2"/>
+          <p:cNvSpPr txBox="1"/>
+          <p:nvPr/>
+        </p:nvSpPr>
+        <p:spPr>
+          <a:xfrm>
+            <a:off x="731520" y="1463040"/>
+            <a:ext cx="10789920" cy="5120640"/>
+          </a:xfrm>
+          <a:prstGeom prst="rect">
+            <a:avLst/>
+          </a:prstGeom>
+          <a:noFill/>
+        </p:spPr>
+        <p:txBody>
+          <a:bodyPr wrap="square">
+            <a:spAutoFit/>
+          </a:bodyPr>
+          <a:lstStyle/>
+          <a:p>
+            <a:pPr>
+              <a:spcAft>
+                <a:spcPts val="800"/>
+              </a:spcAft>
+            </a:pPr>
+            <a:r>
+              <a:rPr sz="2400">
+                <a:solidFill>
+                  <a:srgbClr val="212121"/>
+                </a:solidFill>
+              </a:rPr>
+              <a:t>1. A tool that never raises a false alarm is called …?</a:t>
+            </a:r>
+          </a:p>
+          <a:p>
+            <a:pPr>
+              <a:spcAft>
+                <a:spcPts val="800"/>
+              </a:spcAft>
+            </a:pPr>
+            <a:r>
+              <a:rPr sz="2400">
+                <a:solidFill>
+                  <a:srgbClr val="212121"/>
+                </a:solidFill>
+              </a:rPr>
+              <a:t>2. ESBMC returns UNSAT for C ∧ ¬P at --unwind 10. What do we know?</a:t>
+            </a:r>
+          </a:p>
+          <a:p>
+            <a:pPr>
+              <a:spcAft>
+                <a:spcPts val="800"/>
+              </a:spcAft>
+            </a:pPr>
+            <a:r>
+              <a:rPr sz="2400">
+                <a:solidFill>
+                  <a:srgbClr val="212121"/>
+                </a:solidFill>
+              </a:rPr>
+              <a:t>3. What's inside a counterexample?</a:t>
+            </a:r>
+          </a:p>
+          <a:p>
+            <a:pPr>
+              <a:spcAft>
+                <a:spcPts val="800"/>
+              </a:spcAft>
+            </a:pPr>
+            <a:r>
+              <a:rPr sz="2400">
+                <a:solidFill>
+                  <a:srgbClr val="212121"/>
+                </a:solidFill>
+              </a:rPr>
+              <a:t>4. Which technique proved the A340 flight-control code free of runtime errors?</a:t>
+            </a:r>
+          </a:p>
+          <a:p>
+            <a:pPr>
+              <a:spcAft>
+                <a:spcPts val="800"/>
+              </a:spcAft>
+            </a:pPr>
+            <a:r>
+              <a:rPr sz="2400">
+                <a:solidFill>
+                  <a:srgbClr val="212121"/>
+                </a:solidFill>
+              </a:rPr>
+              <a:t>5. Why can't testing prove the getPassword program safe?</a:t>
+            </a:r>
+          </a:p>
+        </p:txBody>
+      </p:sp>
+    </p:spTree>
+  </p:cSld>
+  <p:clrMapOvr>
+    <a:masterClrMapping/>
+  </p:clrMapOvr>
+</p:sld>
+</file>
+
+<file path=ppt/slides/slide51.xml><?xml version="1.0" encoding="utf-8"?>
+<p:sld xmlns:a="http://schemas.openxmlformats.org/drawingml/2006/main" xmlns:p="http://schemas.openxmlformats.org/presentationml/2006/main" xmlns:r="http://schemas.openxmlformats.org/officeDocument/2006/relationships">
+  <p:cSld>
+    <p:spTree>
+      <p:nvGrpSpPr>
+        <p:cNvPr id="1" name=""/>
+        <p:cNvGrpSpPr/>
+        <p:nvPr/>
+      </p:nvGrpSpPr>
+      <p:grpSpPr/>
+      <p:sp>
+        <p:nvSpPr>
+          <p:cNvPr id="2" name="TextBox 1"/>
+          <p:cNvSpPr txBox="1"/>
+          <p:nvPr/>
+        </p:nvSpPr>
+        <p:spPr>
+          <a:xfrm>
+            <a:off x="548640" y="365760"/>
+            <a:ext cx="11064240" cy="1005840"/>
+          </a:xfrm>
+          <a:prstGeom prst="rect">
+            <a:avLst/>
+          </a:prstGeom>
+          <a:noFill/>
+        </p:spPr>
+        <p:txBody>
+          <a:bodyPr wrap="square">
+            <a:spAutoFit/>
+          </a:bodyPr>
+          <a:lstStyle/>
+          <a:p>
+            <a:r>
+              <a:rPr sz="3600" b="1">
+                <a:solidFill>
+                  <a:srgbClr val="5A0A7A"/>
+                </a:solidFill>
+              </a:rPr>
+              <a:t>Before Session 2 — 10 minutes of homework</a:t>
+            </a:r>
+          </a:p>
+        </p:txBody>
+      </p:sp>
+      <p:sp>
+        <p:nvSpPr>
+          <p:cNvPr id="3" name="TextBox 2"/>
+          <p:cNvSpPr txBox="1"/>
+          <p:nvPr/>
+        </p:nvSpPr>
+        <p:spPr>
+          <a:xfrm>
+            <a:off x="731520" y="1463040"/>
+            <a:ext cx="10789920" cy="5120640"/>
+          </a:xfrm>
+          <a:prstGeom prst="rect">
+            <a:avLst/>
+          </a:prstGeom>
+          <a:noFill/>
+        </p:spPr>
+        <p:txBody>
+          <a:bodyPr wrap="square">
+            <a:spAutoFit/>
+          </a:bodyPr>
+          <a:lstStyle/>
+          <a:p>
+            <a:pPr>
+              <a:spcAft>
+                <a:spcPts val="800"/>
+              </a:spcAft>
+            </a:pPr>
+            <a:r>
+              <a:rPr sz="2200">
+                <a:solidFill>
+                  <a:srgbClr val="212121"/>
+                </a:solidFill>
+              </a:rPr>
+              <a:t>Follow handouts/setup.md in the repo:</a:t>
+            </a:r>
+          </a:p>
+          <a:p>
+            <a:pPr>
+              <a:spcAft>
+                <a:spcPts val="0"/>
+              </a:spcAft>
+            </a:pPr>
+            <a:r>
+              <a:rPr sz="1800">
+                <a:solidFill>
+                  <a:srgbClr val="212121"/>
+                </a:solidFill>
+                <a:latin typeface="Courier New"/>
+              </a:rPr>
+              <a:t>1.  pip install z3-solver</a:t>
+            </a:r>
+          </a:p>
+          <a:p>
+            <a:pPr>
+              <a:spcAft>
+                <a:spcPts val="0"/>
+              </a:spcAft>
+            </a:pPr>
+            <a:r>
+              <a:rPr sz="1800">
+                <a:solidFill>
+                  <a:srgbClr val="212121"/>
+                </a:solidFill>
+                <a:latin typeface="Courier New"/>
+              </a:rPr>
+              <a:t>2.  download ESBMC: github.com/esbmc/esbmc/releases</a:t>
+            </a:r>
+          </a:p>
+          <a:p>
+            <a:pPr>
+              <a:spcAft>
+                <a:spcPts val="0"/>
+              </a:spcAft>
+            </a:pPr>
+            <a:r>
+              <a:rPr sz="1800">
+                <a:solidFill>
+                  <a:srgbClr val="212121"/>
+                </a:solidFill>
+                <a:latin typeface="Courier New"/>
+              </a:rPr>
+              <a:t>3.  smoke test:  esbmc labs/lab4/float.c</a:t>
+            </a:r>
+          </a:p>
+          <a:p>
+            <a:pPr>
+              <a:spcAft>
+                <a:spcPts val="0"/>
+              </a:spcAft>
+            </a:pPr>
+            <a:r>
+              <a:rPr sz="1800">
+                <a:solidFill>
+                  <a:srgbClr val="212121"/>
+                </a:solidFill>
+                <a:latin typeface="Courier New"/>
+              </a:rPr>
+              <a:t>    → should print VERIFICATION FAILED (yes, failed — that's the point)</a:t>
+            </a:r>
+          </a:p>
+          <a:p>
+            <a:pPr>
+              <a:spcAft>
+                <a:spcPts val="800"/>
+              </a:spcAft>
+            </a:pPr>
+            <a:r>
+              <a:rPr sz="2200">
+                <a:solidFill>
+                  <a:srgbClr val="212121"/>
+                </a:solidFill>
+              </a:rPr>
+              <a:t>Can't make it work? Come at 17:45 — we'll fix it together.</a:t>
             </a:r>
           </a:p>
         </p:txBody>

</xml_diff>

<commit_message>
Add runnable SEND+MORE=MONEY Z3 demo for slide 34
New session1-demos/send_more_money.py encodes the puzzle for Z3 (place-value
sums, Distinct, no leading zero), prints 9567 + 1085 = 10652, then uses the
negation trick to show the solution is unique (unsat). Point slide 34 at it and
add a run-sheet row. Verified against Z3 4.16.0; pylint clean.
</commit_message>
<xml_diff>
--- a/slides/session1/01-session1-fundamentals.pptx
+++ b/slides/session1/01-session1-fundamentals.pptx
@@ -9058,6 +9058,44 @@
                 </a:solidFill>
               </a:rPr>
               <a:t>Lab 1, Stage 2: you run this yourself.</a:t>
+            </a:r>
+          </a:p>
+        </p:txBody>
+      </p:sp>
+      <p:sp>
+        <p:nvSpPr>
+          <p:cNvPr id="4" name="TextBox 3"/>
+          <p:cNvSpPr txBox="1"/>
+          <p:nvPr/>
+        </p:nvSpPr>
+        <p:spPr>
+          <a:xfrm>
+            <a:off x="731520" y="6400800"/>
+            <a:ext cx="10789920" cy="182880"/>
+          </a:xfrm>
+          <a:prstGeom prst="rect">
+            <a:avLst/>
+          </a:prstGeom>
+          <a:noFill/>
+        </p:spPr>
+        <p:txBody>
+          <a:bodyPr wrap="square">
+            <a:spAutoFit/>
+          </a:bodyPr>
+          <a:lstStyle/>
+          <a:p>
+            <a:pPr>
+              <a:spcAft>
+                <a:spcPts val="800"/>
+              </a:spcAft>
+            </a:pPr>
+            <a:r>
+              <a:rPr sz="1400">
+                <a:solidFill>
+                  <a:srgbClr val="212121"/>
+                </a:solidFill>
+              </a:rPr>
+              <a:t>Run it live: session1-demos/send_more_money.py</a:t>
             </a:r>
           </a:p>
         </p:txBody>

</xml_diff>

<commit_message>
Show the send_more_money.py run command on slide 34
Mention the program to run inline, matching the z3_demo/offbyone live-demo
slides ('$ python3 send_more_money.py # in session1-demos/' above its output),
instead of a small footer path.
</commit_message>
<xml_diff>
--- a/slides/session1/01-session1-fundamentals.pptx
+++ b/slides/session1/01-session1-fundamentals.pptx
@@ -9012,6 +9012,22 @@
                 </a:solidFill>
                 <a:latin typeface="Courier New"/>
               </a:rPr>
+              <a:t>$ python3 send_more_money.py        # in session1-demos/</a:t>
+            </a:r>
+          </a:p>
+          <a:p>
+            <a:pPr lvl="1">
+              <a:spcAft>
+                <a:spcPts val="0"/>
+              </a:spcAft>
+            </a:pPr>
+            <a:r>
+              <a:rPr sz="1800">
+                <a:solidFill>
+                  <a:srgbClr val="212121"/>
+                </a:solidFill>
+                <a:latin typeface="Courier New"/>
+              </a:rPr>
               <a:t>9567 + 1085 = 10652   (S=9 E=5 N=6 D=7 M=1 O=0 R=8 Y=2)</a:t>
             </a:r>
           </a:p>
@@ -9058,44 +9074,6 @@
                 </a:solidFill>
               </a:rPr>
               <a:t>Lab 1, Stage 2: you run this yourself.</a:t>
-            </a:r>
-          </a:p>
-        </p:txBody>
-      </p:sp>
-      <p:sp>
-        <p:nvSpPr>
-          <p:cNvPr id="4" name="TextBox 3"/>
-          <p:cNvSpPr txBox="1"/>
-          <p:nvPr/>
-        </p:nvSpPr>
-        <p:spPr>
-          <a:xfrm>
-            <a:off x="731520" y="6400800"/>
-            <a:ext cx="10789920" cy="182880"/>
-          </a:xfrm>
-          <a:prstGeom prst="rect">
-            <a:avLst/>
-          </a:prstGeom>
-          <a:noFill/>
-        </p:spPr>
-        <p:txBody>
-          <a:bodyPr wrap="square">
-            <a:spAutoFit/>
-          </a:bodyPr>
-          <a:lstStyle/>
-          <a:p>
-            <a:pPr>
-              <a:spcAft>
-                <a:spcPts val="800"/>
-              </a:spcAft>
-            </a:pPr>
-            <a:r>
-              <a:rPr sz="1400">
-                <a:solidFill>
-                  <a:srgbClr val="212121"/>
-                </a:solidFill>
-              </a:rPr>
-              <a:t>Run it live: session1-demos/send_more_money.py</a:t>
             </a:r>
           </a:p>
         </p:txBody>

</xml_diff>

<commit_message>
Add optional 'under the hood' slide on ESBMC internals + irep2
New closing aside after Discussion (before the quiz): ESBMC's real pipeline
(Clang → irep2 typed IR → GOTO → symex → SMT backends) and a contributor
pointer to src/irep2/README.md. Kept out of the conceptual BMC pipeline since
irep2 is a developer-facing internal, not end-user material. Deck now 52
slides; update the README run order.
</commit_message>
<xml_diff>
--- a/slides/session1/01-session1-fundamentals.pptx
+++ b/slides/session1/01-session1-fundamentals.pptx
@@ -56,6 +56,7 @@
     <p:sldId id="304" r:id="rId55"/>
     <p:sldId id="305" r:id="rId56"/>
     <p:sldId id="306" r:id="rId57"/>
+    <p:sldId id="307" r:id="rId58"/>
   </p:sldIdLst>
   <p:sldSz cx="12191695" cy="6858000" type="screen4x3"/>
   <p:notesSz cx="6858000" cy="9144000"/>
@@ -12507,7 +12508,7 @@
                   <a:srgbClr val="5A0A7A"/>
                 </a:solidFill>
               </a:rPr>
-              <a:t>Closing quiz</a:t>
+              <a:t>Under the hood — and how to hack on it</a:t>
             </a:r>
           </a:p>
         </p:txBody>
@@ -12540,72 +12541,157 @@
               </a:spcAft>
             </a:pPr>
             <a:r>
-              <a:rPr sz="2400">
-                <a:solidFill>
-                  <a:srgbClr val="212121"/>
-                </a:solidFill>
-              </a:rPr>
-              <a:t>1. A tool that never raises a false alarm is called …?</a:t>
-            </a:r>
-          </a:p>
-          <a:p>
-            <a:pPr>
-              <a:spcAft>
-                <a:spcPts val="800"/>
-              </a:spcAft>
-            </a:pPr>
-            <a:r>
-              <a:rPr sz="2400">
-                <a:solidFill>
-                  <a:srgbClr val="212121"/>
-                </a:solidFill>
-              </a:rPr>
-              <a:t>2. ESBMC returns UNSAT for C ∧ ¬P at --unwind 10. What do we know?</a:t>
-            </a:r>
-          </a:p>
-          <a:p>
-            <a:pPr>
-              <a:spcAft>
-                <a:spcPts val="800"/>
-              </a:spcAft>
-            </a:pPr>
-            <a:r>
-              <a:rPr sz="2400">
-                <a:solidFill>
-                  <a:srgbClr val="212121"/>
-                </a:solidFill>
-              </a:rPr>
-              <a:t>3. What's inside a counterexample?</a:t>
-            </a:r>
-          </a:p>
-          <a:p>
-            <a:pPr>
-              <a:spcAft>
-                <a:spcPts val="800"/>
-              </a:spcAft>
-            </a:pPr>
-            <a:r>
-              <a:rPr sz="2400">
-                <a:solidFill>
-                  <a:srgbClr val="212121"/>
-                </a:solidFill>
-              </a:rPr>
-              <a:t>4. Which technique proved the A340 flight-control code free of runtime errors?</a:t>
-            </a:r>
-          </a:p>
-          <a:p>
-            <a:pPr>
-              <a:spcAft>
-                <a:spcPts val="800"/>
-              </a:spcAft>
-            </a:pPr>
-            <a:r>
-              <a:rPr sz="2400">
-                <a:solidFill>
-                  <a:srgbClr val="212121"/>
-                </a:solidFill>
-              </a:rPr>
-              <a:t>5. Why can't testing prove the getPassword program safe?</a:t>
+              <a:rPr sz="2200">
+                <a:solidFill>
+                  <a:srgbClr val="212121"/>
+                </a:solidFill>
+              </a:rPr>
+              <a:t>Tonight's pipeline was the conceptual one. ESBMC's real pipeline:</a:t>
+            </a:r>
+          </a:p>
+          <a:p>
+            <a:pPr lvl="1">
+              <a:spcAft>
+                <a:spcPts val="800"/>
+              </a:spcAft>
+            </a:pPr>
+            <a:r>
+              <a:rPr sz="2000">
+                <a:solidFill>
+                  <a:srgbClr val="212121"/>
+                </a:solidFill>
+              </a:rPr>
+              <a:t>Clang frontend → irep2 (typed IR) → GOTO program → symbolic execution (unwind, SSA) → SMT backends (Z3, Bitwuzla, cvc5)</a:t>
+            </a:r>
+          </a:p>
+          <a:p>
+            <a:pPr>
+              <a:spcAft>
+                <a:spcPts val="800"/>
+              </a:spcAft>
+            </a:pPr>
+            <a:r>
+              <a:rPr sz="2200">
+                <a:solidFill>
+                  <a:srgbClr val="212121"/>
+                </a:solidFill>
+              </a:rPr>
+              <a:t/>
+            </a:r>
+          </a:p>
+          <a:p>
+            <a:pPr>
+              <a:spcAft>
+                <a:spcPts val="800"/>
+              </a:spcAft>
+            </a:pPr>
+            <a:r>
+              <a:rPr sz="2200">
+                <a:solidFill>
+                  <a:srgbClr val="212121"/>
+                </a:solidFill>
+              </a:rPr>
+              <a:t>irep2 is the typed, reference-counted representation everything lowers to and every backend consumes.</a:t>
+            </a:r>
+          </a:p>
+          <a:p>
+            <a:pPr>
+              <a:spcAft>
+                <a:spcPts val="800"/>
+              </a:spcAft>
+            </a:pPr>
+            <a:r>
+              <a:rPr sz="2200">
+                <a:solidFill>
+                  <a:srgbClr val="212121"/>
+                </a:solidFill>
+              </a:rPr>
+              <a:t>Want to add a check, a frontend, or a new node type? Start here:</a:t>
+            </a:r>
+          </a:p>
+          <a:p>
+            <a:pPr lvl="1">
+              <a:spcAft>
+                <a:spcPts val="0"/>
+              </a:spcAft>
+            </a:pPr>
+            <a:r>
+              <a:rPr sz="1800">
+                <a:solidFill>
+                  <a:srgbClr val="212121"/>
+                </a:solidFill>
+                <a:latin typeface="Courier New"/>
+              </a:rPr>
+              <a:t>github.com/esbmc/esbmc  →  src/irep2/README.md</a:t>
+            </a:r>
+          </a:p>
+          <a:p>
+            <a:pPr>
+              <a:spcAft>
+                <a:spcPts val="800"/>
+              </a:spcAft>
+            </a:pPr>
+            <a:r>
+              <a:rPr sz="2200">
+                <a:solidFill>
+                  <a:srgbClr val="212121"/>
+                </a:solidFill>
+              </a:rPr>
+              <a:t/>
+            </a:r>
+          </a:p>
+          <a:p>
+            <a:pPr>
+              <a:spcAft>
+                <a:spcPts val="800"/>
+              </a:spcAft>
+            </a:pPr>
+            <a:r>
+              <a:rPr sz="2200">
+                <a:solidFill>
+                  <a:srgbClr val="212121"/>
+                </a:solidFill>
+              </a:rPr>
+              <a:t>For the curious — and anyone who wants to contribute.</a:t>
+            </a:r>
+          </a:p>
+        </p:txBody>
+      </p:sp>
+      <p:sp>
+        <p:nvSpPr>
+          <p:cNvPr id="4" name="TextBox 3"/>
+          <p:cNvSpPr txBox="1"/>
+          <p:nvPr/>
+        </p:nvSpPr>
+        <p:spPr>
+          <a:xfrm>
+            <a:off x="731520" y="6400800"/>
+            <a:ext cx="10789920" cy="182880"/>
+          </a:xfrm>
+          <a:prstGeom prst="rect">
+            <a:avLst/>
+          </a:prstGeom>
+          <a:noFill/>
+        </p:spPr>
+        <p:txBody>
+          <a:bodyPr wrap="square">
+            <a:spAutoFit/>
+          </a:bodyPr>
+          <a:lstStyle/>
+          <a:p>
+            <a:pPr>
+              <a:spcAft>
+                <a:spcPts val="800"/>
+              </a:spcAft>
+            </a:pPr>
+            <a:r>
+              <a:rPr sz="1400">
+                <a:solidFill>
+                  <a:srgbClr val="212121"/>
+                </a:solidFill>
+                <a:hlinkClick r:id="rId2"/>
+              </a:rPr>
+              <a:t>src/irep2/README.md</a:t>
             </a:r>
           </a:p>
         </p:txBody>
@@ -12619,6 +12705,155 @@
 </file>
 
 <file path=ppt/slides/slide51.xml><?xml version="1.0" encoding="utf-8"?>
+<p:sld xmlns:a="http://schemas.openxmlformats.org/drawingml/2006/main" xmlns:p="http://schemas.openxmlformats.org/presentationml/2006/main" xmlns:r="http://schemas.openxmlformats.org/officeDocument/2006/relationships">
+  <p:cSld>
+    <p:spTree>
+      <p:nvGrpSpPr>
+        <p:cNvPr id="1" name=""/>
+        <p:cNvGrpSpPr/>
+        <p:nvPr/>
+      </p:nvGrpSpPr>
+      <p:grpSpPr/>
+      <p:sp>
+        <p:nvSpPr>
+          <p:cNvPr id="2" name="TextBox 1"/>
+          <p:cNvSpPr txBox="1"/>
+          <p:nvPr/>
+        </p:nvSpPr>
+        <p:spPr>
+          <a:xfrm>
+            <a:off x="548640" y="365760"/>
+            <a:ext cx="11064240" cy="1005840"/>
+          </a:xfrm>
+          <a:prstGeom prst="rect">
+            <a:avLst/>
+          </a:prstGeom>
+          <a:noFill/>
+        </p:spPr>
+        <p:txBody>
+          <a:bodyPr wrap="square">
+            <a:spAutoFit/>
+          </a:bodyPr>
+          <a:lstStyle/>
+          <a:p>
+            <a:r>
+              <a:rPr sz="3600" b="1">
+                <a:solidFill>
+                  <a:srgbClr val="5A0A7A"/>
+                </a:solidFill>
+              </a:rPr>
+              <a:t>Closing quiz</a:t>
+            </a:r>
+          </a:p>
+        </p:txBody>
+      </p:sp>
+      <p:sp>
+        <p:nvSpPr>
+          <p:cNvPr id="3" name="TextBox 2"/>
+          <p:cNvSpPr txBox="1"/>
+          <p:nvPr/>
+        </p:nvSpPr>
+        <p:spPr>
+          <a:xfrm>
+            <a:off x="731520" y="1463040"/>
+            <a:ext cx="10789920" cy="5120640"/>
+          </a:xfrm>
+          <a:prstGeom prst="rect">
+            <a:avLst/>
+          </a:prstGeom>
+          <a:noFill/>
+        </p:spPr>
+        <p:txBody>
+          <a:bodyPr wrap="square">
+            <a:spAutoFit/>
+          </a:bodyPr>
+          <a:lstStyle/>
+          <a:p>
+            <a:pPr>
+              <a:spcAft>
+                <a:spcPts val="800"/>
+              </a:spcAft>
+            </a:pPr>
+            <a:r>
+              <a:rPr sz="2400">
+                <a:solidFill>
+                  <a:srgbClr val="212121"/>
+                </a:solidFill>
+              </a:rPr>
+              <a:t>1. A tool that never raises a false alarm is called …?</a:t>
+            </a:r>
+          </a:p>
+          <a:p>
+            <a:pPr>
+              <a:spcAft>
+                <a:spcPts val="800"/>
+              </a:spcAft>
+            </a:pPr>
+            <a:r>
+              <a:rPr sz="2400">
+                <a:solidFill>
+                  <a:srgbClr val="212121"/>
+                </a:solidFill>
+              </a:rPr>
+              <a:t>2. ESBMC returns UNSAT for C ∧ ¬P at --unwind 10. What do we know?</a:t>
+            </a:r>
+          </a:p>
+          <a:p>
+            <a:pPr>
+              <a:spcAft>
+                <a:spcPts val="800"/>
+              </a:spcAft>
+            </a:pPr>
+            <a:r>
+              <a:rPr sz="2400">
+                <a:solidFill>
+                  <a:srgbClr val="212121"/>
+                </a:solidFill>
+              </a:rPr>
+              <a:t>3. What's inside a counterexample?</a:t>
+            </a:r>
+          </a:p>
+          <a:p>
+            <a:pPr>
+              <a:spcAft>
+                <a:spcPts val="800"/>
+              </a:spcAft>
+            </a:pPr>
+            <a:r>
+              <a:rPr sz="2400">
+                <a:solidFill>
+                  <a:srgbClr val="212121"/>
+                </a:solidFill>
+              </a:rPr>
+              <a:t>4. Which technique proved the A340 flight-control code free of runtime errors?</a:t>
+            </a:r>
+          </a:p>
+          <a:p>
+            <a:pPr>
+              <a:spcAft>
+                <a:spcPts val="800"/>
+              </a:spcAft>
+            </a:pPr>
+            <a:r>
+              <a:rPr sz="2400">
+                <a:solidFill>
+                  <a:srgbClr val="212121"/>
+                </a:solidFill>
+              </a:rPr>
+              <a:t>5. Why can't testing prove the getPassword program safe?</a:t>
+            </a:r>
+          </a:p>
+        </p:txBody>
+      </p:sp>
+    </p:spTree>
+  </p:cSld>
+  <p:clrMapOvr>
+    <a:masterClrMapping/>
+  </p:clrMapOvr>
+</p:sld>
+</file>
+
+<file path=ppt/slides/slide52.xml><?xml version="1.0" encoding="utf-8"?>
 <p:sld xmlns:a="http://schemas.openxmlformats.org/drawingml/2006/main" xmlns:p="http://schemas.openxmlformats.org/presentationml/2006/main" xmlns:r="http://schemas.openxmlformats.org/officeDocument/2006/relationships">
   <p:cSld>
     <p:spTree>

</xml_diff>

<commit_message>
Refresh Session 1 deck and add PDF export
Re-save the session-1 fundamentals .pptx (slide text unchanged from the
prior commit; visual/binary refresh) and add a PDF export of the deck.
</commit_message>
<xml_diff>
--- a/slides/session1/01-session1-fundamentals.pptx
+++ b/slides/session1/01-session1-fundamentals.pptx
@@ -5,60 +5,60 @@
     <p:sldMasterId id="2147483648" r:id="rId1"/>
   </p:sldMasterIdLst>
   <p:sldIdLst>
-    <p:sldId id="256" r:id="rId7"/>
-    <p:sldId id="257" r:id="rId8"/>
-    <p:sldId id="258" r:id="rId9"/>
-    <p:sldId id="259" r:id="rId10"/>
-    <p:sldId id="260" r:id="rId11"/>
-    <p:sldId id="261" r:id="rId12"/>
-    <p:sldId id="262" r:id="rId13"/>
-    <p:sldId id="263" r:id="rId14"/>
-    <p:sldId id="264" r:id="rId15"/>
-    <p:sldId id="265" r:id="rId16"/>
-    <p:sldId id="266" r:id="rId17"/>
-    <p:sldId id="267" r:id="rId18"/>
-    <p:sldId id="268" r:id="rId19"/>
-    <p:sldId id="269" r:id="rId20"/>
-    <p:sldId id="270" r:id="rId21"/>
-    <p:sldId id="271" r:id="rId22"/>
-    <p:sldId id="272" r:id="rId23"/>
-    <p:sldId id="273" r:id="rId24"/>
-    <p:sldId id="274" r:id="rId25"/>
-    <p:sldId id="275" r:id="rId26"/>
-    <p:sldId id="276" r:id="rId27"/>
-    <p:sldId id="277" r:id="rId28"/>
-    <p:sldId id="278" r:id="rId29"/>
-    <p:sldId id="279" r:id="rId30"/>
-    <p:sldId id="280" r:id="rId31"/>
-    <p:sldId id="281" r:id="rId32"/>
-    <p:sldId id="282" r:id="rId33"/>
-    <p:sldId id="283" r:id="rId34"/>
-    <p:sldId id="284" r:id="rId35"/>
-    <p:sldId id="285" r:id="rId36"/>
-    <p:sldId id="286" r:id="rId37"/>
-    <p:sldId id="287" r:id="rId38"/>
-    <p:sldId id="288" r:id="rId39"/>
-    <p:sldId id="289" r:id="rId40"/>
-    <p:sldId id="290" r:id="rId41"/>
-    <p:sldId id="291" r:id="rId42"/>
-    <p:sldId id="292" r:id="rId43"/>
-    <p:sldId id="293" r:id="rId44"/>
-    <p:sldId id="294" r:id="rId45"/>
-    <p:sldId id="295" r:id="rId46"/>
-    <p:sldId id="296" r:id="rId47"/>
-    <p:sldId id="297" r:id="rId48"/>
-    <p:sldId id="298" r:id="rId49"/>
-    <p:sldId id="299" r:id="rId50"/>
-    <p:sldId id="300" r:id="rId51"/>
-    <p:sldId id="301" r:id="rId52"/>
-    <p:sldId id="302" r:id="rId53"/>
-    <p:sldId id="303" r:id="rId54"/>
-    <p:sldId id="304" r:id="rId55"/>
-    <p:sldId id="305" r:id="rId56"/>
-    <p:sldId id="306" r:id="rId57"/>
-    <p:sldId id="307" r:id="rId58"/>
+    <p:sldId id="256" r:id="rId2"/>
+    <p:sldId id="257" r:id="rId3"/>
+    <p:sldId id="258" r:id="rId4"/>
+    <p:sldId id="259" r:id="rId5"/>
+    <p:sldId id="260" r:id="rId6"/>
+    <p:sldId id="261" r:id="rId7"/>
+    <p:sldId id="262" r:id="rId8"/>
+    <p:sldId id="263" r:id="rId9"/>
+    <p:sldId id="264" r:id="rId10"/>
+    <p:sldId id="265" r:id="rId11"/>
+    <p:sldId id="266" r:id="rId12"/>
+    <p:sldId id="267" r:id="rId13"/>
+    <p:sldId id="268" r:id="rId14"/>
+    <p:sldId id="269" r:id="rId15"/>
+    <p:sldId id="270" r:id="rId16"/>
+    <p:sldId id="271" r:id="rId17"/>
+    <p:sldId id="272" r:id="rId18"/>
+    <p:sldId id="273" r:id="rId19"/>
+    <p:sldId id="274" r:id="rId20"/>
+    <p:sldId id="275" r:id="rId21"/>
+    <p:sldId id="276" r:id="rId22"/>
+    <p:sldId id="277" r:id="rId23"/>
+    <p:sldId id="278" r:id="rId24"/>
+    <p:sldId id="279" r:id="rId25"/>
+    <p:sldId id="280" r:id="rId26"/>
+    <p:sldId id="281" r:id="rId27"/>
+    <p:sldId id="282" r:id="rId28"/>
+    <p:sldId id="283" r:id="rId29"/>
+    <p:sldId id="284" r:id="rId30"/>
+    <p:sldId id="285" r:id="rId31"/>
+    <p:sldId id="286" r:id="rId32"/>
+    <p:sldId id="287" r:id="rId33"/>
+    <p:sldId id="288" r:id="rId34"/>
+    <p:sldId id="289" r:id="rId35"/>
+    <p:sldId id="290" r:id="rId36"/>
+    <p:sldId id="291" r:id="rId37"/>
+    <p:sldId id="292" r:id="rId38"/>
+    <p:sldId id="293" r:id="rId39"/>
+    <p:sldId id="294" r:id="rId40"/>
+    <p:sldId id="295" r:id="rId41"/>
+    <p:sldId id="296" r:id="rId42"/>
+    <p:sldId id="297" r:id="rId43"/>
+    <p:sldId id="298" r:id="rId44"/>
+    <p:sldId id="299" r:id="rId45"/>
+    <p:sldId id="300" r:id="rId46"/>
+    <p:sldId id="301" r:id="rId47"/>
+    <p:sldId id="302" r:id="rId48"/>
+    <p:sldId id="303" r:id="rId49"/>
+    <p:sldId id="304" r:id="rId50"/>
+    <p:sldId id="305" r:id="rId51"/>
+    <p:sldId id="306" r:id="rId52"/>
+    <p:sldId id="307" r:id="rId53"/>
   </p:sldIdLst>
-  <p:sldSz cx="12191695" cy="6858000" type="screen4x3"/>
+  <p:sldSz cx="12192000" cy="6858000"/>
   <p:notesSz cx="6858000" cy="9144000"/>
   <p:defaultTextStyle>
     <a:defPPr>
@@ -155,15 +155,38 @@
       </a:defRPr>
     </a:lvl9pPr>
   </p:defaultTextStyle>
+  <p:extLst>
+    <p:ext uri="{EFAFB233-063F-42B5-8137-9DF3F51BA10A}">
+      <p15:sldGuideLst xmlns:p15="http://schemas.microsoft.com/office/powerpoint/2012/main">
+        <p15:guide id="1" orient="horz" pos="2160">
+          <p15:clr>
+            <a:srgbClr val="A4A3A4"/>
+          </p15:clr>
+        </p15:guide>
+        <p15:guide id="2" pos="2880">
+          <p15:clr>
+            <a:srgbClr val="A4A3A4"/>
+          </p15:clr>
+        </p15:guide>
+      </p15:sldGuideLst>
+    </p:ext>
+  </p:extLst>
 </p:presentation>
 </file>
 
 <file path=ppt/charts/chart1.xml><?xml version="1.0" encoding="utf-8"?>
-<c:chartSpace xmlns:c="http://schemas.openxmlformats.org/drawingml/2006/chart" xmlns:a="http://schemas.openxmlformats.org/drawingml/2006/main" xmlns:r="http://schemas.openxmlformats.org/officeDocument/2006/relationships">
+<c:chartSpace xmlns:c="http://schemas.openxmlformats.org/drawingml/2006/chart" xmlns:a="http://schemas.openxmlformats.org/drawingml/2006/main" xmlns:r="http://schemas.openxmlformats.org/officeDocument/2006/relationships" xmlns:c16r2="http://schemas.microsoft.com/office/drawing/2015/06/chart">
   <c:date1904 val="0"/>
+  <c:lang val="en-GB"/>
+  <c:roundedCorners val="1"/>
+  <c:style val="2"/>
   <c:chart>
+    <c:title>
+      <c:overlay val="0"/>
+    </c:title>
     <c:autoTitleDeleted val="0"/>
     <c:plotArea>
+      <c:layout/>
       <c:lineChart>
         <c:grouping val="standard"/>
         <c:varyColors val="0"/>
@@ -259,7 +282,20 @@
             </c:numRef>
           </c:val>
           <c:smooth val="0"/>
+          <c:extLst>
+            <c:ext xmlns:c16="http://schemas.microsoft.com/office/drawing/2014/chart" uri="{C3380CC4-5D6E-409C-BE32-E72D297353CC}">
+              <c16:uniqueId val="{00000000-3DAB-F942-930F-2328B436AADD}"/>
+            </c:ext>
+          </c:extLst>
         </c:ser>
+        <c:dLbls>
+          <c:showLegendKey val="0"/>
+          <c:showVal val="0"/>
+          <c:showCatName val="0"/>
+          <c:showSerName val="0"/>
+          <c:showPercent val="0"/>
+          <c:showBubbleSize val="0"/>
+        </c:dLbls>
         <c:marker val="1"/>
         <c:smooth val="0"/>
         <c:axId val="2118791784"/>
@@ -272,6 +308,7 @@
         </c:scaling>
         <c:delete val="0"/>
         <c:axPos val="b"/>
+        <c:numFmt formatCode="General" sourceLinked="0"/>
         <c:majorTickMark val="out"/>
         <c:minorTickMark val="none"/>
         <c:tickLblPos val="nextTo"/>
@@ -282,6 +319,7 @@
             <a:pPr>
               <a:defRPr sz="1200"/>
             </a:pPr>
+            <a:endParaRPr lang="en-US"/>
           </a:p>
         </c:txPr>
         <c:crossAx val="2140495176"/>
@@ -293,10 +331,13 @@
       </c:catAx>
       <c:valAx>
         <c:axId val="2140495176"/>
-        <c:scaling/>
+        <c:scaling>
+          <c:orientation val="minMax"/>
+        </c:scaling>
         <c:delete val="0"/>
         <c:axPos val="l"/>
         <c:majorGridlines/>
+        <c:numFmt formatCode="General" sourceLinked="1"/>
         <c:majorTickMark val="out"/>
         <c:minorTickMark val="none"/>
         <c:tickLblPos val="nextTo"/>
@@ -307,10 +348,12 @@
             <a:pPr>
               <a:defRPr sz="1200"/>
             </a:pPr>
+            <a:endParaRPr lang="en-US"/>
           </a:p>
         </c:txPr>
         <c:crossAx val="2118791784"/>
         <c:crosses val="autoZero"/>
+        <c:crossBetween val="between"/>
       </c:valAx>
     </c:plotArea>
     <c:plotVisOnly val="1"/>
@@ -334,14 +377,22 @@
 </file>
 
 <file path=ppt/charts/chart2.xml><?xml version="1.0" encoding="utf-8"?>
-<c:chartSpace xmlns:c="http://schemas.openxmlformats.org/drawingml/2006/chart" xmlns:a="http://schemas.openxmlformats.org/drawingml/2006/main" xmlns:r="http://schemas.openxmlformats.org/officeDocument/2006/relationships">
+<c:chartSpace xmlns:c="http://schemas.openxmlformats.org/drawingml/2006/chart" xmlns:a="http://schemas.openxmlformats.org/drawingml/2006/main" xmlns:r="http://schemas.openxmlformats.org/officeDocument/2006/relationships" xmlns:c16r2="http://schemas.microsoft.com/office/drawing/2015/06/chart">
   <c:date1904 val="0"/>
+  <c:lang val="en-GB"/>
+  <c:roundedCorners val="1"/>
+  <c:style val="2"/>
   <c:chart>
+    <c:title>
+      <c:overlay val="0"/>
+    </c:title>
     <c:autoTitleDeleted val="0"/>
     <c:plotArea>
+      <c:layout/>
       <c:barChart>
         <c:barDir val="bar"/>
         <c:grouping val="clustered"/>
+        <c:varyColors val="1"/>
         <c:ser>
           <c:idx val="0"/>
           <c:order val="0"/>
@@ -356,6 +407,7 @@
               </c:strCache>
             </c:strRef>
           </c:tx>
+          <c:invertIfNegative val="1"/>
           <c:cat>
             <c:strRef>
               <c:f>Sheet1!$A$2:$A$11</c:f>
@@ -410,7 +462,7 @@
                   <c:v>7.88</c:v>
                 </c:pt>
                 <c:pt idx="3">
-                  <c:v>8.47</c:v>
+                  <c:v>8.4700000000000006</c:v>
                 </c:pt>
                 <c:pt idx="4">
                   <c:v>8.99</c:v>
@@ -433,7 +485,21 @@
               </c:numCache>
             </c:numRef>
           </c:val>
+          <c:extLst>
+            <c:ext xmlns:c16="http://schemas.microsoft.com/office/drawing/2014/chart" uri="{C3380CC4-5D6E-409C-BE32-E72D297353CC}">
+              <c16:uniqueId val="{00000000-FE76-5642-BD96-C4DA54E1A2AB}"/>
+            </c:ext>
+          </c:extLst>
         </c:ser>
+        <c:dLbls>
+          <c:showLegendKey val="0"/>
+          <c:showVal val="0"/>
+          <c:showCatName val="0"/>
+          <c:showSerName val="0"/>
+          <c:showPercent val="0"/>
+          <c:showBubbleSize val="0"/>
+        </c:dLbls>
+        <c:gapWidth val="150"/>
         <c:axId val="-2068027336"/>
         <c:axId val="-2113994440"/>
       </c:barChart>
@@ -444,6 +510,7 @@
         </c:scaling>
         <c:delete val="0"/>
         <c:axPos val="l"/>
+        <c:numFmt formatCode="General" sourceLinked="0"/>
         <c:majorTickMark val="out"/>
         <c:minorTickMark val="none"/>
         <c:tickLblPos val="nextTo"/>
@@ -454,6 +521,7 @@
             <a:pPr>
               <a:defRPr sz="1200"/>
             </a:pPr>
+            <a:endParaRPr lang="en-US"/>
           </a:p>
         </c:txPr>
         <c:crossAx val="-2113994440"/>
@@ -465,10 +533,13 @@
       </c:catAx>
       <c:valAx>
         <c:axId val="-2113994440"/>
-        <c:scaling/>
+        <c:scaling>
+          <c:orientation val="minMax"/>
+        </c:scaling>
         <c:delete val="0"/>
         <c:axPos val="b"/>
         <c:majorGridlines/>
+        <c:numFmt formatCode="General" sourceLinked="1"/>
         <c:majorTickMark val="out"/>
         <c:minorTickMark val="none"/>
         <c:tickLblPos val="nextTo"/>
@@ -479,13 +550,17 @@
             <a:pPr>
               <a:defRPr sz="1200"/>
             </a:pPr>
+            <a:endParaRPr lang="en-US"/>
           </a:p>
         </c:txPr>
         <c:crossAx val="-2068027336"/>
         <c:crosses val="autoZero"/>
+        <c:crossBetween val="between"/>
       </c:valAx>
     </c:plotArea>
+    <c:plotVisOnly val="1"/>
     <c:dispBlanksAs val="gap"/>
+    <c:showDLblsOverMax val="1"/>
   </c:chart>
   <c:txPr>
     <a:bodyPr/>
@@ -541,10 +616,9 @@
           <a:lstStyle/>
           <a:p>
             <a:r>
-              <a:rPr lang="en-US" smtClean="0"/>
+              <a:rPr lang="en-US"/>
               <a:t>Click to edit Master title style</a:t>
             </a:r>
-            <a:endParaRPr lang="en-US"/>
           </a:p>
         </p:txBody>
       </p:sp>
@@ -660,10 +734,9 @@
           </a:lstStyle>
           <a:p>
             <a:r>
-              <a:rPr lang="en-US" smtClean="0"/>
+              <a:rPr lang="en-US"/>
               <a:t>Click to edit Master subtitle style</a:t>
             </a:r>
-            <a:endParaRPr lang="en-US"/>
           </a:p>
         </p:txBody>
       </p:sp>
@@ -684,7 +757,7 @@
           <a:p>
             <a:fld id="{5BCAD085-E8A6-8845-BD4E-CB4CCA059FC4}" type="datetimeFigureOut">
               <a:rPr lang="en-US" smtClean="0"/>
-              <a:t>1/27/13</a:t>
+              <a:t>6/12/26</a:t>
             </a:fld>
             <a:endParaRPr lang="en-US"/>
           </a:p>
@@ -778,10 +851,9 @@
           <a:lstStyle/>
           <a:p>
             <a:r>
-              <a:rPr lang="en-US" smtClean="0"/>
+              <a:rPr lang="en-US"/>
               <a:t>Click to edit Master title style</a:t>
             </a:r>
-            <a:endParaRPr lang="en-US"/>
           </a:p>
         </p:txBody>
       </p:sp>
@@ -802,38 +874,37 @@
           <a:p>
             <a:pPr lvl="0"/>
             <a:r>
-              <a:rPr lang="en-US" smtClean="0"/>
+              <a:rPr lang="en-US"/>
               <a:t>Click to edit Master text styles</a:t>
             </a:r>
           </a:p>
           <a:p>
             <a:pPr lvl="1"/>
             <a:r>
-              <a:rPr lang="en-US" smtClean="0"/>
+              <a:rPr lang="en-US"/>
               <a:t>Second level</a:t>
             </a:r>
           </a:p>
           <a:p>
             <a:pPr lvl="2"/>
             <a:r>
-              <a:rPr lang="en-US" smtClean="0"/>
+              <a:rPr lang="en-US"/>
               <a:t>Third level</a:t>
             </a:r>
           </a:p>
           <a:p>
             <a:pPr lvl="3"/>
             <a:r>
-              <a:rPr lang="en-US" smtClean="0"/>
+              <a:rPr lang="en-US"/>
               <a:t>Fourth level</a:t>
             </a:r>
           </a:p>
           <a:p>
             <a:pPr lvl="4"/>
             <a:r>
-              <a:rPr lang="en-US" smtClean="0"/>
+              <a:rPr lang="en-US"/>
               <a:t>Fifth level</a:t>
             </a:r>
-            <a:endParaRPr lang="en-US"/>
           </a:p>
         </p:txBody>
       </p:sp>
@@ -854,7 +925,7 @@
           <a:p>
             <a:fld id="{5BCAD085-E8A6-8845-BD4E-CB4CCA059FC4}" type="datetimeFigureOut">
               <a:rPr lang="en-US" smtClean="0"/>
-              <a:t>1/27/13</a:t>
+              <a:t>6/12/26</a:t>
             </a:fld>
             <a:endParaRPr lang="en-US"/>
           </a:p>
@@ -953,10 +1024,9 @@
           <a:lstStyle/>
           <a:p>
             <a:r>
-              <a:rPr lang="en-US" smtClean="0"/>
+              <a:rPr lang="en-US"/>
               <a:t>Click to edit Master title style</a:t>
             </a:r>
-            <a:endParaRPr lang="en-US"/>
           </a:p>
         </p:txBody>
       </p:sp>
@@ -982,38 +1052,37 @@
           <a:p>
             <a:pPr lvl="0"/>
             <a:r>
-              <a:rPr lang="en-US" smtClean="0"/>
+              <a:rPr lang="en-US"/>
               <a:t>Click to edit Master text styles</a:t>
             </a:r>
           </a:p>
           <a:p>
             <a:pPr lvl="1"/>
             <a:r>
-              <a:rPr lang="en-US" smtClean="0"/>
+              <a:rPr lang="en-US"/>
               <a:t>Second level</a:t>
             </a:r>
           </a:p>
           <a:p>
             <a:pPr lvl="2"/>
             <a:r>
-              <a:rPr lang="en-US" smtClean="0"/>
+              <a:rPr lang="en-US"/>
               <a:t>Third level</a:t>
             </a:r>
           </a:p>
           <a:p>
             <a:pPr lvl="3"/>
             <a:r>
-              <a:rPr lang="en-US" smtClean="0"/>
+              <a:rPr lang="en-US"/>
               <a:t>Fourth level</a:t>
             </a:r>
           </a:p>
           <a:p>
             <a:pPr lvl="4"/>
             <a:r>
-              <a:rPr lang="en-US" smtClean="0"/>
+              <a:rPr lang="en-US"/>
               <a:t>Fifth level</a:t>
             </a:r>
-            <a:endParaRPr lang="en-US"/>
           </a:p>
         </p:txBody>
       </p:sp>
@@ -1034,7 +1103,7 @@
           <a:p>
             <a:fld id="{5BCAD085-E8A6-8845-BD4E-CB4CCA059FC4}" type="datetimeFigureOut">
               <a:rPr lang="en-US" smtClean="0"/>
-              <a:t>1/27/13</a:t>
+              <a:t>6/12/26</a:t>
             </a:fld>
             <a:endParaRPr lang="en-US"/>
           </a:p>
@@ -1128,10 +1197,9 @@
           <a:lstStyle/>
           <a:p>
             <a:r>
-              <a:rPr lang="en-US" smtClean="0"/>
+              <a:rPr lang="en-US"/>
               <a:t>Click to edit Master title style</a:t>
             </a:r>
-            <a:endParaRPr lang="en-US"/>
           </a:p>
         </p:txBody>
       </p:sp>
@@ -1152,38 +1220,37 @@
           <a:p>
             <a:pPr lvl="0"/>
             <a:r>
-              <a:rPr lang="en-US" smtClean="0"/>
+              <a:rPr lang="en-US"/>
               <a:t>Click to edit Master text styles</a:t>
             </a:r>
           </a:p>
           <a:p>
             <a:pPr lvl="1"/>
             <a:r>
-              <a:rPr lang="en-US" smtClean="0"/>
+              <a:rPr lang="en-US"/>
               <a:t>Second level</a:t>
             </a:r>
           </a:p>
           <a:p>
             <a:pPr lvl="2"/>
             <a:r>
-              <a:rPr lang="en-US" smtClean="0"/>
+              <a:rPr lang="en-US"/>
               <a:t>Third level</a:t>
             </a:r>
           </a:p>
           <a:p>
             <a:pPr lvl="3"/>
             <a:r>
-              <a:rPr lang="en-US" smtClean="0"/>
+              <a:rPr lang="en-US"/>
               <a:t>Fourth level</a:t>
             </a:r>
           </a:p>
           <a:p>
             <a:pPr lvl="4"/>
             <a:r>
-              <a:rPr lang="en-US" smtClean="0"/>
+              <a:rPr lang="en-US"/>
               <a:t>Fifth level</a:t>
             </a:r>
-            <a:endParaRPr lang="en-US"/>
           </a:p>
         </p:txBody>
       </p:sp>
@@ -1204,7 +1271,7 @@
           <a:p>
             <a:fld id="{5BCAD085-E8A6-8845-BD4E-CB4CCA059FC4}" type="datetimeFigureOut">
               <a:rPr lang="en-US" smtClean="0"/>
-              <a:t>1/27/13</a:t>
+              <a:t>6/12/26</a:t>
             </a:fld>
             <a:endParaRPr lang="en-US"/>
           </a:p>
@@ -1307,10 +1374,9 @@
           </a:lstStyle>
           <a:p>
             <a:r>
-              <a:rPr lang="en-US" smtClean="0"/>
+              <a:rPr lang="en-US"/>
               <a:t>Click to edit Master title style</a:t>
             </a:r>
-            <a:endParaRPr lang="en-US"/>
           </a:p>
         </p:txBody>
       </p:sp>
@@ -1427,7 +1493,7 @@
           <a:p>
             <a:pPr lvl="0"/>
             <a:r>
-              <a:rPr lang="en-US" smtClean="0"/>
+              <a:rPr lang="en-US"/>
               <a:t>Click to edit Master text styles</a:t>
             </a:r>
           </a:p>
@@ -1450,7 +1516,7 @@
           <a:p>
             <a:fld id="{5BCAD085-E8A6-8845-BD4E-CB4CCA059FC4}" type="datetimeFigureOut">
               <a:rPr lang="en-US" smtClean="0"/>
-              <a:t>1/27/13</a:t>
+              <a:t>6/12/26</a:t>
             </a:fld>
             <a:endParaRPr lang="en-US"/>
           </a:p>
@@ -1544,10 +1610,9 @@
           <a:lstStyle/>
           <a:p>
             <a:r>
-              <a:rPr lang="en-US" smtClean="0"/>
+              <a:rPr lang="en-US"/>
               <a:t>Click to edit Master title style</a:t>
             </a:r>
-            <a:endParaRPr lang="en-US"/>
           </a:p>
         </p:txBody>
       </p:sp>
@@ -1601,38 +1666,37 @@
           <a:p>
             <a:pPr lvl="0"/>
             <a:r>
-              <a:rPr lang="en-US" smtClean="0"/>
+              <a:rPr lang="en-US"/>
               <a:t>Click to edit Master text styles</a:t>
             </a:r>
           </a:p>
           <a:p>
             <a:pPr lvl="1"/>
             <a:r>
-              <a:rPr lang="en-US" smtClean="0"/>
+              <a:rPr lang="en-US"/>
               <a:t>Second level</a:t>
             </a:r>
           </a:p>
           <a:p>
             <a:pPr lvl="2"/>
             <a:r>
-              <a:rPr lang="en-US" smtClean="0"/>
+              <a:rPr lang="en-US"/>
               <a:t>Third level</a:t>
             </a:r>
           </a:p>
           <a:p>
             <a:pPr lvl="3"/>
             <a:r>
-              <a:rPr lang="en-US" smtClean="0"/>
+              <a:rPr lang="en-US"/>
               <a:t>Fourth level</a:t>
             </a:r>
           </a:p>
           <a:p>
             <a:pPr lvl="4"/>
             <a:r>
-              <a:rPr lang="en-US" smtClean="0"/>
+              <a:rPr lang="en-US"/>
               <a:t>Fifth level</a:t>
             </a:r>
-            <a:endParaRPr lang="en-US"/>
           </a:p>
         </p:txBody>
       </p:sp>
@@ -1686,38 +1750,37 @@
           <a:p>
             <a:pPr lvl="0"/>
             <a:r>
-              <a:rPr lang="en-US" smtClean="0"/>
+              <a:rPr lang="en-US"/>
               <a:t>Click to edit Master text styles</a:t>
             </a:r>
           </a:p>
           <a:p>
             <a:pPr lvl="1"/>
             <a:r>
-              <a:rPr lang="en-US" smtClean="0"/>
+              <a:rPr lang="en-US"/>
               <a:t>Second level</a:t>
             </a:r>
           </a:p>
           <a:p>
             <a:pPr lvl="2"/>
             <a:r>
-              <a:rPr lang="en-US" smtClean="0"/>
+              <a:rPr lang="en-US"/>
               <a:t>Third level</a:t>
             </a:r>
           </a:p>
           <a:p>
             <a:pPr lvl="3"/>
             <a:r>
-              <a:rPr lang="en-US" smtClean="0"/>
+              <a:rPr lang="en-US"/>
               <a:t>Fourth level</a:t>
             </a:r>
           </a:p>
           <a:p>
             <a:pPr lvl="4"/>
             <a:r>
-              <a:rPr lang="en-US" smtClean="0"/>
+              <a:rPr lang="en-US"/>
               <a:t>Fifth level</a:t>
             </a:r>
-            <a:endParaRPr lang="en-US"/>
           </a:p>
         </p:txBody>
       </p:sp>
@@ -1738,7 +1801,7 @@
           <a:p>
             <a:fld id="{5BCAD085-E8A6-8845-BD4E-CB4CCA059FC4}" type="datetimeFigureOut">
               <a:rPr lang="en-US" smtClean="0"/>
-              <a:t>1/27/13</a:t>
+              <a:t>6/12/26</a:t>
             </a:fld>
             <a:endParaRPr lang="en-US"/>
           </a:p>
@@ -1836,10 +1899,9 @@
           </a:lstStyle>
           <a:p>
             <a:r>
-              <a:rPr lang="en-US" smtClean="0"/>
+              <a:rPr lang="en-US"/>
               <a:t>Click to edit Master title style</a:t>
             </a:r>
-            <a:endParaRPr lang="en-US"/>
           </a:p>
         </p:txBody>
       </p:sp>
@@ -1902,7 +1964,7 @@
           <a:p>
             <a:pPr lvl="0"/>
             <a:r>
-              <a:rPr lang="en-US" smtClean="0"/>
+              <a:rPr lang="en-US"/>
               <a:t>Click to edit Master text styles</a:t>
             </a:r>
           </a:p>
@@ -1958,38 +2020,37 @@
           <a:p>
             <a:pPr lvl="0"/>
             <a:r>
-              <a:rPr lang="en-US" smtClean="0"/>
+              <a:rPr lang="en-US"/>
               <a:t>Click to edit Master text styles</a:t>
             </a:r>
           </a:p>
           <a:p>
             <a:pPr lvl="1"/>
             <a:r>
-              <a:rPr lang="en-US" smtClean="0"/>
+              <a:rPr lang="en-US"/>
               <a:t>Second level</a:t>
             </a:r>
           </a:p>
           <a:p>
             <a:pPr lvl="2"/>
             <a:r>
-              <a:rPr lang="en-US" smtClean="0"/>
+              <a:rPr lang="en-US"/>
               <a:t>Third level</a:t>
             </a:r>
           </a:p>
           <a:p>
             <a:pPr lvl="3"/>
             <a:r>
-              <a:rPr lang="en-US" smtClean="0"/>
+              <a:rPr lang="en-US"/>
               <a:t>Fourth level</a:t>
             </a:r>
           </a:p>
           <a:p>
             <a:pPr lvl="4"/>
             <a:r>
-              <a:rPr lang="en-US" smtClean="0"/>
+              <a:rPr lang="en-US"/>
               <a:t>Fifth level</a:t>
             </a:r>
-            <a:endParaRPr lang="en-US"/>
           </a:p>
         </p:txBody>
       </p:sp>
@@ -2052,7 +2113,7 @@
           <a:p>
             <a:pPr lvl="0"/>
             <a:r>
-              <a:rPr lang="en-US" smtClean="0"/>
+              <a:rPr lang="en-US"/>
               <a:t>Click to edit Master text styles</a:t>
             </a:r>
           </a:p>
@@ -2108,38 +2169,37 @@
           <a:p>
             <a:pPr lvl="0"/>
             <a:r>
-              <a:rPr lang="en-US" smtClean="0"/>
+              <a:rPr lang="en-US"/>
               <a:t>Click to edit Master text styles</a:t>
             </a:r>
           </a:p>
           <a:p>
             <a:pPr lvl="1"/>
             <a:r>
-              <a:rPr lang="en-US" smtClean="0"/>
+              <a:rPr lang="en-US"/>
               <a:t>Second level</a:t>
             </a:r>
           </a:p>
           <a:p>
             <a:pPr lvl="2"/>
             <a:r>
-              <a:rPr lang="en-US" smtClean="0"/>
+              <a:rPr lang="en-US"/>
               <a:t>Third level</a:t>
             </a:r>
           </a:p>
           <a:p>
             <a:pPr lvl="3"/>
             <a:r>
-              <a:rPr lang="en-US" smtClean="0"/>
+              <a:rPr lang="en-US"/>
               <a:t>Fourth level</a:t>
             </a:r>
           </a:p>
           <a:p>
             <a:pPr lvl="4"/>
             <a:r>
-              <a:rPr lang="en-US" smtClean="0"/>
+              <a:rPr lang="en-US"/>
               <a:t>Fifth level</a:t>
             </a:r>
-            <a:endParaRPr lang="en-US"/>
           </a:p>
         </p:txBody>
       </p:sp>
@@ -2160,7 +2220,7 @@
           <a:p>
             <a:fld id="{5BCAD085-E8A6-8845-BD4E-CB4CCA059FC4}" type="datetimeFigureOut">
               <a:rPr lang="en-US" smtClean="0"/>
-              <a:t>1/27/13</a:t>
+              <a:t>6/12/26</a:t>
             </a:fld>
             <a:endParaRPr lang="en-US"/>
           </a:p>
@@ -2254,10 +2314,9 @@
           <a:lstStyle/>
           <a:p>
             <a:r>
-              <a:rPr lang="en-US" smtClean="0"/>
+              <a:rPr lang="en-US"/>
               <a:t>Click to edit Master title style</a:t>
             </a:r>
-            <a:endParaRPr lang="en-US"/>
           </a:p>
         </p:txBody>
       </p:sp>
@@ -2278,7 +2337,7 @@
           <a:p>
             <a:fld id="{5BCAD085-E8A6-8845-BD4E-CB4CCA059FC4}" type="datetimeFigureOut">
               <a:rPr lang="en-US" smtClean="0"/>
-              <a:t>1/27/13</a:t>
+              <a:t>6/12/26</a:t>
             </a:fld>
             <a:endParaRPr lang="en-US"/>
           </a:p>
@@ -2373,7 +2432,7 @@
           <a:p>
             <a:fld id="{5BCAD085-E8A6-8845-BD4E-CB4CCA059FC4}" type="datetimeFigureOut">
               <a:rPr lang="en-US" smtClean="0"/>
-              <a:t>1/27/13</a:t>
+              <a:t>6/12/26</a:t>
             </a:fld>
             <a:endParaRPr lang="en-US"/>
           </a:p>
@@ -2476,10 +2535,9 @@
           </a:lstStyle>
           <a:p>
             <a:r>
-              <a:rPr lang="en-US" smtClean="0"/>
+              <a:rPr lang="en-US"/>
               <a:t>Click to edit Master title style</a:t>
             </a:r>
-            <a:endParaRPr lang="en-US"/>
           </a:p>
         </p:txBody>
       </p:sp>
@@ -2533,38 +2591,37 @@
           <a:p>
             <a:pPr lvl="0"/>
             <a:r>
-              <a:rPr lang="en-US" smtClean="0"/>
+              <a:rPr lang="en-US"/>
               <a:t>Click to edit Master text styles</a:t>
             </a:r>
           </a:p>
           <a:p>
             <a:pPr lvl="1"/>
             <a:r>
-              <a:rPr lang="en-US" smtClean="0"/>
+              <a:rPr lang="en-US"/>
               <a:t>Second level</a:t>
             </a:r>
           </a:p>
           <a:p>
             <a:pPr lvl="2"/>
             <a:r>
-              <a:rPr lang="en-US" smtClean="0"/>
+              <a:rPr lang="en-US"/>
               <a:t>Third level</a:t>
             </a:r>
           </a:p>
           <a:p>
             <a:pPr lvl="3"/>
             <a:r>
-              <a:rPr lang="en-US" smtClean="0"/>
+              <a:rPr lang="en-US"/>
               <a:t>Fourth level</a:t>
             </a:r>
           </a:p>
           <a:p>
             <a:pPr lvl="4"/>
             <a:r>
-              <a:rPr lang="en-US" smtClean="0"/>
+              <a:rPr lang="en-US"/>
               <a:t>Fifth level</a:t>
             </a:r>
-            <a:endParaRPr lang="en-US"/>
           </a:p>
         </p:txBody>
       </p:sp>
@@ -2627,7 +2684,7 @@
           <a:p>
             <a:pPr lvl="0"/>
             <a:r>
-              <a:rPr lang="en-US" smtClean="0"/>
+              <a:rPr lang="en-US"/>
               <a:t>Click to edit Master text styles</a:t>
             </a:r>
           </a:p>
@@ -2650,7 +2707,7 @@
           <a:p>
             <a:fld id="{5BCAD085-E8A6-8845-BD4E-CB4CCA059FC4}" type="datetimeFigureOut">
               <a:rPr lang="en-US" smtClean="0"/>
-              <a:t>1/27/13</a:t>
+              <a:t>6/12/26</a:t>
             </a:fld>
             <a:endParaRPr lang="en-US"/>
           </a:p>
@@ -2753,10 +2810,9 @@
           </a:lstStyle>
           <a:p>
             <a:r>
-              <a:rPr lang="en-US" smtClean="0"/>
+              <a:rPr lang="en-US"/>
               <a:t>Click to edit Master title style</a:t>
             </a:r>
-            <a:endParaRPr lang="en-US"/>
           </a:p>
         </p:txBody>
       </p:sp>
@@ -2880,7 +2936,7 @@
           <a:p>
             <a:pPr lvl="0"/>
             <a:r>
-              <a:rPr lang="en-US" smtClean="0"/>
+              <a:rPr lang="en-US"/>
               <a:t>Click to edit Master text styles</a:t>
             </a:r>
           </a:p>
@@ -2903,7 +2959,7 @@
           <a:p>
             <a:fld id="{5BCAD085-E8A6-8845-BD4E-CB4CCA059FC4}" type="datetimeFigureOut">
               <a:rPr lang="en-US" smtClean="0"/>
-              <a:t>1/27/13</a:t>
+              <a:t>6/12/26</a:t>
             </a:fld>
             <a:endParaRPr lang="en-US"/>
           </a:p>
@@ -3012,10 +3068,9 @@
           <a:lstStyle/>
           <a:p>
             <a:r>
-              <a:rPr lang="en-US" smtClean="0"/>
+              <a:rPr lang="en-US"/>
               <a:t>Click to edit Master title style</a:t>
             </a:r>
-            <a:endParaRPr lang="en-US"/>
           </a:p>
         </p:txBody>
       </p:sp>
@@ -3046,38 +3101,37 @@
           <a:p>
             <a:pPr lvl="0"/>
             <a:r>
-              <a:rPr lang="en-US" smtClean="0"/>
+              <a:rPr lang="en-US"/>
               <a:t>Click to edit Master text styles</a:t>
             </a:r>
           </a:p>
           <a:p>
             <a:pPr lvl="1"/>
             <a:r>
-              <a:rPr lang="en-US" smtClean="0"/>
+              <a:rPr lang="en-US"/>
               <a:t>Second level</a:t>
             </a:r>
           </a:p>
           <a:p>
             <a:pPr lvl="2"/>
             <a:r>
-              <a:rPr lang="en-US" smtClean="0"/>
+              <a:rPr lang="en-US"/>
               <a:t>Third level</a:t>
             </a:r>
           </a:p>
           <a:p>
             <a:pPr lvl="3"/>
             <a:r>
-              <a:rPr lang="en-US" smtClean="0"/>
+              <a:rPr lang="en-US"/>
               <a:t>Fourth level</a:t>
             </a:r>
           </a:p>
           <a:p>
             <a:pPr lvl="4"/>
             <a:r>
-              <a:rPr lang="en-US" smtClean="0"/>
+              <a:rPr lang="en-US"/>
               <a:t>Fifth level</a:t>
             </a:r>
-            <a:endParaRPr lang="en-US"/>
           </a:p>
         </p:txBody>
       </p:sp>
@@ -3116,7 +3170,7 @@
           <a:p>
             <a:fld id="{5BCAD085-E8A6-8845-BD4E-CB4CCA059FC4}" type="datetimeFigureOut">
               <a:rPr lang="en-US" smtClean="0"/>
-              <a:t>1/27/13</a:t>
+              <a:t>6/12/26</a:t>
             </a:fld>
             <a:endParaRPr lang="en-US"/>
           </a:p>
@@ -3475,7 +3529,7 @@
 </file>
 
 <file path=ppt/slides/slide1.xml><?xml version="1.0" encoding="utf-8"?>
-<p:sld xmlns:a="http://schemas.openxmlformats.org/drawingml/2006/main" xmlns:p="http://schemas.openxmlformats.org/presentationml/2006/main" xmlns:r="http://schemas.openxmlformats.org/officeDocument/2006/relationships">
+<p:sld xmlns:a="http://schemas.openxmlformats.org/drawingml/2006/main" xmlns:r="http://schemas.openxmlformats.org/officeDocument/2006/relationships" xmlns:p="http://schemas.openxmlformats.org/presentationml/2006/main">
   <p:cSld>
     <p:spTree>
       <p:nvGrpSpPr>
@@ -3483,7 +3537,14 @@
         <p:cNvGrpSpPr/>
         <p:nvPr/>
       </p:nvGrpSpPr>
-      <p:grpSpPr/>
+      <p:grpSpPr>
+        <a:xfrm>
+          <a:off x="0" y="0"/>
+          <a:ext cx="0" cy="0"/>
+          <a:chOff x="0" y="0"/>
+          <a:chExt cx="0" cy="0"/>
+        </a:xfrm>
+      </p:grpSpPr>
       <p:sp>
         <p:nvSpPr>
           <p:cNvPr id="2" name="TextBox 1"/>
@@ -3595,7 +3656,7 @@
 </file>
 
 <file path=ppt/slides/slide10.xml><?xml version="1.0" encoding="utf-8"?>
-<p:sld xmlns:a="http://schemas.openxmlformats.org/drawingml/2006/main" xmlns:p="http://schemas.openxmlformats.org/presentationml/2006/main" xmlns:r="http://schemas.openxmlformats.org/officeDocument/2006/relationships">
+<p:sld xmlns:a="http://schemas.openxmlformats.org/drawingml/2006/main" xmlns:r="http://schemas.openxmlformats.org/officeDocument/2006/relationships" xmlns:p="http://schemas.openxmlformats.org/presentationml/2006/main">
   <p:cSld>
     <p:spTree>
       <p:nvGrpSpPr>
@@ -3603,7 +3664,14 @@
         <p:cNvGrpSpPr/>
         <p:nvPr/>
       </p:nvGrpSpPr>
-      <p:grpSpPr/>
+      <p:grpSpPr>
+        <a:xfrm>
+          <a:off x="0" y="0"/>
+          <a:ext cx="0" cy="0"/>
+          <a:chOff x="0" y="0"/>
+          <a:chExt cx="0" cy="0"/>
+        </a:xfrm>
+      </p:grpSpPr>
       <p:sp>
         <p:nvSpPr>
           <p:cNvPr id="2" name="TextBox 1"/>
@@ -3724,9 +3792,27 @@
                 <a:tableStyleId>{5C22544A-7EE6-4342-B048-85BDC9FD1C3A}</a:tableStyleId>
               </a:tblPr>
               <a:tblGrid>
-                <a:gridCol w="2560320"/>
-                <a:gridCol w="3840480"/>
-                <a:gridCol w="4297680"/>
+                <a:gridCol w="2560320">
+                  <a:extLst>
+                    <a:ext uri="{9D8B030D-6E8A-4147-A177-3AD203B41FA5}">
+                      <a16:colId xmlns:a16="http://schemas.microsoft.com/office/drawing/2014/main" val="20000"/>
+                    </a:ext>
+                  </a:extLst>
+                </a:gridCol>
+                <a:gridCol w="3840480">
+                  <a:extLst>
+                    <a:ext uri="{9D8B030D-6E8A-4147-A177-3AD203B41FA5}">
+                      <a16:colId xmlns:a16="http://schemas.microsoft.com/office/drawing/2014/main" val="20001"/>
+                    </a:ext>
+                  </a:extLst>
+                </a:gridCol>
+                <a:gridCol w="4297680">
+                  <a:extLst>
+                    <a:ext uri="{9D8B030D-6E8A-4147-A177-3AD203B41FA5}">
+                      <a16:colId xmlns:a16="http://schemas.microsoft.com/office/drawing/2014/main" val="20002"/>
+                    </a:ext>
+                  </a:extLst>
+                </a:gridCol>
               </a:tblGrid>
               <a:tr h="365760">
                 <a:tc>
@@ -3768,6 +3854,11 @@
                   </a:txBody>
                   <a:tcPr/>
                 </a:tc>
+                <a:extLst>
+                  <a:ext uri="{0D108BD9-81ED-4DB2-BD59-A6C34878D82A}">
+                    <a16:rowId xmlns:a16="http://schemas.microsoft.com/office/drawing/2014/main" val="10000"/>
+                  </a:ext>
+                </a:extLst>
               </a:tr>
               <a:tr h="365760">
                 <a:tc>
@@ -3809,6 +3900,11 @@
                   </a:txBody>
                   <a:tcPr/>
                 </a:tc>
+                <a:extLst>
+                  <a:ext uri="{0D108BD9-81ED-4DB2-BD59-A6C34878D82A}">
+                    <a16:rowId xmlns:a16="http://schemas.microsoft.com/office/drawing/2014/main" val="10001"/>
+                  </a:ext>
+                </a:extLst>
               </a:tr>
               <a:tr h="365760">
                 <a:tc>
@@ -3850,6 +3946,11 @@
                   </a:txBody>
                   <a:tcPr/>
                 </a:tc>
+                <a:extLst>
+                  <a:ext uri="{0D108BD9-81ED-4DB2-BD59-A6C34878D82A}">
+                    <a16:rowId xmlns:a16="http://schemas.microsoft.com/office/drawing/2014/main" val="10002"/>
+                  </a:ext>
+                </a:extLst>
               </a:tr>
               <a:tr h="365760">
                 <a:tc>
@@ -3891,6 +3992,11 @@
                   </a:txBody>
                   <a:tcPr/>
                 </a:tc>
+                <a:extLst>
+                  <a:ext uri="{0D108BD9-81ED-4DB2-BD59-A6C34878D82A}">
+                    <a16:rowId xmlns:a16="http://schemas.microsoft.com/office/drawing/2014/main" val="10003"/>
+                  </a:ext>
+                </a:extLst>
               </a:tr>
             </a:tbl>
           </a:graphicData>
@@ -3905,7 +4011,7 @@
 </file>
 
 <file path=ppt/slides/slide11.xml><?xml version="1.0" encoding="utf-8"?>
-<p:sld xmlns:a="http://schemas.openxmlformats.org/drawingml/2006/main" xmlns:p="http://schemas.openxmlformats.org/presentationml/2006/main" xmlns:r="http://schemas.openxmlformats.org/officeDocument/2006/relationships">
+<p:sld xmlns:a="http://schemas.openxmlformats.org/drawingml/2006/main" xmlns:r="http://schemas.openxmlformats.org/officeDocument/2006/relationships" xmlns:p="http://schemas.openxmlformats.org/presentationml/2006/main">
   <p:cSld>
     <p:spTree>
       <p:nvGrpSpPr>
@@ -3913,7 +4019,14 @@
         <p:cNvGrpSpPr/>
         <p:nvPr/>
       </p:nvGrpSpPr>
-      <p:grpSpPr/>
+      <p:grpSpPr>
+        <a:xfrm>
+          <a:off x="0" y="0"/>
+          <a:ext cx="0" cy="0"/>
+          <a:chOff x="0" y="0"/>
+          <a:chExt cx="0" cy="0"/>
+        </a:xfrm>
+      </p:grpSpPr>
       <p:sp>
         <p:nvSpPr>
           <p:cNvPr id="2" name="TextBox 1"/>
@@ -4019,14 +4132,11 @@
                 <a:spcPts val="800"/>
               </a:spcAft>
             </a:pPr>
-            <a:r>
-              <a:rPr sz="2400">
-                <a:solidFill>
-                  <a:srgbClr val="212121"/>
-                </a:solidFill>
-              </a:rPr>
-              <a:t/>
-            </a:r>
+            <a:endParaRPr sz="2400">
+              <a:solidFill>
+                <a:srgbClr val="212121"/>
+              </a:solidFill>
+            </a:endParaRPr>
           </a:p>
           <a:p>
             <a:pPr>
@@ -4054,7 +4164,7 @@
 </file>
 
 <file path=ppt/slides/slide12.xml><?xml version="1.0" encoding="utf-8"?>
-<p:sld xmlns:a="http://schemas.openxmlformats.org/drawingml/2006/main" xmlns:p="http://schemas.openxmlformats.org/presentationml/2006/main" xmlns:r="http://schemas.openxmlformats.org/officeDocument/2006/relationships">
+<p:sld xmlns:a="http://schemas.openxmlformats.org/drawingml/2006/main" xmlns:r="http://schemas.openxmlformats.org/officeDocument/2006/relationships" xmlns:p="http://schemas.openxmlformats.org/presentationml/2006/main">
   <p:cSld>
     <p:spTree>
       <p:nvGrpSpPr>
@@ -4062,7 +4172,14 @@
         <p:cNvGrpSpPr/>
         <p:nvPr/>
       </p:nvGrpSpPr>
-      <p:grpSpPr/>
+      <p:grpSpPr>
+        <a:xfrm>
+          <a:off x="0" y="0"/>
+          <a:ext cx="0" cy="0"/>
+          <a:chOff x="0" y="0"/>
+          <a:chExt cx="0" cy="0"/>
+        </a:xfrm>
+      </p:grpSpPr>
       <p:sp>
         <p:nvSpPr>
           <p:cNvPr id="2" name="TextBox 1"/>
@@ -4110,7 +4227,7 @@
         </p:xfrm>
         <a:graphic>
           <a:graphicData uri="http://schemas.openxmlformats.org/drawingml/2006/chart">
-            <c:chart xmlns:c="http://schemas.openxmlformats.org/drawingml/2006/chart" r:id="rId2"/>
+            <c:chart xmlns:c="http://schemas.openxmlformats.org/drawingml/2006/chart" xmlns:r="http://schemas.openxmlformats.org/officeDocument/2006/relationships" r:id="rId2"/>
           </a:graphicData>
         </a:graphic>
       </p:graphicFrame>
@@ -4161,7 +4278,7 @@
 </file>
 
 <file path=ppt/slides/slide13.xml><?xml version="1.0" encoding="utf-8"?>
-<p:sld xmlns:a="http://schemas.openxmlformats.org/drawingml/2006/main" xmlns:p="http://schemas.openxmlformats.org/presentationml/2006/main" xmlns:r="http://schemas.openxmlformats.org/officeDocument/2006/relationships">
+<p:sld xmlns:a="http://schemas.openxmlformats.org/drawingml/2006/main" xmlns:r="http://schemas.openxmlformats.org/officeDocument/2006/relationships" xmlns:p="http://schemas.openxmlformats.org/presentationml/2006/main">
   <p:cSld>
     <p:spTree>
       <p:nvGrpSpPr>
@@ -4169,7 +4286,14 @@
         <p:cNvGrpSpPr/>
         <p:nvPr/>
       </p:nvGrpSpPr>
-      <p:grpSpPr/>
+      <p:grpSpPr>
+        <a:xfrm>
+          <a:off x="0" y="0"/>
+          <a:ext cx="0" cy="0"/>
+          <a:chOff x="0" y="0"/>
+          <a:chExt cx="0" cy="0"/>
+        </a:xfrm>
+      </p:grpSpPr>
       <p:sp>
         <p:nvSpPr>
           <p:cNvPr id="2" name="TextBox 1"/>
@@ -4217,7 +4341,7 @@
         </p:xfrm>
         <a:graphic>
           <a:graphicData uri="http://schemas.openxmlformats.org/drawingml/2006/chart">
-            <c:chart xmlns:c="http://schemas.openxmlformats.org/drawingml/2006/chart" r:id="rId2"/>
+            <c:chart xmlns:c="http://schemas.openxmlformats.org/drawingml/2006/chart" xmlns:r="http://schemas.openxmlformats.org/officeDocument/2006/relationships" r:id="rId2"/>
           </a:graphicData>
         </a:graphic>
       </p:graphicFrame>
@@ -4268,7 +4392,7 @@
 </file>
 
 <file path=ppt/slides/slide14.xml><?xml version="1.0" encoding="utf-8"?>
-<p:sld xmlns:a="http://schemas.openxmlformats.org/drawingml/2006/main" xmlns:p="http://schemas.openxmlformats.org/presentationml/2006/main" xmlns:r="http://schemas.openxmlformats.org/officeDocument/2006/relationships">
+<p:sld xmlns:a="http://schemas.openxmlformats.org/drawingml/2006/main" xmlns:r="http://schemas.openxmlformats.org/officeDocument/2006/relationships" xmlns:p="http://schemas.openxmlformats.org/presentationml/2006/main">
   <p:cSld>
     <p:spTree>
       <p:nvGrpSpPr>
@@ -4276,7 +4400,14 @@
         <p:cNvGrpSpPr/>
         <p:nvPr/>
       </p:nvGrpSpPr>
-      <p:grpSpPr/>
+      <p:grpSpPr>
+        <a:xfrm>
+          <a:off x="0" y="0"/>
+          <a:ext cx="0" cy="0"/>
+          <a:chOff x="0" y="0"/>
+          <a:chExt cx="0" cy="0"/>
+        </a:xfrm>
+      </p:grpSpPr>
       <p:sp>
         <p:nvSpPr>
           <p:cNvPr id="2" name="TextBox 1"/>
@@ -4367,14 +4498,11 @@
                 <a:spcPts val="800"/>
               </a:spcAft>
             </a:pPr>
-            <a:r>
-              <a:rPr sz="2400">
-                <a:solidFill>
-                  <a:srgbClr val="212121"/>
-                </a:solidFill>
-              </a:rPr>
-              <a:t/>
-            </a:r>
+            <a:endParaRPr sz="2400">
+              <a:solidFill>
+                <a:srgbClr val="212121"/>
+              </a:solidFill>
+            </a:endParaRPr>
           </a:p>
           <a:p>
             <a:pPr>
@@ -4432,7 +4560,7 @@
 </file>
 
 <file path=ppt/slides/slide15.xml><?xml version="1.0" encoding="utf-8"?>
-<p:sld xmlns:a="http://schemas.openxmlformats.org/drawingml/2006/main" xmlns:p="http://schemas.openxmlformats.org/presentationml/2006/main" xmlns:r="http://schemas.openxmlformats.org/officeDocument/2006/relationships">
+<p:sld xmlns:a="http://schemas.openxmlformats.org/drawingml/2006/main" xmlns:r="http://schemas.openxmlformats.org/officeDocument/2006/relationships" xmlns:p="http://schemas.openxmlformats.org/presentationml/2006/main">
   <p:cSld>
     <p:spTree>
       <p:nvGrpSpPr>
@@ -4440,7 +4568,14 @@
         <p:cNvGrpSpPr/>
         <p:nvPr/>
       </p:nvGrpSpPr>
-      <p:grpSpPr/>
+      <p:grpSpPr>
+        <a:xfrm>
+          <a:off x="0" y="0"/>
+          <a:ext cx="0" cy="0"/>
+          <a:chOff x="0" y="0"/>
+          <a:chExt cx="0" cy="0"/>
+        </a:xfrm>
+      </p:grpSpPr>
       <p:sp>
         <p:nvSpPr>
           <p:cNvPr id="2" name="TextBox 1"/>
@@ -4663,7 +4798,7 @@
 </file>
 
 <file path=ppt/slides/slide16.xml><?xml version="1.0" encoding="utf-8"?>
-<p:sld xmlns:a="http://schemas.openxmlformats.org/drawingml/2006/main" xmlns:p="http://schemas.openxmlformats.org/presentationml/2006/main" xmlns:r="http://schemas.openxmlformats.org/officeDocument/2006/relationships">
+<p:sld xmlns:a="http://schemas.openxmlformats.org/drawingml/2006/main" xmlns:r="http://schemas.openxmlformats.org/officeDocument/2006/relationships" xmlns:p="http://schemas.openxmlformats.org/presentationml/2006/main">
   <p:cSld>
     <p:spTree>
       <p:nvGrpSpPr>
@@ -4671,7 +4806,14 @@
         <p:cNvGrpSpPr/>
         <p:nvPr/>
       </p:nvGrpSpPr>
-      <p:grpSpPr/>
+      <p:grpSpPr>
+        <a:xfrm>
+          <a:off x="0" y="0"/>
+          <a:ext cx="0" cy="0"/>
+          <a:chOff x="0" y="0"/>
+          <a:chExt cx="0" cy="0"/>
+        </a:xfrm>
+      </p:grpSpPr>
       <p:sp>
         <p:nvSpPr>
           <p:cNvPr id="2" name="TextBox 1"/>
@@ -4762,14 +4904,11 @@
                 <a:spcPts val="800"/>
               </a:spcAft>
             </a:pPr>
-            <a:r>
-              <a:rPr sz="2600">
-                <a:solidFill>
-                  <a:srgbClr val="212121"/>
-                </a:solidFill>
-              </a:rPr>
-              <a:t/>
-            </a:r>
+            <a:endParaRPr sz="2600">
+              <a:solidFill>
+                <a:srgbClr val="212121"/>
+              </a:solidFill>
+            </a:endParaRPr>
           </a:p>
           <a:p>
             <a:pPr>
@@ -4797,7 +4936,7 @@
 </file>
 
 <file path=ppt/slides/slide17.xml><?xml version="1.0" encoding="utf-8"?>
-<p:sld xmlns:a="http://schemas.openxmlformats.org/drawingml/2006/main" xmlns:p="http://schemas.openxmlformats.org/presentationml/2006/main" xmlns:r="http://schemas.openxmlformats.org/officeDocument/2006/relationships">
+<p:sld xmlns:a="http://schemas.openxmlformats.org/drawingml/2006/main" xmlns:r="http://schemas.openxmlformats.org/officeDocument/2006/relationships" xmlns:p="http://schemas.openxmlformats.org/presentationml/2006/main">
   <p:cSld>
     <p:spTree>
       <p:nvGrpSpPr>
@@ -4805,7 +4944,14 @@
         <p:cNvGrpSpPr/>
         <p:nvPr/>
       </p:nvGrpSpPr>
-      <p:grpSpPr/>
+      <p:grpSpPr>
+        <a:xfrm>
+          <a:off x="0" y="0"/>
+          <a:ext cx="0" cy="0"/>
+          <a:chOff x="0" y="0"/>
+          <a:chExt cx="0" cy="0"/>
+        </a:xfrm>
+      </p:grpSpPr>
       <p:sp>
         <p:nvSpPr>
           <p:cNvPr id="2" name="TextBox 1"/>
@@ -4911,27 +5057,24 @@
                 <a:spcPts val="800"/>
               </a:spcAft>
             </a:pPr>
+            <a:endParaRPr sz="2400">
+              <a:solidFill>
+                <a:srgbClr val="212121"/>
+              </a:solidFill>
+            </a:endParaRPr>
+          </a:p>
+          <a:p>
+            <a:pPr>
+              <a:spcAft>
+                <a:spcPts val="800"/>
+              </a:spcAft>
+            </a:pPr>
             <a:r>
               <a:rPr sz="2400">
                 <a:solidFill>
                   <a:srgbClr val="212121"/>
                 </a:solidFill>
               </a:rPr>
-              <a:t/>
-            </a:r>
-          </a:p>
-          <a:p>
-            <a:pPr>
-              <a:spcAft>
-                <a:spcPts val="800"/>
-              </a:spcAft>
-            </a:pPr>
-            <a:r>
-              <a:rPr sz="2400">
-                <a:solidFill>
-                  <a:srgbClr val="212121"/>
-                </a:solidFill>
-              </a:rPr>
               <a:t>“Program testing can be used to show the presence of bugs, but never to show their absence.” — E. W. Dijkstra, 1970</a:t>
             </a:r>
           </a:p>
@@ -4941,14 +5084,11 @@
                 <a:spcPts val="800"/>
               </a:spcAft>
             </a:pPr>
-            <a:r>
-              <a:rPr sz="2400">
-                <a:solidFill>
-                  <a:srgbClr val="212121"/>
-                </a:solidFill>
-              </a:rPr>
-              <a:t/>
-            </a:r>
+            <a:endParaRPr sz="2400">
+              <a:solidFill>
+                <a:srgbClr val="212121"/>
+              </a:solidFill>
+            </a:endParaRPr>
           </a:p>
           <a:p>
             <a:pPr>
@@ -4976,7 +5116,7 @@
 </file>
 
 <file path=ppt/slides/slide18.xml><?xml version="1.0" encoding="utf-8"?>
-<p:sld xmlns:a="http://schemas.openxmlformats.org/drawingml/2006/main" xmlns:p="http://schemas.openxmlformats.org/presentationml/2006/main" xmlns:r="http://schemas.openxmlformats.org/officeDocument/2006/relationships">
+<p:sld xmlns:a="http://schemas.openxmlformats.org/drawingml/2006/main" xmlns:r="http://schemas.openxmlformats.org/officeDocument/2006/relationships" xmlns:p="http://schemas.openxmlformats.org/presentationml/2006/main">
   <p:cSld>
     <p:spTree>
       <p:nvGrpSpPr>
@@ -4984,7 +5124,14 @@
         <p:cNvGrpSpPr/>
         <p:nvPr/>
       </p:nvGrpSpPr>
-      <p:grpSpPr/>
+      <p:grpSpPr>
+        <a:xfrm>
+          <a:off x="0" y="0"/>
+          <a:ext cx="0" cy="0"/>
+          <a:chOff x="0" y="0"/>
+          <a:chExt cx="0" cy="0"/>
+        </a:xfrm>
+      </p:grpSpPr>
       <p:sp>
         <p:nvSpPr>
           <p:cNvPr id="2" name="TextBox 1"/>
@@ -5060,27 +5207,24 @@
                 <a:spcPts val="800"/>
               </a:spcAft>
             </a:pPr>
+            <a:endParaRPr sz="2600">
+              <a:solidFill>
+                <a:srgbClr val="212121"/>
+              </a:solidFill>
+            </a:endParaRPr>
+          </a:p>
+          <a:p>
+            <a:pPr>
+              <a:spcAft>
+                <a:spcPts val="800"/>
+              </a:spcAft>
+            </a:pPr>
             <a:r>
               <a:rPr sz="2600">
                 <a:solidFill>
                   <a:srgbClr val="212121"/>
                 </a:solidFill>
               </a:rPr>
-              <a:t/>
-            </a:r>
-          </a:p>
-          <a:p>
-            <a:pPr>
-              <a:spcAft>
-                <a:spcPts val="800"/>
-              </a:spcAft>
-            </a:pPr>
-            <a:r>
-              <a:rPr sz="2600">
-                <a:solidFill>
-                  <a:srgbClr val="212121"/>
-                </a:solidFill>
-              </a:rPr>
               <a:t>Can the program reach a state where the property fails?</a:t>
             </a:r>
           </a:p>
@@ -5090,14 +5234,11 @@
                 <a:spcPts val="800"/>
               </a:spcAft>
             </a:pPr>
-            <a:r>
-              <a:rPr sz="2600">
-                <a:solidFill>
-                  <a:srgbClr val="212121"/>
-                </a:solidFill>
-              </a:rPr>
-              <a:t/>
-            </a:r>
+            <a:endParaRPr sz="2600">
+              <a:solidFill>
+                <a:srgbClr val="212121"/>
+              </a:solidFill>
+            </a:endParaRPr>
           </a:p>
           <a:p>
             <a:pPr lvl="1">
@@ -5135,14 +5276,11 @@
                 <a:spcPts val="800"/>
               </a:spcAft>
             </a:pPr>
-            <a:r>
-              <a:rPr sz="2600">
-                <a:solidFill>
-                  <a:srgbClr val="212121"/>
-                </a:solidFill>
-              </a:rPr>
-              <a:t/>
-            </a:r>
+            <a:endParaRPr sz="2400">
+              <a:solidFill>
+                <a:srgbClr val="212121"/>
+              </a:solidFill>
+            </a:endParaRPr>
           </a:p>
           <a:p>
             <a:pPr>
@@ -5170,7 +5308,7 @@
 </file>
 
 <file path=ppt/slides/slide19.xml><?xml version="1.0" encoding="utf-8"?>
-<p:sld xmlns:a="http://schemas.openxmlformats.org/drawingml/2006/main" xmlns:p="http://schemas.openxmlformats.org/presentationml/2006/main" xmlns:r="http://schemas.openxmlformats.org/officeDocument/2006/relationships">
+<p:sld xmlns:a="http://schemas.openxmlformats.org/drawingml/2006/main" xmlns:r="http://schemas.openxmlformats.org/officeDocument/2006/relationships" xmlns:p="http://schemas.openxmlformats.org/presentationml/2006/main">
   <p:cSld>
     <p:spTree>
       <p:nvGrpSpPr>
@@ -5178,7 +5316,14 @@
         <p:cNvGrpSpPr/>
         <p:nvPr/>
       </p:nvGrpSpPr>
-      <p:grpSpPr/>
+      <p:grpSpPr>
+        <a:xfrm>
+          <a:off x="0" y="0"/>
+          <a:ext cx="0" cy="0"/>
+          <a:chOff x="0" y="0"/>
+          <a:chExt cx="0" cy="0"/>
+        </a:xfrm>
+      </p:grpSpPr>
       <p:sp>
         <p:nvSpPr>
           <p:cNvPr id="2" name="TextBox 1"/>
@@ -5299,14 +5444,11 @@
                 <a:spcPts val="800"/>
               </a:spcAft>
             </a:pPr>
-            <a:r>
-              <a:rPr sz="2400">
-                <a:solidFill>
-                  <a:srgbClr val="212121"/>
-                </a:solidFill>
-              </a:rPr>
-              <a:t/>
-            </a:r>
+            <a:endParaRPr sz="2200">
+              <a:solidFill>
+                <a:srgbClr val="212121"/>
+              </a:solidFill>
+            </a:endParaRPr>
           </a:p>
           <a:p>
             <a:pPr>
@@ -5364,7 +5506,7 @@
 </file>
 
 <file path=ppt/slides/slide2.xml><?xml version="1.0" encoding="utf-8"?>
-<p:sld xmlns:a="http://schemas.openxmlformats.org/drawingml/2006/main" xmlns:p="http://schemas.openxmlformats.org/presentationml/2006/main" xmlns:r="http://schemas.openxmlformats.org/officeDocument/2006/relationships">
+<p:sld xmlns:a="http://schemas.openxmlformats.org/drawingml/2006/main" xmlns:r="http://schemas.openxmlformats.org/officeDocument/2006/relationships" xmlns:p="http://schemas.openxmlformats.org/presentationml/2006/main">
   <p:cSld>
     <p:spTree>
       <p:nvGrpSpPr>
@@ -5372,7 +5514,14 @@
         <p:cNvGrpSpPr/>
         <p:nvPr/>
       </p:nvGrpSpPr>
-      <p:grpSpPr/>
+      <p:grpSpPr>
+        <a:xfrm>
+          <a:off x="0" y="0"/>
+          <a:ext cx="0" cy="0"/>
+          <a:chOff x="0" y="0"/>
+          <a:chExt cx="0" cy="0"/>
+        </a:xfrm>
+      </p:grpSpPr>
       <p:sp>
         <p:nvSpPr>
           <p:cNvPr id="2" name="TextBox 1"/>
@@ -5416,7 +5565,7 @@
         </p:nvGraphicFramePr>
         <p:xfrm>
           <a:off x="731520" y="1371600"/>
-          <a:ext cx="10698480" cy="3657600"/>
+          <a:ext cx="10698480" cy="3962400"/>
         </p:xfrm>
         <a:graphic>
           <a:graphicData uri="http://schemas.openxmlformats.org/drawingml/2006/table">
@@ -5425,8 +5574,20 @@
                 <a:tableStyleId>{5C22544A-7EE6-4342-B048-85BDC9FD1C3A}</a:tableStyleId>
               </a:tblPr>
               <a:tblGrid>
-                <a:gridCol w="1463040"/>
-                <a:gridCol w="9235440"/>
+                <a:gridCol w="1463040">
+                  <a:extLst>
+                    <a:ext uri="{9D8B030D-6E8A-4147-A177-3AD203B41FA5}">
+                      <a16:colId xmlns:a16="http://schemas.microsoft.com/office/drawing/2014/main" val="20000"/>
+                    </a:ext>
+                  </a:extLst>
+                </a:gridCol>
+                <a:gridCol w="9235440">
+                  <a:extLst>
+                    <a:ext uri="{9D8B030D-6E8A-4147-A177-3AD203B41FA5}">
+                      <a16:colId xmlns:a16="http://schemas.microsoft.com/office/drawing/2014/main" val="20001"/>
+                    </a:ext>
+                  </a:extLst>
+                </a:gridCol>
               </a:tblGrid>
               <a:tr h="365760">
                 <a:tc>
@@ -5455,6 +5616,11 @@
                   </a:txBody>
                   <a:tcPr/>
                 </a:tc>
+                <a:extLst>
+                  <a:ext uri="{0D108BD9-81ED-4DB2-BD59-A6C34878D82A}">
+                    <a16:rowId xmlns:a16="http://schemas.microsoft.com/office/drawing/2014/main" val="10000"/>
+                  </a:ext>
+                </a:extLst>
               </a:tr>
               <a:tr h="365760">
                 <a:tc>
@@ -5483,6 +5649,11 @@
                   </a:txBody>
                   <a:tcPr/>
                 </a:tc>
+                <a:extLst>
+                  <a:ext uri="{0D108BD9-81ED-4DB2-BD59-A6C34878D82A}">
+                    <a16:rowId xmlns:a16="http://schemas.microsoft.com/office/drawing/2014/main" val="10001"/>
+                  </a:ext>
+                </a:extLst>
               </a:tr>
               <a:tr h="365760">
                 <a:tc>
@@ -5511,6 +5682,11 @@
                   </a:txBody>
                   <a:tcPr/>
                 </a:tc>
+                <a:extLst>
+                  <a:ext uri="{0D108BD9-81ED-4DB2-BD59-A6C34878D82A}">
+                    <a16:rowId xmlns:a16="http://schemas.microsoft.com/office/drawing/2014/main" val="10002"/>
+                  </a:ext>
+                </a:extLst>
               </a:tr>
               <a:tr h="365760">
                 <a:tc>
@@ -5539,6 +5715,11 @@
                   </a:txBody>
                   <a:tcPr/>
                 </a:tc>
+                <a:extLst>
+                  <a:ext uri="{0D108BD9-81ED-4DB2-BD59-A6C34878D82A}">
+                    <a16:rowId xmlns:a16="http://schemas.microsoft.com/office/drawing/2014/main" val="10003"/>
+                  </a:ext>
+                </a:extLst>
               </a:tr>
               <a:tr h="365760">
                 <a:tc>
@@ -5567,6 +5748,11 @@
                   </a:txBody>
                   <a:tcPr/>
                 </a:tc>
+                <a:extLst>
+                  <a:ext uri="{0D108BD9-81ED-4DB2-BD59-A6C34878D82A}">
+                    <a16:rowId xmlns:a16="http://schemas.microsoft.com/office/drawing/2014/main" val="10004"/>
+                  </a:ext>
+                </a:extLst>
               </a:tr>
               <a:tr h="365760">
                 <a:tc>
@@ -5595,6 +5781,11 @@
                   </a:txBody>
                   <a:tcPr/>
                 </a:tc>
+                <a:extLst>
+                  <a:ext uri="{0D108BD9-81ED-4DB2-BD59-A6C34878D82A}">
+                    <a16:rowId xmlns:a16="http://schemas.microsoft.com/office/drawing/2014/main" val="10005"/>
+                  </a:ext>
+                </a:extLst>
               </a:tr>
               <a:tr h="365760">
                 <a:tc>
@@ -5623,6 +5814,11 @@
                   </a:txBody>
                   <a:tcPr/>
                 </a:tc>
+                <a:extLst>
+                  <a:ext uri="{0D108BD9-81ED-4DB2-BD59-A6C34878D82A}">
+                    <a16:rowId xmlns:a16="http://schemas.microsoft.com/office/drawing/2014/main" val="10006"/>
+                  </a:ext>
+                </a:extLst>
               </a:tr>
               <a:tr h="365760">
                 <a:tc>
@@ -5651,6 +5847,11 @@
                   </a:txBody>
                   <a:tcPr/>
                 </a:tc>
+                <a:extLst>
+                  <a:ext uri="{0D108BD9-81ED-4DB2-BD59-A6C34878D82A}">
+                    <a16:rowId xmlns:a16="http://schemas.microsoft.com/office/drawing/2014/main" val="10007"/>
+                  </a:ext>
+                </a:extLst>
               </a:tr>
               <a:tr h="365760">
                 <a:tc>
@@ -5679,6 +5880,11 @@
                   </a:txBody>
                   <a:tcPr/>
                 </a:tc>
+                <a:extLst>
+                  <a:ext uri="{0D108BD9-81ED-4DB2-BD59-A6C34878D82A}">
+                    <a16:rowId xmlns:a16="http://schemas.microsoft.com/office/drawing/2014/main" val="10008"/>
+                  </a:ext>
+                </a:extLst>
               </a:tr>
               <a:tr h="365760">
                 <a:tc>
@@ -5707,6 +5913,11 @@
                   </a:txBody>
                   <a:tcPr/>
                 </a:tc>
+                <a:extLst>
+                  <a:ext uri="{0D108BD9-81ED-4DB2-BD59-A6C34878D82A}">
+                    <a16:rowId xmlns:a16="http://schemas.microsoft.com/office/drawing/2014/main" val="10009"/>
+                  </a:ext>
+                </a:extLst>
               </a:tr>
             </a:tbl>
           </a:graphicData>
@@ -5721,7 +5932,7 @@
 </file>
 
 <file path=ppt/slides/slide20.xml><?xml version="1.0" encoding="utf-8"?>
-<p:sld xmlns:a="http://schemas.openxmlformats.org/drawingml/2006/main" xmlns:p="http://schemas.openxmlformats.org/presentationml/2006/main" xmlns:r="http://schemas.openxmlformats.org/officeDocument/2006/relationships">
+<p:sld xmlns:a="http://schemas.openxmlformats.org/drawingml/2006/main" xmlns:r="http://schemas.openxmlformats.org/officeDocument/2006/relationships" xmlns:p="http://schemas.openxmlformats.org/presentationml/2006/main">
   <p:cSld>
     <p:spTree>
       <p:nvGrpSpPr>
@@ -5729,7 +5940,14 @@
         <p:cNvGrpSpPr/>
         <p:nvPr/>
       </p:nvGrpSpPr>
-      <p:grpSpPr/>
+      <p:grpSpPr>
+        <a:xfrm>
+          <a:off x="0" y="0"/>
+          <a:ext cx="0" cy="0"/>
+          <a:chOff x="0" y="0"/>
+          <a:chExt cx="0" cy="0"/>
+        </a:xfrm>
+      </p:grpSpPr>
       <p:sp>
         <p:nvSpPr>
           <p:cNvPr id="2" name="TextBox 1"/>
@@ -5773,7 +5991,7 @@
         </p:nvGraphicFramePr>
         <p:xfrm>
           <a:off x="731520" y="1280160"/>
-          <a:ext cx="10698480" cy="2560320"/>
+          <a:ext cx="10698480" cy="3108960"/>
         </p:xfrm>
         <a:graphic>
           <a:graphicData uri="http://schemas.openxmlformats.org/drawingml/2006/table">
@@ -5782,9 +6000,27 @@
                 <a:tableStyleId>{5C22544A-7EE6-4342-B048-85BDC9FD1C3A}</a:tableStyleId>
               </a:tblPr>
               <a:tblGrid>
-                <a:gridCol w="2468880"/>
-                <a:gridCol w="4206240"/>
-                <a:gridCol w="4023360"/>
+                <a:gridCol w="2468880">
+                  <a:extLst>
+                    <a:ext uri="{9D8B030D-6E8A-4147-A177-3AD203B41FA5}">
+                      <a16:colId xmlns:a16="http://schemas.microsoft.com/office/drawing/2014/main" val="20000"/>
+                    </a:ext>
+                  </a:extLst>
+                </a:gridCol>
+                <a:gridCol w="4206240">
+                  <a:extLst>
+                    <a:ext uri="{9D8B030D-6E8A-4147-A177-3AD203B41FA5}">
+                      <a16:colId xmlns:a16="http://schemas.microsoft.com/office/drawing/2014/main" val="20001"/>
+                    </a:ext>
+                  </a:extLst>
+                </a:gridCol>
+                <a:gridCol w="4023360">
+                  <a:extLst>
+                    <a:ext uri="{9D8B030D-6E8A-4147-A177-3AD203B41FA5}">
+                      <a16:colId xmlns:a16="http://schemas.microsoft.com/office/drawing/2014/main" val="20002"/>
+                    </a:ext>
+                  </a:extLst>
+                </a:gridCol>
               </a:tblGrid>
               <a:tr h="365760">
                 <a:tc>
@@ -5826,6 +6062,11 @@
                   </a:txBody>
                   <a:tcPr/>
                 </a:tc>
+                <a:extLst>
+                  <a:ext uri="{0D108BD9-81ED-4DB2-BD59-A6C34878D82A}">
+                    <a16:rowId xmlns:a16="http://schemas.microsoft.com/office/drawing/2014/main" val="10000"/>
+                  </a:ext>
+                </a:extLst>
               </a:tr>
               <a:tr h="365760">
                 <a:tc>
@@ -5867,6 +6108,11 @@
                   </a:txBody>
                   <a:tcPr/>
                 </a:tc>
+                <a:extLst>
+                  <a:ext uri="{0D108BD9-81ED-4DB2-BD59-A6C34878D82A}">
+                    <a16:rowId xmlns:a16="http://schemas.microsoft.com/office/drawing/2014/main" val="10001"/>
+                  </a:ext>
+                </a:extLst>
               </a:tr>
               <a:tr h="365760">
                 <a:tc>
@@ -5908,6 +6154,11 @@
                   </a:txBody>
                   <a:tcPr/>
                 </a:tc>
+                <a:extLst>
+                  <a:ext uri="{0D108BD9-81ED-4DB2-BD59-A6C34878D82A}">
+                    <a16:rowId xmlns:a16="http://schemas.microsoft.com/office/drawing/2014/main" val="10002"/>
+                  </a:ext>
+                </a:extLst>
               </a:tr>
               <a:tr h="365760">
                 <a:tc>
@@ -5949,6 +6200,11 @@
                   </a:txBody>
                   <a:tcPr/>
                 </a:tc>
+                <a:extLst>
+                  <a:ext uri="{0D108BD9-81ED-4DB2-BD59-A6C34878D82A}">
+                    <a16:rowId xmlns:a16="http://schemas.microsoft.com/office/drawing/2014/main" val="10003"/>
+                  </a:ext>
+                </a:extLst>
               </a:tr>
               <a:tr h="365760">
                 <a:tc>
@@ -5990,6 +6246,11 @@
                   </a:txBody>
                   <a:tcPr/>
                 </a:tc>
+                <a:extLst>
+                  <a:ext uri="{0D108BD9-81ED-4DB2-BD59-A6C34878D82A}">
+                    <a16:rowId xmlns:a16="http://schemas.microsoft.com/office/drawing/2014/main" val="10004"/>
+                  </a:ext>
+                </a:extLst>
               </a:tr>
               <a:tr h="365760">
                 <a:tc>
@@ -6031,6 +6292,11 @@
                   </a:txBody>
                   <a:tcPr/>
                 </a:tc>
+                <a:extLst>
+                  <a:ext uri="{0D108BD9-81ED-4DB2-BD59-A6C34878D82A}">
+                    <a16:rowId xmlns:a16="http://schemas.microsoft.com/office/drawing/2014/main" val="10005"/>
+                  </a:ext>
+                </a:extLst>
               </a:tr>
               <a:tr h="365760">
                 <a:tc>
@@ -6072,6 +6338,11 @@
                   </a:txBody>
                   <a:tcPr/>
                 </a:tc>
+                <a:extLst>
+                  <a:ext uri="{0D108BD9-81ED-4DB2-BD59-A6C34878D82A}">
+                    <a16:rowId xmlns:a16="http://schemas.microsoft.com/office/drawing/2014/main" val="10006"/>
+                  </a:ext>
+                </a:extLst>
               </a:tr>
             </a:tbl>
           </a:graphicData>
@@ -6124,7 +6395,7 @@
 </file>
 
 <file path=ppt/slides/slide21.xml><?xml version="1.0" encoding="utf-8"?>
-<p:sld xmlns:a="http://schemas.openxmlformats.org/drawingml/2006/main" xmlns:p="http://schemas.openxmlformats.org/presentationml/2006/main" xmlns:r="http://schemas.openxmlformats.org/officeDocument/2006/relationships">
+<p:sld xmlns:a="http://schemas.openxmlformats.org/drawingml/2006/main" xmlns:r="http://schemas.openxmlformats.org/officeDocument/2006/relationships" xmlns:p="http://schemas.openxmlformats.org/presentationml/2006/main">
   <p:cSld>
     <p:spTree>
       <p:nvGrpSpPr>
@@ -6132,7 +6403,14 @@
         <p:cNvGrpSpPr/>
         <p:nvPr/>
       </p:nvGrpSpPr>
-      <p:grpSpPr/>
+      <p:grpSpPr>
+        <a:xfrm>
+          <a:off x="0" y="0"/>
+          <a:ext cx="0" cy="0"/>
+          <a:chOff x="0" y="0"/>
+          <a:chExt cx="0" cy="0"/>
+        </a:xfrm>
+      </p:grpSpPr>
       <p:sp>
         <p:nvSpPr>
           <p:cNvPr id="2" name="TextBox 1"/>
@@ -6176,7 +6454,7 @@
         </p:nvGraphicFramePr>
         <p:xfrm>
           <a:off x="731520" y="1554480"/>
-          <a:ext cx="10698480" cy="1097280"/>
+          <a:ext cx="10698480" cy="1188720"/>
         </p:xfrm>
         <a:graphic>
           <a:graphicData uri="http://schemas.openxmlformats.org/drawingml/2006/table">
@@ -6185,16 +6463,36 @@
                 <a:tableStyleId>{5C22544A-7EE6-4342-B048-85BDC9FD1C3A}</a:tableStyleId>
               </a:tblPr>
               <a:tblGrid>
-                <a:gridCol w="3108960"/>
-                <a:gridCol w="4023360"/>
-                <a:gridCol w="3566160"/>
+                <a:gridCol w="3108960">
+                  <a:extLst>
+                    <a:ext uri="{9D8B030D-6E8A-4147-A177-3AD203B41FA5}">
+                      <a16:colId xmlns:a16="http://schemas.microsoft.com/office/drawing/2014/main" val="20000"/>
+                    </a:ext>
+                  </a:extLst>
+                </a:gridCol>
+                <a:gridCol w="4023360">
+                  <a:extLst>
+                    <a:ext uri="{9D8B030D-6E8A-4147-A177-3AD203B41FA5}">
+                      <a16:colId xmlns:a16="http://schemas.microsoft.com/office/drawing/2014/main" val="20001"/>
+                    </a:ext>
+                  </a:extLst>
+                </a:gridCol>
+                <a:gridCol w="3566160">
+                  <a:extLst>
+                    <a:ext uri="{9D8B030D-6E8A-4147-A177-3AD203B41FA5}">
+                      <a16:colId xmlns:a16="http://schemas.microsoft.com/office/drawing/2014/main" val="20002"/>
+                    </a:ext>
+                  </a:extLst>
+                </a:gridCol>
               </a:tblGrid>
               <a:tr h="365760">
                 <a:tc>
                   <a:txBody>
                     <a:bodyPr/>
                     <a:lstStyle/>
-                    <a:p/>
+                    <a:p>
+                      <a:endParaRPr/>
+                    </a:p>
                   </a:txBody>
                   <a:tcPr/>
                 </a:tc>
@@ -6224,6 +6522,11 @@
                   </a:txBody>
                   <a:tcPr/>
                 </a:tc>
+                <a:extLst>
+                  <a:ext uri="{0D108BD9-81ED-4DB2-BD59-A6C34878D82A}">
+                    <a16:rowId xmlns:a16="http://schemas.microsoft.com/office/drawing/2014/main" val="10000"/>
+                  </a:ext>
+                </a:extLst>
               </a:tr>
               <a:tr h="365760">
                 <a:tc>
@@ -6265,6 +6568,11 @@
                   </a:txBody>
                   <a:tcPr/>
                 </a:tc>
+                <a:extLst>
+                  <a:ext uri="{0D108BD9-81ED-4DB2-BD59-A6C34878D82A}">
+                    <a16:rowId xmlns:a16="http://schemas.microsoft.com/office/drawing/2014/main" val="10001"/>
+                  </a:ext>
+                </a:extLst>
               </a:tr>
               <a:tr h="365760">
                 <a:tc>
@@ -6306,6 +6614,11 @@
                   </a:txBody>
                   <a:tcPr/>
                 </a:tc>
+                <a:extLst>
+                  <a:ext uri="{0D108BD9-81ED-4DB2-BD59-A6C34878D82A}">
+                    <a16:rowId xmlns:a16="http://schemas.microsoft.com/office/drawing/2014/main" val="10002"/>
+                  </a:ext>
+                </a:extLst>
               </a:tr>
             </a:tbl>
           </a:graphicData>
@@ -6373,7 +6686,7 @@
 </file>
 
 <file path=ppt/slides/slide22.xml><?xml version="1.0" encoding="utf-8"?>
-<p:sld xmlns:a="http://schemas.openxmlformats.org/drawingml/2006/main" xmlns:p="http://schemas.openxmlformats.org/presentationml/2006/main" xmlns:r="http://schemas.openxmlformats.org/officeDocument/2006/relationships">
+<p:sld xmlns:a="http://schemas.openxmlformats.org/drawingml/2006/main" xmlns:r="http://schemas.openxmlformats.org/officeDocument/2006/relationships" xmlns:p="http://schemas.openxmlformats.org/presentationml/2006/main">
   <p:cSld>
     <p:spTree>
       <p:nvGrpSpPr>
@@ -6381,7 +6694,14 @@
         <p:cNvGrpSpPr/>
         <p:nvPr/>
       </p:nvGrpSpPr>
-      <p:grpSpPr/>
+      <p:grpSpPr>
+        <a:xfrm>
+          <a:off x="0" y="0"/>
+          <a:ext cx="0" cy="0"/>
+          <a:chOff x="0" y="0"/>
+          <a:chExt cx="0" cy="0"/>
+        </a:xfrm>
+      </p:grpSpPr>
       <p:sp>
         <p:nvSpPr>
           <p:cNvPr id="2" name="TextBox 1"/>
@@ -6434,9 +6754,27 @@
                 <a:tableStyleId>{5C22544A-7EE6-4342-B048-85BDC9FD1C3A}</a:tableStyleId>
               </a:tblPr>
               <a:tblGrid>
-                <a:gridCol w="3474720"/>
-                <a:gridCol w="4023360"/>
-                <a:gridCol w="3200400"/>
+                <a:gridCol w="3474720">
+                  <a:extLst>
+                    <a:ext uri="{9D8B030D-6E8A-4147-A177-3AD203B41FA5}">
+                      <a16:colId xmlns:a16="http://schemas.microsoft.com/office/drawing/2014/main" val="20000"/>
+                    </a:ext>
+                  </a:extLst>
+                </a:gridCol>
+                <a:gridCol w="4023360">
+                  <a:extLst>
+                    <a:ext uri="{9D8B030D-6E8A-4147-A177-3AD203B41FA5}">
+                      <a16:colId xmlns:a16="http://schemas.microsoft.com/office/drawing/2014/main" val="20001"/>
+                    </a:ext>
+                  </a:extLst>
+                </a:gridCol>
+                <a:gridCol w="3200400">
+                  <a:extLst>
+                    <a:ext uri="{9D8B030D-6E8A-4147-A177-3AD203B41FA5}">
+                      <a16:colId xmlns:a16="http://schemas.microsoft.com/office/drawing/2014/main" val="20002"/>
+                    </a:ext>
+                  </a:extLst>
+                </a:gridCol>
               </a:tblGrid>
               <a:tr h="365760">
                 <a:tc>
@@ -6478,6 +6816,11 @@
                   </a:txBody>
                   <a:tcPr/>
                 </a:tc>
+                <a:extLst>
+                  <a:ext uri="{0D108BD9-81ED-4DB2-BD59-A6C34878D82A}">
+                    <a16:rowId xmlns:a16="http://schemas.microsoft.com/office/drawing/2014/main" val="10000"/>
+                  </a:ext>
+                </a:extLst>
               </a:tr>
               <a:tr h="365760">
                 <a:tc>
@@ -6519,6 +6862,11 @@
                   </a:txBody>
                   <a:tcPr/>
                 </a:tc>
+                <a:extLst>
+                  <a:ext uri="{0D108BD9-81ED-4DB2-BD59-A6C34878D82A}">
+                    <a16:rowId xmlns:a16="http://schemas.microsoft.com/office/drawing/2014/main" val="10001"/>
+                  </a:ext>
+                </a:extLst>
               </a:tr>
               <a:tr h="365760">
                 <a:tc>
@@ -6560,6 +6908,11 @@
                   </a:txBody>
                   <a:tcPr/>
                 </a:tc>
+                <a:extLst>
+                  <a:ext uri="{0D108BD9-81ED-4DB2-BD59-A6C34878D82A}">
+                    <a16:rowId xmlns:a16="http://schemas.microsoft.com/office/drawing/2014/main" val="10002"/>
+                  </a:ext>
+                </a:extLst>
               </a:tr>
               <a:tr h="365760">
                 <a:tc>
@@ -6601,6 +6954,11 @@
                   </a:txBody>
                   <a:tcPr/>
                 </a:tc>
+                <a:extLst>
+                  <a:ext uri="{0D108BD9-81ED-4DB2-BD59-A6C34878D82A}">
+                    <a16:rowId xmlns:a16="http://schemas.microsoft.com/office/drawing/2014/main" val="10003"/>
+                  </a:ext>
+                </a:extLst>
               </a:tr>
               <a:tr h="365760">
                 <a:tc>
@@ -6642,6 +7000,11 @@
                   </a:txBody>
                   <a:tcPr/>
                 </a:tc>
+                <a:extLst>
+                  <a:ext uri="{0D108BD9-81ED-4DB2-BD59-A6C34878D82A}">
+                    <a16:rowId xmlns:a16="http://schemas.microsoft.com/office/drawing/2014/main" val="10004"/>
+                  </a:ext>
+                </a:extLst>
               </a:tr>
               <a:tr h="365760">
                 <a:tc>
@@ -6683,6 +7046,11 @@
                   </a:txBody>
                   <a:tcPr/>
                 </a:tc>
+                <a:extLst>
+                  <a:ext uri="{0D108BD9-81ED-4DB2-BD59-A6C34878D82A}">
+                    <a16:rowId xmlns:a16="http://schemas.microsoft.com/office/drawing/2014/main" val="10005"/>
+                  </a:ext>
+                </a:extLst>
               </a:tr>
             </a:tbl>
           </a:graphicData>
@@ -6735,7 +7103,7 @@
 </file>
 
 <file path=ppt/slides/slide23.xml><?xml version="1.0" encoding="utf-8"?>
-<p:sld xmlns:a="http://schemas.openxmlformats.org/drawingml/2006/main" xmlns:p="http://schemas.openxmlformats.org/presentationml/2006/main" xmlns:r="http://schemas.openxmlformats.org/officeDocument/2006/relationships">
+<p:sld xmlns:a="http://schemas.openxmlformats.org/drawingml/2006/main" xmlns:r="http://schemas.openxmlformats.org/officeDocument/2006/relationships" xmlns:p="http://schemas.openxmlformats.org/presentationml/2006/main">
   <p:cSld>
     <p:spTree>
       <p:nvGrpSpPr>
@@ -6743,7 +7111,14 @@
         <p:cNvGrpSpPr/>
         <p:nvPr/>
       </p:nvGrpSpPr>
-      <p:grpSpPr/>
+      <p:grpSpPr>
+        <a:xfrm>
+          <a:off x="0" y="0"/>
+          <a:ext cx="0" cy="0"/>
+          <a:chOff x="0" y="0"/>
+          <a:chExt cx="0" cy="0"/>
+        </a:xfrm>
+      </p:grpSpPr>
       <p:sp>
         <p:nvSpPr>
           <p:cNvPr id="2" name="TextBox 1"/>
@@ -6937,7 +7312,7 @@
 </file>
 
 <file path=ppt/slides/slide24.xml><?xml version="1.0" encoding="utf-8"?>
-<p:sld xmlns:a="http://schemas.openxmlformats.org/drawingml/2006/main" xmlns:p="http://schemas.openxmlformats.org/presentationml/2006/main" xmlns:r="http://schemas.openxmlformats.org/officeDocument/2006/relationships">
+<p:sld xmlns:a="http://schemas.openxmlformats.org/drawingml/2006/main" xmlns:r="http://schemas.openxmlformats.org/officeDocument/2006/relationships" xmlns:p="http://schemas.openxmlformats.org/presentationml/2006/main">
   <p:cSld>
     <p:spTree>
       <p:nvGrpSpPr>
@@ -6945,7 +7320,14 @@
         <p:cNvGrpSpPr/>
         <p:nvPr/>
       </p:nvGrpSpPr>
-      <p:grpSpPr/>
+      <p:grpSpPr>
+        <a:xfrm>
+          <a:off x="0" y="0"/>
+          <a:ext cx="0" cy="0"/>
+          <a:chOff x="0" y="0"/>
+          <a:chExt cx="0" cy="0"/>
+        </a:xfrm>
+      </p:grpSpPr>
       <p:sp>
         <p:nvSpPr>
           <p:cNvPr id="2" name="TextBox 1"/>
@@ -7051,27 +7433,24 @@
                 <a:spcPts val="800"/>
               </a:spcAft>
             </a:pPr>
+            <a:endParaRPr sz="2400">
+              <a:solidFill>
+                <a:srgbClr val="212121"/>
+              </a:solidFill>
+            </a:endParaRPr>
+          </a:p>
+          <a:p>
+            <a:pPr>
+              <a:spcAft>
+                <a:spcPts val="800"/>
+              </a:spcAft>
+            </a:pPr>
             <a:r>
               <a:rPr sz="2600">
                 <a:solidFill>
                   <a:srgbClr val="212121"/>
                 </a:solidFill>
               </a:rPr>
-              <a:t/>
-            </a:r>
-          </a:p>
-          <a:p>
-            <a:pPr>
-              <a:spcAft>
-                <a:spcPts val="800"/>
-              </a:spcAft>
-            </a:pPr>
-            <a:r>
-              <a:rPr sz="2600">
-                <a:solidFill>
-                  <a:srgbClr val="212121"/>
-                </a:solidFill>
-              </a:rPr>
               <a:t>Every tool tonight, and every lab in Session 2, is this one move in different costumes.</a:t>
             </a:r>
           </a:p>
@@ -7081,14 +7460,11 @@
                 <a:spcPts val="800"/>
               </a:spcAft>
             </a:pPr>
-            <a:r>
-              <a:rPr sz="2600">
-                <a:solidFill>
-                  <a:srgbClr val="212121"/>
-                </a:solidFill>
-              </a:rPr>
-              <a:t/>
-            </a:r>
+            <a:endParaRPr sz="2600">
+              <a:solidFill>
+                <a:srgbClr val="212121"/>
+              </a:solidFill>
+            </a:endParaRPr>
           </a:p>
           <a:p>
             <a:pPr>
@@ -7116,7 +7492,7 @@
 </file>
 
 <file path=ppt/slides/slide25.xml><?xml version="1.0" encoding="utf-8"?>
-<p:sld xmlns:a="http://schemas.openxmlformats.org/drawingml/2006/main" xmlns:p="http://schemas.openxmlformats.org/presentationml/2006/main" xmlns:r="http://schemas.openxmlformats.org/officeDocument/2006/relationships">
+<p:sld xmlns:a="http://schemas.openxmlformats.org/drawingml/2006/main" xmlns:r="http://schemas.openxmlformats.org/officeDocument/2006/relationships" xmlns:p="http://schemas.openxmlformats.org/presentationml/2006/main">
   <p:cSld>
     <p:spTree>
       <p:nvGrpSpPr>
@@ -7124,7 +7500,14 @@
         <p:cNvGrpSpPr/>
         <p:nvPr/>
       </p:nvGrpSpPr>
-      <p:grpSpPr/>
+      <p:grpSpPr>
+        <a:xfrm>
+          <a:off x="0" y="0"/>
+          <a:ext cx="0" cy="0"/>
+          <a:chOff x="0" y="0"/>
+          <a:chExt cx="0" cy="0"/>
+        </a:xfrm>
+      </p:grpSpPr>
       <p:sp>
         <p:nvSpPr>
           <p:cNvPr id="2" name="TextBox 1"/>
@@ -7167,7 +7550,7 @@
 </file>
 
 <file path=ppt/slides/slide26.xml><?xml version="1.0" encoding="utf-8"?>
-<p:sld xmlns:a="http://schemas.openxmlformats.org/drawingml/2006/main" xmlns:p="http://schemas.openxmlformats.org/presentationml/2006/main" xmlns:r="http://schemas.openxmlformats.org/officeDocument/2006/relationships">
+<p:sld xmlns:a="http://schemas.openxmlformats.org/drawingml/2006/main" xmlns:r="http://schemas.openxmlformats.org/officeDocument/2006/relationships" xmlns:p="http://schemas.openxmlformats.org/presentationml/2006/main">
   <p:cSld>
     <p:spTree>
       <p:nvGrpSpPr>
@@ -7175,7 +7558,14 @@
         <p:cNvGrpSpPr/>
         <p:nvPr/>
       </p:nvGrpSpPr>
-      <p:grpSpPr/>
+      <p:grpSpPr>
+        <a:xfrm>
+          <a:off x="0" y="0"/>
+          <a:ext cx="0" cy="0"/>
+          <a:chOff x="0" y="0"/>
+          <a:chExt cx="0" cy="0"/>
+        </a:xfrm>
+      </p:grpSpPr>
       <p:sp>
         <p:nvSpPr>
           <p:cNvPr id="2" name="TextBox 1"/>
@@ -7252,27 +7642,25 @@
                 <a:spcPts val="800"/>
               </a:spcAft>
             </a:pPr>
+            <a:endParaRPr sz="2000">
+              <a:solidFill>
+                <a:srgbClr val="212121"/>
+              </a:solidFill>
+              <a:latin typeface="Courier New"/>
+            </a:endParaRPr>
+          </a:p>
+          <a:p>
+            <a:pPr>
+              <a:spcAft>
+                <a:spcPts val="800"/>
+              </a:spcAft>
+            </a:pPr>
             <a:r>
               <a:rPr sz="2400">
                 <a:solidFill>
                   <a:srgbClr val="212121"/>
                 </a:solidFill>
               </a:rPr>
-              <a:t/>
-            </a:r>
-          </a:p>
-          <a:p>
-            <a:pPr>
-              <a:spcAft>
-                <a:spcPts val="800"/>
-              </a:spcAft>
-            </a:pPr>
-            <a:r>
-              <a:rPr sz="2400">
-                <a:solidFill>
-                  <a:srgbClr val="212121"/>
-                </a:solidFill>
-              </a:rPr>
               <a:t>Is there a true/false assignment that makes the whole formula true?</a:t>
             </a:r>
           </a:p>
@@ -7282,14 +7670,11 @@
                 <a:spcPts val="800"/>
               </a:spcAft>
             </a:pPr>
-            <a:r>
-              <a:rPr sz="2400">
-                <a:solidFill>
-                  <a:srgbClr val="212121"/>
-                </a:solidFill>
-              </a:rPr>
-              <a:t/>
-            </a:r>
+            <a:endParaRPr sz="2400">
+              <a:solidFill>
+                <a:srgbClr val="212121"/>
+              </a:solidFill>
+            </a:endParaRPr>
           </a:p>
           <a:p>
             <a:pPr>
@@ -7332,7 +7717,7 @@
 </file>
 
 <file path=ppt/slides/slide27.xml><?xml version="1.0" encoding="utf-8"?>
-<p:sld xmlns:a="http://schemas.openxmlformats.org/drawingml/2006/main" xmlns:p="http://schemas.openxmlformats.org/presentationml/2006/main" xmlns:r="http://schemas.openxmlformats.org/officeDocument/2006/relationships">
+<p:sld xmlns:a="http://schemas.openxmlformats.org/drawingml/2006/main" xmlns:r="http://schemas.openxmlformats.org/officeDocument/2006/relationships" xmlns:p="http://schemas.openxmlformats.org/presentationml/2006/main">
   <p:cSld>
     <p:spTree>
       <p:nvGrpSpPr>
@@ -7340,7 +7725,14 @@
         <p:cNvGrpSpPr/>
         <p:nvPr/>
       </p:nvGrpSpPr>
-      <p:grpSpPr/>
+      <p:grpSpPr>
+        <a:xfrm>
+          <a:off x="0" y="0"/>
+          <a:ext cx="0" cy="0"/>
+          <a:chOff x="0" y="0"/>
+          <a:chExt cx="0" cy="0"/>
+        </a:xfrm>
+      </p:grpSpPr>
       <p:sp>
         <p:nvSpPr>
           <p:cNvPr id="2" name="TextBox 1"/>
@@ -7461,14 +7853,11 @@
                 <a:spcPts val="800"/>
               </a:spcAft>
             </a:pPr>
-            <a:r>
-              <a:rPr sz="2400">
-                <a:solidFill>
-                  <a:srgbClr val="212121"/>
-                </a:solidFill>
-              </a:rPr>
-              <a:t/>
-            </a:r>
+            <a:endParaRPr sz="2200">
+              <a:solidFill>
+                <a:srgbClr val="212121"/>
+              </a:solidFill>
+            </a:endParaRPr>
           </a:p>
           <a:p>
             <a:pPr>
@@ -7526,7 +7915,7 @@
 </file>
 
 <file path=ppt/slides/slide28.xml><?xml version="1.0" encoding="utf-8"?>
-<p:sld xmlns:a="http://schemas.openxmlformats.org/drawingml/2006/main" xmlns:p="http://schemas.openxmlformats.org/presentationml/2006/main" xmlns:r="http://schemas.openxmlformats.org/officeDocument/2006/relationships">
+<p:sld xmlns:a="http://schemas.openxmlformats.org/drawingml/2006/main" xmlns:r="http://schemas.openxmlformats.org/officeDocument/2006/relationships" xmlns:p="http://schemas.openxmlformats.org/presentationml/2006/main">
   <p:cSld>
     <p:spTree>
       <p:nvGrpSpPr>
@@ -7534,7 +7923,14 @@
         <p:cNvGrpSpPr/>
         <p:nvPr/>
       </p:nvGrpSpPr>
-      <p:grpSpPr/>
+      <p:grpSpPr>
+        <a:xfrm>
+          <a:off x="0" y="0"/>
+          <a:ext cx="0" cy="0"/>
+          <a:chOff x="0" y="0"/>
+          <a:chExt cx="0" cy="0"/>
+        </a:xfrm>
+      </p:grpSpPr>
       <p:sp>
         <p:nvSpPr>
           <p:cNvPr id="2" name="TextBox 1"/>
@@ -7578,7 +7974,7 @@
         </p:nvGraphicFramePr>
         <p:xfrm>
           <a:off x="731520" y="1554480"/>
-          <a:ext cx="10698480" cy="1828800"/>
+          <a:ext cx="10698480" cy="1981200"/>
         </p:xfrm>
         <a:graphic>
           <a:graphicData uri="http://schemas.openxmlformats.org/drawingml/2006/table">
@@ -7587,8 +7983,20 @@
                 <a:tableStyleId>{5C22544A-7EE6-4342-B048-85BDC9FD1C3A}</a:tableStyleId>
               </a:tblPr>
               <a:tblGrid>
-                <a:gridCol w="4754880"/>
-                <a:gridCol w="5943600"/>
+                <a:gridCol w="4754880">
+                  <a:extLst>
+                    <a:ext uri="{9D8B030D-6E8A-4147-A177-3AD203B41FA5}">
+                      <a16:colId xmlns:a16="http://schemas.microsoft.com/office/drawing/2014/main" val="20000"/>
+                    </a:ext>
+                  </a:extLst>
+                </a:gridCol>
+                <a:gridCol w="5943600">
+                  <a:extLst>
+                    <a:ext uri="{9D8B030D-6E8A-4147-A177-3AD203B41FA5}">
+                      <a16:colId xmlns:a16="http://schemas.microsoft.com/office/drawing/2014/main" val="20001"/>
+                    </a:ext>
+                  </a:extLst>
+                </a:gridCol>
               </a:tblGrid>
               <a:tr h="365760">
                 <a:tc>
@@ -7617,6 +8025,11 @@
                   </a:txBody>
                   <a:tcPr/>
                 </a:tc>
+                <a:extLst>
+                  <a:ext uri="{0D108BD9-81ED-4DB2-BD59-A6C34878D82A}">
+                    <a16:rowId xmlns:a16="http://schemas.microsoft.com/office/drawing/2014/main" val="10000"/>
+                  </a:ext>
+                </a:extLst>
               </a:tr>
               <a:tr h="365760">
                 <a:tc>
@@ -7645,6 +8058,11 @@
                   </a:txBody>
                   <a:tcPr/>
                 </a:tc>
+                <a:extLst>
+                  <a:ext uri="{0D108BD9-81ED-4DB2-BD59-A6C34878D82A}">
+                    <a16:rowId xmlns:a16="http://schemas.microsoft.com/office/drawing/2014/main" val="10001"/>
+                  </a:ext>
+                </a:extLst>
               </a:tr>
               <a:tr h="365760">
                 <a:tc>
@@ -7673,6 +8091,11 @@
                   </a:txBody>
                   <a:tcPr/>
                 </a:tc>
+                <a:extLst>
+                  <a:ext uri="{0D108BD9-81ED-4DB2-BD59-A6C34878D82A}">
+                    <a16:rowId xmlns:a16="http://schemas.microsoft.com/office/drawing/2014/main" val="10002"/>
+                  </a:ext>
+                </a:extLst>
               </a:tr>
               <a:tr h="365760">
                 <a:tc>
@@ -7701,6 +8124,11 @@
                   </a:txBody>
                   <a:tcPr/>
                 </a:tc>
+                <a:extLst>
+                  <a:ext uri="{0D108BD9-81ED-4DB2-BD59-A6C34878D82A}">
+                    <a16:rowId xmlns:a16="http://schemas.microsoft.com/office/drawing/2014/main" val="10003"/>
+                  </a:ext>
+                </a:extLst>
               </a:tr>
               <a:tr h="365760">
                 <a:tc>
@@ -7729,6 +8157,11 @@
                   </a:txBody>
                   <a:tcPr/>
                 </a:tc>
+                <a:extLst>
+                  <a:ext uri="{0D108BD9-81ED-4DB2-BD59-A6C34878D82A}">
+                    <a16:rowId xmlns:a16="http://schemas.microsoft.com/office/drawing/2014/main" val="10004"/>
+                  </a:ext>
+                </a:extLst>
               </a:tr>
             </a:tbl>
           </a:graphicData>
@@ -7781,7 +8214,7 @@
 </file>
 
 <file path=ppt/slides/slide29.xml><?xml version="1.0" encoding="utf-8"?>
-<p:sld xmlns:a="http://schemas.openxmlformats.org/drawingml/2006/main" xmlns:p="http://schemas.openxmlformats.org/presentationml/2006/main" xmlns:r="http://schemas.openxmlformats.org/officeDocument/2006/relationships">
+<p:sld xmlns:a="http://schemas.openxmlformats.org/drawingml/2006/main" xmlns:r="http://schemas.openxmlformats.org/officeDocument/2006/relationships" xmlns:p="http://schemas.openxmlformats.org/presentationml/2006/main">
   <p:cSld>
     <p:spTree>
       <p:nvGrpSpPr>
@@ -7789,7 +8222,14 @@
         <p:cNvGrpSpPr/>
         <p:nvPr/>
       </p:nvGrpSpPr>
-      <p:grpSpPr/>
+      <p:grpSpPr>
+        <a:xfrm>
+          <a:off x="0" y="0"/>
+          <a:ext cx="0" cy="0"/>
+          <a:chOff x="0" y="0"/>
+          <a:chExt cx="0" cy="0"/>
+        </a:xfrm>
+      </p:grpSpPr>
       <p:sp>
         <p:nvSpPr>
           <p:cNvPr id="2" name="TextBox 1"/>
@@ -7882,14 +8322,12 @@
                 <a:spcPts val="800"/>
               </a:spcAft>
             </a:pPr>
-            <a:r>
-              <a:rPr sz="2400">
-                <a:solidFill>
-                  <a:srgbClr val="212121"/>
-                </a:solidFill>
-              </a:rPr>
-              <a:t/>
-            </a:r>
+            <a:endParaRPr sz="2000">
+              <a:solidFill>
+                <a:srgbClr val="212121"/>
+              </a:solidFill>
+              <a:latin typeface="Courier New"/>
+            </a:endParaRPr>
           </a:p>
           <a:p>
             <a:pPr>
@@ -7962,7 +8400,7 @@
 </file>
 
 <file path=ppt/slides/slide3.xml><?xml version="1.0" encoding="utf-8"?>
-<p:sld xmlns:a="http://schemas.openxmlformats.org/drawingml/2006/main" xmlns:p="http://schemas.openxmlformats.org/presentationml/2006/main" xmlns:r="http://schemas.openxmlformats.org/officeDocument/2006/relationships">
+<p:sld xmlns:a="http://schemas.openxmlformats.org/drawingml/2006/main" xmlns:r="http://schemas.openxmlformats.org/officeDocument/2006/relationships" xmlns:p="http://schemas.openxmlformats.org/presentationml/2006/main">
   <p:cSld>
     <p:spTree>
       <p:nvGrpSpPr>
@@ -7970,7 +8408,14 @@
         <p:cNvGrpSpPr/>
         <p:nvPr/>
       </p:nvGrpSpPr>
-      <p:grpSpPr/>
+      <p:grpSpPr>
+        <a:xfrm>
+          <a:off x="0" y="0"/>
+          <a:ext cx="0" cy="0"/>
+          <a:chOff x="0" y="0"/>
+          <a:chExt cx="0" cy="0"/>
+        </a:xfrm>
+      </p:grpSpPr>
       <p:sp>
         <p:nvSpPr>
           <p:cNvPr id="2" name="TextBox 1"/>
@@ -8066,7 +8511,7 @@
 </file>
 
 <file path=ppt/slides/slide30.xml><?xml version="1.0" encoding="utf-8"?>
-<p:sld xmlns:a="http://schemas.openxmlformats.org/drawingml/2006/main" xmlns:p="http://schemas.openxmlformats.org/presentationml/2006/main" xmlns:r="http://schemas.openxmlformats.org/officeDocument/2006/relationships">
+<p:sld xmlns:a="http://schemas.openxmlformats.org/drawingml/2006/main" xmlns:r="http://schemas.openxmlformats.org/officeDocument/2006/relationships" xmlns:p="http://schemas.openxmlformats.org/presentationml/2006/main">
   <p:cSld>
     <p:spTree>
       <p:nvGrpSpPr>
@@ -8074,7 +8519,14 @@
         <p:cNvGrpSpPr/>
         <p:nvPr/>
       </p:nvGrpSpPr>
-      <p:grpSpPr/>
+      <p:grpSpPr>
+        <a:xfrm>
+          <a:off x="0" y="0"/>
+          <a:ext cx="0" cy="0"/>
+          <a:chOff x="0" y="0"/>
+          <a:chExt cx="0" cy="0"/>
+        </a:xfrm>
+      </p:grpSpPr>
       <p:sp>
         <p:nvSpPr>
           <p:cNvPr id="2" name="TextBox 1"/>
@@ -8151,6 +8603,19 @@
                 <a:spcPts val="0"/>
               </a:spcAft>
             </a:pPr>
+            <a:endParaRPr sz="1800">
+              <a:solidFill>
+                <a:srgbClr val="212121"/>
+              </a:solidFill>
+              <a:latin typeface="Courier New"/>
+            </a:endParaRPr>
+          </a:p>
+          <a:p>
+            <a:pPr>
+              <a:spcAft>
+                <a:spcPts val="0"/>
+              </a:spcAft>
+            </a:pPr>
             <a:r>
               <a:rPr sz="1800">
                 <a:solidFill>
@@ -8158,7 +8623,7 @@
                 </a:solidFill>
                 <a:latin typeface="Courier New"/>
               </a:rPr>
-              <a:t/>
+              <a:t>Query 1: x + y == 42 and x &gt; 100</a:t>
             </a:r>
           </a:p>
           <a:p>
@@ -8174,7 +8639,7 @@
                 </a:solidFill>
                 <a:latin typeface="Courier New"/>
               </a:rPr>
-              <a:t>Query 1: x + y == 42 and x &gt; 100</a:t>
+              <a:t>[y = -59, x = 101]            ← a model, in milliseconds</a:t>
             </a:r>
           </a:p>
           <a:p>
@@ -8183,6 +8648,19 @@
                 <a:spcPts val="0"/>
               </a:spcAft>
             </a:pPr>
+            <a:endParaRPr sz="1800">
+              <a:solidFill>
+                <a:srgbClr val="212121"/>
+              </a:solidFill>
+              <a:latin typeface="Courier New"/>
+            </a:endParaRPr>
+          </a:p>
+          <a:p>
+            <a:pPr>
+              <a:spcAft>
+                <a:spcPts val="0"/>
+              </a:spcAft>
+            </a:pPr>
             <a:r>
               <a:rPr sz="1800">
                 <a:solidFill>
@@ -8190,7 +8668,7 @@
                 </a:solidFill>
                 <a:latin typeface="Courier New"/>
               </a:rPr>
-              <a:t>[y = -59, x = 101]            ← a model, in milliseconds</a:t>
+              <a:t>Query 2: x*x == 2*y*y, x &gt; 0, y &gt; 0 (no overflow)</a:t>
             </a:r>
           </a:p>
           <a:p>
@@ -8206,38 +8684,6 @@
                 </a:solidFill>
                 <a:latin typeface="Courier New"/>
               </a:rPr>
-              <a:t/>
-            </a:r>
-          </a:p>
-          <a:p>
-            <a:pPr>
-              <a:spcAft>
-                <a:spcPts val="0"/>
-              </a:spcAft>
-            </a:pPr>
-            <a:r>
-              <a:rPr sz="1800">
-                <a:solidFill>
-                  <a:srgbClr val="212121"/>
-                </a:solidFill>
-                <a:latin typeface="Courier New"/>
-              </a:rPr>
-              <a:t>Query 2: x*x == 2*y*y, x &gt; 0, y &gt; 0 (no overflow)</a:t>
-            </a:r>
-          </a:p>
-          <a:p>
-            <a:pPr>
-              <a:spcAft>
-                <a:spcPts val="0"/>
-              </a:spcAft>
-            </a:pPr>
-            <a:r>
-              <a:rPr sz="1800">
-                <a:solidFill>
-                  <a:srgbClr val="212121"/>
-                </a:solidFill>
-                <a:latin typeface="Courier New"/>
-              </a:rPr>
               <a:t>unsat                          ← a proof</a:t>
             </a:r>
           </a:p>
@@ -8247,14 +8693,12 @@
                 <a:spcPts val="800"/>
               </a:spcAft>
             </a:pPr>
-            <a:r>
-              <a:rPr sz="2200">
-                <a:solidFill>
-                  <a:srgbClr val="212121"/>
-                </a:solidFill>
-              </a:rPr>
-              <a:t/>
-            </a:r>
+            <a:endParaRPr sz="1800">
+              <a:solidFill>
+                <a:srgbClr val="212121"/>
+              </a:solidFill>
+              <a:latin typeface="Courier New"/>
+            </a:endParaRPr>
           </a:p>
           <a:p>
             <a:pPr>
@@ -8282,7 +8726,7 @@
 </file>
 
 <file path=ppt/slides/slide31.xml><?xml version="1.0" encoding="utf-8"?>
-<p:sld xmlns:a="http://schemas.openxmlformats.org/drawingml/2006/main" xmlns:p="http://schemas.openxmlformats.org/presentationml/2006/main" xmlns:r="http://schemas.openxmlformats.org/officeDocument/2006/relationships">
+<p:sld xmlns:a="http://schemas.openxmlformats.org/drawingml/2006/main" xmlns:r="http://schemas.openxmlformats.org/officeDocument/2006/relationships" xmlns:p="http://schemas.openxmlformats.org/presentationml/2006/main">
   <p:cSld>
     <p:spTree>
       <p:nvGrpSpPr>
@@ -8290,7 +8734,14 @@
         <p:cNvGrpSpPr/>
         <p:nvPr/>
       </p:nvGrpSpPr>
-      <p:grpSpPr/>
+      <p:grpSpPr>
+        <a:xfrm>
+          <a:off x="0" y="0"/>
+          <a:ext cx="0" cy="0"/>
+          <a:chOff x="0" y="0"/>
+          <a:chExt cx="0" cy="0"/>
+        </a:xfrm>
+      </p:grpSpPr>
       <p:sp>
         <p:nvSpPr>
           <p:cNvPr id="2" name="TextBox 1"/>
@@ -8399,14 +8850,12 @@
                 <a:spcPts val="800"/>
               </a:spcAft>
             </a:pPr>
-            <a:r>
-              <a:rPr sz="2200">
-                <a:solidFill>
-                  <a:srgbClr val="212121"/>
-                </a:solidFill>
-              </a:rPr>
-              <a:t/>
-            </a:r>
+            <a:endParaRPr sz="1800">
+              <a:solidFill>
+                <a:srgbClr val="212121"/>
+              </a:solidFill>
+              <a:latin typeface="Courier New"/>
+            </a:endParaRPr>
           </a:p>
           <a:p>
             <a:pPr>
@@ -8462,14 +8911,12 @@
                 <a:spcPts val="800"/>
               </a:spcAft>
             </a:pPr>
-            <a:r>
-              <a:rPr sz="2200">
-                <a:solidFill>
-                  <a:srgbClr val="212121"/>
-                </a:solidFill>
-              </a:rPr>
-              <a:t/>
-            </a:r>
+            <a:endParaRPr sz="1800">
+              <a:solidFill>
+                <a:srgbClr val="212121"/>
+              </a:solidFill>
+              <a:latin typeface="Courier New"/>
+            </a:endParaRPr>
           </a:p>
           <a:p>
             <a:pPr>
@@ -8497,7 +8944,7 @@
 </file>
 
 <file path=ppt/slides/slide32.xml><?xml version="1.0" encoding="utf-8"?>
-<p:sld xmlns:a="http://schemas.openxmlformats.org/drawingml/2006/main" xmlns:p="http://schemas.openxmlformats.org/presentationml/2006/main" xmlns:r="http://schemas.openxmlformats.org/officeDocument/2006/relationships">
+<p:sld xmlns:a="http://schemas.openxmlformats.org/drawingml/2006/main" xmlns:r="http://schemas.openxmlformats.org/officeDocument/2006/relationships" xmlns:p="http://schemas.openxmlformats.org/presentationml/2006/main">
   <p:cSld>
     <p:spTree>
       <p:nvGrpSpPr>
@@ -8505,7 +8952,14 @@
         <p:cNvGrpSpPr/>
         <p:nvPr/>
       </p:nvGrpSpPr>
-      <p:grpSpPr/>
+      <p:grpSpPr>
+        <a:xfrm>
+          <a:off x="0" y="0"/>
+          <a:ext cx="0" cy="0"/>
+          <a:chOff x="0" y="0"/>
+          <a:chExt cx="0" cy="0"/>
+        </a:xfrm>
+      </p:grpSpPr>
       <p:sp>
         <p:nvSpPr>
           <p:cNvPr id="2" name="TextBox 1"/>
@@ -8630,14 +9084,12 @@
                 <a:spcPts val="800"/>
               </a:spcAft>
             </a:pPr>
-            <a:r>
-              <a:rPr sz="2200">
-                <a:solidFill>
-                  <a:srgbClr val="212121"/>
-                </a:solidFill>
-              </a:rPr>
-              <a:t/>
-            </a:r>
+            <a:endParaRPr sz="1800">
+              <a:solidFill>
+                <a:srgbClr val="212121"/>
+              </a:solidFill>
+              <a:latin typeface="Courier New"/>
+            </a:endParaRPr>
           </a:p>
           <a:p>
             <a:pPr>
@@ -8695,7 +9147,7 @@
 </file>
 
 <file path=ppt/slides/slide33.xml><?xml version="1.0" encoding="utf-8"?>
-<p:sld xmlns:a="http://schemas.openxmlformats.org/drawingml/2006/main" xmlns:p="http://schemas.openxmlformats.org/presentationml/2006/main" xmlns:r="http://schemas.openxmlformats.org/officeDocument/2006/relationships">
+<p:sld xmlns:a="http://schemas.openxmlformats.org/drawingml/2006/main" xmlns:r="http://schemas.openxmlformats.org/officeDocument/2006/relationships" xmlns:p="http://schemas.openxmlformats.org/presentationml/2006/main">
   <p:cSld>
     <p:spTree>
       <p:nvGrpSpPr>
@@ -8703,7 +9155,14 @@
         <p:cNvGrpSpPr/>
         <p:nvPr/>
       </p:nvGrpSpPr>
-      <p:grpSpPr/>
+      <p:grpSpPr>
+        <a:xfrm>
+          <a:off x="0" y="0"/>
+          <a:ext cx="0" cy="0"/>
+          <a:chOff x="0" y="0"/>
+          <a:chExt cx="0" cy="0"/>
+        </a:xfrm>
+      </p:grpSpPr>
       <p:sp>
         <p:nvSpPr>
           <p:cNvPr id="2" name="TextBox 1"/>
@@ -8827,14 +9286,12 @@
                 <a:spcPts val="800"/>
               </a:spcAft>
             </a:pPr>
-            <a:r>
-              <a:rPr sz="2200">
-                <a:solidFill>
-                  <a:srgbClr val="212121"/>
-                </a:solidFill>
-              </a:rPr>
-              <a:t/>
-            </a:r>
+            <a:endParaRPr sz="1800">
+              <a:solidFill>
+                <a:srgbClr val="212121"/>
+              </a:solidFill>
+              <a:latin typeface="Courier New"/>
+            </a:endParaRPr>
           </a:p>
           <a:p>
             <a:pPr>
@@ -8892,7 +9349,7 @@
 </file>
 
 <file path=ppt/slides/slide34.xml><?xml version="1.0" encoding="utf-8"?>
-<p:sld xmlns:a="http://schemas.openxmlformats.org/drawingml/2006/main" xmlns:p="http://schemas.openxmlformats.org/presentationml/2006/main" xmlns:r="http://schemas.openxmlformats.org/officeDocument/2006/relationships">
+<p:sld xmlns:a="http://schemas.openxmlformats.org/drawingml/2006/main" xmlns:r="http://schemas.openxmlformats.org/officeDocument/2006/relationships" xmlns:p="http://schemas.openxmlformats.org/presentationml/2006/main">
   <p:cSld>
     <p:spTree>
       <p:nvGrpSpPr>
@@ -8900,7 +9357,14 @@
         <p:cNvGrpSpPr/>
         <p:nvPr/>
       </p:nvGrpSpPr>
-      <p:grpSpPr/>
+      <p:grpSpPr>
+        <a:xfrm>
+          <a:off x="0" y="0"/>
+          <a:ext cx="0" cy="0"/>
+          <a:chOff x="0" y="0"/>
+          <a:chExt cx="0" cy="0"/>
+        </a:xfrm>
+      </p:grpSpPr>
       <p:sp>
         <p:nvSpPr>
           <p:cNvPr id="2" name="TextBox 1"/>
@@ -9038,14 +9502,12 @@
                 <a:spcPts val="800"/>
               </a:spcAft>
             </a:pPr>
-            <a:r>
-              <a:rPr sz="2200">
-                <a:solidFill>
-                  <a:srgbClr val="212121"/>
-                </a:solidFill>
-              </a:rPr>
-              <a:t/>
-            </a:r>
+            <a:endParaRPr sz="1800">
+              <a:solidFill>
+                <a:srgbClr val="212121"/>
+              </a:solidFill>
+              <a:latin typeface="Courier New"/>
+            </a:endParaRPr>
           </a:p>
           <a:p>
             <a:pPr>
@@ -9088,7 +9550,7 @@
 </file>
 
 <file path=ppt/slides/slide35.xml><?xml version="1.0" encoding="utf-8"?>
-<p:sld xmlns:a="http://schemas.openxmlformats.org/drawingml/2006/main" xmlns:p="http://schemas.openxmlformats.org/presentationml/2006/main" xmlns:r="http://schemas.openxmlformats.org/officeDocument/2006/relationships">
+<p:sld xmlns:a="http://schemas.openxmlformats.org/drawingml/2006/main" xmlns:r="http://schemas.openxmlformats.org/officeDocument/2006/relationships" xmlns:p="http://schemas.openxmlformats.org/presentationml/2006/main">
   <p:cSld>
     <p:spTree>
       <p:nvGrpSpPr>
@@ -9096,7 +9558,14 @@
         <p:cNvGrpSpPr/>
         <p:nvPr/>
       </p:nvGrpSpPr>
-      <p:grpSpPr/>
+      <p:grpSpPr>
+        <a:xfrm>
+          <a:off x="0" y="0"/>
+          <a:ext cx="0" cy="0"/>
+          <a:chOff x="0" y="0"/>
+          <a:chExt cx="0" cy="0"/>
+        </a:xfrm>
+      </p:grpSpPr>
       <p:sp>
         <p:nvSpPr>
           <p:cNvPr id="2" name="TextBox 1"/>
@@ -9168,7 +9637,7 @@
           </a:fontRef>
         </p:style>
         <p:txBody>
-          <a:bodyPr rtlCol="0" anchor="ctr" wrap="square"/>
+          <a:bodyPr wrap="square" rtlCol="0" anchor="ctr"/>
           <a:lstStyle/>
           <a:p>
             <a:pPr algn="ctr"/>
@@ -9221,7 +9690,7 @@
           </a:fontRef>
         </p:style>
         <p:txBody>
-          <a:bodyPr rtlCol="0" anchor="ctr" wrap="square"/>
+          <a:bodyPr wrap="square" rtlCol="0" anchor="ctr"/>
           <a:lstStyle/>
           <a:p>
             <a:pPr algn="ctr"/>
@@ -9276,6 +9745,7 @@
           <a:lstStyle/>
           <a:p>
             <a:pPr algn="ctr"/>
+            <a:endParaRPr/>
           </a:p>
         </p:txBody>
       </p:sp>
@@ -9317,7 +9787,7 @@
           </a:fontRef>
         </p:style>
         <p:txBody>
-          <a:bodyPr rtlCol="0" anchor="ctr" wrap="square"/>
+          <a:bodyPr wrap="square" rtlCol="0" anchor="ctr"/>
           <a:lstStyle/>
           <a:p>
             <a:pPr algn="ctr"/>
@@ -9373,6 +9843,7 @@
           <a:lstStyle/>
           <a:p>
             <a:pPr algn="ctr"/>
+            <a:endParaRPr/>
           </a:p>
         </p:txBody>
       </p:sp>
@@ -9414,7 +9885,7 @@
           </a:fontRef>
         </p:style>
         <p:txBody>
-          <a:bodyPr rtlCol="0" anchor="ctr" wrap="square"/>
+          <a:bodyPr wrap="square" rtlCol="0" anchor="ctr"/>
           <a:lstStyle/>
           <a:p>
             <a:pPr algn="ctr"/>
@@ -9469,6 +9940,7 @@
           <a:lstStyle/>
           <a:p>
             <a:pPr algn="ctr"/>
+            <a:endParaRPr/>
           </a:p>
         </p:txBody>
       </p:sp>
@@ -9510,7 +9982,7 @@
           </a:fontRef>
         </p:style>
         <p:txBody>
-          <a:bodyPr rtlCol="0" anchor="ctr" wrap="square"/>
+          <a:bodyPr wrap="square" rtlCol="0" anchor="ctr"/>
           <a:lstStyle/>
           <a:p>
             <a:pPr algn="ctr"/>
@@ -9565,6 +10037,7 @@
           <a:lstStyle/>
           <a:p>
             <a:pPr algn="ctr"/>
+            <a:endParaRPr/>
           </a:p>
         </p:txBody>
       </p:sp>
@@ -9625,14 +10098,11 @@
                 <a:spcPts val="800"/>
               </a:spcAft>
             </a:pPr>
-            <a:r>
-              <a:rPr sz="2400">
-                <a:solidFill>
-                  <a:srgbClr val="212121"/>
-                </a:solidFill>
-              </a:rPr>
-              <a:t/>
-            </a:r>
+            <a:endParaRPr sz="2400">
+              <a:solidFill>
+                <a:srgbClr val="212121"/>
+              </a:solidFill>
+            </a:endParaRPr>
           </a:p>
           <a:p>
             <a:pPr>
@@ -9660,7 +10130,7 @@
 </file>
 
 <file path=ppt/slides/slide36.xml><?xml version="1.0" encoding="utf-8"?>
-<p:sld xmlns:a="http://schemas.openxmlformats.org/drawingml/2006/main" xmlns:p="http://schemas.openxmlformats.org/presentationml/2006/main" xmlns:r="http://schemas.openxmlformats.org/officeDocument/2006/relationships">
+<p:sld xmlns:a="http://schemas.openxmlformats.org/drawingml/2006/main" xmlns:r="http://schemas.openxmlformats.org/officeDocument/2006/relationships" xmlns:p="http://schemas.openxmlformats.org/presentationml/2006/main">
   <p:cSld>
     <p:spTree>
       <p:nvGrpSpPr>
@@ -9668,7 +10138,14 @@
         <p:cNvGrpSpPr/>
         <p:nvPr/>
       </p:nvGrpSpPr>
-      <p:grpSpPr/>
+      <p:grpSpPr>
+        <a:xfrm>
+          <a:off x="0" y="0"/>
+          <a:ext cx="0" cy="0"/>
+          <a:chOff x="0" y="0"/>
+          <a:chExt cx="0" cy="0"/>
+        </a:xfrm>
+      </p:grpSpPr>
       <p:sp>
         <p:nvSpPr>
           <p:cNvPr id="2" name="TextBox 1"/>
@@ -9745,13 +10222,26 @@
                 <a:spcPts val="800"/>
               </a:spcAft>
             </a:pPr>
+            <a:endParaRPr sz="2000">
+              <a:solidFill>
+                <a:srgbClr val="212121"/>
+              </a:solidFill>
+              <a:latin typeface="Courier New"/>
+            </a:endParaRPr>
+          </a:p>
+          <a:p>
+            <a:pPr>
+              <a:spcAft>
+                <a:spcPts val="800"/>
+              </a:spcAft>
+            </a:pPr>
             <a:r>
               <a:rPr sz="2400">
                 <a:solidFill>
                   <a:srgbClr val="212121"/>
                 </a:solidFill>
               </a:rPr>
-              <a:t/>
+              <a:t>--unwind k copies the loop body k times, each copy guarded by the loop condition.</a:t>
             </a:r>
           </a:p>
           <a:p>
@@ -9766,21 +10256,6 @@
                   <a:srgbClr val="212121"/>
                 </a:solidFill>
               </a:rPr>
-              <a:t>--unwind k copies the loop body k times, each copy guarded by the loop condition.</a:t>
-            </a:r>
-          </a:p>
-          <a:p>
-            <a:pPr>
-              <a:spcAft>
-                <a:spcPts val="800"/>
-              </a:spcAft>
-            </a:pPr>
-            <a:r>
-              <a:rPr sz="2400">
-                <a:solidFill>
-                  <a:srgbClr val="212121"/>
-                </a:solidFill>
-              </a:rPr>
               <a:t>Then one extra check, the unwinding assertion:</a:t>
             </a:r>
           </a:p>
@@ -9805,14 +10280,11 @@
                 <a:spcPts val="800"/>
               </a:spcAft>
             </a:pPr>
-            <a:r>
-              <a:rPr sz="2400">
-                <a:solidFill>
-                  <a:srgbClr val="212121"/>
-                </a:solidFill>
-              </a:rPr>
-              <a:t/>
-            </a:r>
+            <a:endParaRPr sz="2200">
+              <a:solidFill>
+                <a:srgbClr val="212121"/>
+              </a:solidFill>
+            </a:endParaRPr>
           </a:p>
           <a:p>
             <a:pPr>
@@ -9840,7 +10312,7 @@
 </file>
 
 <file path=ppt/slides/slide37.xml><?xml version="1.0" encoding="utf-8"?>
-<p:sld xmlns:a="http://schemas.openxmlformats.org/drawingml/2006/main" xmlns:p="http://schemas.openxmlformats.org/presentationml/2006/main" xmlns:r="http://schemas.openxmlformats.org/officeDocument/2006/relationships">
+<p:sld xmlns:a="http://schemas.openxmlformats.org/drawingml/2006/main" xmlns:r="http://schemas.openxmlformats.org/officeDocument/2006/relationships" xmlns:p="http://schemas.openxmlformats.org/presentationml/2006/main">
   <p:cSld>
     <p:spTree>
       <p:nvGrpSpPr>
@@ -9848,7 +10320,14 @@
         <p:cNvGrpSpPr/>
         <p:nvPr/>
       </p:nvGrpSpPr>
-      <p:grpSpPr/>
+      <p:grpSpPr>
+        <a:xfrm>
+          <a:off x="0" y="0"/>
+          <a:ext cx="0" cy="0"/>
+          <a:chOff x="0" y="0"/>
+          <a:chExt cx="0" cy="0"/>
+        </a:xfrm>
+      </p:grpSpPr>
       <p:sp>
         <p:nvSpPr>
           <p:cNvPr id="2" name="TextBox 1"/>
@@ -9892,7 +10371,7 @@
         </p:nvGraphicFramePr>
         <p:xfrm>
           <a:off x="731520" y="1554480"/>
-          <a:ext cx="10698480" cy="1463040"/>
+          <a:ext cx="10698480" cy="1889760"/>
         </p:xfrm>
         <a:graphic>
           <a:graphicData uri="http://schemas.openxmlformats.org/drawingml/2006/table">
@@ -9901,8 +10380,20 @@
                 <a:tableStyleId>{5C22544A-7EE6-4342-B048-85BDC9FD1C3A}</a:tableStyleId>
               </a:tblPr>
               <a:tblGrid>
-                <a:gridCol w="4572000"/>
-                <a:gridCol w="6126480"/>
+                <a:gridCol w="4572000">
+                  <a:extLst>
+                    <a:ext uri="{9D8B030D-6E8A-4147-A177-3AD203B41FA5}">
+                      <a16:colId xmlns:a16="http://schemas.microsoft.com/office/drawing/2014/main" val="20000"/>
+                    </a:ext>
+                  </a:extLst>
+                </a:gridCol>
+                <a:gridCol w="6126480">
+                  <a:extLst>
+                    <a:ext uri="{9D8B030D-6E8A-4147-A177-3AD203B41FA5}">
+                      <a16:colId xmlns:a16="http://schemas.microsoft.com/office/drawing/2014/main" val="20001"/>
+                    </a:ext>
+                  </a:extLst>
+                </a:gridCol>
               </a:tblGrid>
               <a:tr h="365760">
                 <a:tc>
@@ -9931,6 +10422,11 @@
                   </a:txBody>
                   <a:tcPr/>
                 </a:tc>
+                <a:extLst>
+                  <a:ext uri="{0D108BD9-81ED-4DB2-BD59-A6C34878D82A}">
+                    <a16:rowId xmlns:a16="http://schemas.microsoft.com/office/drawing/2014/main" val="10000"/>
+                  </a:ext>
+                </a:extLst>
               </a:tr>
               <a:tr h="365760">
                 <a:tc>
@@ -9959,6 +10455,11 @@
                   </a:txBody>
                   <a:tcPr/>
                 </a:tc>
+                <a:extLst>
+                  <a:ext uri="{0D108BD9-81ED-4DB2-BD59-A6C34878D82A}">
+                    <a16:rowId xmlns:a16="http://schemas.microsoft.com/office/drawing/2014/main" val="10001"/>
+                  </a:ext>
+                </a:extLst>
               </a:tr>
               <a:tr h="365760">
                 <a:tc>
@@ -9987,6 +10488,11 @@
                   </a:txBody>
                   <a:tcPr/>
                 </a:tc>
+                <a:extLst>
+                  <a:ext uri="{0D108BD9-81ED-4DB2-BD59-A6C34878D82A}">
+                    <a16:rowId xmlns:a16="http://schemas.microsoft.com/office/drawing/2014/main" val="10002"/>
+                  </a:ext>
+                </a:extLst>
               </a:tr>
               <a:tr h="365760">
                 <a:tc>
@@ -10015,6 +10521,11 @@
                   </a:txBody>
                   <a:tcPr/>
                 </a:tc>
+                <a:extLst>
+                  <a:ext uri="{0D108BD9-81ED-4DB2-BD59-A6C34878D82A}">
+                    <a16:rowId xmlns:a16="http://schemas.microsoft.com/office/drawing/2014/main" val="10003"/>
+                  </a:ext>
+                </a:extLst>
               </a:tr>
             </a:tbl>
           </a:graphicData>
@@ -10082,7 +10593,7 @@
 </file>
 
 <file path=ppt/slides/slide38.xml><?xml version="1.0" encoding="utf-8"?>
-<p:sld xmlns:a="http://schemas.openxmlformats.org/drawingml/2006/main" xmlns:p="http://schemas.openxmlformats.org/presentationml/2006/main" xmlns:r="http://schemas.openxmlformats.org/officeDocument/2006/relationships">
+<p:sld xmlns:a="http://schemas.openxmlformats.org/drawingml/2006/main" xmlns:r="http://schemas.openxmlformats.org/officeDocument/2006/relationships" xmlns:p="http://schemas.openxmlformats.org/presentationml/2006/main">
   <p:cSld>
     <p:spTree>
       <p:nvGrpSpPr>
@@ -10090,7 +10601,14 @@
         <p:cNvGrpSpPr/>
         <p:nvPr/>
       </p:nvGrpSpPr>
-      <p:grpSpPr/>
+      <p:grpSpPr>
+        <a:xfrm>
+          <a:off x="0" y="0"/>
+          <a:ext cx="0" cy="0"/>
+          <a:chOff x="0" y="0"/>
+          <a:chExt cx="0" cy="0"/>
+        </a:xfrm>
+      </p:grpSpPr>
       <p:sp>
         <p:nvSpPr>
           <p:cNvPr id="2" name="TextBox 1"/>
@@ -10199,14 +10717,12 @@
                 <a:spcPts val="800"/>
               </a:spcAft>
             </a:pPr>
-            <a:r>
-              <a:rPr sz="2400">
-                <a:solidFill>
-                  <a:srgbClr val="212121"/>
-                </a:solidFill>
-              </a:rPr>
-              <a:t/>
-            </a:r>
+            <a:endParaRPr sz="2000">
+              <a:solidFill>
+                <a:srgbClr val="212121"/>
+              </a:solidFill>
+              <a:latin typeface="Courier New"/>
+            </a:endParaRPr>
           </a:p>
           <a:p>
             <a:pPr>
@@ -10249,7 +10765,7 @@
 </file>
 
 <file path=ppt/slides/slide39.xml><?xml version="1.0" encoding="utf-8"?>
-<p:sld xmlns:a="http://schemas.openxmlformats.org/drawingml/2006/main" xmlns:p="http://schemas.openxmlformats.org/presentationml/2006/main" xmlns:r="http://schemas.openxmlformats.org/officeDocument/2006/relationships">
+<p:sld xmlns:a="http://schemas.openxmlformats.org/drawingml/2006/main" xmlns:r="http://schemas.openxmlformats.org/officeDocument/2006/relationships" xmlns:p="http://schemas.openxmlformats.org/presentationml/2006/main">
   <p:cSld>
     <p:spTree>
       <p:nvGrpSpPr>
@@ -10257,7 +10773,14 @@
         <p:cNvGrpSpPr/>
         <p:nvPr/>
       </p:nvGrpSpPr>
-      <p:grpSpPr/>
+      <p:grpSpPr>
+        <a:xfrm>
+          <a:off x="0" y="0"/>
+          <a:ext cx="0" cy="0"/>
+          <a:chOff x="0" y="0"/>
+          <a:chExt cx="0" cy="0"/>
+        </a:xfrm>
+      </p:grpSpPr>
       <p:sp>
         <p:nvSpPr>
           <p:cNvPr id="2" name="TextBox 1"/>
@@ -10334,13 +10857,26 @@
                 <a:spcPts val="800"/>
               </a:spcAft>
             </a:pPr>
+            <a:endParaRPr sz="2200">
+              <a:solidFill>
+                <a:srgbClr val="212121"/>
+              </a:solidFill>
+              <a:latin typeface="Courier New"/>
+            </a:endParaRPr>
+          </a:p>
+          <a:p>
+            <a:pPr>
+              <a:spcAft>
+                <a:spcPts val="800"/>
+              </a:spcAft>
+            </a:pPr>
             <a:r>
               <a:rPr sz="2600">
                 <a:solidFill>
                   <a:srgbClr val="212121"/>
                 </a:solidFill>
               </a:rPr>
-              <a:t/>
+              <a:t>sat — the model assigns every input and every choice: replayed in program order, that is the counterexample trace.</a:t>
             </a:r>
           </a:p>
           <a:p>
@@ -10355,21 +10891,6 @@
                   <a:srgbClr val="212121"/>
                 </a:solidFill>
               </a:rPr>
-              <a:t>sat — the model assigns every input and every choice: replayed in program order, that is the counterexample trace.</a:t>
-            </a:r>
-          </a:p>
-          <a:p>
-            <a:pPr>
-              <a:spcAft>
-                <a:spcPts val="800"/>
-              </a:spcAft>
-            </a:pPr>
-            <a:r>
-              <a:rPr sz="2600">
-                <a:solidFill>
-                  <a:srgbClr val="212121"/>
-                </a:solidFill>
-              </a:rPr>
               <a:t>unsat — no execution within the bound violates P.</a:t>
             </a:r>
           </a:p>
@@ -10379,14 +10900,11 @@
                 <a:spcPts val="800"/>
               </a:spcAft>
             </a:pPr>
-            <a:r>
-              <a:rPr sz="2600">
-                <a:solidFill>
-                  <a:srgbClr val="212121"/>
-                </a:solidFill>
-              </a:rPr>
-              <a:t/>
-            </a:r>
+            <a:endParaRPr sz="2600">
+              <a:solidFill>
+                <a:srgbClr val="212121"/>
+              </a:solidFill>
+            </a:endParaRPr>
           </a:p>
           <a:p>
             <a:pPr>
@@ -10414,7 +10932,7 @@
 </file>
 
 <file path=ppt/slides/slide4.xml><?xml version="1.0" encoding="utf-8"?>
-<p:sld xmlns:a="http://schemas.openxmlformats.org/drawingml/2006/main" xmlns:p="http://schemas.openxmlformats.org/presentationml/2006/main" xmlns:r="http://schemas.openxmlformats.org/officeDocument/2006/relationships">
+<p:sld xmlns:a="http://schemas.openxmlformats.org/drawingml/2006/main" xmlns:r="http://schemas.openxmlformats.org/officeDocument/2006/relationships" xmlns:p="http://schemas.openxmlformats.org/presentationml/2006/main">
   <p:cSld>
     <p:spTree>
       <p:nvGrpSpPr>
@@ -10422,7 +10940,14 @@
         <p:cNvGrpSpPr/>
         <p:nvPr/>
       </p:nvGrpSpPr>
-      <p:grpSpPr/>
+      <p:grpSpPr>
+        <a:xfrm>
+          <a:off x="0" y="0"/>
+          <a:ext cx="0" cy="0"/>
+          <a:chOff x="0" y="0"/>
+          <a:chExt cx="0" cy="0"/>
+        </a:xfrm>
+      </p:grpSpPr>
       <p:sp>
         <p:nvSpPr>
           <p:cNvPr id="2" name="TextBox 1"/>
@@ -10573,14 +11098,11 @@
                 <a:spcPts val="800"/>
               </a:spcAft>
             </a:pPr>
-            <a:r>
-              <a:rPr sz="2200">
-                <a:solidFill>
-                  <a:srgbClr val="212121"/>
-                </a:solidFill>
-              </a:rPr>
-              <a:t/>
-            </a:r>
+            <a:endParaRPr sz="2000">
+              <a:solidFill>
+                <a:srgbClr val="212121"/>
+              </a:solidFill>
+            </a:endParaRPr>
           </a:p>
           <a:p>
             <a:pPr>
@@ -10608,7 +11130,7 @@
 </file>
 
 <file path=ppt/slides/slide40.xml><?xml version="1.0" encoding="utf-8"?>
-<p:sld xmlns:a="http://schemas.openxmlformats.org/drawingml/2006/main" xmlns:p="http://schemas.openxmlformats.org/presentationml/2006/main" xmlns:r="http://schemas.openxmlformats.org/officeDocument/2006/relationships">
+<p:sld xmlns:a="http://schemas.openxmlformats.org/drawingml/2006/main" xmlns:r="http://schemas.openxmlformats.org/officeDocument/2006/relationships" xmlns:p="http://schemas.openxmlformats.org/presentationml/2006/main">
   <p:cSld>
     <p:spTree>
       <p:nvGrpSpPr>
@@ -10616,7 +11138,14 @@
         <p:cNvGrpSpPr/>
         <p:nvPr/>
       </p:nvGrpSpPr>
-      <p:grpSpPr/>
+      <p:grpSpPr>
+        <a:xfrm>
+          <a:off x="0" y="0"/>
+          <a:ext cx="0" cy="0"/>
+          <a:chOff x="0" y="0"/>
+          <a:chExt cx="0" cy="0"/>
+        </a:xfrm>
+      </p:grpSpPr>
       <p:sp>
         <p:nvSpPr>
           <p:cNvPr id="2" name="TextBox 1"/>
@@ -10773,14 +11302,12 @@
                 <a:spcPts val="800"/>
               </a:spcAft>
             </a:pPr>
-            <a:r>
-              <a:rPr sz="2200">
-                <a:solidFill>
-                  <a:srgbClr val="212121"/>
-                </a:solidFill>
-              </a:rPr>
-              <a:t/>
-            </a:r>
+            <a:endParaRPr sz="1800">
+              <a:solidFill>
+                <a:srgbClr val="212121"/>
+              </a:solidFill>
+              <a:latin typeface="Courier New"/>
+            </a:endParaRPr>
           </a:p>
           <a:p>
             <a:pPr>
@@ -10823,7 +11350,7 @@
 </file>
 
 <file path=ppt/slides/slide41.xml><?xml version="1.0" encoding="utf-8"?>
-<p:sld xmlns:a="http://schemas.openxmlformats.org/drawingml/2006/main" xmlns:p="http://schemas.openxmlformats.org/presentationml/2006/main" xmlns:r="http://schemas.openxmlformats.org/officeDocument/2006/relationships">
+<p:sld xmlns:a="http://schemas.openxmlformats.org/drawingml/2006/main" xmlns:r="http://schemas.openxmlformats.org/officeDocument/2006/relationships" xmlns:p="http://schemas.openxmlformats.org/presentationml/2006/main">
   <p:cSld>
     <p:spTree>
       <p:nvGrpSpPr>
@@ -10831,7 +11358,14 @@
         <p:cNvGrpSpPr/>
         <p:nvPr/>
       </p:nvGrpSpPr>
-      <p:grpSpPr/>
+      <p:grpSpPr>
+        <a:xfrm>
+          <a:off x="0" y="0"/>
+          <a:ext cx="0" cy="0"/>
+          <a:chOff x="0" y="0"/>
+          <a:chExt cx="0" cy="0"/>
+        </a:xfrm>
+      </p:grpSpPr>
       <p:sp>
         <p:nvSpPr>
           <p:cNvPr id="2" name="TextBox 1"/>
@@ -10988,6 +11522,19 @@
                 <a:spcPts val="0"/>
               </a:spcAft>
             </a:pPr>
+            <a:endParaRPr sz="1800">
+              <a:solidFill>
+                <a:srgbClr val="212121"/>
+              </a:solidFill>
+              <a:latin typeface="Courier New"/>
+            </a:endParaRPr>
+          </a:p>
+          <a:p>
+            <a:pPr>
+              <a:spcAft>
+                <a:spcPts val="0"/>
+              </a:spcAft>
+            </a:pPr>
             <a:r>
               <a:rPr sz="1800">
                 <a:solidFill>
@@ -10995,22 +11542,6 @@
                 </a:solidFill>
                 <a:latin typeface="Courier New"/>
               </a:rPr>
-              <a:t/>
-            </a:r>
-          </a:p>
-          <a:p>
-            <a:pPr>
-              <a:spcAft>
-                <a:spcPts val="0"/>
-              </a:spcAft>
-            </a:pPr>
-            <a:r>
-              <a:rPr sz="1800">
-                <a:solidFill>
-                  <a:srgbClr val="212121"/>
-                </a:solidFill>
-                <a:latin typeface="Courier New"/>
-              </a:rPr>
               <a:t>$ esbmc offbyone.c --unwind 7</a:t>
             </a:r>
           </a:p>
@@ -11020,14 +11551,12 @@
                 <a:spcPts val="800"/>
               </a:spcAft>
             </a:pPr>
-            <a:r>
-              <a:rPr sz="2200">
-                <a:solidFill>
-                  <a:srgbClr val="212121"/>
-                </a:solidFill>
-              </a:rPr>
-              <a:t/>
-            </a:r>
+            <a:endParaRPr sz="1800">
+              <a:solidFill>
+                <a:srgbClr val="212121"/>
+              </a:solidFill>
+              <a:latin typeface="Courier New"/>
+            </a:endParaRPr>
           </a:p>
           <a:p>
             <a:pPr>
@@ -11070,7 +11599,7 @@
 </file>
 
 <file path=ppt/slides/slide42.xml><?xml version="1.0" encoding="utf-8"?>
-<p:sld xmlns:a="http://schemas.openxmlformats.org/drawingml/2006/main" xmlns:p="http://schemas.openxmlformats.org/presentationml/2006/main" xmlns:r="http://schemas.openxmlformats.org/officeDocument/2006/relationships">
+<p:sld xmlns:a="http://schemas.openxmlformats.org/drawingml/2006/main" xmlns:r="http://schemas.openxmlformats.org/officeDocument/2006/relationships" xmlns:p="http://schemas.openxmlformats.org/presentationml/2006/main">
   <p:cSld>
     <p:spTree>
       <p:nvGrpSpPr>
@@ -11078,7 +11607,14 @@
         <p:cNvGrpSpPr/>
         <p:nvPr/>
       </p:nvGrpSpPr>
-      <p:grpSpPr/>
+      <p:grpSpPr>
+        <a:xfrm>
+          <a:off x="0" y="0"/>
+          <a:ext cx="0" cy="0"/>
+          <a:chOff x="0" y="0"/>
+          <a:chExt cx="0" cy="0"/>
+        </a:xfrm>
+      </p:grpSpPr>
       <p:sp>
         <p:nvSpPr>
           <p:cNvPr id="2" name="TextBox 1"/>
@@ -11187,14 +11723,12 @@
                 <a:spcPts val="800"/>
               </a:spcAft>
             </a:pPr>
-            <a:r>
-              <a:rPr sz="2200">
-                <a:solidFill>
-                  <a:srgbClr val="212121"/>
-                </a:solidFill>
-              </a:rPr>
-              <a:t/>
-            </a:r>
+            <a:endParaRPr sz="1800">
+              <a:solidFill>
+                <a:srgbClr val="212121"/>
+              </a:solidFill>
+              <a:latin typeface="Courier New"/>
+            </a:endParaRPr>
           </a:p>
           <a:p>
             <a:pPr>
@@ -11237,7 +11771,7 @@
 </file>
 
 <file path=ppt/slides/slide43.xml><?xml version="1.0" encoding="utf-8"?>
-<p:sld xmlns:a="http://schemas.openxmlformats.org/drawingml/2006/main" xmlns:p="http://schemas.openxmlformats.org/presentationml/2006/main" xmlns:r="http://schemas.openxmlformats.org/officeDocument/2006/relationships">
+<p:sld xmlns:a="http://schemas.openxmlformats.org/drawingml/2006/main" xmlns:r="http://schemas.openxmlformats.org/officeDocument/2006/relationships" xmlns:p="http://schemas.openxmlformats.org/presentationml/2006/main">
   <p:cSld>
     <p:spTree>
       <p:nvGrpSpPr>
@@ -11245,7 +11779,14 @@
         <p:cNvGrpSpPr/>
         <p:nvPr/>
       </p:nvGrpSpPr>
-      <p:grpSpPr/>
+      <p:grpSpPr>
+        <a:xfrm>
+          <a:off x="0" y="0"/>
+          <a:ext cx="0" cy="0"/>
+          <a:chOff x="0" y="0"/>
+          <a:chExt cx="0" cy="0"/>
+        </a:xfrm>
+      </p:grpSpPr>
       <p:sp>
         <p:nvSpPr>
           <p:cNvPr id="2" name="TextBox 1"/>
@@ -11351,14 +11892,11 @@
                 <a:spcPts val="800"/>
               </a:spcAft>
             </a:pPr>
-            <a:r>
-              <a:rPr sz="2400">
-                <a:solidFill>
-                  <a:srgbClr val="212121"/>
-                </a:solidFill>
-              </a:rPr>
-              <a:t/>
-            </a:r>
+            <a:endParaRPr sz="2400">
+              <a:solidFill>
+                <a:srgbClr val="212121"/>
+              </a:solidFill>
+            </a:endParaRPr>
           </a:p>
           <a:p>
             <a:pPr>
@@ -11386,7 +11924,7 @@
 </file>
 
 <file path=ppt/slides/slide44.xml><?xml version="1.0" encoding="utf-8"?>
-<p:sld xmlns:a="http://schemas.openxmlformats.org/drawingml/2006/main" xmlns:p="http://schemas.openxmlformats.org/presentationml/2006/main" xmlns:r="http://schemas.openxmlformats.org/officeDocument/2006/relationships">
+<p:sld xmlns:a="http://schemas.openxmlformats.org/drawingml/2006/main" xmlns:r="http://schemas.openxmlformats.org/officeDocument/2006/relationships" xmlns:p="http://schemas.openxmlformats.org/presentationml/2006/main">
   <p:cSld>
     <p:spTree>
       <p:nvGrpSpPr>
@@ -11394,7 +11932,14 @@
         <p:cNvGrpSpPr/>
         <p:nvPr/>
       </p:nvGrpSpPr>
-      <p:grpSpPr/>
+      <p:grpSpPr>
+        <a:xfrm>
+          <a:off x="0" y="0"/>
+          <a:ext cx="0" cy="0"/>
+          <a:chOff x="0" y="0"/>
+          <a:chExt cx="0" cy="0"/>
+        </a:xfrm>
+      </p:grpSpPr>
       <p:sp>
         <p:nvSpPr>
           <p:cNvPr id="2" name="TextBox 1"/>
@@ -11487,27 +12032,25 @@
                 <a:spcPts val="800"/>
               </a:spcAft>
             </a:pPr>
+            <a:endParaRPr sz="2200">
+              <a:solidFill>
+                <a:srgbClr val="212121"/>
+              </a:solidFill>
+              <a:latin typeface="Courier New"/>
+            </a:endParaRPr>
+          </a:p>
+          <a:p>
+            <a:pPr>
+              <a:spcAft>
+                <a:spcPts val="800"/>
+              </a:spcAft>
+            </a:pPr>
             <a:r>
               <a:rPr sz="2600">
                 <a:solidFill>
                   <a:srgbClr val="212121"/>
                 </a:solidFill>
               </a:rPr>
-              <a:t/>
-            </a:r>
-          </a:p>
-          <a:p>
-            <a:pPr>
-              <a:spcAft>
-                <a:spcPts val="800"/>
-              </a:spcAft>
-            </a:pPr>
-            <a:r>
-              <a:rPr sz="2600">
-                <a:solidFill>
-                  <a:srgbClr val="212121"/>
-                </a:solidFill>
-              </a:rPr>
               <a:t>FAILED or SUCCESSFUL?</a:t>
             </a:r>
           </a:p>
@@ -11517,14 +12060,11 @@
                 <a:spcPts val="800"/>
               </a:spcAft>
             </a:pPr>
-            <a:r>
-              <a:rPr sz="2600">
-                <a:solidFill>
-                  <a:srgbClr val="212121"/>
-                </a:solidFill>
-              </a:rPr>
-              <a:t/>
-            </a:r>
+            <a:endParaRPr sz="2600">
+              <a:solidFill>
+                <a:srgbClr val="212121"/>
+              </a:solidFill>
+            </a:endParaRPr>
           </a:p>
           <a:p>
             <a:pPr>
@@ -11567,7 +12107,7 @@
 </file>
 
 <file path=ppt/slides/slide45.xml><?xml version="1.0" encoding="utf-8"?>
-<p:sld xmlns:a="http://schemas.openxmlformats.org/drawingml/2006/main" xmlns:p="http://schemas.openxmlformats.org/presentationml/2006/main" xmlns:r="http://schemas.openxmlformats.org/officeDocument/2006/relationships">
+<p:sld xmlns:a="http://schemas.openxmlformats.org/drawingml/2006/main" xmlns:r="http://schemas.openxmlformats.org/officeDocument/2006/relationships" xmlns:p="http://schemas.openxmlformats.org/presentationml/2006/main">
   <p:cSld>
     <p:spTree>
       <p:nvGrpSpPr>
@@ -11575,7 +12115,14 @@
         <p:cNvGrpSpPr/>
         <p:nvPr/>
       </p:nvGrpSpPr>
-      <p:grpSpPr/>
+      <p:grpSpPr>
+        <a:xfrm>
+          <a:off x="0" y="0"/>
+          <a:ext cx="0" cy="0"/>
+          <a:chOff x="0" y="0"/>
+          <a:chExt cx="0" cy="0"/>
+        </a:xfrm>
+      </p:grpSpPr>
       <p:sp>
         <p:nvSpPr>
           <p:cNvPr id="2" name="TextBox 1"/>
@@ -11716,7 +12263,7 @@
 </file>
 
 <file path=ppt/slides/slide46.xml><?xml version="1.0" encoding="utf-8"?>
-<p:sld xmlns:a="http://schemas.openxmlformats.org/drawingml/2006/main" xmlns:p="http://schemas.openxmlformats.org/presentationml/2006/main" xmlns:r="http://schemas.openxmlformats.org/officeDocument/2006/relationships">
+<p:sld xmlns:a="http://schemas.openxmlformats.org/drawingml/2006/main" xmlns:r="http://schemas.openxmlformats.org/officeDocument/2006/relationships" xmlns:p="http://schemas.openxmlformats.org/presentationml/2006/main">
   <p:cSld>
     <p:spTree>
       <p:nvGrpSpPr>
@@ -11724,7 +12271,14 @@
         <p:cNvGrpSpPr/>
         <p:nvPr/>
       </p:nvGrpSpPr>
-      <p:grpSpPr/>
+      <p:grpSpPr>
+        <a:xfrm>
+          <a:off x="0" y="0"/>
+          <a:ext cx="0" cy="0"/>
+          <a:chOff x="0" y="0"/>
+          <a:chExt cx="0" cy="0"/>
+        </a:xfrm>
+      </p:grpSpPr>
       <p:sp>
         <p:nvSpPr>
           <p:cNvPr id="2" name="TextBox 1"/>
@@ -11835,7 +12389,7 @@
 </file>
 
 <file path=ppt/slides/slide47.xml><?xml version="1.0" encoding="utf-8"?>
-<p:sld xmlns:a="http://schemas.openxmlformats.org/drawingml/2006/main" xmlns:p="http://schemas.openxmlformats.org/presentationml/2006/main" xmlns:r="http://schemas.openxmlformats.org/officeDocument/2006/relationships">
+<p:sld xmlns:a="http://schemas.openxmlformats.org/drawingml/2006/main" xmlns:r="http://schemas.openxmlformats.org/officeDocument/2006/relationships" xmlns:p="http://schemas.openxmlformats.org/presentationml/2006/main">
   <p:cSld>
     <p:spTree>
       <p:nvGrpSpPr>
@@ -11843,7 +12397,14 @@
         <p:cNvGrpSpPr/>
         <p:nvPr/>
       </p:nvGrpSpPr>
-      <p:grpSpPr/>
+      <p:grpSpPr>
+        <a:xfrm>
+          <a:off x="0" y="0"/>
+          <a:ext cx="0" cy="0"/>
+          <a:chOff x="0" y="0"/>
+          <a:chExt cx="0" cy="0"/>
+        </a:xfrm>
+      </p:grpSpPr>
       <p:sp>
         <p:nvSpPr>
           <p:cNvPr id="2" name="TextBox 1"/>
@@ -11969,7 +12530,7 @@
 </file>
 
 <file path=ppt/slides/slide48.xml><?xml version="1.0" encoding="utf-8"?>
-<p:sld xmlns:a="http://schemas.openxmlformats.org/drawingml/2006/main" xmlns:p="http://schemas.openxmlformats.org/presentationml/2006/main" xmlns:r="http://schemas.openxmlformats.org/officeDocument/2006/relationships">
+<p:sld xmlns:a="http://schemas.openxmlformats.org/drawingml/2006/main" xmlns:r="http://schemas.openxmlformats.org/officeDocument/2006/relationships" xmlns:p="http://schemas.openxmlformats.org/presentationml/2006/main">
   <p:cSld>
     <p:spTree>
       <p:nvGrpSpPr>
@@ -11977,7 +12538,14 @@
         <p:cNvGrpSpPr/>
         <p:nvPr/>
       </p:nvGrpSpPr>
-      <p:grpSpPr/>
+      <p:grpSpPr>
+        <a:xfrm>
+          <a:off x="0" y="0"/>
+          <a:ext cx="0" cy="0"/>
+          <a:chOff x="0" y="0"/>
+          <a:chExt cx="0" cy="0"/>
+        </a:xfrm>
+      </p:grpSpPr>
       <p:sp>
         <p:nvSpPr>
           <p:cNvPr id="2" name="TextBox 1"/>
@@ -12088,7 +12656,7 @@
 </file>
 
 <file path=ppt/slides/slide49.xml><?xml version="1.0" encoding="utf-8"?>
-<p:sld xmlns:a="http://schemas.openxmlformats.org/drawingml/2006/main" xmlns:p="http://schemas.openxmlformats.org/presentationml/2006/main" xmlns:r="http://schemas.openxmlformats.org/officeDocument/2006/relationships">
+<p:sld xmlns:a="http://schemas.openxmlformats.org/drawingml/2006/main" xmlns:r="http://schemas.openxmlformats.org/officeDocument/2006/relationships" xmlns:p="http://schemas.openxmlformats.org/presentationml/2006/main">
   <p:cSld>
     <p:spTree>
       <p:nvGrpSpPr>
@@ -12096,7 +12664,14 @@
         <p:cNvGrpSpPr/>
         <p:nvPr/>
       </p:nvGrpSpPr>
-      <p:grpSpPr/>
+      <p:grpSpPr>
+        <a:xfrm>
+          <a:off x="0" y="0"/>
+          <a:ext cx="0" cy="0"/>
+          <a:chOff x="0" y="0"/>
+          <a:chExt cx="0" cy="0"/>
+        </a:xfrm>
+      </p:grpSpPr>
       <p:sp>
         <p:nvSpPr>
           <p:cNvPr id="2" name="TextBox 1"/>
@@ -12207,7 +12782,7 @@
 </file>
 
 <file path=ppt/slides/slide5.xml><?xml version="1.0" encoding="utf-8"?>
-<p:sld xmlns:a="http://schemas.openxmlformats.org/drawingml/2006/main" xmlns:p="http://schemas.openxmlformats.org/presentationml/2006/main" xmlns:r="http://schemas.openxmlformats.org/officeDocument/2006/relationships">
+<p:sld xmlns:a="http://schemas.openxmlformats.org/drawingml/2006/main" xmlns:r="http://schemas.openxmlformats.org/officeDocument/2006/relationships" xmlns:p="http://schemas.openxmlformats.org/presentationml/2006/main">
   <p:cSld>
     <p:spTree>
       <p:nvGrpSpPr>
@@ -12215,7 +12790,14 @@
         <p:cNvGrpSpPr/>
         <p:nvPr/>
       </p:nvGrpSpPr>
-      <p:grpSpPr/>
+      <p:grpSpPr>
+        <a:xfrm>
+          <a:off x="0" y="0"/>
+          <a:ext cx="0" cy="0"/>
+          <a:chOff x="0" y="0"/>
+          <a:chExt cx="0" cy="0"/>
+        </a:xfrm>
+      </p:grpSpPr>
       <p:sp>
         <p:nvSpPr>
           <p:cNvPr id="2" name="TextBox 1"/>
@@ -12292,6 +12874,19 @@
                 <a:spcPts val="0"/>
               </a:spcAft>
             </a:pPr>
+            <a:endParaRPr sz="2000">
+              <a:solidFill>
+                <a:srgbClr val="212121"/>
+              </a:solidFill>
+              <a:latin typeface="Courier New"/>
+            </a:endParaRPr>
+          </a:p>
+          <a:p>
+            <a:pPr>
+              <a:spcAft>
+                <a:spcPts val="0"/>
+              </a:spcAft>
+            </a:pPr>
             <a:r>
               <a:rPr sz="2000">
                 <a:solidFill>
@@ -12299,7 +12894,7 @@
                 </a:solidFill>
                 <a:latin typeface="Courier New"/>
               </a:rPr>
-              <a:t/>
+              <a:t>int getPassword(void)</a:t>
             </a:r>
           </a:p>
           <a:p>
@@ -12315,7 +12910,7 @@
                 </a:solidFill>
                 <a:latin typeface="Courier New"/>
               </a:rPr>
-              <a:t>int getPassword(void)</a:t>
+              <a:t>{</a:t>
             </a:r>
           </a:p>
           <a:p>
@@ -12331,7 +12926,7 @@
                 </a:solidFill>
                 <a:latin typeface="Courier New"/>
               </a:rPr>
-              <a:t>{</a:t>
+              <a:t>  char buf[4];</a:t>
             </a:r>
           </a:p>
           <a:p>
@@ -12347,7 +12942,7 @@
                 </a:solidFill>
                 <a:latin typeface="Courier New"/>
               </a:rPr>
-              <a:t>  char buf[4];</a:t>
+              <a:t>  gets(buf);</a:t>
             </a:r>
           </a:p>
           <a:p>
@@ -12363,7 +12958,7 @@
                 </a:solidFill>
                 <a:latin typeface="Courier New"/>
               </a:rPr>
-              <a:t>  gets(buf);</a:t>
+              <a:t>  return strcmp(buf, "SMT");</a:t>
             </a:r>
           </a:p>
           <a:p>
@@ -12379,7 +12974,7 @@
                 </a:solidFill>
                 <a:latin typeface="Courier New"/>
               </a:rPr>
-              <a:t>  return strcmp(buf, "SMT");</a:t>
+              <a:t>}</a:t>
             </a:r>
           </a:p>
           <a:p>
@@ -12388,6 +12983,19 @@
                 <a:spcPts val="0"/>
               </a:spcAft>
             </a:pPr>
+            <a:endParaRPr sz="2000">
+              <a:solidFill>
+                <a:srgbClr val="212121"/>
+              </a:solidFill>
+              <a:latin typeface="Courier New"/>
+            </a:endParaRPr>
+          </a:p>
+          <a:p>
+            <a:pPr>
+              <a:spcAft>
+                <a:spcPts val="0"/>
+              </a:spcAft>
+            </a:pPr>
             <a:r>
               <a:rPr sz="2000">
                 <a:solidFill>
@@ -12395,38 +13003,6 @@
                 </a:solidFill>
                 <a:latin typeface="Courier New"/>
               </a:rPr>
-              <a:t>}</a:t>
-            </a:r>
-          </a:p>
-          <a:p>
-            <a:pPr>
-              <a:spcAft>
-                <a:spcPts val="0"/>
-              </a:spcAft>
-            </a:pPr>
-            <a:r>
-              <a:rPr sz="2000">
-                <a:solidFill>
-                  <a:srgbClr val="212121"/>
-                </a:solidFill>
-                <a:latin typeface="Courier New"/>
-              </a:rPr>
-              <a:t/>
-            </a:r>
-          </a:p>
-          <a:p>
-            <a:pPr>
-              <a:spcAft>
-                <a:spcPts val="0"/>
-              </a:spcAft>
-            </a:pPr>
-            <a:r>
-              <a:rPr sz="2000">
-                <a:solidFill>
-                  <a:srgbClr val="212121"/>
-                </a:solidFill>
-                <a:latin typeface="Courier New"/>
-              </a:rPr>
               <a:t>/* main: 0 from getPassword =&gt; "Access Granted" */</a:t>
             </a:r>
           </a:p>
@@ -12436,14 +13012,12 @@
                 <a:spcPts val="800"/>
               </a:spcAft>
             </a:pPr>
-            <a:r>
-              <a:rPr sz="2400">
-                <a:solidFill>
-                  <a:srgbClr val="212121"/>
-                </a:solidFill>
-              </a:rPr>
-              <a:t/>
-            </a:r>
+            <a:endParaRPr sz="2000">
+              <a:solidFill>
+                <a:srgbClr val="212121"/>
+              </a:solidFill>
+              <a:latin typeface="Courier New"/>
+            </a:endParaRPr>
           </a:p>
           <a:p>
             <a:pPr>
@@ -12471,7 +13045,7 @@
 </file>
 
 <file path=ppt/slides/slide50.xml><?xml version="1.0" encoding="utf-8"?>
-<p:sld xmlns:a="http://schemas.openxmlformats.org/drawingml/2006/main" xmlns:p="http://schemas.openxmlformats.org/presentationml/2006/main" xmlns:r="http://schemas.openxmlformats.org/officeDocument/2006/relationships">
+<p:sld xmlns:a="http://schemas.openxmlformats.org/drawingml/2006/main" xmlns:r="http://schemas.openxmlformats.org/officeDocument/2006/relationships" xmlns:p="http://schemas.openxmlformats.org/presentationml/2006/main">
   <p:cSld>
     <p:spTree>
       <p:nvGrpSpPr>
@@ -12479,7 +13053,14 @@
         <p:cNvGrpSpPr/>
         <p:nvPr/>
       </p:nvGrpSpPr>
-      <p:grpSpPr/>
+      <p:grpSpPr>
+        <a:xfrm>
+          <a:off x="0" y="0"/>
+          <a:ext cx="0" cy="0"/>
+          <a:chOff x="0" y="0"/>
+          <a:chExt cx="0" cy="0"/>
+        </a:xfrm>
+      </p:grpSpPr>
       <p:sp>
         <p:nvSpPr>
           <p:cNvPr id="2" name="TextBox 1"/>
@@ -12570,13 +13151,25 @@
                 <a:spcPts val="800"/>
               </a:spcAft>
             </a:pPr>
+            <a:endParaRPr sz="2000">
+              <a:solidFill>
+                <a:srgbClr val="212121"/>
+              </a:solidFill>
+            </a:endParaRPr>
+          </a:p>
+          <a:p>
+            <a:pPr>
+              <a:spcAft>
+                <a:spcPts val="800"/>
+              </a:spcAft>
+            </a:pPr>
             <a:r>
               <a:rPr sz="2200">
                 <a:solidFill>
                   <a:srgbClr val="212121"/>
                 </a:solidFill>
               </a:rPr>
-              <a:t/>
+              <a:t>irep2 is the typed, reference-counted representation everything lowers to and every backend consumes.</a:t>
             </a:r>
           </a:p>
           <a:p>
@@ -12591,21 +13184,6 @@
                   <a:srgbClr val="212121"/>
                 </a:solidFill>
               </a:rPr>
-              <a:t>irep2 is the typed, reference-counted representation everything lowers to and every backend consumes.</a:t>
-            </a:r>
-          </a:p>
-          <a:p>
-            <a:pPr>
-              <a:spcAft>
-                <a:spcPts val="800"/>
-              </a:spcAft>
-            </a:pPr>
-            <a:r>
-              <a:rPr sz="2200">
-                <a:solidFill>
-                  <a:srgbClr val="212121"/>
-                </a:solidFill>
-              </a:rPr>
               <a:t>Want to add a check, a frontend, or a new node type? Start here:</a:t>
             </a:r>
           </a:p>
@@ -12631,14 +13209,12 @@
                 <a:spcPts val="800"/>
               </a:spcAft>
             </a:pPr>
-            <a:r>
-              <a:rPr sz="2200">
-                <a:solidFill>
-                  <a:srgbClr val="212121"/>
-                </a:solidFill>
-              </a:rPr>
-              <a:t/>
-            </a:r>
+            <a:endParaRPr sz="1800">
+              <a:solidFill>
+                <a:srgbClr val="212121"/>
+              </a:solidFill>
+              <a:latin typeface="Courier New"/>
+            </a:endParaRPr>
           </a:p>
           <a:p>
             <a:pPr>
@@ -12705,7 +13281,7 @@
 </file>
 
 <file path=ppt/slides/slide51.xml><?xml version="1.0" encoding="utf-8"?>
-<p:sld xmlns:a="http://schemas.openxmlformats.org/drawingml/2006/main" xmlns:p="http://schemas.openxmlformats.org/presentationml/2006/main" xmlns:r="http://schemas.openxmlformats.org/officeDocument/2006/relationships">
+<p:sld xmlns:a="http://schemas.openxmlformats.org/drawingml/2006/main" xmlns:r="http://schemas.openxmlformats.org/officeDocument/2006/relationships" xmlns:p="http://schemas.openxmlformats.org/presentationml/2006/main">
   <p:cSld>
     <p:spTree>
       <p:nvGrpSpPr>
@@ -12713,7 +13289,14 @@
         <p:cNvGrpSpPr/>
         <p:nvPr/>
       </p:nvGrpSpPr>
-      <p:grpSpPr/>
+      <p:grpSpPr>
+        <a:xfrm>
+          <a:off x="0" y="0"/>
+          <a:ext cx="0" cy="0"/>
+          <a:chOff x="0" y="0"/>
+          <a:chExt cx="0" cy="0"/>
+        </a:xfrm>
+      </p:grpSpPr>
       <p:sp>
         <p:nvSpPr>
           <p:cNvPr id="2" name="TextBox 1"/>
@@ -12854,7 +13437,7 @@
 </file>
 
 <file path=ppt/slides/slide52.xml><?xml version="1.0" encoding="utf-8"?>
-<p:sld xmlns:a="http://schemas.openxmlformats.org/drawingml/2006/main" xmlns:p="http://schemas.openxmlformats.org/presentationml/2006/main" xmlns:r="http://schemas.openxmlformats.org/officeDocument/2006/relationships">
+<p:sld xmlns:a="http://schemas.openxmlformats.org/drawingml/2006/main" xmlns:r="http://schemas.openxmlformats.org/officeDocument/2006/relationships" xmlns:p="http://schemas.openxmlformats.org/presentationml/2006/main">
   <p:cSld>
     <p:spTree>
       <p:nvGrpSpPr>
@@ -12862,7 +13445,14 @@
         <p:cNvGrpSpPr/>
         <p:nvPr/>
       </p:nvGrpSpPr>
-      <p:grpSpPr/>
+      <p:grpSpPr>
+        <a:xfrm>
+          <a:off x="0" y="0"/>
+          <a:ext cx="0" cy="0"/>
+          <a:chOff x="0" y="0"/>
+          <a:chExt cx="0" cy="0"/>
+        </a:xfrm>
+      </p:grpSpPr>
       <p:sp>
         <p:nvSpPr>
           <p:cNvPr id="2" name="TextBox 1"/>
@@ -13022,7 +13612,7 @@
 </file>
 
 <file path=ppt/slides/slide6.xml><?xml version="1.0" encoding="utf-8"?>
-<p:sld xmlns:a="http://schemas.openxmlformats.org/drawingml/2006/main" xmlns:p="http://schemas.openxmlformats.org/presentationml/2006/main" xmlns:r="http://schemas.openxmlformats.org/officeDocument/2006/relationships">
+<p:sld xmlns:a="http://schemas.openxmlformats.org/drawingml/2006/main" xmlns:r="http://schemas.openxmlformats.org/officeDocument/2006/relationships" xmlns:p="http://schemas.openxmlformats.org/presentationml/2006/main">
   <p:cSld>
     <p:spTree>
       <p:nvGrpSpPr>
@@ -13030,7 +13620,14 @@
         <p:cNvGrpSpPr/>
         <p:nvPr/>
       </p:nvGrpSpPr>
-      <p:grpSpPr/>
+      <p:grpSpPr>
+        <a:xfrm>
+          <a:off x="0" y="0"/>
+          <a:ext cx="0" cy="0"/>
+          <a:chOff x="0" y="0"/>
+          <a:chExt cx="0" cy="0"/>
+        </a:xfrm>
+      </p:grpSpPr>
       <p:sp>
         <p:nvSpPr>
           <p:cNvPr id="2" name="TextBox 1"/>
@@ -13074,7 +13671,7 @@
         </p:nvGraphicFramePr>
         <p:xfrm>
           <a:off x="731520" y="1463040"/>
-          <a:ext cx="10698480" cy="1463040"/>
+          <a:ext cx="10698480" cy="1584960"/>
         </p:xfrm>
         <a:graphic>
           <a:graphicData uri="http://schemas.openxmlformats.org/drawingml/2006/table">
@@ -13083,8 +13680,20 @@
                 <a:tableStyleId>{5C22544A-7EE6-4342-B048-85BDC9FD1C3A}</a:tableStyleId>
               </a:tblPr>
               <a:tblGrid>
-                <a:gridCol w="3840480"/>
-                <a:gridCol w="6858000"/>
+                <a:gridCol w="3840480">
+                  <a:extLst>
+                    <a:ext uri="{9D8B030D-6E8A-4147-A177-3AD203B41FA5}">
+                      <a16:colId xmlns:a16="http://schemas.microsoft.com/office/drawing/2014/main" val="20000"/>
+                    </a:ext>
+                  </a:extLst>
+                </a:gridCol>
+                <a:gridCol w="6858000">
+                  <a:extLst>
+                    <a:ext uri="{9D8B030D-6E8A-4147-A177-3AD203B41FA5}">
+                      <a16:colId xmlns:a16="http://schemas.microsoft.com/office/drawing/2014/main" val="20001"/>
+                    </a:ext>
+                  </a:extLst>
+                </a:gridCol>
               </a:tblGrid>
               <a:tr h="365760">
                 <a:tc>
@@ -13104,10 +13713,17 @@
                   <a:txBody>
                     <a:bodyPr/>
                     <a:lstStyle/>
-                    <a:p/>
+                    <a:p>
+                      <a:endParaRPr/>
+                    </a:p>
                   </a:txBody>
                   <a:tcPr/>
                 </a:tc>
+                <a:extLst>
+                  <a:ext uri="{0D108BD9-81ED-4DB2-BD59-A6C34878D82A}">
+                    <a16:rowId xmlns:a16="http://schemas.microsoft.com/office/drawing/2014/main" val="10000"/>
+                  </a:ext>
+                </a:extLst>
               </a:tr>
               <a:tr h="365760">
                 <a:tc>
@@ -13136,6 +13752,11 @@
                   </a:txBody>
                   <a:tcPr/>
                 </a:tc>
+                <a:extLst>
+                  <a:ext uri="{0D108BD9-81ED-4DB2-BD59-A6C34878D82A}">
+                    <a16:rowId xmlns:a16="http://schemas.microsoft.com/office/drawing/2014/main" val="10001"/>
+                  </a:ext>
+                </a:extLst>
               </a:tr>
               <a:tr h="365760">
                 <a:tc>
@@ -13164,6 +13785,11 @@
                   </a:txBody>
                   <a:tcPr/>
                 </a:tc>
+                <a:extLst>
+                  <a:ext uri="{0D108BD9-81ED-4DB2-BD59-A6C34878D82A}">
+                    <a16:rowId xmlns:a16="http://schemas.microsoft.com/office/drawing/2014/main" val="10002"/>
+                  </a:ext>
+                </a:extLst>
               </a:tr>
               <a:tr h="365760">
                 <a:tc>
@@ -13192,6 +13818,11 @@
                   </a:txBody>
                   <a:tcPr/>
                 </a:tc>
+                <a:extLst>
+                  <a:ext uri="{0D108BD9-81ED-4DB2-BD59-A6C34878D82A}">
+                    <a16:rowId xmlns:a16="http://schemas.microsoft.com/office/drawing/2014/main" val="10003"/>
+                  </a:ext>
+                </a:extLst>
               </a:tr>
             </a:tbl>
           </a:graphicData>
@@ -13289,7 +13920,7 @@
 </file>
 
 <file path=ppt/slides/slide7.xml><?xml version="1.0" encoding="utf-8"?>
-<p:sld xmlns:a="http://schemas.openxmlformats.org/drawingml/2006/main" xmlns:p="http://schemas.openxmlformats.org/presentationml/2006/main" xmlns:r="http://schemas.openxmlformats.org/officeDocument/2006/relationships">
+<p:sld xmlns:a="http://schemas.openxmlformats.org/drawingml/2006/main" xmlns:r="http://schemas.openxmlformats.org/officeDocument/2006/relationships" xmlns:p="http://schemas.openxmlformats.org/presentationml/2006/main">
   <p:cSld>
     <p:spTree>
       <p:nvGrpSpPr>
@@ -13297,7 +13928,14 @@
         <p:cNvGrpSpPr/>
         <p:nvPr/>
       </p:nvGrpSpPr>
-      <p:grpSpPr/>
+      <p:grpSpPr>
+        <a:xfrm>
+          <a:off x="0" y="0"/>
+          <a:ext cx="0" cy="0"/>
+          <a:chOff x="0" y="0"/>
+          <a:chExt cx="0" cy="0"/>
+        </a:xfrm>
+      </p:grpSpPr>
       <p:sp>
         <p:nvSpPr>
           <p:cNvPr id="2" name="TextBox 1"/>
@@ -13374,6 +14012,19 @@
                 <a:spcPts val="0"/>
               </a:spcAft>
             </a:pPr>
+            <a:endParaRPr sz="1800">
+              <a:solidFill>
+                <a:srgbClr val="212121"/>
+              </a:solidFill>
+              <a:latin typeface="Courier New"/>
+            </a:endParaRPr>
+          </a:p>
+          <a:p>
+            <a:pPr>
+              <a:spcAft>
+                <a:spcPts val="0"/>
+              </a:spcAft>
+            </a:pPr>
             <a:r>
               <a:rPr sz="1800">
                 <a:solidFill>
@@ -13381,7 +14032,7 @@
                 </a:solidFill>
                 <a:latin typeface="Courier New"/>
               </a:rPr>
-              <a:t/>
+              <a:t>[Counterexample]</a:t>
             </a:r>
           </a:p>
           <a:p>
@@ -13397,7 +14048,7 @@
                 </a:solidFill>
                 <a:latin typeface="Courier New"/>
               </a:rPr>
-              <a:t>[Counterexample]</a:t>
+              <a:t>...</a:t>
             </a:r>
           </a:p>
           <a:p>
@@ -13413,7 +14064,7 @@
                 </a:solidFill>
                 <a:latin typeface="Courier New"/>
               </a:rPr>
-              <a:t>...</a:t>
+              <a:t>Violated property:</a:t>
             </a:r>
           </a:p>
           <a:p>
@@ -13429,7 +14080,7 @@
                 </a:solidFill>
                 <a:latin typeface="Courier New"/>
               </a:rPr>
-              <a:t>Violated property:</a:t>
+              <a:t>  dereference failure: array bounds violated</a:t>
             </a:r>
           </a:p>
           <a:p>
@@ -13445,7 +14096,7 @@
                 </a:solidFill>
                 <a:latin typeface="Courier New"/>
               </a:rPr>
-              <a:t>  dereference failure: array bounds violated</a:t>
+              <a:t>  CWE: CWE-787 (out-of-bounds write)</a:t>
             </a:r>
           </a:p>
           <a:p>
@@ -13454,6 +14105,19 @@
                 <a:spcPts val="0"/>
               </a:spcAft>
             </a:pPr>
+            <a:endParaRPr sz="1800">
+              <a:solidFill>
+                <a:srgbClr val="212121"/>
+              </a:solidFill>
+              <a:latin typeface="Courier New"/>
+            </a:endParaRPr>
+          </a:p>
+          <a:p>
+            <a:pPr>
+              <a:spcAft>
+                <a:spcPts val="0"/>
+              </a:spcAft>
+            </a:pPr>
             <a:r>
               <a:rPr sz="1800">
                 <a:solidFill>
@@ -13461,38 +14125,6 @@
                 </a:solidFill>
                 <a:latin typeface="Courier New"/>
               </a:rPr>
-              <a:t>  CWE: CWE-787 (out-of-bounds write)</a:t>
-            </a:r>
-          </a:p>
-          <a:p>
-            <a:pPr>
-              <a:spcAft>
-                <a:spcPts val="0"/>
-              </a:spcAft>
-            </a:pPr>
-            <a:r>
-              <a:rPr sz="1800">
-                <a:solidFill>
-                  <a:srgbClr val="212121"/>
-                </a:solidFill>
-                <a:latin typeface="Courier New"/>
-              </a:rPr>
-              <a:t/>
-            </a:r>
-          </a:p>
-          <a:p>
-            <a:pPr>
-              <a:spcAft>
-                <a:spcPts val="0"/>
-              </a:spcAft>
-            </a:pPr>
-            <a:r>
-              <a:rPr sz="1800">
-                <a:solidFill>
-                  <a:srgbClr val="212121"/>
-                </a:solidFill>
-                <a:latin typeface="Courier New"/>
-              </a:rPr>
               <a:t>VERIFICATION FAILED</a:t>
             </a:r>
           </a:p>
@@ -13502,14 +14134,12 @@
                 <a:spcPts val="800"/>
               </a:spcAft>
             </a:pPr>
-            <a:r>
-              <a:rPr sz="2200">
-                <a:solidFill>
-                  <a:srgbClr val="212121"/>
-                </a:solidFill>
-              </a:rPr>
-              <a:t/>
-            </a:r>
+            <a:endParaRPr sz="1800">
+              <a:solidFill>
+                <a:srgbClr val="212121"/>
+              </a:solidFill>
+              <a:latin typeface="Courier New"/>
+            </a:endParaRPr>
           </a:p>
           <a:p>
             <a:pPr>
@@ -13537,7 +14167,7 @@
 </file>
 
 <file path=ppt/slides/slide8.xml><?xml version="1.0" encoding="utf-8"?>
-<p:sld xmlns:a="http://schemas.openxmlformats.org/drawingml/2006/main" xmlns:p="http://schemas.openxmlformats.org/presentationml/2006/main" xmlns:r="http://schemas.openxmlformats.org/officeDocument/2006/relationships">
+<p:sld xmlns:a="http://schemas.openxmlformats.org/drawingml/2006/main" xmlns:r="http://schemas.openxmlformats.org/officeDocument/2006/relationships" xmlns:p="http://schemas.openxmlformats.org/presentationml/2006/main">
   <p:cSld>
     <p:spTree>
       <p:nvGrpSpPr>
@@ -13545,7 +14175,14 @@
         <p:cNvGrpSpPr/>
         <p:nvPr/>
       </p:nvGrpSpPr>
-      <p:grpSpPr/>
+      <p:grpSpPr>
+        <a:xfrm>
+          <a:off x="0" y="0"/>
+          <a:ext cx="0" cy="0"/>
+          <a:chOff x="0" y="0"/>
+          <a:chExt cx="0" cy="0"/>
+        </a:xfrm>
+      </p:grpSpPr>
       <p:sp>
         <p:nvSpPr>
           <p:cNvPr id="2" name="TextBox 1"/>
@@ -13701,6 +14338,19 @@
                 <a:spcPts val="0"/>
               </a:spcAft>
             </a:pPr>
+            <a:endParaRPr sz="1600">
+              <a:solidFill>
+                <a:srgbClr val="212121"/>
+              </a:solidFill>
+              <a:latin typeface="Courier New"/>
+            </a:endParaRPr>
+          </a:p>
+          <a:p>
+            <a:pPr>
+              <a:spcAft>
+                <a:spcPts val="0"/>
+              </a:spcAft>
+            </a:pPr>
             <a:r>
               <a:rPr sz="1600">
                 <a:solidFill>
@@ -13708,7 +14358,7 @@
                 </a:solidFill>
                 <a:latin typeface="Courier New"/>
               </a:rPr>
-              <a:t/>
+              <a:t>$ esbmc getpassword.c --unwind 8 --generate-ctest-testcase</a:t>
             </a:r>
           </a:p>
           <a:p>
@@ -13724,7 +14374,7 @@
                 </a:solidFill>
                 <a:latin typeface="Courier New"/>
               </a:rPr>
-              <a:t>$ esbmc getpassword.c --unwind 8 --generate-ctest-testcase</a:t>
+              <a:t>  → Generated CTest test case: test_case.c</a:t>
             </a:r>
           </a:p>
           <a:p>
@@ -13733,6 +14383,19 @@
                 <a:spcPts val="0"/>
               </a:spcAft>
             </a:pPr>
+            <a:endParaRPr sz="1600">
+              <a:solidFill>
+                <a:srgbClr val="212121"/>
+              </a:solidFill>
+              <a:latin typeface="Courier New"/>
+            </a:endParaRPr>
+          </a:p>
+          <a:p>
+            <a:pPr>
+              <a:spcAft>
+                <a:spcPts val="0"/>
+              </a:spcAft>
+            </a:pPr>
             <a:r>
               <a:rPr sz="1600">
                 <a:solidFill>
@@ -13740,7 +14403,7 @@
                 </a:solidFill>
                 <a:latin typeface="Courier New"/>
               </a:rPr>
-              <a:t>  → Generated CTest test case: test_case.c</a:t>
+              <a:t>char nondet_char(void) {            /* test_case.c */</a:t>
             </a:r>
           </a:p>
           <a:p>
@@ -13756,7 +14419,7 @@
                 </a:solidFill>
                 <a:latin typeface="Courier New"/>
               </a:rPr>
-              <a:t/>
+              <a:t>  static const char v[] = { 83, 77, 84 };  /* "SMT" */</a:t>
             </a:r>
           </a:p>
           <a:p>
@@ -13772,7 +14435,7 @@
                 </a:solidFill>
                 <a:latin typeface="Courier New"/>
               </a:rPr>
-              <a:t>char nondet_char(void) {            /* test_case.c */</a:t>
+              <a:t>  static int i = 0; return v[i++];</a:t>
             </a:r>
           </a:p>
           <a:p>
@@ -13788,38 +14451,6 @@
                 </a:solidFill>
                 <a:latin typeface="Courier New"/>
               </a:rPr>
-              <a:t>  static const char v[] = { 83, 77, 84 };  /* "SMT" */</a:t>
-            </a:r>
-          </a:p>
-          <a:p>
-            <a:pPr>
-              <a:spcAft>
-                <a:spcPts val="0"/>
-              </a:spcAft>
-            </a:pPr>
-            <a:r>
-              <a:rPr sz="1600">
-                <a:solidFill>
-                  <a:srgbClr val="212121"/>
-                </a:solidFill>
-                <a:latin typeface="Courier New"/>
-              </a:rPr>
-              <a:t>  static int i = 0; return v[i++];</a:t>
-            </a:r>
-          </a:p>
-          <a:p>
-            <a:pPr>
-              <a:spcAft>
-                <a:spcPts val="0"/>
-              </a:spcAft>
-            </a:pPr>
-            <a:r>
-              <a:rPr sz="1600">
-                <a:solidFill>
-                  <a:srgbClr val="212121"/>
-                </a:solidFill>
-                <a:latin typeface="Courier New"/>
-              </a:rPr>
               <a:t>}</a:t>
             </a:r>
           </a:p>
@@ -13829,14 +14460,12 @@
                 <a:spcPts val="800"/>
               </a:spcAft>
             </a:pPr>
-            <a:r>
-              <a:rPr sz="2000">
-                <a:solidFill>
-                  <a:srgbClr val="212121"/>
-                </a:solidFill>
-              </a:rPr>
-              <a:t/>
-            </a:r>
+            <a:endParaRPr sz="1600">
+              <a:solidFill>
+                <a:srgbClr val="212121"/>
+              </a:solidFill>
+              <a:latin typeface="Courier New"/>
+            </a:endParaRPr>
           </a:p>
           <a:p>
             <a:pPr>
@@ -13903,7 +14532,7 @@
 </file>
 
 <file path=ppt/slides/slide9.xml><?xml version="1.0" encoding="utf-8"?>
-<p:sld xmlns:a="http://schemas.openxmlformats.org/drawingml/2006/main" xmlns:p="http://schemas.openxmlformats.org/presentationml/2006/main" xmlns:r="http://schemas.openxmlformats.org/officeDocument/2006/relationships">
+<p:sld xmlns:a="http://schemas.openxmlformats.org/drawingml/2006/main" xmlns:r="http://schemas.openxmlformats.org/officeDocument/2006/relationships" xmlns:p="http://schemas.openxmlformats.org/presentationml/2006/main">
   <p:cSld>
     <p:spTree>
       <p:nvGrpSpPr>
@@ -13911,7 +14540,14 @@
         <p:cNvGrpSpPr/>
         <p:nvPr/>
       </p:nvGrpSpPr>
-      <p:grpSpPr/>
+      <p:grpSpPr>
+        <a:xfrm>
+          <a:off x="0" y="0"/>
+          <a:ext cx="0" cy="0"/>
+          <a:chOff x="0" y="0"/>
+          <a:chExt cx="0" cy="0"/>
+        </a:xfrm>
+      </p:grpSpPr>
       <p:sp>
         <p:nvSpPr>
           <p:cNvPr id="2" name="TextBox 1"/>
@@ -14035,6 +14671,19 @@
                 <a:spcPts val="0"/>
               </a:spcAft>
             </a:pPr>
+            <a:endParaRPr sz="1600">
+              <a:solidFill>
+                <a:srgbClr val="212121"/>
+              </a:solidFill>
+              <a:latin typeface="Courier New"/>
+            </a:endParaRPr>
+          </a:p>
+          <a:p>
+            <a:pPr>
+              <a:spcAft>
+                <a:spcPts val="0"/>
+              </a:spcAft>
+            </a:pPr>
             <a:r>
               <a:rPr sz="1600">
                 <a:solidFill>
@@ -14042,7 +14691,7 @@
                 </a:solidFill>
                 <a:latin typeface="Courier New"/>
               </a:rPr>
-              <a:t/>
+              <a:t>  if (access_granted(buf) &amp;&amp; strcmp(buf, "SMT") != 0)</a:t>
             </a:r>
           </a:p>
           <a:p>
@@ -14058,7 +14707,7 @@
                 </a:solidFill>
                 <a:latin typeface="Courier New"/>
               </a:rPr>
-              <a:t>  if (access_granted(buf) &amp;&amp; strcmp(buf, "SMT") != 0)</a:t>
+              <a:t>    assert(0);     /* got in WITHOUT the password */</a:t>
             </a:r>
           </a:p>
           <a:p>
@@ -14067,6 +14716,19 @@
                 <a:spcPts val="0"/>
               </a:spcAft>
             </a:pPr>
+            <a:endParaRPr sz="1600">
+              <a:solidFill>
+                <a:srgbClr val="212121"/>
+              </a:solidFill>
+              <a:latin typeface="Courier New"/>
+            </a:endParaRPr>
+          </a:p>
+          <a:p>
+            <a:pPr>
+              <a:spcAft>
+                <a:spcPts val="0"/>
+              </a:spcAft>
+            </a:pPr>
             <a:r>
               <a:rPr sz="1600">
                 <a:solidFill>
@@ -14074,7 +14736,7 @@
                 </a:solidFill>
                 <a:latin typeface="Courier New"/>
               </a:rPr>
-              <a:t>    assert(0);     /* got in WITHOUT the password */</a:t>
+              <a:t>$ esbmc getpassword.c --unwind 8 --generate-ctest-testcase</a:t>
             </a:r>
           </a:p>
           <a:p>
@@ -14090,7 +14752,7 @@
                 </a:solidFill>
                 <a:latin typeface="Courier New"/>
               </a:rPr>
-              <a:t/>
+              <a:t>  buf = { 0, 0, 0 }            → the empty string ""</a:t>
             </a:r>
           </a:p>
           <a:p>
@@ -14106,38 +14768,6 @@
                 </a:solidFill>
                 <a:latin typeface="Courier New"/>
               </a:rPr>
-              <a:t>$ esbmc getpassword.c --unwind 8 --generate-ctest-testcase</a:t>
-            </a:r>
-          </a:p>
-          <a:p>
-            <a:pPr>
-              <a:spcAft>
-                <a:spcPts val="0"/>
-              </a:spcAft>
-            </a:pPr>
-            <a:r>
-              <a:rPr sz="1600">
-                <a:solidFill>
-                  <a:srgbClr val="212121"/>
-                </a:solidFill>
-                <a:latin typeface="Courier New"/>
-              </a:rPr>
-              <a:t>  buf = { 0, 0, 0 }            → the empty string ""</a:t>
-            </a:r>
-          </a:p>
-          <a:p>
-            <a:pPr>
-              <a:spcAft>
-                <a:spcPts val="0"/>
-              </a:spcAft>
-            </a:pPr>
-            <a:r>
-              <a:rPr sz="1600">
-                <a:solidFill>
-                  <a:srgbClr val="212121"/>
-                </a:solidFill>
-                <a:latin typeface="Courier New"/>
-              </a:rPr>
               <a:t>VERIFICATION FAILED</a:t>
             </a:r>
           </a:p>
@@ -14147,14 +14777,12 @@
                 <a:spcPts val="800"/>
               </a:spcAft>
             </a:pPr>
-            <a:r>
-              <a:rPr sz="2000">
-                <a:solidFill>
-                  <a:srgbClr val="212121"/>
-                </a:solidFill>
-              </a:rPr>
-              <a:t/>
-            </a:r>
+            <a:endParaRPr sz="1600">
+              <a:solidFill>
+                <a:srgbClr val="212121"/>
+              </a:solidFill>
+              <a:latin typeface="Courier New"/>
+            </a:endParaRPr>
           </a:p>
           <a:p>
             <a:pPr>

</xml_diff>

<commit_message>
Cite Cousot & Cousot (POPL 1977) for the sound-over-approximation claim
Add a verified source footer — Cousot & Cousot, POPL 1977,
doi:10.1145/512950.512973 — to the abstract-interpretation slides in both
decks (S1 slide 48, S2 slide 5), backing the 'sound, not complete:
over-approximation -> false alarm' claim. Citation VERIFIED via the
citation-verifier agent against DBLP (conf/popl/CousotC77).

Rebuilding S1 from the build script also restored em-dashes that an earlier
pptx re-save (8708505) had mangled into semicolons; the build script is the
source of truth.
</commit_message>
<xml_diff>
--- a/slides/session1/01-session1-fundamentals.pptx
+++ b/slides/session1/01-session1-fundamentals.pptx
@@ -5,62 +5,62 @@
     <p:sldMasterId id="2147483648" r:id="rId1"/>
   </p:sldMasterIdLst>
   <p:sldIdLst>
-    <p:sldId id="256" r:id="rId2"/>
-    <p:sldId id="257" r:id="rId3"/>
-    <p:sldId id="258" r:id="rId4"/>
-    <p:sldId id="259" r:id="rId5"/>
-    <p:sldId id="260" r:id="rId6"/>
-    <p:sldId id="261" r:id="rId7"/>
-    <p:sldId id="262" r:id="rId8"/>
-    <p:sldId id="263" r:id="rId9"/>
-    <p:sldId id="264" r:id="rId10"/>
-    <p:sldId id="265" r:id="rId11"/>
-    <p:sldId id="266" r:id="rId12"/>
-    <p:sldId id="267" r:id="rId13"/>
-    <p:sldId id="268" r:id="rId14"/>
-    <p:sldId id="269" r:id="rId15"/>
-    <p:sldId id="270" r:id="rId16"/>
-    <p:sldId id="271" r:id="rId17"/>
-    <p:sldId id="272" r:id="rId18"/>
-    <p:sldId id="273" r:id="rId19"/>
-    <p:sldId id="274" r:id="rId20"/>
-    <p:sldId id="275" r:id="rId21"/>
-    <p:sldId id="276" r:id="rId22"/>
-    <p:sldId id="277" r:id="rId23"/>
-    <p:sldId id="278" r:id="rId24"/>
-    <p:sldId id="279" r:id="rId25"/>
-    <p:sldId id="280" r:id="rId26"/>
-    <p:sldId id="281" r:id="rId27"/>
-    <p:sldId id="282" r:id="rId28"/>
-    <p:sldId id="283" r:id="rId29"/>
-    <p:sldId id="284" r:id="rId30"/>
-    <p:sldId id="285" r:id="rId31"/>
-    <p:sldId id="286" r:id="rId32"/>
-    <p:sldId id="287" r:id="rId33"/>
-    <p:sldId id="288" r:id="rId34"/>
-    <p:sldId id="289" r:id="rId35"/>
-    <p:sldId id="290" r:id="rId36"/>
-    <p:sldId id="291" r:id="rId37"/>
-    <p:sldId id="292" r:id="rId38"/>
-    <p:sldId id="293" r:id="rId39"/>
-    <p:sldId id="294" r:id="rId40"/>
-    <p:sldId id="295" r:id="rId41"/>
-    <p:sldId id="296" r:id="rId42"/>
-    <p:sldId id="297" r:id="rId43"/>
-    <p:sldId id="298" r:id="rId44"/>
-    <p:sldId id="299" r:id="rId45"/>
-    <p:sldId id="300" r:id="rId46"/>
-    <p:sldId id="301" r:id="rId47"/>
-    <p:sldId id="302" r:id="rId48"/>
-    <p:sldId id="303" r:id="rId49"/>
-    <p:sldId id="304" r:id="rId50"/>
-    <p:sldId id="305" r:id="rId51"/>
-    <p:sldId id="306" r:id="rId52"/>
-    <p:sldId id="307" r:id="rId53"/>
-    <p:sldId id="308" r:id="rId54"/>
-    <p:sldId id="309" r:id="rId55"/>
+    <p:sldId id="256" r:id="rId7"/>
+    <p:sldId id="257" r:id="rId8"/>
+    <p:sldId id="258" r:id="rId9"/>
+    <p:sldId id="259" r:id="rId10"/>
+    <p:sldId id="260" r:id="rId11"/>
+    <p:sldId id="261" r:id="rId12"/>
+    <p:sldId id="262" r:id="rId13"/>
+    <p:sldId id="263" r:id="rId14"/>
+    <p:sldId id="264" r:id="rId15"/>
+    <p:sldId id="265" r:id="rId16"/>
+    <p:sldId id="266" r:id="rId17"/>
+    <p:sldId id="267" r:id="rId18"/>
+    <p:sldId id="268" r:id="rId19"/>
+    <p:sldId id="269" r:id="rId20"/>
+    <p:sldId id="270" r:id="rId21"/>
+    <p:sldId id="271" r:id="rId22"/>
+    <p:sldId id="272" r:id="rId23"/>
+    <p:sldId id="273" r:id="rId24"/>
+    <p:sldId id="274" r:id="rId25"/>
+    <p:sldId id="275" r:id="rId26"/>
+    <p:sldId id="276" r:id="rId27"/>
+    <p:sldId id="277" r:id="rId28"/>
+    <p:sldId id="278" r:id="rId29"/>
+    <p:sldId id="279" r:id="rId30"/>
+    <p:sldId id="280" r:id="rId31"/>
+    <p:sldId id="281" r:id="rId32"/>
+    <p:sldId id="282" r:id="rId33"/>
+    <p:sldId id="283" r:id="rId34"/>
+    <p:sldId id="284" r:id="rId35"/>
+    <p:sldId id="285" r:id="rId36"/>
+    <p:sldId id="286" r:id="rId37"/>
+    <p:sldId id="287" r:id="rId38"/>
+    <p:sldId id="288" r:id="rId39"/>
+    <p:sldId id="289" r:id="rId40"/>
+    <p:sldId id="290" r:id="rId41"/>
+    <p:sldId id="291" r:id="rId42"/>
+    <p:sldId id="292" r:id="rId43"/>
+    <p:sldId id="293" r:id="rId44"/>
+    <p:sldId id="294" r:id="rId45"/>
+    <p:sldId id="295" r:id="rId46"/>
+    <p:sldId id="296" r:id="rId47"/>
+    <p:sldId id="297" r:id="rId48"/>
+    <p:sldId id="298" r:id="rId49"/>
+    <p:sldId id="299" r:id="rId50"/>
+    <p:sldId id="300" r:id="rId51"/>
+    <p:sldId id="301" r:id="rId52"/>
+    <p:sldId id="302" r:id="rId53"/>
+    <p:sldId id="303" r:id="rId54"/>
+    <p:sldId id="304" r:id="rId55"/>
+    <p:sldId id="305" r:id="rId56"/>
+    <p:sldId id="306" r:id="rId57"/>
+    <p:sldId id="307" r:id="rId58"/>
+    <p:sldId id="308" r:id="rId59"/>
+    <p:sldId id="309" r:id="rId60"/>
   </p:sldIdLst>
-  <p:sldSz cx="12192000" cy="6858000"/>
+  <p:sldSz cx="12191695" cy="6858000" type="screen4x3"/>
   <p:notesSz cx="6858000" cy="9144000"/>
   <p:defaultTextStyle>
     <a:defPPr>
@@ -157,38 +157,15 @@
       </a:defRPr>
     </a:lvl9pPr>
   </p:defaultTextStyle>
-  <p:extLst>
-    <p:ext uri="{EFAFB233-063F-42B5-8137-9DF3F51BA10A}">
-      <p15:sldGuideLst xmlns:p15="http://schemas.microsoft.com/office/powerpoint/2012/main">
-        <p15:guide id="1" orient="horz" pos="2160">
-          <p15:clr>
-            <a:srgbClr val="A4A3A4"/>
-          </p15:clr>
-        </p15:guide>
-        <p15:guide id="2" pos="2880">
-          <p15:clr>
-            <a:srgbClr val="A4A3A4"/>
-          </p15:clr>
-        </p15:guide>
-      </p15:sldGuideLst>
-    </p:ext>
-  </p:extLst>
 </p:presentation>
 </file>
 
 <file path=ppt/charts/chart1.xml><?xml version="1.0" encoding="utf-8"?>
-<c:chartSpace xmlns:c="http://schemas.openxmlformats.org/drawingml/2006/chart" xmlns:a="http://schemas.openxmlformats.org/drawingml/2006/main" xmlns:r="http://schemas.openxmlformats.org/officeDocument/2006/relationships" xmlns:c16r2="http://schemas.microsoft.com/office/drawing/2015/06/chart">
+<c:chartSpace xmlns:c="http://schemas.openxmlformats.org/drawingml/2006/chart" xmlns:a="http://schemas.openxmlformats.org/drawingml/2006/main" xmlns:r="http://schemas.openxmlformats.org/officeDocument/2006/relationships">
   <c:date1904 val="0"/>
-  <c:lang val="en-GB"/>
-  <c:roundedCorners val="1"/>
-  <c:style val="2"/>
   <c:chart>
-    <c:title>
-      <c:overlay val="0"/>
-    </c:title>
     <c:autoTitleDeleted val="0"/>
     <c:plotArea>
-      <c:layout/>
       <c:lineChart>
         <c:grouping val="standard"/>
         <c:varyColors val="0"/>
@@ -284,20 +261,7 @@
             </c:numRef>
           </c:val>
           <c:smooth val="0"/>
-          <c:extLst>
-            <c:ext xmlns:c16="http://schemas.microsoft.com/office/drawing/2014/chart" uri="{C3380CC4-5D6E-409C-BE32-E72D297353CC}">
-              <c16:uniqueId val="{00000000-11F0-1948-BDAE-261F7823F5CE}"/>
-            </c:ext>
-          </c:extLst>
         </c:ser>
-        <c:dLbls>
-          <c:showLegendKey val="0"/>
-          <c:showVal val="0"/>
-          <c:showCatName val="0"/>
-          <c:showSerName val="0"/>
-          <c:showPercent val="0"/>
-          <c:showBubbleSize val="0"/>
-        </c:dLbls>
         <c:marker val="1"/>
         <c:smooth val="0"/>
         <c:axId val="2118791784"/>
@@ -310,7 +274,6 @@
         </c:scaling>
         <c:delete val="0"/>
         <c:axPos val="b"/>
-        <c:numFmt formatCode="General" sourceLinked="0"/>
         <c:majorTickMark val="out"/>
         <c:minorTickMark val="none"/>
         <c:tickLblPos val="nextTo"/>
@@ -321,7 +284,6 @@
             <a:pPr>
               <a:defRPr sz="1200"/>
             </a:pPr>
-            <a:endParaRPr lang="en-US"/>
           </a:p>
         </c:txPr>
         <c:crossAx val="2140495176"/>
@@ -333,13 +295,10 @@
       </c:catAx>
       <c:valAx>
         <c:axId val="2140495176"/>
-        <c:scaling>
-          <c:orientation val="minMax"/>
-        </c:scaling>
+        <c:scaling/>
         <c:delete val="0"/>
         <c:axPos val="l"/>
         <c:majorGridlines/>
-        <c:numFmt formatCode="General" sourceLinked="1"/>
         <c:majorTickMark val="out"/>
         <c:minorTickMark val="none"/>
         <c:tickLblPos val="nextTo"/>
@@ -350,12 +309,10 @@
             <a:pPr>
               <a:defRPr sz="1200"/>
             </a:pPr>
-            <a:endParaRPr lang="en-US"/>
           </a:p>
         </c:txPr>
         <c:crossAx val="2118791784"/>
         <c:crosses val="autoZero"/>
-        <c:crossBetween val="between"/>
       </c:valAx>
     </c:plotArea>
     <c:plotVisOnly val="1"/>
@@ -379,22 +336,14 @@
 </file>
 
 <file path=ppt/charts/chart2.xml><?xml version="1.0" encoding="utf-8"?>
-<c:chartSpace xmlns:c="http://schemas.openxmlformats.org/drawingml/2006/chart" xmlns:a="http://schemas.openxmlformats.org/drawingml/2006/main" xmlns:r="http://schemas.openxmlformats.org/officeDocument/2006/relationships" xmlns:c16r2="http://schemas.microsoft.com/office/drawing/2015/06/chart">
+<c:chartSpace xmlns:c="http://schemas.openxmlformats.org/drawingml/2006/chart" xmlns:a="http://schemas.openxmlformats.org/drawingml/2006/main" xmlns:r="http://schemas.openxmlformats.org/officeDocument/2006/relationships">
   <c:date1904 val="0"/>
-  <c:lang val="en-GB"/>
-  <c:roundedCorners val="1"/>
-  <c:style val="2"/>
   <c:chart>
-    <c:title>
-      <c:overlay val="0"/>
-    </c:title>
     <c:autoTitleDeleted val="0"/>
     <c:plotArea>
-      <c:layout/>
       <c:barChart>
         <c:barDir val="bar"/>
         <c:grouping val="clustered"/>
-        <c:varyColors val="1"/>
         <c:ser>
           <c:idx val="0"/>
           <c:order val="0"/>
@@ -409,7 +358,6 @@
               </c:strCache>
             </c:strRef>
           </c:tx>
-          <c:invertIfNegative val="1"/>
           <c:cat>
             <c:strRef>
               <c:f>Sheet1!$A$2:$A$11</c:f>
@@ -464,7 +412,7 @@
                   <c:v>7.88</c:v>
                 </c:pt>
                 <c:pt idx="3">
-                  <c:v>8.4700000000000006</c:v>
+                  <c:v>8.47</c:v>
                 </c:pt>
                 <c:pt idx="4">
                   <c:v>8.99</c:v>
@@ -487,21 +435,7 @@
               </c:numCache>
             </c:numRef>
           </c:val>
-          <c:extLst>
-            <c:ext xmlns:c16="http://schemas.microsoft.com/office/drawing/2014/chart" uri="{C3380CC4-5D6E-409C-BE32-E72D297353CC}">
-              <c16:uniqueId val="{00000000-3865-8246-B023-CCC09D27C1E9}"/>
-            </c:ext>
-          </c:extLst>
         </c:ser>
-        <c:dLbls>
-          <c:showLegendKey val="0"/>
-          <c:showVal val="0"/>
-          <c:showCatName val="0"/>
-          <c:showSerName val="0"/>
-          <c:showPercent val="0"/>
-          <c:showBubbleSize val="0"/>
-        </c:dLbls>
-        <c:gapWidth val="150"/>
         <c:axId val="-2068027336"/>
         <c:axId val="-2113994440"/>
       </c:barChart>
@@ -512,7 +446,6 @@
         </c:scaling>
         <c:delete val="0"/>
         <c:axPos val="l"/>
-        <c:numFmt formatCode="General" sourceLinked="0"/>
         <c:majorTickMark val="out"/>
         <c:minorTickMark val="none"/>
         <c:tickLblPos val="nextTo"/>
@@ -523,7 +456,6 @@
             <a:pPr>
               <a:defRPr sz="1200"/>
             </a:pPr>
-            <a:endParaRPr lang="en-US"/>
           </a:p>
         </c:txPr>
         <c:crossAx val="-2113994440"/>
@@ -535,13 +467,10 @@
       </c:catAx>
       <c:valAx>
         <c:axId val="-2113994440"/>
-        <c:scaling>
-          <c:orientation val="minMax"/>
-        </c:scaling>
+        <c:scaling/>
         <c:delete val="0"/>
         <c:axPos val="b"/>
         <c:majorGridlines/>
-        <c:numFmt formatCode="General" sourceLinked="1"/>
         <c:majorTickMark val="out"/>
         <c:minorTickMark val="none"/>
         <c:tickLblPos val="nextTo"/>
@@ -552,17 +481,13 @@
             <a:pPr>
               <a:defRPr sz="1200"/>
             </a:pPr>
-            <a:endParaRPr lang="en-US"/>
           </a:p>
         </c:txPr>
         <c:crossAx val="-2068027336"/>
         <c:crosses val="autoZero"/>
-        <c:crossBetween val="between"/>
       </c:valAx>
     </c:plotArea>
-    <c:plotVisOnly val="1"/>
     <c:dispBlanksAs val="gap"/>
-    <c:showDLblsOverMax val="1"/>
   </c:chart>
   <c:txPr>
     <a:bodyPr/>
@@ -618,9 +543,10 @@
           <a:lstStyle/>
           <a:p>
             <a:r>
-              <a:rPr lang="en-US"/>
+              <a:rPr lang="en-US" smtClean="0"/>
               <a:t>Click to edit Master title style</a:t>
             </a:r>
+            <a:endParaRPr lang="en-US"/>
           </a:p>
         </p:txBody>
       </p:sp>
@@ -736,9 +662,10 @@
           </a:lstStyle>
           <a:p>
             <a:r>
-              <a:rPr lang="en-US"/>
+              <a:rPr lang="en-US" smtClean="0"/>
               <a:t>Click to edit Master subtitle style</a:t>
             </a:r>
+            <a:endParaRPr lang="en-US"/>
           </a:p>
         </p:txBody>
       </p:sp>
@@ -759,7 +686,7 @@
           <a:p>
             <a:fld id="{5BCAD085-E8A6-8845-BD4E-CB4CCA059FC4}" type="datetimeFigureOut">
               <a:rPr lang="en-US" smtClean="0"/>
-              <a:t>6/13/26</a:t>
+              <a:t>1/27/13</a:t>
             </a:fld>
             <a:endParaRPr lang="en-US"/>
           </a:p>
@@ -853,9 +780,10 @@
           <a:lstStyle/>
           <a:p>
             <a:r>
-              <a:rPr lang="en-US"/>
+              <a:rPr lang="en-US" smtClean="0"/>
               <a:t>Click to edit Master title style</a:t>
             </a:r>
+            <a:endParaRPr lang="en-US"/>
           </a:p>
         </p:txBody>
       </p:sp>
@@ -876,37 +804,38 @@
           <a:p>
             <a:pPr lvl="0"/>
             <a:r>
-              <a:rPr lang="en-US"/>
+              <a:rPr lang="en-US" smtClean="0"/>
               <a:t>Click to edit Master text styles</a:t>
             </a:r>
           </a:p>
           <a:p>
             <a:pPr lvl="1"/>
             <a:r>
-              <a:rPr lang="en-US"/>
+              <a:rPr lang="en-US" smtClean="0"/>
               <a:t>Second level</a:t>
             </a:r>
           </a:p>
           <a:p>
             <a:pPr lvl="2"/>
             <a:r>
-              <a:rPr lang="en-US"/>
+              <a:rPr lang="en-US" smtClean="0"/>
               <a:t>Third level</a:t>
             </a:r>
           </a:p>
           <a:p>
             <a:pPr lvl="3"/>
             <a:r>
-              <a:rPr lang="en-US"/>
+              <a:rPr lang="en-US" smtClean="0"/>
               <a:t>Fourth level</a:t>
             </a:r>
           </a:p>
           <a:p>
             <a:pPr lvl="4"/>
             <a:r>
-              <a:rPr lang="en-US"/>
+              <a:rPr lang="en-US" smtClean="0"/>
               <a:t>Fifth level</a:t>
             </a:r>
+            <a:endParaRPr lang="en-US"/>
           </a:p>
         </p:txBody>
       </p:sp>
@@ -927,7 +856,7 @@
           <a:p>
             <a:fld id="{5BCAD085-E8A6-8845-BD4E-CB4CCA059FC4}" type="datetimeFigureOut">
               <a:rPr lang="en-US" smtClean="0"/>
-              <a:t>6/13/26</a:t>
+              <a:t>1/27/13</a:t>
             </a:fld>
             <a:endParaRPr lang="en-US"/>
           </a:p>
@@ -1026,9 +955,10 @@
           <a:lstStyle/>
           <a:p>
             <a:r>
-              <a:rPr lang="en-US"/>
+              <a:rPr lang="en-US" smtClean="0"/>
               <a:t>Click to edit Master title style</a:t>
             </a:r>
+            <a:endParaRPr lang="en-US"/>
           </a:p>
         </p:txBody>
       </p:sp>
@@ -1054,37 +984,38 @@
           <a:p>
             <a:pPr lvl="0"/>
             <a:r>
-              <a:rPr lang="en-US"/>
+              <a:rPr lang="en-US" smtClean="0"/>
               <a:t>Click to edit Master text styles</a:t>
             </a:r>
           </a:p>
           <a:p>
             <a:pPr lvl="1"/>
             <a:r>
-              <a:rPr lang="en-US"/>
+              <a:rPr lang="en-US" smtClean="0"/>
               <a:t>Second level</a:t>
             </a:r>
           </a:p>
           <a:p>
             <a:pPr lvl="2"/>
             <a:r>
-              <a:rPr lang="en-US"/>
+              <a:rPr lang="en-US" smtClean="0"/>
               <a:t>Third level</a:t>
             </a:r>
           </a:p>
           <a:p>
             <a:pPr lvl="3"/>
             <a:r>
-              <a:rPr lang="en-US"/>
+              <a:rPr lang="en-US" smtClean="0"/>
               <a:t>Fourth level</a:t>
             </a:r>
           </a:p>
           <a:p>
             <a:pPr lvl="4"/>
             <a:r>
-              <a:rPr lang="en-US"/>
+              <a:rPr lang="en-US" smtClean="0"/>
               <a:t>Fifth level</a:t>
             </a:r>
+            <a:endParaRPr lang="en-US"/>
           </a:p>
         </p:txBody>
       </p:sp>
@@ -1105,7 +1036,7 @@
           <a:p>
             <a:fld id="{5BCAD085-E8A6-8845-BD4E-CB4CCA059FC4}" type="datetimeFigureOut">
               <a:rPr lang="en-US" smtClean="0"/>
-              <a:t>6/13/26</a:t>
+              <a:t>1/27/13</a:t>
             </a:fld>
             <a:endParaRPr lang="en-US"/>
           </a:p>
@@ -1199,9 +1130,10 @@
           <a:lstStyle/>
           <a:p>
             <a:r>
-              <a:rPr lang="en-US"/>
+              <a:rPr lang="en-US" smtClean="0"/>
               <a:t>Click to edit Master title style</a:t>
             </a:r>
+            <a:endParaRPr lang="en-US"/>
           </a:p>
         </p:txBody>
       </p:sp>
@@ -1222,37 +1154,38 @@
           <a:p>
             <a:pPr lvl="0"/>
             <a:r>
-              <a:rPr lang="en-US"/>
+              <a:rPr lang="en-US" smtClean="0"/>
               <a:t>Click to edit Master text styles</a:t>
             </a:r>
           </a:p>
           <a:p>
             <a:pPr lvl="1"/>
             <a:r>
-              <a:rPr lang="en-US"/>
+              <a:rPr lang="en-US" smtClean="0"/>
               <a:t>Second level</a:t>
             </a:r>
           </a:p>
           <a:p>
             <a:pPr lvl="2"/>
             <a:r>
-              <a:rPr lang="en-US"/>
+              <a:rPr lang="en-US" smtClean="0"/>
               <a:t>Third level</a:t>
             </a:r>
           </a:p>
           <a:p>
             <a:pPr lvl="3"/>
             <a:r>
-              <a:rPr lang="en-US"/>
+              <a:rPr lang="en-US" smtClean="0"/>
               <a:t>Fourth level</a:t>
             </a:r>
           </a:p>
           <a:p>
             <a:pPr lvl="4"/>
             <a:r>
-              <a:rPr lang="en-US"/>
+              <a:rPr lang="en-US" smtClean="0"/>
               <a:t>Fifth level</a:t>
             </a:r>
+            <a:endParaRPr lang="en-US"/>
           </a:p>
         </p:txBody>
       </p:sp>
@@ -1273,7 +1206,7 @@
           <a:p>
             <a:fld id="{5BCAD085-E8A6-8845-BD4E-CB4CCA059FC4}" type="datetimeFigureOut">
               <a:rPr lang="en-US" smtClean="0"/>
-              <a:t>6/13/26</a:t>
+              <a:t>1/27/13</a:t>
             </a:fld>
             <a:endParaRPr lang="en-US"/>
           </a:p>
@@ -1376,9 +1309,10 @@
           </a:lstStyle>
           <a:p>
             <a:r>
-              <a:rPr lang="en-US"/>
+              <a:rPr lang="en-US" smtClean="0"/>
               <a:t>Click to edit Master title style</a:t>
             </a:r>
+            <a:endParaRPr lang="en-US"/>
           </a:p>
         </p:txBody>
       </p:sp>
@@ -1495,7 +1429,7 @@
           <a:p>
             <a:pPr lvl="0"/>
             <a:r>
-              <a:rPr lang="en-US"/>
+              <a:rPr lang="en-US" smtClean="0"/>
               <a:t>Click to edit Master text styles</a:t>
             </a:r>
           </a:p>
@@ -1518,7 +1452,7 @@
           <a:p>
             <a:fld id="{5BCAD085-E8A6-8845-BD4E-CB4CCA059FC4}" type="datetimeFigureOut">
               <a:rPr lang="en-US" smtClean="0"/>
-              <a:t>6/13/26</a:t>
+              <a:t>1/27/13</a:t>
             </a:fld>
             <a:endParaRPr lang="en-US"/>
           </a:p>
@@ -1612,9 +1546,10 @@
           <a:lstStyle/>
           <a:p>
             <a:r>
-              <a:rPr lang="en-US"/>
+              <a:rPr lang="en-US" smtClean="0"/>
               <a:t>Click to edit Master title style</a:t>
             </a:r>
+            <a:endParaRPr lang="en-US"/>
           </a:p>
         </p:txBody>
       </p:sp>
@@ -1668,37 +1603,38 @@
           <a:p>
             <a:pPr lvl="0"/>
             <a:r>
-              <a:rPr lang="en-US"/>
+              <a:rPr lang="en-US" smtClean="0"/>
               <a:t>Click to edit Master text styles</a:t>
             </a:r>
           </a:p>
           <a:p>
             <a:pPr lvl="1"/>
             <a:r>
-              <a:rPr lang="en-US"/>
+              <a:rPr lang="en-US" smtClean="0"/>
               <a:t>Second level</a:t>
             </a:r>
           </a:p>
           <a:p>
             <a:pPr lvl="2"/>
             <a:r>
-              <a:rPr lang="en-US"/>
+              <a:rPr lang="en-US" smtClean="0"/>
               <a:t>Third level</a:t>
             </a:r>
           </a:p>
           <a:p>
             <a:pPr lvl="3"/>
             <a:r>
-              <a:rPr lang="en-US"/>
+              <a:rPr lang="en-US" smtClean="0"/>
               <a:t>Fourth level</a:t>
             </a:r>
           </a:p>
           <a:p>
             <a:pPr lvl="4"/>
             <a:r>
-              <a:rPr lang="en-US"/>
+              <a:rPr lang="en-US" smtClean="0"/>
               <a:t>Fifth level</a:t>
             </a:r>
+            <a:endParaRPr lang="en-US"/>
           </a:p>
         </p:txBody>
       </p:sp>
@@ -1752,37 +1688,38 @@
           <a:p>
             <a:pPr lvl="0"/>
             <a:r>
-              <a:rPr lang="en-US"/>
+              <a:rPr lang="en-US" smtClean="0"/>
               <a:t>Click to edit Master text styles</a:t>
             </a:r>
           </a:p>
           <a:p>
             <a:pPr lvl="1"/>
             <a:r>
-              <a:rPr lang="en-US"/>
+              <a:rPr lang="en-US" smtClean="0"/>
               <a:t>Second level</a:t>
             </a:r>
           </a:p>
           <a:p>
             <a:pPr lvl="2"/>
             <a:r>
-              <a:rPr lang="en-US"/>
+              <a:rPr lang="en-US" smtClean="0"/>
               <a:t>Third level</a:t>
             </a:r>
           </a:p>
           <a:p>
             <a:pPr lvl="3"/>
             <a:r>
-              <a:rPr lang="en-US"/>
+              <a:rPr lang="en-US" smtClean="0"/>
               <a:t>Fourth level</a:t>
             </a:r>
           </a:p>
           <a:p>
             <a:pPr lvl="4"/>
             <a:r>
-              <a:rPr lang="en-US"/>
+              <a:rPr lang="en-US" smtClean="0"/>
               <a:t>Fifth level</a:t>
             </a:r>
+            <a:endParaRPr lang="en-US"/>
           </a:p>
         </p:txBody>
       </p:sp>
@@ -1803,7 +1740,7 @@
           <a:p>
             <a:fld id="{5BCAD085-E8A6-8845-BD4E-CB4CCA059FC4}" type="datetimeFigureOut">
               <a:rPr lang="en-US" smtClean="0"/>
-              <a:t>6/13/26</a:t>
+              <a:t>1/27/13</a:t>
             </a:fld>
             <a:endParaRPr lang="en-US"/>
           </a:p>
@@ -1901,9 +1838,10 @@
           </a:lstStyle>
           <a:p>
             <a:r>
-              <a:rPr lang="en-US"/>
+              <a:rPr lang="en-US" smtClean="0"/>
               <a:t>Click to edit Master title style</a:t>
             </a:r>
+            <a:endParaRPr lang="en-US"/>
           </a:p>
         </p:txBody>
       </p:sp>
@@ -1966,7 +1904,7 @@
           <a:p>
             <a:pPr lvl="0"/>
             <a:r>
-              <a:rPr lang="en-US"/>
+              <a:rPr lang="en-US" smtClean="0"/>
               <a:t>Click to edit Master text styles</a:t>
             </a:r>
           </a:p>
@@ -2022,37 +1960,38 @@
           <a:p>
             <a:pPr lvl="0"/>
             <a:r>
-              <a:rPr lang="en-US"/>
+              <a:rPr lang="en-US" smtClean="0"/>
               <a:t>Click to edit Master text styles</a:t>
             </a:r>
           </a:p>
           <a:p>
             <a:pPr lvl="1"/>
             <a:r>
-              <a:rPr lang="en-US"/>
+              <a:rPr lang="en-US" smtClean="0"/>
               <a:t>Second level</a:t>
             </a:r>
           </a:p>
           <a:p>
             <a:pPr lvl="2"/>
             <a:r>
-              <a:rPr lang="en-US"/>
+              <a:rPr lang="en-US" smtClean="0"/>
               <a:t>Third level</a:t>
             </a:r>
           </a:p>
           <a:p>
             <a:pPr lvl="3"/>
             <a:r>
-              <a:rPr lang="en-US"/>
+              <a:rPr lang="en-US" smtClean="0"/>
               <a:t>Fourth level</a:t>
             </a:r>
           </a:p>
           <a:p>
             <a:pPr lvl="4"/>
             <a:r>
-              <a:rPr lang="en-US"/>
+              <a:rPr lang="en-US" smtClean="0"/>
               <a:t>Fifth level</a:t>
             </a:r>
+            <a:endParaRPr lang="en-US"/>
           </a:p>
         </p:txBody>
       </p:sp>
@@ -2115,7 +2054,7 @@
           <a:p>
             <a:pPr lvl="0"/>
             <a:r>
-              <a:rPr lang="en-US"/>
+              <a:rPr lang="en-US" smtClean="0"/>
               <a:t>Click to edit Master text styles</a:t>
             </a:r>
           </a:p>
@@ -2171,37 +2110,38 @@
           <a:p>
             <a:pPr lvl="0"/>
             <a:r>
-              <a:rPr lang="en-US"/>
+              <a:rPr lang="en-US" smtClean="0"/>
               <a:t>Click to edit Master text styles</a:t>
             </a:r>
           </a:p>
           <a:p>
             <a:pPr lvl="1"/>
             <a:r>
-              <a:rPr lang="en-US"/>
+              <a:rPr lang="en-US" smtClean="0"/>
               <a:t>Second level</a:t>
             </a:r>
           </a:p>
           <a:p>
             <a:pPr lvl="2"/>
             <a:r>
-              <a:rPr lang="en-US"/>
+              <a:rPr lang="en-US" smtClean="0"/>
               <a:t>Third level</a:t>
             </a:r>
           </a:p>
           <a:p>
             <a:pPr lvl="3"/>
             <a:r>
-              <a:rPr lang="en-US"/>
+              <a:rPr lang="en-US" smtClean="0"/>
               <a:t>Fourth level</a:t>
             </a:r>
           </a:p>
           <a:p>
             <a:pPr lvl="4"/>
             <a:r>
-              <a:rPr lang="en-US"/>
+              <a:rPr lang="en-US" smtClean="0"/>
               <a:t>Fifth level</a:t>
             </a:r>
+            <a:endParaRPr lang="en-US"/>
           </a:p>
         </p:txBody>
       </p:sp>
@@ -2222,7 +2162,7 @@
           <a:p>
             <a:fld id="{5BCAD085-E8A6-8845-BD4E-CB4CCA059FC4}" type="datetimeFigureOut">
               <a:rPr lang="en-US" smtClean="0"/>
-              <a:t>6/13/26</a:t>
+              <a:t>1/27/13</a:t>
             </a:fld>
             <a:endParaRPr lang="en-US"/>
           </a:p>
@@ -2316,9 +2256,10 @@
           <a:lstStyle/>
           <a:p>
             <a:r>
-              <a:rPr lang="en-US"/>
+              <a:rPr lang="en-US" smtClean="0"/>
               <a:t>Click to edit Master title style</a:t>
             </a:r>
+            <a:endParaRPr lang="en-US"/>
           </a:p>
         </p:txBody>
       </p:sp>
@@ -2339,7 +2280,7 @@
           <a:p>
             <a:fld id="{5BCAD085-E8A6-8845-BD4E-CB4CCA059FC4}" type="datetimeFigureOut">
               <a:rPr lang="en-US" smtClean="0"/>
-              <a:t>6/13/26</a:t>
+              <a:t>1/27/13</a:t>
             </a:fld>
             <a:endParaRPr lang="en-US"/>
           </a:p>
@@ -2434,7 +2375,7 @@
           <a:p>
             <a:fld id="{5BCAD085-E8A6-8845-BD4E-CB4CCA059FC4}" type="datetimeFigureOut">
               <a:rPr lang="en-US" smtClean="0"/>
-              <a:t>6/13/26</a:t>
+              <a:t>1/27/13</a:t>
             </a:fld>
             <a:endParaRPr lang="en-US"/>
           </a:p>
@@ -2537,9 +2478,10 @@
           </a:lstStyle>
           <a:p>
             <a:r>
-              <a:rPr lang="en-US"/>
+              <a:rPr lang="en-US" smtClean="0"/>
               <a:t>Click to edit Master title style</a:t>
             </a:r>
+            <a:endParaRPr lang="en-US"/>
           </a:p>
         </p:txBody>
       </p:sp>
@@ -2593,37 +2535,38 @@
           <a:p>
             <a:pPr lvl="0"/>
             <a:r>
-              <a:rPr lang="en-US"/>
+              <a:rPr lang="en-US" smtClean="0"/>
               <a:t>Click to edit Master text styles</a:t>
             </a:r>
           </a:p>
           <a:p>
             <a:pPr lvl="1"/>
             <a:r>
-              <a:rPr lang="en-US"/>
+              <a:rPr lang="en-US" smtClean="0"/>
               <a:t>Second level</a:t>
             </a:r>
           </a:p>
           <a:p>
             <a:pPr lvl="2"/>
             <a:r>
-              <a:rPr lang="en-US"/>
+              <a:rPr lang="en-US" smtClean="0"/>
               <a:t>Third level</a:t>
             </a:r>
           </a:p>
           <a:p>
             <a:pPr lvl="3"/>
             <a:r>
-              <a:rPr lang="en-US"/>
+              <a:rPr lang="en-US" smtClean="0"/>
               <a:t>Fourth level</a:t>
             </a:r>
           </a:p>
           <a:p>
             <a:pPr lvl="4"/>
             <a:r>
-              <a:rPr lang="en-US"/>
+              <a:rPr lang="en-US" smtClean="0"/>
               <a:t>Fifth level</a:t>
             </a:r>
+            <a:endParaRPr lang="en-US"/>
           </a:p>
         </p:txBody>
       </p:sp>
@@ -2686,7 +2629,7 @@
           <a:p>
             <a:pPr lvl="0"/>
             <a:r>
-              <a:rPr lang="en-US"/>
+              <a:rPr lang="en-US" smtClean="0"/>
               <a:t>Click to edit Master text styles</a:t>
             </a:r>
           </a:p>
@@ -2709,7 +2652,7 @@
           <a:p>
             <a:fld id="{5BCAD085-E8A6-8845-BD4E-CB4CCA059FC4}" type="datetimeFigureOut">
               <a:rPr lang="en-US" smtClean="0"/>
-              <a:t>6/13/26</a:t>
+              <a:t>1/27/13</a:t>
             </a:fld>
             <a:endParaRPr lang="en-US"/>
           </a:p>
@@ -2812,9 +2755,10 @@
           </a:lstStyle>
           <a:p>
             <a:r>
-              <a:rPr lang="en-US"/>
+              <a:rPr lang="en-US" smtClean="0"/>
               <a:t>Click to edit Master title style</a:t>
             </a:r>
+            <a:endParaRPr lang="en-US"/>
           </a:p>
         </p:txBody>
       </p:sp>
@@ -2938,7 +2882,7 @@
           <a:p>
             <a:pPr lvl="0"/>
             <a:r>
-              <a:rPr lang="en-US"/>
+              <a:rPr lang="en-US" smtClean="0"/>
               <a:t>Click to edit Master text styles</a:t>
             </a:r>
           </a:p>
@@ -2961,7 +2905,7 @@
           <a:p>
             <a:fld id="{5BCAD085-E8A6-8845-BD4E-CB4CCA059FC4}" type="datetimeFigureOut">
               <a:rPr lang="en-US" smtClean="0"/>
-              <a:t>6/13/26</a:t>
+              <a:t>1/27/13</a:t>
             </a:fld>
             <a:endParaRPr lang="en-US"/>
           </a:p>
@@ -3070,9 +3014,10 @@
           <a:lstStyle/>
           <a:p>
             <a:r>
-              <a:rPr lang="en-US"/>
+              <a:rPr lang="en-US" smtClean="0"/>
               <a:t>Click to edit Master title style</a:t>
             </a:r>
+            <a:endParaRPr lang="en-US"/>
           </a:p>
         </p:txBody>
       </p:sp>
@@ -3103,37 +3048,38 @@
           <a:p>
             <a:pPr lvl="0"/>
             <a:r>
-              <a:rPr lang="en-US"/>
+              <a:rPr lang="en-US" smtClean="0"/>
               <a:t>Click to edit Master text styles</a:t>
             </a:r>
           </a:p>
           <a:p>
             <a:pPr lvl="1"/>
             <a:r>
-              <a:rPr lang="en-US"/>
+              <a:rPr lang="en-US" smtClean="0"/>
               <a:t>Second level</a:t>
             </a:r>
           </a:p>
           <a:p>
             <a:pPr lvl="2"/>
             <a:r>
-              <a:rPr lang="en-US"/>
+              <a:rPr lang="en-US" smtClean="0"/>
               <a:t>Third level</a:t>
             </a:r>
           </a:p>
           <a:p>
             <a:pPr lvl="3"/>
             <a:r>
-              <a:rPr lang="en-US"/>
+              <a:rPr lang="en-US" smtClean="0"/>
               <a:t>Fourth level</a:t>
             </a:r>
           </a:p>
           <a:p>
             <a:pPr lvl="4"/>
             <a:r>
-              <a:rPr lang="en-US"/>
+              <a:rPr lang="en-US" smtClean="0"/>
               <a:t>Fifth level</a:t>
             </a:r>
+            <a:endParaRPr lang="en-US"/>
           </a:p>
         </p:txBody>
       </p:sp>
@@ -3172,7 +3118,7 @@
           <a:p>
             <a:fld id="{5BCAD085-E8A6-8845-BD4E-CB4CCA059FC4}" type="datetimeFigureOut">
               <a:rPr lang="en-US" smtClean="0"/>
-              <a:t>6/13/26</a:t>
+              <a:t>1/27/13</a:t>
             </a:fld>
             <a:endParaRPr lang="en-US"/>
           </a:p>
@@ -3531,7 +3477,7 @@
 </file>
 
 <file path=ppt/slides/slide1.xml><?xml version="1.0" encoding="utf-8"?>
-<p:sld xmlns:a="http://schemas.openxmlformats.org/drawingml/2006/main" xmlns:r="http://schemas.openxmlformats.org/officeDocument/2006/relationships" xmlns:p="http://schemas.openxmlformats.org/presentationml/2006/main">
+<p:sld xmlns:a="http://schemas.openxmlformats.org/drawingml/2006/main" xmlns:p="http://schemas.openxmlformats.org/presentationml/2006/main" xmlns:r="http://schemas.openxmlformats.org/officeDocument/2006/relationships">
   <p:cSld>
     <p:spTree>
       <p:nvGrpSpPr>
@@ -3539,14 +3485,7 @@
         <p:cNvGrpSpPr/>
         <p:nvPr/>
       </p:nvGrpSpPr>
-      <p:grpSpPr>
-        <a:xfrm>
-          <a:off x="0" y="0"/>
-          <a:ext cx="0" cy="0"/>
-          <a:chOff x="0" y="0"/>
-          <a:chExt cx="0" cy="0"/>
-        </a:xfrm>
-      </p:grpSpPr>
+      <p:grpSpPr/>
       <p:sp>
         <p:nvSpPr>
           <p:cNvPr id="2" name="TextBox 1"/>
@@ -3658,7 +3597,7 @@
 </file>
 
 <file path=ppt/slides/slide10.xml><?xml version="1.0" encoding="utf-8"?>
-<p:sld xmlns:a="http://schemas.openxmlformats.org/drawingml/2006/main" xmlns:r="http://schemas.openxmlformats.org/officeDocument/2006/relationships" xmlns:p="http://schemas.openxmlformats.org/presentationml/2006/main">
+<p:sld xmlns:a="http://schemas.openxmlformats.org/drawingml/2006/main" xmlns:p="http://schemas.openxmlformats.org/presentationml/2006/main" xmlns:r="http://schemas.openxmlformats.org/officeDocument/2006/relationships">
   <p:cSld>
     <p:spTree>
       <p:nvGrpSpPr>
@@ -3666,14 +3605,7 @@
         <p:cNvGrpSpPr/>
         <p:nvPr/>
       </p:nvGrpSpPr>
-      <p:grpSpPr>
-        <a:xfrm>
-          <a:off x="0" y="0"/>
-          <a:ext cx="0" cy="0"/>
-          <a:chOff x="0" y="0"/>
-          <a:chExt cx="0" cy="0"/>
-        </a:xfrm>
-      </p:grpSpPr>
+      <p:grpSpPr/>
       <p:sp>
         <p:nvSpPr>
           <p:cNvPr id="2" name="TextBox 1"/>
@@ -3794,27 +3726,9 @@
                 <a:tableStyleId>{5C22544A-7EE6-4342-B048-85BDC9FD1C3A}</a:tableStyleId>
               </a:tblPr>
               <a:tblGrid>
-                <a:gridCol w="2560320">
-                  <a:extLst>
-                    <a:ext uri="{9D8B030D-6E8A-4147-A177-3AD203B41FA5}">
-                      <a16:colId xmlns:a16="http://schemas.microsoft.com/office/drawing/2014/main" val="20000"/>
-                    </a:ext>
-                  </a:extLst>
-                </a:gridCol>
-                <a:gridCol w="3840480">
-                  <a:extLst>
-                    <a:ext uri="{9D8B030D-6E8A-4147-A177-3AD203B41FA5}">
-                      <a16:colId xmlns:a16="http://schemas.microsoft.com/office/drawing/2014/main" val="20001"/>
-                    </a:ext>
-                  </a:extLst>
-                </a:gridCol>
-                <a:gridCol w="4297680">
-                  <a:extLst>
-                    <a:ext uri="{9D8B030D-6E8A-4147-A177-3AD203B41FA5}">
-                      <a16:colId xmlns:a16="http://schemas.microsoft.com/office/drawing/2014/main" val="20002"/>
-                    </a:ext>
-                  </a:extLst>
-                </a:gridCol>
+                <a:gridCol w="2560320"/>
+                <a:gridCol w="3840480"/>
+                <a:gridCol w="4297680"/>
               </a:tblGrid>
               <a:tr h="365760">
                 <a:tc>
@@ -3856,11 +3770,6 @@
                   </a:txBody>
                   <a:tcPr/>
                 </a:tc>
-                <a:extLst>
-                  <a:ext uri="{0D108BD9-81ED-4DB2-BD59-A6C34878D82A}">
-                    <a16:rowId xmlns:a16="http://schemas.microsoft.com/office/drawing/2014/main" val="10000"/>
-                  </a:ext>
-                </a:extLst>
               </a:tr>
               <a:tr h="365760">
                 <a:tc>
@@ -3902,11 +3811,6 @@
                   </a:txBody>
                   <a:tcPr/>
                 </a:tc>
-                <a:extLst>
-                  <a:ext uri="{0D108BD9-81ED-4DB2-BD59-A6C34878D82A}">
-                    <a16:rowId xmlns:a16="http://schemas.microsoft.com/office/drawing/2014/main" val="10001"/>
-                  </a:ext>
-                </a:extLst>
               </a:tr>
               <a:tr h="365760">
                 <a:tc>
@@ -3948,11 +3852,6 @@
                   </a:txBody>
                   <a:tcPr/>
                 </a:tc>
-                <a:extLst>
-                  <a:ext uri="{0D108BD9-81ED-4DB2-BD59-A6C34878D82A}">
-                    <a16:rowId xmlns:a16="http://schemas.microsoft.com/office/drawing/2014/main" val="10002"/>
-                  </a:ext>
-                </a:extLst>
               </a:tr>
               <a:tr h="365760">
                 <a:tc>
@@ -3994,11 +3893,6 @@
                   </a:txBody>
                   <a:tcPr/>
                 </a:tc>
-                <a:extLst>
-                  <a:ext uri="{0D108BD9-81ED-4DB2-BD59-A6C34878D82A}">
-                    <a16:rowId xmlns:a16="http://schemas.microsoft.com/office/drawing/2014/main" val="10003"/>
-                  </a:ext>
-                </a:extLst>
               </a:tr>
             </a:tbl>
           </a:graphicData>
@@ -4013,7 +3907,7 @@
 </file>
 
 <file path=ppt/slides/slide11.xml><?xml version="1.0" encoding="utf-8"?>
-<p:sld xmlns:a="http://schemas.openxmlformats.org/drawingml/2006/main" xmlns:r="http://schemas.openxmlformats.org/officeDocument/2006/relationships" xmlns:p="http://schemas.openxmlformats.org/presentationml/2006/main">
+<p:sld xmlns:a="http://schemas.openxmlformats.org/drawingml/2006/main" xmlns:p="http://schemas.openxmlformats.org/presentationml/2006/main" xmlns:r="http://schemas.openxmlformats.org/officeDocument/2006/relationships">
   <p:cSld>
     <p:spTree>
       <p:nvGrpSpPr>
@@ -4021,14 +3915,7 @@
         <p:cNvGrpSpPr/>
         <p:nvPr/>
       </p:nvGrpSpPr>
-      <p:grpSpPr>
-        <a:xfrm>
-          <a:off x="0" y="0"/>
-          <a:ext cx="0" cy="0"/>
-          <a:chOff x="0" y="0"/>
-          <a:chExt cx="0" cy="0"/>
-        </a:xfrm>
-      </p:grpSpPr>
+      <p:grpSpPr/>
       <p:sp>
         <p:nvSpPr>
           <p:cNvPr id="2" name="TextBox 1"/>
@@ -4134,11 +4021,14 @@
                 <a:spcPts val="800"/>
               </a:spcAft>
             </a:pPr>
-            <a:endParaRPr sz="2400">
-              <a:solidFill>
-                <a:srgbClr val="212121"/>
-              </a:solidFill>
-            </a:endParaRPr>
+            <a:r>
+              <a:rPr sz="2400">
+                <a:solidFill>
+                  <a:srgbClr val="212121"/>
+                </a:solidFill>
+              </a:rPr>
+              <a:t/>
+            </a:r>
           </a:p>
           <a:p>
             <a:pPr>
@@ -4166,7 +4056,7 @@
 </file>
 
 <file path=ppt/slides/slide12.xml><?xml version="1.0" encoding="utf-8"?>
-<p:sld xmlns:a="http://schemas.openxmlformats.org/drawingml/2006/main" xmlns:r="http://schemas.openxmlformats.org/officeDocument/2006/relationships" xmlns:p="http://schemas.openxmlformats.org/presentationml/2006/main">
+<p:sld xmlns:a="http://schemas.openxmlformats.org/drawingml/2006/main" xmlns:p="http://schemas.openxmlformats.org/presentationml/2006/main" xmlns:r="http://schemas.openxmlformats.org/officeDocument/2006/relationships">
   <p:cSld>
     <p:spTree>
       <p:nvGrpSpPr>
@@ -4174,14 +4064,7 @@
         <p:cNvGrpSpPr/>
         <p:nvPr/>
       </p:nvGrpSpPr>
-      <p:grpSpPr>
-        <a:xfrm>
-          <a:off x="0" y="0"/>
-          <a:ext cx="0" cy="0"/>
-          <a:chOff x="0" y="0"/>
-          <a:chExt cx="0" cy="0"/>
-        </a:xfrm>
-      </p:grpSpPr>
+      <p:grpSpPr/>
       <p:sp>
         <p:nvSpPr>
           <p:cNvPr id="2" name="TextBox 1"/>
@@ -4229,7 +4112,7 @@
         </p:xfrm>
         <a:graphic>
           <a:graphicData uri="http://schemas.openxmlformats.org/drawingml/2006/chart">
-            <c:chart xmlns:c="http://schemas.openxmlformats.org/drawingml/2006/chart" xmlns:r="http://schemas.openxmlformats.org/officeDocument/2006/relationships" r:id="rId2"/>
+            <c:chart xmlns:c="http://schemas.openxmlformats.org/drawingml/2006/chart" r:id="rId2"/>
           </a:graphicData>
         </a:graphic>
       </p:graphicFrame>
@@ -4280,7 +4163,7 @@
 </file>
 
 <file path=ppt/slides/slide13.xml><?xml version="1.0" encoding="utf-8"?>
-<p:sld xmlns:a="http://schemas.openxmlformats.org/drawingml/2006/main" xmlns:r="http://schemas.openxmlformats.org/officeDocument/2006/relationships" xmlns:p="http://schemas.openxmlformats.org/presentationml/2006/main">
+<p:sld xmlns:a="http://schemas.openxmlformats.org/drawingml/2006/main" xmlns:p="http://schemas.openxmlformats.org/presentationml/2006/main" xmlns:r="http://schemas.openxmlformats.org/officeDocument/2006/relationships">
   <p:cSld>
     <p:spTree>
       <p:nvGrpSpPr>
@@ -4288,14 +4171,7 @@
         <p:cNvGrpSpPr/>
         <p:nvPr/>
       </p:nvGrpSpPr>
-      <p:grpSpPr>
-        <a:xfrm>
-          <a:off x="0" y="0"/>
-          <a:ext cx="0" cy="0"/>
-          <a:chOff x="0" y="0"/>
-          <a:chExt cx="0" cy="0"/>
-        </a:xfrm>
-      </p:grpSpPr>
+      <p:grpSpPr/>
       <p:sp>
         <p:nvSpPr>
           <p:cNvPr id="2" name="TextBox 1"/>
@@ -4343,7 +4219,7 @@
         </p:xfrm>
         <a:graphic>
           <a:graphicData uri="http://schemas.openxmlformats.org/drawingml/2006/chart">
-            <c:chart xmlns:c="http://schemas.openxmlformats.org/drawingml/2006/chart" xmlns:r="http://schemas.openxmlformats.org/officeDocument/2006/relationships" r:id="rId2"/>
+            <c:chart xmlns:c="http://schemas.openxmlformats.org/drawingml/2006/chart" r:id="rId2"/>
           </a:graphicData>
         </a:graphic>
       </p:graphicFrame>
@@ -4394,7 +4270,7 @@
 </file>
 
 <file path=ppt/slides/slide14.xml><?xml version="1.0" encoding="utf-8"?>
-<p:sld xmlns:a="http://schemas.openxmlformats.org/drawingml/2006/main" xmlns:r="http://schemas.openxmlformats.org/officeDocument/2006/relationships" xmlns:p="http://schemas.openxmlformats.org/presentationml/2006/main">
+<p:sld xmlns:a="http://schemas.openxmlformats.org/drawingml/2006/main" xmlns:p="http://schemas.openxmlformats.org/presentationml/2006/main" xmlns:r="http://schemas.openxmlformats.org/officeDocument/2006/relationships">
   <p:cSld>
     <p:spTree>
       <p:nvGrpSpPr>
@@ -4402,14 +4278,7 @@
         <p:cNvGrpSpPr/>
         <p:nvPr/>
       </p:nvGrpSpPr>
-      <p:grpSpPr>
-        <a:xfrm>
-          <a:off x="0" y="0"/>
-          <a:ext cx="0" cy="0"/>
-          <a:chOff x="0" y="0"/>
-          <a:chExt cx="0" cy="0"/>
-        </a:xfrm>
-      </p:grpSpPr>
+      <p:grpSpPr/>
       <p:sp>
         <p:nvSpPr>
           <p:cNvPr id="2" name="TextBox 1"/>
@@ -4500,11 +4369,14 @@
                 <a:spcPts val="800"/>
               </a:spcAft>
             </a:pPr>
-            <a:endParaRPr sz="2400">
-              <a:solidFill>
-                <a:srgbClr val="212121"/>
-              </a:solidFill>
-            </a:endParaRPr>
+            <a:r>
+              <a:rPr sz="2400">
+                <a:solidFill>
+                  <a:srgbClr val="212121"/>
+                </a:solidFill>
+              </a:rPr>
+              <a:t/>
+            </a:r>
           </a:p>
           <a:p>
             <a:pPr>
@@ -4562,7 +4434,7 @@
 </file>
 
 <file path=ppt/slides/slide15.xml><?xml version="1.0" encoding="utf-8"?>
-<p:sld xmlns:a="http://schemas.openxmlformats.org/drawingml/2006/main" xmlns:r="http://schemas.openxmlformats.org/officeDocument/2006/relationships" xmlns:p="http://schemas.openxmlformats.org/presentationml/2006/main">
+<p:sld xmlns:a="http://schemas.openxmlformats.org/drawingml/2006/main" xmlns:p="http://schemas.openxmlformats.org/presentationml/2006/main" xmlns:r="http://schemas.openxmlformats.org/officeDocument/2006/relationships">
   <p:cSld>
     <p:spTree>
       <p:nvGrpSpPr>
@@ -4570,14 +4442,7 @@
         <p:cNvGrpSpPr/>
         <p:nvPr/>
       </p:nvGrpSpPr>
-      <p:grpSpPr>
-        <a:xfrm>
-          <a:off x="0" y="0"/>
-          <a:ext cx="0" cy="0"/>
-          <a:chOff x="0" y="0"/>
-          <a:chExt cx="0" cy="0"/>
-        </a:xfrm>
-      </p:grpSpPr>
+      <p:grpSpPr/>
       <p:sp>
         <p:nvSpPr>
           <p:cNvPr id="2" name="TextBox 1"/>
@@ -4800,7 +4665,7 @@
 </file>
 
 <file path=ppt/slides/slide16.xml><?xml version="1.0" encoding="utf-8"?>
-<p:sld xmlns:a="http://schemas.openxmlformats.org/drawingml/2006/main" xmlns:r="http://schemas.openxmlformats.org/officeDocument/2006/relationships" xmlns:p="http://schemas.openxmlformats.org/presentationml/2006/main">
+<p:sld xmlns:a="http://schemas.openxmlformats.org/drawingml/2006/main" xmlns:p="http://schemas.openxmlformats.org/presentationml/2006/main" xmlns:r="http://schemas.openxmlformats.org/officeDocument/2006/relationships">
   <p:cSld>
     <p:spTree>
       <p:nvGrpSpPr>
@@ -4808,14 +4673,7 @@
         <p:cNvGrpSpPr/>
         <p:nvPr/>
       </p:nvGrpSpPr>
-      <p:grpSpPr>
-        <a:xfrm>
-          <a:off x="0" y="0"/>
-          <a:ext cx="0" cy="0"/>
-          <a:chOff x="0" y="0"/>
-          <a:chExt cx="0" cy="0"/>
-        </a:xfrm>
-      </p:grpSpPr>
+      <p:grpSpPr/>
       <p:sp>
         <p:nvSpPr>
           <p:cNvPr id="2" name="TextBox 1"/>
@@ -4906,11 +4764,14 @@
                 <a:spcPts val="800"/>
               </a:spcAft>
             </a:pPr>
-            <a:endParaRPr sz="2600">
-              <a:solidFill>
-                <a:srgbClr val="212121"/>
-              </a:solidFill>
-            </a:endParaRPr>
+            <a:r>
+              <a:rPr sz="2600">
+                <a:solidFill>
+                  <a:srgbClr val="212121"/>
+                </a:solidFill>
+              </a:rPr>
+              <a:t/>
+            </a:r>
           </a:p>
           <a:p>
             <a:pPr>
@@ -4938,7 +4799,7 @@
 </file>
 
 <file path=ppt/slides/slide17.xml><?xml version="1.0" encoding="utf-8"?>
-<p:sld xmlns:a="http://schemas.openxmlformats.org/drawingml/2006/main" xmlns:r="http://schemas.openxmlformats.org/officeDocument/2006/relationships" xmlns:p="http://schemas.openxmlformats.org/presentationml/2006/main">
+<p:sld xmlns:a="http://schemas.openxmlformats.org/drawingml/2006/main" xmlns:p="http://schemas.openxmlformats.org/presentationml/2006/main" xmlns:r="http://schemas.openxmlformats.org/officeDocument/2006/relationships">
   <p:cSld>
     <p:spTree>
       <p:nvGrpSpPr>
@@ -4946,14 +4807,7 @@
         <p:cNvGrpSpPr/>
         <p:nvPr/>
       </p:nvGrpSpPr>
-      <p:grpSpPr>
-        <a:xfrm>
-          <a:off x="0" y="0"/>
-          <a:ext cx="0" cy="0"/>
-          <a:chOff x="0" y="0"/>
-          <a:chExt cx="0" cy="0"/>
-        </a:xfrm>
-      </p:grpSpPr>
+      <p:grpSpPr/>
       <p:sp>
         <p:nvSpPr>
           <p:cNvPr id="2" name="TextBox 1"/>
@@ -5059,24 +4913,27 @@
                 <a:spcPts val="800"/>
               </a:spcAft>
             </a:pPr>
-            <a:endParaRPr sz="2400">
-              <a:solidFill>
-                <a:srgbClr val="212121"/>
-              </a:solidFill>
-            </a:endParaRPr>
-          </a:p>
-          <a:p>
-            <a:pPr>
-              <a:spcAft>
-                <a:spcPts val="800"/>
-              </a:spcAft>
-            </a:pPr>
             <a:r>
               <a:rPr sz="2400">
                 <a:solidFill>
                   <a:srgbClr val="212121"/>
                 </a:solidFill>
               </a:rPr>
+              <a:t/>
+            </a:r>
+          </a:p>
+          <a:p>
+            <a:pPr>
+              <a:spcAft>
+                <a:spcPts val="800"/>
+              </a:spcAft>
+            </a:pPr>
+            <a:r>
+              <a:rPr sz="2400">
+                <a:solidFill>
+                  <a:srgbClr val="212121"/>
+                </a:solidFill>
+              </a:rPr>
               <a:t>“Program testing can be used to show the presence of bugs, but never to show their absence.” — E. W. Dijkstra, 1970</a:t>
             </a:r>
           </a:p>
@@ -5086,11 +4943,14 @@
                 <a:spcPts val="800"/>
               </a:spcAft>
             </a:pPr>
-            <a:endParaRPr sz="2400">
-              <a:solidFill>
-                <a:srgbClr val="212121"/>
-              </a:solidFill>
-            </a:endParaRPr>
+            <a:r>
+              <a:rPr sz="2400">
+                <a:solidFill>
+                  <a:srgbClr val="212121"/>
+                </a:solidFill>
+              </a:rPr>
+              <a:t/>
+            </a:r>
           </a:p>
           <a:p>
             <a:pPr>
@@ -5118,7 +4978,7 @@
 </file>
 
 <file path=ppt/slides/slide18.xml><?xml version="1.0" encoding="utf-8"?>
-<p:sld xmlns:a="http://schemas.openxmlformats.org/drawingml/2006/main" xmlns:r="http://schemas.openxmlformats.org/officeDocument/2006/relationships" xmlns:p="http://schemas.openxmlformats.org/presentationml/2006/main">
+<p:sld xmlns:a="http://schemas.openxmlformats.org/drawingml/2006/main" xmlns:p="http://schemas.openxmlformats.org/presentationml/2006/main" xmlns:r="http://schemas.openxmlformats.org/officeDocument/2006/relationships">
   <p:cSld>
     <p:spTree>
       <p:nvGrpSpPr>
@@ -5126,14 +4986,7 @@
         <p:cNvGrpSpPr/>
         <p:nvPr/>
       </p:nvGrpSpPr>
-      <p:grpSpPr>
-        <a:xfrm>
-          <a:off x="0" y="0"/>
-          <a:ext cx="0" cy="0"/>
-          <a:chOff x="0" y="0"/>
-          <a:chExt cx="0" cy="0"/>
-        </a:xfrm>
-      </p:grpSpPr>
+      <p:grpSpPr/>
       <p:sp>
         <p:nvSpPr>
           <p:cNvPr id="2" name="TextBox 1"/>
@@ -5209,24 +5062,27 @@
                 <a:spcPts val="800"/>
               </a:spcAft>
             </a:pPr>
-            <a:endParaRPr sz="2600">
-              <a:solidFill>
-                <a:srgbClr val="212121"/>
-              </a:solidFill>
-            </a:endParaRPr>
-          </a:p>
-          <a:p>
-            <a:pPr>
-              <a:spcAft>
-                <a:spcPts val="800"/>
-              </a:spcAft>
-            </a:pPr>
             <a:r>
               <a:rPr sz="2600">
                 <a:solidFill>
                   <a:srgbClr val="212121"/>
                 </a:solidFill>
               </a:rPr>
+              <a:t/>
+            </a:r>
+          </a:p>
+          <a:p>
+            <a:pPr>
+              <a:spcAft>
+                <a:spcPts val="800"/>
+              </a:spcAft>
+            </a:pPr>
+            <a:r>
+              <a:rPr sz="2600">
+                <a:solidFill>
+                  <a:srgbClr val="212121"/>
+                </a:solidFill>
+              </a:rPr>
               <a:t>Can the program reach a state where the property fails?</a:t>
             </a:r>
           </a:p>
@@ -5236,11 +5092,14 @@
                 <a:spcPts val="800"/>
               </a:spcAft>
             </a:pPr>
-            <a:endParaRPr sz="2600">
-              <a:solidFill>
-                <a:srgbClr val="212121"/>
-              </a:solidFill>
-            </a:endParaRPr>
+            <a:r>
+              <a:rPr sz="2600">
+                <a:solidFill>
+                  <a:srgbClr val="212121"/>
+                </a:solidFill>
+              </a:rPr>
+              <a:t/>
+            </a:r>
           </a:p>
           <a:p>
             <a:pPr lvl="1">
@@ -5278,11 +5137,14 @@
                 <a:spcPts val="800"/>
               </a:spcAft>
             </a:pPr>
-            <a:endParaRPr sz="2400">
-              <a:solidFill>
-                <a:srgbClr val="212121"/>
-              </a:solidFill>
-            </a:endParaRPr>
+            <a:r>
+              <a:rPr sz="2600">
+                <a:solidFill>
+                  <a:srgbClr val="212121"/>
+                </a:solidFill>
+              </a:rPr>
+              <a:t/>
+            </a:r>
           </a:p>
           <a:p>
             <a:pPr>
@@ -5310,7 +5172,7 @@
 </file>
 
 <file path=ppt/slides/slide19.xml><?xml version="1.0" encoding="utf-8"?>
-<p:sld xmlns:a="http://schemas.openxmlformats.org/drawingml/2006/main" xmlns:r="http://schemas.openxmlformats.org/officeDocument/2006/relationships" xmlns:p="http://schemas.openxmlformats.org/presentationml/2006/main">
+<p:sld xmlns:a="http://schemas.openxmlformats.org/drawingml/2006/main" xmlns:p="http://schemas.openxmlformats.org/presentationml/2006/main" xmlns:r="http://schemas.openxmlformats.org/officeDocument/2006/relationships">
   <p:cSld>
     <p:spTree>
       <p:nvGrpSpPr>
@@ -5318,14 +5180,7 @@
         <p:cNvGrpSpPr/>
         <p:nvPr/>
       </p:nvGrpSpPr>
-      <p:grpSpPr>
-        <a:xfrm>
-          <a:off x="0" y="0"/>
-          <a:ext cx="0" cy="0"/>
-          <a:chOff x="0" y="0"/>
-          <a:chExt cx="0" cy="0"/>
-        </a:xfrm>
-      </p:grpSpPr>
+      <p:grpSpPr/>
       <p:sp>
         <p:nvSpPr>
           <p:cNvPr id="2" name="TextBox 1"/>
@@ -5446,11 +5301,14 @@
                 <a:spcPts val="800"/>
               </a:spcAft>
             </a:pPr>
-            <a:endParaRPr sz="2200">
-              <a:solidFill>
-                <a:srgbClr val="212121"/>
-              </a:solidFill>
-            </a:endParaRPr>
+            <a:r>
+              <a:rPr sz="2400">
+                <a:solidFill>
+                  <a:srgbClr val="212121"/>
+                </a:solidFill>
+              </a:rPr>
+              <a:t/>
+            </a:r>
           </a:p>
           <a:p>
             <a:pPr>
@@ -5508,7 +5366,7 @@
 </file>
 
 <file path=ppt/slides/slide2.xml><?xml version="1.0" encoding="utf-8"?>
-<p:sld xmlns:a="http://schemas.openxmlformats.org/drawingml/2006/main" xmlns:r="http://schemas.openxmlformats.org/officeDocument/2006/relationships" xmlns:p="http://schemas.openxmlformats.org/presentationml/2006/main">
+<p:sld xmlns:a="http://schemas.openxmlformats.org/drawingml/2006/main" xmlns:p="http://schemas.openxmlformats.org/presentationml/2006/main" xmlns:r="http://schemas.openxmlformats.org/officeDocument/2006/relationships">
   <p:cSld>
     <p:spTree>
       <p:nvGrpSpPr>
@@ -5516,14 +5374,7 @@
         <p:cNvGrpSpPr/>
         <p:nvPr/>
       </p:nvGrpSpPr>
-      <p:grpSpPr>
-        <a:xfrm>
-          <a:off x="0" y="0"/>
-          <a:ext cx="0" cy="0"/>
-          <a:chOff x="0" y="0"/>
-          <a:chExt cx="0" cy="0"/>
-        </a:xfrm>
-      </p:grpSpPr>
+      <p:grpSpPr/>
       <p:sp>
         <p:nvSpPr>
           <p:cNvPr id="2" name="TextBox 1"/>
@@ -5567,7 +5418,7 @@
         </p:nvGraphicFramePr>
         <p:xfrm>
           <a:off x="731520" y="1371600"/>
-          <a:ext cx="10698480" cy="3962400"/>
+          <a:ext cx="10698480" cy="3657600"/>
         </p:xfrm>
         <a:graphic>
           <a:graphicData uri="http://schemas.openxmlformats.org/drawingml/2006/table">
@@ -5576,20 +5427,8 @@
                 <a:tableStyleId>{5C22544A-7EE6-4342-B048-85BDC9FD1C3A}</a:tableStyleId>
               </a:tblPr>
               <a:tblGrid>
-                <a:gridCol w="1463040">
-                  <a:extLst>
-                    <a:ext uri="{9D8B030D-6E8A-4147-A177-3AD203B41FA5}">
-                      <a16:colId xmlns:a16="http://schemas.microsoft.com/office/drawing/2014/main" val="20000"/>
-                    </a:ext>
-                  </a:extLst>
-                </a:gridCol>
-                <a:gridCol w="9235440">
-                  <a:extLst>
-                    <a:ext uri="{9D8B030D-6E8A-4147-A177-3AD203B41FA5}">
-                      <a16:colId xmlns:a16="http://schemas.microsoft.com/office/drawing/2014/main" val="20001"/>
-                    </a:ext>
-                  </a:extLst>
-                </a:gridCol>
+                <a:gridCol w="1463040"/>
+                <a:gridCol w="9235440"/>
               </a:tblGrid>
               <a:tr h="365760">
                 <a:tc>
@@ -5618,11 +5457,6 @@
                   </a:txBody>
                   <a:tcPr/>
                 </a:tc>
-                <a:extLst>
-                  <a:ext uri="{0D108BD9-81ED-4DB2-BD59-A6C34878D82A}">
-                    <a16:rowId xmlns:a16="http://schemas.microsoft.com/office/drawing/2014/main" val="10000"/>
-                  </a:ext>
-                </a:extLst>
               </a:tr>
               <a:tr h="365760">
                 <a:tc>
@@ -5651,11 +5485,6 @@
                   </a:txBody>
                   <a:tcPr/>
                 </a:tc>
-                <a:extLst>
-                  <a:ext uri="{0D108BD9-81ED-4DB2-BD59-A6C34878D82A}">
-                    <a16:rowId xmlns:a16="http://schemas.microsoft.com/office/drawing/2014/main" val="10001"/>
-                  </a:ext>
-                </a:extLst>
               </a:tr>
               <a:tr h="365760">
                 <a:tc>
@@ -5684,11 +5513,6 @@
                   </a:txBody>
                   <a:tcPr/>
                 </a:tc>
-                <a:extLst>
-                  <a:ext uri="{0D108BD9-81ED-4DB2-BD59-A6C34878D82A}">
-                    <a16:rowId xmlns:a16="http://schemas.microsoft.com/office/drawing/2014/main" val="10002"/>
-                  </a:ext>
-                </a:extLst>
               </a:tr>
               <a:tr h="365760">
                 <a:tc>
@@ -5717,11 +5541,6 @@
                   </a:txBody>
                   <a:tcPr/>
                 </a:tc>
-                <a:extLst>
-                  <a:ext uri="{0D108BD9-81ED-4DB2-BD59-A6C34878D82A}">
-                    <a16:rowId xmlns:a16="http://schemas.microsoft.com/office/drawing/2014/main" val="10003"/>
-                  </a:ext>
-                </a:extLst>
               </a:tr>
               <a:tr h="365760">
                 <a:tc>
@@ -5750,11 +5569,6 @@
                   </a:txBody>
                   <a:tcPr/>
                 </a:tc>
-                <a:extLst>
-                  <a:ext uri="{0D108BD9-81ED-4DB2-BD59-A6C34878D82A}">
-                    <a16:rowId xmlns:a16="http://schemas.microsoft.com/office/drawing/2014/main" val="10004"/>
-                  </a:ext>
-                </a:extLst>
               </a:tr>
               <a:tr h="365760">
                 <a:tc>
@@ -5783,11 +5597,6 @@
                   </a:txBody>
                   <a:tcPr/>
                 </a:tc>
-                <a:extLst>
-                  <a:ext uri="{0D108BD9-81ED-4DB2-BD59-A6C34878D82A}">
-                    <a16:rowId xmlns:a16="http://schemas.microsoft.com/office/drawing/2014/main" val="10005"/>
-                  </a:ext>
-                </a:extLst>
               </a:tr>
               <a:tr h="365760">
                 <a:tc>
@@ -5816,11 +5625,6 @@
                   </a:txBody>
                   <a:tcPr/>
                 </a:tc>
-                <a:extLst>
-                  <a:ext uri="{0D108BD9-81ED-4DB2-BD59-A6C34878D82A}">
-                    <a16:rowId xmlns:a16="http://schemas.microsoft.com/office/drawing/2014/main" val="10006"/>
-                  </a:ext>
-                </a:extLst>
               </a:tr>
               <a:tr h="365760">
                 <a:tc>
@@ -5849,11 +5653,6 @@
                   </a:txBody>
                   <a:tcPr/>
                 </a:tc>
-                <a:extLst>
-                  <a:ext uri="{0D108BD9-81ED-4DB2-BD59-A6C34878D82A}">
-                    <a16:rowId xmlns:a16="http://schemas.microsoft.com/office/drawing/2014/main" val="10007"/>
-                  </a:ext>
-                </a:extLst>
               </a:tr>
               <a:tr h="365760">
                 <a:tc>
@@ -5882,11 +5681,6 @@
                   </a:txBody>
                   <a:tcPr/>
                 </a:tc>
-                <a:extLst>
-                  <a:ext uri="{0D108BD9-81ED-4DB2-BD59-A6C34878D82A}">
-                    <a16:rowId xmlns:a16="http://schemas.microsoft.com/office/drawing/2014/main" val="10008"/>
-                  </a:ext>
-                </a:extLst>
               </a:tr>
               <a:tr h="365760">
                 <a:tc>
@@ -5915,11 +5709,6 @@
                   </a:txBody>
                   <a:tcPr/>
                 </a:tc>
-                <a:extLst>
-                  <a:ext uri="{0D108BD9-81ED-4DB2-BD59-A6C34878D82A}">
-                    <a16:rowId xmlns:a16="http://schemas.microsoft.com/office/drawing/2014/main" val="10009"/>
-                  </a:ext>
-                </a:extLst>
               </a:tr>
             </a:tbl>
           </a:graphicData>
@@ -5934,7 +5723,7 @@
 </file>
 
 <file path=ppt/slides/slide20.xml><?xml version="1.0" encoding="utf-8"?>
-<p:sld xmlns:a="http://schemas.openxmlformats.org/drawingml/2006/main" xmlns:r="http://schemas.openxmlformats.org/officeDocument/2006/relationships" xmlns:p="http://schemas.openxmlformats.org/presentationml/2006/main">
+<p:sld xmlns:a="http://schemas.openxmlformats.org/drawingml/2006/main" xmlns:p="http://schemas.openxmlformats.org/presentationml/2006/main" xmlns:r="http://schemas.openxmlformats.org/officeDocument/2006/relationships">
   <p:cSld>
     <p:spTree>
       <p:nvGrpSpPr>
@@ -5942,14 +5731,7 @@
         <p:cNvGrpSpPr/>
         <p:nvPr/>
       </p:nvGrpSpPr>
-      <p:grpSpPr>
-        <a:xfrm>
-          <a:off x="0" y="0"/>
-          <a:ext cx="0" cy="0"/>
-          <a:chOff x="0" y="0"/>
-          <a:chExt cx="0" cy="0"/>
-        </a:xfrm>
-      </p:grpSpPr>
+      <p:grpSpPr/>
       <p:sp>
         <p:nvSpPr>
           <p:cNvPr id="2" name="TextBox 1"/>
@@ -5993,7 +5775,7 @@
         </p:nvGraphicFramePr>
         <p:xfrm>
           <a:off x="731520" y="1280160"/>
-          <a:ext cx="10698480" cy="3108960"/>
+          <a:ext cx="10698480" cy="2560320"/>
         </p:xfrm>
         <a:graphic>
           <a:graphicData uri="http://schemas.openxmlformats.org/drawingml/2006/table">
@@ -6002,27 +5784,9 @@
                 <a:tableStyleId>{5C22544A-7EE6-4342-B048-85BDC9FD1C3A}</a:tableStyleId>
               </a:tblPr>
               <a:tblGrid>
-                <a:gridCol w="2468880">
-                  <a:extLst>
-                    <a:ext uri="{9D8B030D-6E8A-4147-A177-3AD203B41FA5}">
-                      <a16:colId xmlns:a16="http://schemas.microsoft.com/office/drawing/2014/main" val="20000"/>
-                    </a:ext>
-                  </a:extLst>
-                </a:gridCol>
-                <a:gridCol w="4206240">
-                  <a:extLst>
-                    <a:ext uri="{9D8B030D-6E8A-4147-A177-3AD203B41FA5}">
-                      <a16:colId xmlns:a16="http://schemas.microsoft.com/office/drawing/2014/main" val="20001"/>
-                    </a:ext>
-                  </a:extLst>
-                </a:gridCol>
-                <a:gridCol w="4023360">
-                  <a:extLst>
-                    <a:ext uri="{9D8B030D-6E8A-4147-A177-3AD203B41FA5}">
-                      <a16:colId xmlns:a16="http://schemas.microsoft.com/office/drawing/2014/main" val="20002"/>
-                    </a:ext>
-                  </a:extLst>
-                </a:gridCol>
+                <a:gridCol w="2468880"/>
+                <a:gridCol w="4206240"/>
+                <a:gridCol w="4023360"/>
               </a:tblGrid>
               <a:tr h="365760">
                 <a:tc>
@@ -6064,11 +5828,6 @@
                   </a:txBody>
                   <a:tcPr/>
                 </a:tc>
-                <a:extLst>
-                  <a:ext uri="{0D108BD9-81ED-4DB2-BD59-A6C34878D82A}">
-                    <a16:rowId xmlns:a16="http://schemas.microsoft.com/office/drawing/2014/main" val="10000"/>
-                  </a:ext>
-                </a:extLst>
               </a:tr>
               <a:tr h="365760">
                 <a:tc>
@@ -6110,11 +5869,6 @@
                   </a:txBody>
                   <a:tcPr/>
                 </a:tc>
-                <a:extLst>
-                  <a:ext uri="{0D108BD9-81ED-4DB2-BD59-A6C34878D82A}">
-                    <a16:rowId xmlns:a16="http://schemas.microsoft.com/office/drawing/2014/main" val="10001"/>
-                  </a:ext>
-                </a:extLst>
               </a:tr>
               <a:tr h="365760">
                 <a:tc>
@@ -6156,11 +5910,6 @@
                   </a:txBody>
                   <a:tcPr/>
                 </a:tc>
-                <a:extLst>
-                  <a:ext uri="{0D108BD9-81ED-4DB2-BD59-A6C34878D82A}">
-                    <a16:rowId xmlns:a16="http://schemas.microsoft.com/office/drawing/2014/main" val="10002"/>
-                  </a:ext>
-                </a:extLst>
               </a:tr>
               <a:tr h="365760">
                 <a:tc>
@@ -6202,11 +5951,6 @@
                   </a:txBody>
                   <a:tcPr/>
                 </a:tc>
-                <a:extLst>
-                  <a:ext uri="{0D108BD9-81ED-4DB2-BD59-A6C34878D82A}">
-                    <a16:rowId xmlns:a16="http://schemas.microsoft.com/office/drawing/2014/main" val="10003"/>
-                  </a:ext>
-                </a:extLst>
               </a:tr>
               <a:tr h="365760">
                 <a:tc>
@@ -6248,11 +5992,6 @@
                   </a:txBody>
                   <a:tcPr/>
                 </a:tc>
-                <a:extLst>
-                  <a:ext uri="{0D108BD9-81ED-4DB2-BD59-A6C34878D82A}">
-                    <a16:rowId xmlns:a16="http://schemas.microsoft.com/office/drawing/2014/main" val="10004"/>
-                  </a:ext>
-                </a:extLst>
               </a:tr>
               <a:tr h="365760">
                 <a:tc>
@@ -6294,11 +6033,6 @@
                   </a:txBody>
                   <a:tcPr/>
                 </a:tc>
-                <a:extLst>
-                  <a:ext uri="{0D108BD9-81ED-4DB2-BD59-A6C34878D82A}">
-                    <a16:rowId xmlns:a16="http://schemas.microsoft.com/office/drawing/2014/main" val="10005"/>
-                  </a:ext>
-                </a:extLst>
               </a:tr>
               <a:tr h="365760">
                 <a:tc>
@@ -6340,11 +6074,6 @@
                   </a:txBody>
                   <a:tcPr/>
                 </a:tc>
-                <a:extLst>
-                  <a:ext uri="{0D108BD9-81ED-4DB2-BD59-A6C34878D82A}">
-                    <a16:rowId xmlns:a16="http://schemas.microsoft.com/office/drawing/2014/main" val="10006"/>
-                  </a:ext>
-                </a:extLst>
               </a:tr>
             </a:tbl>
           </a:graphicData>
@@ -6397,7 +6126,7 @@
 </file>
 
 <file path=ppt/slides/slide21.xml><?xml version="1.0" encoding="utf-8"?>
-<p:sld xmlns:a="http://schemas.openxmlformats.org/drawingml/2006/main" xmlns:r="http://schemas.openxmlformats.org/officeDocument/2006/relationships" xmlns:p="http://schemas.openxmlformats.org/presentationml/2006/main">
+<p:sld xmlns:a="http://schemas.openxmlformats.org/drawingml/2006/main" xmlns:p="http://schemas.openxmlformats.org/presentationml/2006/main" xmlns:r="http://schemas.openxmlformats.org/officeDocument/2006/relationships">
   <p:cSld>
     <p:spTree>
       <p:nvGrpSpPr>
@@ -6405,14 +6134,7 @@
         <p:cNvGrpSpPr/>
         <p:nvPr/>
       </p:nvGrpSpPr>
-      <p:grpSpPr>
-        <a:xfrm>
-          <a:off x="0" y="0"/>
-          <a:ext cx="0" cy="0"/>
-          <a:chOff x="0" y="0"/>
-          <a:chExt cx="0" cy="0"/>
-        </a:xfrm>
-      </p:grpSpPr>
+      <p:grpSpPr/>
       <p:sp>
         <p:nvSpPr>
           <p:cNvPr id="2" name="TextBox 1"/>
@@ -6456,7 +6178,7 @@
         </p:nvGraphicFramePr>
         <p:xfrm>
           <a:off x="731520" y="1554480"/>
-          <a:ext cx="10698480" cy="1188720"/>
+          <a:ext cx="10698480" cy="1097280"/>
         </p:xfrm>
         <a:graphic>
           <a:graphicData uri="http://schemas.openxmlformats.org/drawingml/2006/table">
@@ -6465,36 +6187,16 @@
                 <a:tableStyleId>{5C22544A-7EE6-4342-B048-85BDC9FD1C3A}</a:tableStyleId>
               </a:tblPr>
               <a:tblGrid>
-                <a:gridCol w="3108960">
-                  <a:extLst>
-                    <a:ext uri="{9D8B030D-6E8A-4147-A177-3AD203B41FA5}">
-                      <a16:colId xmlns:a16="http://schemas.microsoft.com/office/drawing/2014/main" val="20000"/>
-                    </a:ext>
-                  </a:extLst>
-                </a:gridCol>
-                <a:gridCol w="4023360">
-                  <a:extLst>
-                    <a:ext uri="{9D8B030D-6E8A-4147-A177-3AD203B41FA5}">
-                      <a16:colId xmlns:a16="http://schemas.microsoft.com/office/drawing/2014/main" val="20001"/>
-                    </a:ext>
-                  </a:extLst>
-                </a:gridCol>
-                <a:gridCol w="3566160">
-                  <a:extLst>
-                    <a:ext uri="{9D8B030D-6E8A-4147-A177-3AD203B41FA5}">
-                      <a16:colId xmlns:a16="http://schemas.microsoft.com/office/drawing/2014/main" val="20002"/>
-                    </a:ext>
-                  </a:extLst>
-                </a:gridCol>
+                <a:gridCol w="3108960"/>
+                <a:gridCol w="4023360"/>
+                <a:gridCol w="3566160"/>
               </a:tblGrid>
               <a:tr h="365760">
                 <a:tc>
                   <a:txBody>
                     <a:bodyPr/>
                     <a:lstStyle/>
-                    <a:p>
-                      <a:endParaRPr/>
-                    </a:p>
+                    <a:p/>
                   </a:txBody>
                   <a:tcPr/>
                 </a:tc>
@@ -6524,11 +6226,6 @@
                   </a:txBody>
                   <a:tcPr/>
                 </a:tc>
-                <a:extLst>
-                  <a:ext uri="{0D108BD9-81ED-4DB2-BD59-A6C34878D82A}">
-                    <a16:rowId xmlns:a16="http://schemas.microsoft.com/office/drawing/2014/main" val="10000"/>
-                  </a:ext>
-                </a:extLst>
               </a:tr>
               <a:tr h="365760">
                 <a:tc>
@@ -6570,11 +6267,6 @@
                   </a:txBody>
                   <a:tcPr/>
                 </a:tc>
-                <a:extLst>
-                  <a:ext uri="{0D108BD9-81ED-4DB2-BD59-A6C34878D82A}">
-                    <a16:rowId xmlns:a16="http://schemas.microsoft.com/office/drawing/2014/main" val="10001"/>
-                  </a:ext>
-                </a:extLst>
               </a:tr>
               <a:tr h="365760">
                 <a:tc>
@@ -6616,11 +6308,6 @@
                   </a:txBody>
                   <a:tcPr/>
                 </a:tc>
-                <a:extLst>
-                  <a:ext uri="{0D108BD9-81ED-4DB2-BD59-A6C34878D82A}">
-                    <a16:rowId xmlns:a16="http://schemas.microsoft.com/office/drawing/2014/main" val="10002"/>
-                  </a:ext>
-                </a:extLst>
               </a:tr>
             </a:tbl>
           </a:graphicData>
@@ -6688,7 +6375,7 @@
 </file>
 
 <file path=ppt/slides/slide22.xml><?xml version="1.0" encoding="utf-8"?>
-<p:sld xmlns:a="http://schemas.openxmlformats.org/drawingml/2006/main" xmlns:r="http://schemas.openxmlformats.org/officeDocument/2006/relationships" xmlns:p="http://schemas.openxmlformats.org/presentationml/2006/main">
+<p:sld xmlns:a="http://schemas.openxmlformats.org/drawingml/2006/main" xmlns:p="http://schemas.openxmlformats.org/presentationml/2006/main" xmlns:r="http://schemas.openxmlformats.org/officeDocument/2006/relationships">
   <p:cSld>
     <p:spTree>
       <p:nvGrpSpPr>
@@ -6696,14 +6383,7 @@
         <p:cNvGrpSpPr/>
         <p:nvPr/>
       </p:nvGrpSpPr>
-      <p:grpSpPr>
-        <a:xfrm>
-          <a:off x="0" y="0"/>
-          <a:ext cx="0" cy="0"/>
-          <a:chOff x="0" y="0"/>
-          <a:chExt cx="0" cy="0"/>
-        </a:xfrm>
-      </p:grpSpPr>
+      <p:grpSpPr/>
       <p:sp>
         <p:nvSpPr>
           <p:cNvPr id="2" name="TextBox 1"/>
@@ -6756,27 +6436,9 @@
                 <a:tableStyleId>{5C22544A-7EE6-4342-B048-85BDC9FD1C3A}</a:tableStyleId>
               </a:tblPr>
               <a:tblGrid>
-                <a:gridCol w="3474720">
-                  <a:extLst>
-                    <a:ext uri="{9D8B030D-6E8A-4147-A177-3AD203B41FA5}">
-                      <a16:colId xmlns:a16="http://schemas.microsoft.com/office/drawing/2014/main" val="20000"/>
-                    </a:ext>
-                  </a:extLst>
-                </a:gridCol>
-                <a:gridCol w="4023360">
-                  <a:extLst>
-                    <a:ext uri="{9D8B030D-6E8A-4147-A177-3AD203B41FA5}">
-                      <a16:colId xmlns:a16="http://schemas.microsoft.com/office/drawing/2014/main" val="20001"/>
-                    </a:ext>
-                  </a:extLst>
-                </a:gridCol>
-                <a:gridCol w="3200400">
-                  <a:extLst>
-                    <a:ext uri="{9D8B030D-6E8A-4147-A177-3AD203B41FA5}">
-                      <a16:colId xmlns:a16="http://schemas.microsoft.com/office/drawing/2014/main" val="20002"/>
-                    </a:ext>
-                  </a:extLst>
-                </a:gridCol>
+                <a:gridCol w="3474720"/>
+                <a:gridCol w="4023360"/>
+                <a:gridCol w="3200400"/>
               </a:tblGrid>
               <a:tr h="365760">
                 <a:tc>
@@ -6818,11 +6480,6 @@
                   </a:txBody>
                   <a:tcPr/>
                 </a:tc>
-                <a:extLst>
-                  <a:ext uri="{0D108BD9-81ED-4DB2-BD59-A6C34878D82A}">
-                    <a16:rowId xmlns:a16="http://schemas.microsoft.com/office/drawing/2014/main" val="10000"/>
-                  </a:ext>
-                </a:extLst>
               </a:tr>
               <a:tr h="365760">
                 <a:tc>
@@ -6864,11 +6521,6 @@
                   </a:txBody>
                   <a:tcPr/>
                 </a:tc>
-                <a:extLst>
-                  <a:ext uri="{0D108BD9-81ED-4DB2-BD59-A6C34878D82A}">
-                    <a16:rowId xmlns:a16="http://schemas.microsoft.com/office/drawing/2014/main" val="10001"/>
-                  </a:ext>
-                </a:extLst>
               </a:tr>
               <a:tr h="365760">
                 <a:tc>
@@ -6910,11 +6562,6 @@
                   </a:txBody>
                   <a:tcPr/>
                 </a:tc>
-                <a:extLst>
-                  <a:ext uri="{0D108BD9-81ED-4DB2-BD59-A6C34878D82A}">
-                    <a16:rowId xmlns:a16="http://schemas.microsoft.com/office/drawing/2014/main" val="10002"/>
-                  </a:ext>
-                </a:extLst>
               </a:tr>
               <a:tr h="365760">
                 <a:tc>
@@ -6956,11 +6603,6 @@
                   </a:txBody>
                   <a:tcPr/>
                 </a:tc>
-                <a:extLst>
-                  <a:ext uri="{0D108BD9-81ED-4DB2-BD59-A6C34878D82A}">
-                    <a16:rowId xmlns:a16="http://schemas.microsoft.com/office/drawing/2014/main" val="10003"/>
-                  </a:ext>
-                </a:extLst>
               </a:tr>
               <a:tr h="365760">
                 <a:tc>
@@ -7002,11 +6644,6 @@
                   </a:txBody>
                   <a:tcPr/>
                 </a:tc>
-                <a:extLst>
-                  <a:ext uri="{0D108BD9-81ED-4DB2-BD59-A6C34878D82A}">
-                    <a16:rowId xmlns:a16="http://schemas.microsoft.com/office/drawing/2014/main" val="10004"/>
-                  </a:ext>
-                </a:extLst>
               </a:tr>
               <a:tr h="365760">
                 <a:tc>
@@ -7048,11 +6685,6 @@
                   </a:txBody>
                   <a:tcPr/>
                 </a:tc>
-                <a:extLst>
-                  <a:ext uri="{0D108BD9-81ED-4DB2-BD59-A6C34878D82A}">
-                    <a16:rowId xmlns:a16="http://schemas.microsoft.com/office/drawing/2014/main" val="10005"/>
-                  </a:ext>
-                </a:extLst>
               </a:tr>
             </a:tbl>
           </a:graphicData>
@@ -7105,7 +6737,7 @@
 </file>
 
 <file path=ppt/slides/slide23.xml><?xml version="1.0" encoding="utf-8"?>
-<p:sld xmlns:a="http://schemas.openxmlformats.org/drawingml/2006/main" xmlns:r="http://schemas.openxmlformats.org/officeDocument/2006/relationships" xmlns:p="http://schemas.openxmlformats.org/presentationml/2006/main">
+<p:sld xmlns:a="http://schemas.openxmlformats.org/drawingml/2006/main" xmlns:p="http://schemas.openxmlformats.org/presentationml/2006/main" xmlns:r="http://schemas.openxmlformats.org/officeDocument/2006/relationships">
   <p:cSld>
     <p:spTree>
       <p:nvGrpSpPr>
@@ -7113,14 +6745,7 @@
         <p:cNvGrpSpPr/>
         <p:nvPr/>
       </p:nvGrpSpPr>
-      <p:grpSpPr>
-        <a:xfrm>
-          <a:off x="0" y="0"/>
-          <a:ext cx="0" cy="0"/>
-          <a:chOff x="0" y="0"/>
-          <a:chExt cx="0" cy="0"/>
-        </a:xfrm>
-      </p:grpSpPr>
+      <p:grpSpPr/>
       <p:sp>
         <p:nvSpPr>
           <p:cNvPr id="2" name="TextBox 1"/>
@@ -7314,7 +6939,7 @@
 </file>
 
 <file path=ppt/slides/slide24.xml><?xml version="1.0" encoding="utf-8"?>
-<p:sld xmlns:a="http://schemas.openxmlformats.org/drawingml/2006/main" xmlns:r="http://schemas.openxmlformats.org/officeDocument/2006/relationships" xmlns:p="http://schemas.openxmlformats.org/presentationml/2006/main">
+<p:sld xmlns:a="http://schemas.openxmlformats.org/drawingml/2006/main" xmlns:p="http://schemas.openxmlformats.org/presentationml/2006/main" xmlns:r="http://schemas.openxmlformats.org/officeDocument/2006/relationships">
   <p:cSld>
     <p:spTree>
       <p:nvGrpSpPr>
@@ -7322,14 +6947,7 @@
         <p:cNvGrpSpPr/>
         <p:nvPr/>
       </p:nvGrpSpPr>
-      <p:grpSpPr>
-        <a:xfrm>
-          <a:off x="0" y="0"/>
-          <a:ext cx="0" cy="0"/>
-          <a:chOff x="0" y="0"/>
-          <a:chExt cx="0" cy="0"/>
-        </a:xfrm>
-      </p:grpSpPr>
+      <p:grpSpPr/>
       <p:sp>
         <p:nvSpPr>
           <p:cNvPr id="2" name="TextBox 1"/>
@@ -7435,24 +7053,27 @@
                 <a:spcPts val="800"/>
               </a:spcAft>
             </a:pPr>
-            <a:endParaRPr sz="2400">
-              <a:solidFill>
-                <a:srgbClr val="212121"/>
-              </a:solidFill>
-            </a:endParaRPr>
-          </a:p>
-          <a:p>
-            <a:pPr>
-              <a:spcAft>
-                <a:spcPts val="800"/>
-              </a:spcAft>
-            </a:pPr>
             <a:r>
               <a:rPr sz="2600">
                 <a:solidFill>
                   <a:srgbClr val="212121"/>
                 </a:solidFill>
               </a:rPr>
+              <a:t/>
+            </a:r>
+          </a:p>
+          <a:p>
+            <a:pPr>
+              <a:spcAft>
+                <a:spcPts val="800"/>
+              </a:spcAft>
+            </a:pPr>
+            <a:r>
+              <a:rPr sz="2600">
+                <a:solidFill>
+                  <a:srgbClr val="212121"/>
+                </a:solidFill>
+              </a:rPr>
               <a:t>Every tool tonight, and every lab in Session 2, is this one move in different costumes.</a:t>
             </a:r>
           </a:p>
@@ -7462,11 +7083,14 @@
                 <a:spcPts val="800"/>
               </a:spcAft>
             </a:pPr>
-            <a:endParaRPr sz="2600">
-              <a:solidFill>
-                <a:srgbClr val="212121"/>
-              </a:solidFill>
-            </a:endParaRPr>
+            <a:r>
+              <a:rPr sz="2600">
+                <a:solidFill>
+                  <a:srgbClr val="212121"/>
+                </a:solidFill>
+              </a:rPr>
+              <a:t/>
+            </a:r>
           </a:p>
           <a:p>
             <a:pPr>
@@ -7494,7 +7118,7 @@
 </file>
 
 <file path=ppt/slides/slide25.xml><?xml version="1.0" encoding="utf-8"?>
-<p:sld xmlns:a="http://schemas.openxmlformats.org/drawingml/2006/main" xmlns:r="http://schemas.openxmlformats.org/officeDocument/2006/relationships" xmlns:p="http://schemas.openxmlformats.org/presentationml/2006/main">
+<p:sld xmlns:a="http://schemas.openxmlformats.org/drawingml/2006/main" xmlns:p="http://schemas.openxmlformats.org/presentationml/2006/main" xmlns:r="http://schemas.openxmlformats.org/officeDocument/2006/relationships">
   <p:cSld>
     <p:spTree>
       <p:nvGrpSpPr>
@@ -7502,14 +7126,7 @@
         <p:cNvGrpSpPr/>
         <p:nvPr/>
       </p:nvGrpSpPr>
-      <p:grpSpPr>
-        <a:xfrm>
-          <a:off x="0" y="0"/>
-          <a:ext cx="0" cy="0"/>
-          <a:chOff x="0" y="0"/>
-          <a:chExt cx="0" cy="0"/>
-        </a:xfrm>
-      </p:grpSpPr>
+      <p:grpSpPr/>
       <p:sp>
         <p:nvSpPr>
           <p:cNvPr id="2" name="TextBox 1"/>
@@ -7552,7 +7169,7 @@
 </file>
 
 <file path=ppt/slides/slide26.xml><?xml version="1.0" encoding="utf-8"?>
-<p:sld xmlns:a="http://schemas.openxmlformats.org/drawingml/2006/main" xmlns:r="http://schemas.openxmlformats.org/officeDocument/2006/relationships" xmlns:p="http://schemas.openxmlformats.org/presentationml/2006/main">
+<p:sld xmlns:a="http://schemas.openxmlformats.org/drawingml/2006/main" xmlns:p="http://schemas.openxmlformats.org/presentationml/2006/main" xmlns:r="http://schemas.openxmlformats.org/officeDocument/2006/relationships">
   <p:cSld>
     <p:spTree>
       <p:nvGrpSpPr>
@@ -7560,14 +7177,7 @@
         <p:cNvGrpSpPr/>
         <p:nvPr/>
       </p:nvGrpSpPr>
-      <p:grpSpPr>
-        <a:xfrm>
-          <a:off x="0" y="0"/>
-          <a:ext cx="0" cy="0"/>
-          <a:chOff x="0" y="0"/>
-          <a:chExt cx="0" cy="0"/>
-        </a:xfrm>
-      </p:grpSpPr>
+      <p:grpSpPr/>
       <p:sp>
         <p:nvSpPr>
           <p:cNvPr id="2" name="TextBox 1"/>
@@ -7644,25 +7254,27 @@
                 <a:spcPts val="800"/>
               </a:spcAft>
             </a:pPr>
-            <a:endParaRPr sz="2000">
-              <a:solidFill>
-                <a:srgbClr val="212121"/>
-              </a:solidFill>
-              <a:latin typeface="Courier New"/>
-            </a:endParaRPr>
-          </a:p>
-          <a:p>
-            <a:pPr>
-              <a:spcAft>
-                <a:spcPts val="800"/>
-              </a:spcAft>
-            </a:pPr>
             <a:r>
               <a:rPr sz="2400">
                 <a:solidFill>
                   <a:srgbClr val="212121"/>
                 </a:solidFill>
               </a:rPr>
+              <a:t/>
+            </a:r>
+          </a:p>
+          <a:p>
+            <a:pPr>
+              <a:spcAft>
+                <a:spcPts val="800"/>
+              </a:spcAft>
+            </a:pPr>
+            <a:r>
+              <a:rPr sz="2400">
+                <a:solidFill>
+                  <a:srgbClr val="212121"/>
+                </a:solidFill>
+              </a:rPr>
               <a:t>Is there a true/false assignment that makes the whole formula true?</a:t>
             </a:r>
           </a:p>
@@ -7672,11 +7284,14 @@
                 <a:spcPts val="800"/>
               </a:spcAft>
             </a:pPr>
-            <a:endParaRPr sz="2400">
-              <a:solidFill>
-                <a:srgbClr val="212121"/>
-              </a:solidFill>
-            </a:endParaRPr>
+            <a:r>
+              <a:rPr sz="2400">
+                <a:solidFill>
+                  <a:srgbClr val="212121"/>
+                </a:solidFill>
+              </a:rPr>
+              <a:t/>
+            </a:r>
           </a:p>
           <a:p>
             <a:pPr>
@@ -7719,7 +7334,7 @@
 </file>
 
 <file path=ppt/slides/slide27.xml><?xml version="1.0" encoding="utf-8"?>
-<p:sld xmlns:a="http://schemas.openxmlformats.org/drawingml/2006/main" xmlns:r="http://schemas.openxmlformats.org/officeDocument/2006/relationships" xmlns:p="http://schemas.openxmlformats.org/presentationml/2006/main">
+<p:sld xmlns:a="http://schemas.openxmlformats.org/drawingml/2006/main" xmlns:p="http://schemas.openxmlformats.org/presentationml/2006/main" xmlns:r="http://schemas.openxmlformats.org/officeDocument/2006/relationships">
   <p:cSld>
     <p:spTree>
       <p:nvGrpSpPr>
@@ -7727,14 +7342,7 @@
         <p:cNvGrpSpPr/>
         <p:nvPr/>
       </p:nvGrpSpPr>
-      <p:grpSpPr>
-        <a:xfrm>
-          <a:off x="0" y="0"/>
-          <a:ext cx="0" cy="0"/>
-          <a:chOff x="0" y="0"/>
-          <a:chExt cx="0" cy="0"/>
-        </a:xfrm>
-      </p:grpSpPr>
+      <p:grpSpPr/>
       <p:sp>
         <p:nvSpPr>
           <p:cNvPr id="2" name="TextBox 1"/>
@@ -7855,11 +7463,14 @@
                 <a:spcPts val="800"/>
               </a:spcAft>
             </a:pPr>
-            <a:endParaRPr sz="2200">
-              <a:solidFill>
-                <a:srgbClr val="212121"/>
-              </a:solidFill>
-            </a:endParaRPr>
+            <a:r>
+              <a:rPr sz="2400">
+                <a:solidFill>
+                  <a:srgbClr val="212121"/>
+                </a:solidFill>
+              </a:rPr>
+              <a:t/>
+            </a:r>
           </a:p>
           <a:p>
             <a:pPr>
@@ -7917,7 +7528,7 @@
 </file>
 
 <file path=ppt/slides/slide28.xml><?xml version="1.0" encoding="utf-8"?>
-<p:sld xmlns:a="http://schemas.openxmlformats.org/drawingml/2006/main" xmlns:r="http://schemas.openxmlformats.org/officeDocument/2006/relationships" xmlns:p="http://schemas.openxmlformats.org/presentationml/2006/main">
+<p:sld xmlns:a="http://schemas.openxmlformats.org/drawingml/2006/main" xmlns:p="http://schemas.openxmlformats.org/presentationml/2006/main" xmlns:r="http://schemas.openxmlformats.org/officeDocument/2006/relationships">
   <p:cSld>
     <p:spTree>
       <p:nvGrpSpPr>
@@ -7925,14 +7536,7 @@
         <p:cNvGrpSpPr/>
         <p:nvPr/>
       </p:nvGrpSpPr>
-      <p:grpSpPr>
-        <a:xfrm>
-          <a:off x="0" y="0"/>
-          <a:ext cx="0" cy="0"/>
-          <a:chOff x="0" y="0"/>
-          <a:chExt cx="0" cy="0"/>
-        </a:xfrm>
-      </p:grpSpPr>
+      <p:grpSpPr/>
       <p:sp>
         <p:nvSpPr>
           <p:cNvPr id="2" name="TextBox 1"/>
@@ -7976,7 +7580,7 @@
         </p:nvGraphicFramePr>
         <p:xfrm>
           <a:off x="731520" y="1554480"/>
-          <a:ext cx="10698480" cy="1981200"/>
+          <a:ext cx="10698480" cy="1828800"/>
         </p:xfrm>
         <a:graphic>
           <a:graphicData uri="http://schemas.openxmlformats.org/drawingml/2006/table">
@@ -7985,20 +7589,8 @@
                 <a:tableStyleId>{5C22544A-7EE6-4342-B048-85BDC9FD1C3A}</a:tableStyleId>
               </a:tblPr>
               <a:tblGrid>
-                <a:gridCol w="4754880">
-                  <a:extLst>
-                    <a:ext uri="{9D8B030D-6E8A-4147-A177-3AD203B41FA5}">
-                      <a16:colId xmlns:a16="http://schemas.microsoft.com/office/drawing/2014/main" val="20000"/>
-                    </a:ext>
-                  </a:extLst>
-                </a:gridCol>
-                <a:gridCol w="5943600">
-                  <a:extLst>
-                    <a:ext uri="{9D8B030D-6E8A-4147-A177-3AD203B41FA5}">
-                      <a16:colId xmlns:a16="http://schemas.microsoft.com/office/drawing/2014/main" val="20001"/>
-                    </a:ext>
-                  </a:extLst>
-                </a:gridCol>
+                <a:gridCol w="4754880"/>
+                <a:gridCol w="5943600"/>
               </a:tblGrid>
               <a:tr h="365760">
                 <a:tc>
@@ -8027,11 +7619,6 @@
                   </a:txBody>
                   <a:tcPr/>
                 </a:tc>
-                <a:extLst>
-                  <a:ext uri="{0D108BD9-81ED-4DB2-BD59-A6C34878D82A}">
-                    <a16:rowId xmlns:a16="http://schemas.microsoft.com/office/drawing/2014/main" val="10000"/>
-                  </a:ext>
-                </a:extLst>
               </a:tr>
               <a:tr h="365760">
                 <a:tc>
@@ -8060,11 +7647,6 @@
                   </a:txBody>
                   <a:tcPr/>
                 </a:tc>
-                <a:extLst>
-                  <a:ext uri="{0D108BD9-81ED-4DB2-BD59-A6C34878D82A}">
-                    <a16:rowId xmlns:a16="http://schemas.microsoft.com/office/drawing/2014/main" val="10001"/>
-                  </a:ext>
-                </a:extLst>
               </a:tr>
               <a:tr h="365760">
                 <a:tc>
@@ -8093,11 +7675,6 @@
                   </a:txBody>
                   <a:tcPr/>
                 </a:tc>
-                <a:extLst>
-                  <a:ext uri="{0D108BD9-81ED-4DB2-BD59-A6C34878D82A}">
-                    <a16:rowId xmlns:a16="http://schemas.microsoft.com/office/drawing/2014/main" val="10002"/>
-                  </a:ext>
-                </a:extLst>
               </a:tr>
               <a:tr h="365760">
                 <a:tc>
@@ -8126,11 +7703,6 @@
                   </a:txBody>
                   <a:tcPr/>
                 </a:tc>
-                <a:extLst>
-                  <a:ext uri="{0D108BD9-81ED-4DB2-BD59-A6C34878D82A}">
-                    <a16:rowId xmlns:a16="http://schemas.microsoft.com/office/drawing/2014/main" val="10003"/>
-                  </a:ext>
-                </a:extLst>
               </a:tr>
               <a:tr h="365760">
                 <a:tc>
@@ -8159,11 +7731,6 @@
                   </a:txBody>
                   <a:tcPr/>
                 </a:tc>
-                <a:extLst>
-                  <a:ext uri="{0D108BD9-81ED-4DB2-BD59-A6C34878D82A}">
-                    <a16:rowId xmlns:a16="http://schemas.microsoft.com/office/drawing/2014/main" val="10004"/>
-                  </a:ext>
-                </a:extLst>
               </a:tr>
             </a:tbl>
           </a:graphicData>
@@ -8216,7 +7783,7 @@
 </file>
 
 <file path=ppt/slides/slide29.xml><?xml version="1.0" encoding="utf-8"?>
-<p:sld xmlns:a="http://schemas.openxmlformats.org/drawingml/2006/main" xmlns:r="http://schemas.openxmlformats.org/officeDocument/2006/relationships" xmlns:p="http://schemas.openxmlformats.org/presentationml/2006/main">
+<p:sld xmlns:a="http://schemas.openxmlformats.org/drawingml/2006/main" xmlns:p="http://schemas.openxmlformats.org/presentationml/2006/main" xmlns:r="http://schemas.openxmlformats.org/officeDocument/2006/relationships">
   <p:cSld>
     <p:spTree>
       <p:nvGrpSpPr>
@@ -8224,14 +7791,7 @@
         <p:cNvGrpSpPr/>
         <p:nvPr/>
       </p:nvGrpSpPr>
-      <p:grpSpPr>
-        <a:xfrm>
-          <a:off x="0" y="0"/>
-          <a:ext cx="0" cy="0"/>
-          <a:chOff x="0" y="0"/>
-          <a:chExt cx="0" cy="0"/>
-        </a:xfrm>
-      </p:grpSpPr>
+      <p:grpSpPr/>
       <p:sp>
         <p:nvSpPr>
           <p:cNvPr id="2" name="TextBox 1"/>
@@ -8324,12 +7884,14 @@
                 <a:spcPts val="800"/>
               </a:spcAft>
             </a:pPr>
-            <a:endParaRPr sz="2000">
-              <a:solidFill>
-                <a:srgbClr val="212121"/>
-              </a:solidFill>
-              <a:latin typeface="Courier New"/>
-            </a:endParaRPr>
+            <a:r>
+              <a:rPr sz="2400">
+                <a:solidFill>
+                  <a:srgbClr val="212121"/>
+                </a:solidFill>
+              </a:rPr>
+              <a:t/>
+            </a:r>
           </a:p>
           <a:p>
             <a:pPr>
@@ -8402,7 +7964,7 @@
 </file>
 
 <file path=ppt/slides/slide3.xml><?xml version="1.0" encoding="utf-8"?>
-<p:sld xmlns:a="http://schemas.openxmlformats.org/drawingml/2006/main" xmlns:r="http://schemas.openxmlformats.org/officeDocument/2006/relationships" xmlns:p="http://schemas.openxmlformats.org/presentationml/2006/main">
+<p:sld xmlns:a="http://schemas.openxmlformats.org/drawingml/2006/main" xmlns:p="http://schemas.openxmlformats.org/presentationml/2006/main" xmlns:r="http://schemas.openxmlformats.org/officeDocument/2006/relationships">
   <p:cSld>
     <p:spTree>
       <p:nvGrpSpPr>
@@ -8410,14 +7972,7 @@
         <p:cNvGrpSpPr/>
         <p:nvPr/>
       </p:nvGrpSpPr>
-      <p:grpSpPr>
-        <a:xfrm>
-          <a:off x="0" y="0"/>
-          <a:ext cx="0" cy="0"/>
-          <a:chOff x="0" y="0"/>
-          <a:chExt cx="0" cy="0"/>
-        </a:xfrm>
-      </p:grpSpPr>
+      <p:grpSpPr/>
       <p:sp>
         <p:nvSpPr>
           <p:cNvPr id="2" name="TextBox 1"/>
@@ -8513,7 +8068,7 @@
 </file>
 
 <file path=ppt/slides/slide30.xml><?xml version="1.0" encoding="utf-8"?>
-<p:sld xmlns:a="http://schemas.openxmlformats.org/drawingml/2006/main" xmlns:r="http://schemas.openxmlformats.org/officeDocument/2006/relationships" xmlns:p="http://schemas.openxmlformats.org/presentationml/2006/main">
+<p:sld xmlns:a="http://schemas.openxmlformats.org/drawingml/2006/main" xmlns:p="http://schemas.openxmlformats.org/presentationml/2006/main" xmlns:r="http://schemas.openxmlformats.org/officeDocument/2006/relationships">
   <p:cSld>
     <p:spTree>
       <p:nvGrpSpPr>
@@ -8521,14 +8076,7 @@
         <p:cNvGrpSpPr/>
         <p:nvPr/>
       </p:nvGrpSpPr>
-      <p:grpSpPr>
-        <a:xfrm>
-          <a:off x="0" y="0"/>
-          <a:ext cx="0" cy="0"/>
-          <a:chOff x="0" y="0"/>
-          <a:chExt cx="0" cy="0"/>
-        </a:xfrm>
-      </p:grpSpPr>
+      <p:grpSpPr/>
       <p:sp>
         <p:nvSpPr>
           <p:cNvPr id="2" name="TextBox 1"/>
@@ -8605,12 +8153,15 @@
                 <a:spcPts val="0"/>
               </a:spcAft>
             </a:pPr>
-            <a:endParaRPr sz="1800">
-              <a:solidFill>
-                <a:srgbClr val="212121"/>
-              </a:solidFill>
-              <a:latin typeface="Courier New"/>
-            </a:endParaRPr>
+            <a:r>
+              <a:rPr sz="1800">
+                <a:solidFill>
+                  <a:srgbClr val="212121"/>
+                </a:solidFill>
+                <a:latin typeface="Courier New"/>
+              </a:rPr>
+              <a:t/>
+            </a:r>
           </a:p>
           <a:p>
             <a:pPr>
@@ -8650,12 +8201,15 @@
                 <a:spcPts val="0"/>
               </a:spcAft>
             </a:pPr>
-            <a:endParaRPr sz="1800">
-              <a:solidFill>
-                <a:srgbClr val="212121"/>
-              </a:solidFill>
-              <a:latin typeface="Courier New"/>
-            </a:endParaRPr>
+            <a:r>
+              <a:rPr sz="1800">
+                <a:solidFill>
+                  <a:srgbClr val="212121"/>
+                </a:solidFill>
+                <a:latin typeface="Courier New"/>
+              </a:rPr>
+              <a:t/>
+            </a:r>
           </a:p>
           <a:p>
             <a:pPr>
@@ -8695,12 +8249,14 @@
                 <a:spcPts val="800"/>
               </a:spcAft>
             </a:pPr>
-            <a:endParaRPr sz="1800">
-              <a:solidFill>
-                <a:srgbClr val="212121"/>
-              </a:solidFill>
-              <a:latin typeface="Courier New"/>
-            </a:endParaRPr>
+            <a:r>
+              <a:rPr sz="2200">
+                <a:solidFill>
+                  <a:srgbClr val="212121"/>
+                </a:solidFill>
+              </a:rPr>
+              <a:t/>
+            </a:r>
           </a:p>
           <a:p>
             <a:pPr>
@@ -8728,7 +8284,7 @@
 </file>
 
 <file path=ppt/slides/slide31.xml><?xml version="1.0" encoding="utf-8"?>
-<p:sld xmlns:a="http://schemas.openxmlformats.org/drawingml/2006/main" xmlns:r="http://schemas.openxmlformats.org/officeDocument/2006/relationships" xmlns:p="http://schemas.openxmlformats.org/presentationml/2006/main">
+<p:sld xmlns:a="http://schemas.openxmlformats.org/drawingml/2006/main" xmlns:p="http://schemas.openxmlformats.org/presentationml/2006/main" xmlns:r="http://schemas.openxmlformats.org/officeDocument/2006/relationships">
   <p:cSld>
     <p:spTree>
       <p:nvGrpSpPr>
@@ -8736,14 +8292,7 @@
         <p:cNvGrpSpPr/>
         <p:nvPr/>
       </p:nvGrpSpPr>
-      <p:grpSpPr>
-        <a:xfrm>
-          <a:off x="0" y="0"/>
-          <a:ext cx="0" cy="0"/>
-          <a:chOff x="0" y="0"/>
-          <a:chExt cx="0" cy="0"/>
-        </a:xfrm>
-      </p:grpSpPr>
+      <p:grpSpPr/>
       <p:sp>
         <p:nvSpPr>
           <p:cNvPr id="2" name="TextBox 1"/>
@@ -8852,12 +8401,14 @@
                 <a:spcPts val="800"/>
               </a:spcAft>
             </a:pPr>
-            <a:endParaRPr sz="1800">
-              <a:solidFill>
-                <a:srgbClr val="212121"/>
-              </a:solidFill>
-              <a:latin typeface="Courier New"/>
-            </a:endParaRPr>
+            <a:r>
+              <a:rPr sz="2200">
+                <a:solidFill>
+                  <a:srgbClr val="212121"/>
+                </a:solidFill>
+              </a:rPr>
+              <a:t/>
+            </a:r>
           </a:p>
           <a:p>
             <a:pPr>
@@ -8913,12 +8464,14 @@
                 <a:spcPts val="800"/>
               </a:spcAft>
             </a:pPr>
-            <a:endParaRPr sz="1800">
-              <a:solidFill>
-                <a:srgbClr val="212121"/>
-              </a:solidFill>
-              <a:latin typeface="Courier New"/>
-            </a:endParaRPr>
+            <a:r>
+              <a:rPr sz="2200">
+                <a:solidFill>
+                  <a:srgbClr val="212121"/>
+                </a:solidFill>
+              </a:rPr>
+              <a:t/>
+            </a:r>
           </a:p>
           <a:p>
             <a:pPr>
@@ -8946,7 +8499,7 @@
 </file>
 
 <file path=ppt/slides/slide32.xml><?xml version="1.0" encoding="utf-8"?>
-<p:sld xmlns:a="http://schemas.openxmlformats.org/drawingml/2006/main" xmlns:r="http://schemas.openxmlformats.org/officeDocument/2006/relationships" xmlns:p="http://schemas.openxmlformats.org/presentationml/2006/main">
+<p:sld xmlns:a="http://schemas.openxmlformats.org/drawingml/2006/main" xmlns:p="http://schemas.openxmlformats.org/presentationml/2006/main" xmlns:r="http://schemas.openxmlformats.org/officeDocument/2006/relationships">
   <p:cSld>
     <p:spTree>
       <p:nvGrpSpPr>
@@ -8954,14 +8507,7 @@
         <p:cNvGrpSpPr/>
         <p:nvPr/>
       </p:nvGrpSpPr>
-      <p:grpSpPr>
-        <a:xfrm>
-          <a:off x="0" y="0"/>
-          <a:ext cx="0" cy="0"/>
-          <a:chOff x="0" y="0"/>
-          <a:chExt cx="0" cy="0"/>
-        </a:xfrm>
-      </p:grpSpPr>
+      <p:grpSpPr/>
       <p:sp>
         <p:nvSpPr>
           <p:cNvPr id="2" name="TextBox 1"/>
@@ -9086,12 +8632,14 @@
                 <a:spcPts val="800"/>
               </a:spcAft>
             </a:pPr>
-            <a:endParaRPr sz="1800">
-              <a:solidFill>
-                <a:srgbClr val="212121"/>
-              </a:solidFill>
-              <a:latin typeface="Courier New"/>
-            </a:endParaRPr>
+            <a:r>
+              <a:rPr sz="2200">
+                <a:solidFill>
+                  <a:srgbClr val="212121"/>
+                </a:solidFill>
+              </a:rPr>
+              <a:t/>
+            </a:r>
           </a:p>
           <a:p>
             <a:pPr>
@@ -9149,7 +8697,7 @@
 </file>
 
 <file path=ppt/slides/slide33.xml><?xml version="1.0" encoding="utf-8"?>
-<p:sld xmlns:a="http://schemas.openxmlformats.org/drawingml/2006/main" xmlns:r="http://schemas.openxmlformats.org/officeDocument/2006/relationships" xmlns:p="http://schemas.openxmlformats.org/presentationml/2006/main">
+<p:sld xmlns:a="http://schemas.openxmlformats.org/drawingml/2006/main" xmlns:p="http://schemas.openxmlformats.org/presentationml/2006/main" xmlns:r="http://schemas.openxmlformats.org/officeDocument/2006/relationships">
   <p:cSld>
     <p:spTree>
       <p:nvGrpSpPr>
@@ -9157,14 +8705,7 @@
         <p:cNvGrpSpPr/>
         <p:nvPr/>
       </p:nvGrpSpPr>
-      <p:grpSpPr>
-        <a:xfrm>
-          <a:off x="0" y="0"/>
-          <a:ext cx="0" cy="0"/>
-          <a:chOff x="0" y="0"/>
-          <a:chExt cx="0" cy="0"/>
-        </a:xfrm>
-      </p:grpSpPr>
+      <p:grpSpPr/>
       <p:sp>
         <p:nvSpPr>
           <p:cNvPr id="2" name="TextBox 1"/>
@@ -9288,12 +8829,14 @@
                 <a:spcPts val="800"/>
               </a:spcAft>
             </a:pPr>
-            <a:endParaRPr sz="1800">
-              <a:solidFill>
-                <a:srgbClr val="212121"/>
-              </a:solidFill>
-              <a:latin typeface="Courier New"/>
-            </a:endParaRPr>
+            <a:r>
+              <a:rPr sz="2200">
+                <a:solidFill>
+                  <a:srgbClr val="212121"/>
+                </a:solidFill>
+              </a:rPr>
+              <a:t/>
+            </a:r>
           </a:p>
           <a:p>
             <a:pPr>
@@ -9351,7 +8894,7 @@
 </file>
 
 <file path=ppt/slides/slide34.xml><?xml version="1.0" encoding="utf-8"?>
-<p:sld xmlns:a="http://schemas.openxmlformats.org/drawingml/2006/main" xmlns:r="http://schemas.openxmlformats.org/officeDocument/2006/relationships" xmlns:p="http://schemas.openxmlformats.org/presentationml/2006/main">
+<p:sld xmlns:a="http://schemas.openxmlformats.org/drawingml/2006/main" xmlns:p="http://schemas.openxmlformats.org/presentationml/2006/main" xmlns:r="http://schemas.openxmlformats.org/officeDocument/2006/relationships">
   <p:cSld>
     <p:spTree>
       <p:nvGrpSpPr>
@@ -9359,14 +8902,7 @@
         <p:cNvGrpSpPr/>
         <p:nvPr/>
       </p:nvGrpSpPr>
-      <p:grpSpPr>
-        <a:xfrm>
-          <a:off x="0" y="0"/>
-          <a:ext cx="0" cy="0"/>
-          <a:chOff x="0" y="0"/>
-          <a:chExt cx="0" cy="0"/>
-        </a:xfrm>
-      </p:grpSpPr>
+      <p:grpSpPr/>
       <p:sp>
         <p:nvSpPr>
           <p:cNvPr id="2" name="TextBox 1"/>
@@ -9504,12 +9040,14 @@
                 <a:spcPts val="800"/>
               </a:spcAft>
             </a:pPr>
-            <a:endParaRPr sz="1800">
-              <a:solidFill>
-                <a:srgbClr val="212121"/>
-              </a:solidFill>
-              <a:latin typeface="Courier New"/>
-            </a:endParaRPr>
+            <a:r>
+              <a:rPr sz="2200">
+                <a:solidFill>
+                  <a:srgbClr val="212121"/>
+                </a:solidFill>
+              </a:rPr>
+              <a:t/>
+            </a:r>
           </a:p>
           <a:p>
             <a:pPr>
@@ -9552,7 +9090,7 @@
 </file>
 
 <file path=ppt/slides/slide35.xml><?xml version="1.0" encoding="utf-8"?>
-<p:sld xmlns:a="http://schemas.openxmlformats.org/drawingml/2006/main" xmlns:r="http://schemas.openxmlformats.org/officeDocument/2006/relationships" xmlns:p="http://schemas.openxmlformats.org/presentationml/2006/main">
+<p:sld xmlns:a="http://schemas.openxmlformats.org/drawingml/2006/main" xmlns:p="http://schemas.openxmlformats.org/presentationml/2006/main" xmlns:r="http://schemas.openxmlformats.org/officeDocument/2006/relationships">
   <p:cSld>
     <p:spTree>
       <p:nvGrpSpPr>
@@ -9560,14 +9098,7 @@
         <p:cNvGrpSpPr/>
         <p:nvPr/>
       </p:nvGrpSpPr>
-      <p:grpSpPr>
-        <a:xfrm>
-          <a:off x="0" y="0"/>
-          <a:ext cx="0" cy="0"/>
-          <a:chOff x="0" y="0"/>
-          <a:chExt cx="0" cy="0"/>
-        </a:xfrm>
-      </p:grpSpPr>
+      <p:grpSpPr/>
       <p:sp>
         <p:nvSpPr>
           <p:cNvPr id="2" name="TextBox 1"/>
@@ -9639,7 +9170,7 @@
           </a:fontRef>
         </p:style>
         <p:txBody>
-          <a:bodyPr wrap="square" rtlCol="0" anchor="ctr"/>
+          <a:bodyPr rtlCol="0" anchor="ctr" wrap="square"/>
           <a:lstStyle/>
           <a:p>
             <a:pPr algn="ctr"/>
@@ -9692,7 +9223,7 @@
           </a:fontRef>
         </p:style>
         <p:txBody>
-          <a:bodyPr wrap="square" rtlCol="0" anchor="ctr"/>
+          <a:bodyPr rtlCol="0" anchor="ctr" wrap="square"/>
           <a:lstStyle/>
           <a:p>
             <a:pPr algn="ctr"/>
@@ -9747,7 +9278,6 @@
           <a:lstStyle/>
           <a:p>
             <a:pPr algn="ctr"/>
-            <a:endParaRPr/>
           </a:p>
         </p:txBody>
       </p:sp>
@@ -9789,7 +9319,7 @@
           </a:fontRef>
         </p:style>
         <p:txBody>
-          <a:bodyPr wrap="square" rtlCol="0" anchor="ctr"/>
+          <a:bodyPr rtlCol="0" anchor="ctr" wrap="square"/>
           <a:lstStyle/>
           <a:p>
             <a:pPr algn="ctr"/>
@@ -9845,7 +9375,6 @@
           <a:lstStyle/>
           <a:p>
             <a:pPr algn="ctr"/>
-            <a:endParaRPr/>
           </a:p>
         </p:txBody>
       </p:sp>
@@ -9887,7 +9416,7 @@
           </a:fontRef>
         </p:style>
         <p:txBody>
-          <a:bodyPr wrap="square" rtlCol="0" anchor="ctr"/>
+          <a:bodyPr rtlCol="0" anchor="ctr" wrap="square"/>
           <a:lstStyle/>
           <a:p>
             <a:pPr algn="ctr"/>
@@ -9942,7 +9471,6 @@
           <a:lstStyle/>
           <a:p>
             <a:pPr algn="ctr"/>
-            <a:endParaRPr/>
           </a:p>
         </p:txBody>
       </p:sp>
@@ -9984,7 +9512,7 @@
           </a:fontRef>
         </p:style>
         <p:txBody>
-          <a:bodyPr wrap="square" rtlCol="0" anchor="ctr"/>
+          <a:bodyPr rtlCol="0" anchor="ctr" wrap="square"/>
           <a:lstStyle/>
           <a:p>
             <a:pPr algn="ctr"/>
@@ -10039,7 +9567,6 @@
           <a:lstStyle/>
           <a:p>
             <a:pPr algn="ctr"/>
-            <a:endParaRPr/>
           </a:p>
         </p:txBody>
       </p:sp>
@@ -10100,11 +9627,14 @@
                 <a:spcPts val="800"/>
               </a:spcAft>
             </a:pPr>
-            <a:endParaRPr sz="2400">
-              <a:solidFill>
-                <a:srgbClr val="212121"/>
-              </a:solidFill>
-            </a:endParaRPr>
+            <a:r>
+              <a:rPr sz="2400">
+                <a:solidFill>
+                  <a:srgbClr val="212121"/>
+                </a:solidFill>
+              </a:rPr>
+              <a:t/>
+            </a:r>
           </a:p>
           <a:p>
             <a:pPr>
@@ -10132,7 +9662,7 @@
 </file>
 
 <file path=ppt/slides/slide36.xml><?xml version="1.0" encoding="utf-8"?>
-<p:sld xmlns:a="http://schemas.openxmlformats.org/drawingml/2006/main" xmlns:r="http://schemas.openxmlformats.org/officeDocument/2006/relationships" xmlns:p="http://schemas.openxmlformats.org/presentationml/2006/main">
+<p:sld xmlns:a="http://schemas.openxmlformats.org/drawingml/2006/main" xmlns:p="http://schemas.openxmlformats.org/presentationml/2006/main" xmlns:r="http://schemas.openxmlformats.org/officeDocument/2006/relationships">
   <p:cSld>
     <p:spTree>
       <p:nvGrpSpPr>
@@ -10140,14 +9670,7 @@
         <p:cNvGrpSpPr/>
         <p:nvPr/>
       </p:nvGrpSpPr>
-      <p:grpSpPr>
-        <a:xfrm>
-          <a:off x="0" y="0"/>
-          <a:ext cx="0" cy="0"/>
-          <a:chOff x="0" y="0"/>
-          <a:chExt cx="0" cy="0"/>
-        </a:xfrm>
-      </p:grpSpPr>
+      <p:grpSpPr/>
       <p:sp>
         <p:nvSpPr>
           <p:cNvPr id="2" name="TextBox 1"/>
@@ -10224,25 +9747,27 @@
                 <a:spcPts val="800"/>
               </a:spcAft>
             </a:pPr>
-            <a:endParaRPr sz="2000">
-              <a:solidFill>
-                <a:srgbClr val="212121"/>
-              </a:solidFill>
-              <a:latin typeface="Courier New"/>
-            </a:endParaRPr>
-          </a:p>
-          <a:p>
-            <a:pPr>
-              <a:spcAft>
-                <a:spcPts val="800"/>
-              </a:spcAft>
-            </a:pPr>
             <a:r>
               <a:rPr sz="2400">
                 <a:solidFill>
                   <a:srgbClr val="212121"/>
                 </a:solidFill>
               </a:rPr>
+              <a:t/>
+            </a:r>
+          </a:p>
+          <a:p>
+            <a:pPr>
+              <a:spcAft>
+                <a:spcPts val="800"/>
+              </a:spcAft>
+            </a:pPr>
+            <a:r>
+              <a:rPr sz="2400">
+                <a:solidFill>
+                  <a:srgbClr val="212121"/>
+                </a:solidFill>
+              </a:rPr>
               <a:t>--unwind k copies the loop body k times, each copy guarded by the loop condition.</a:t>
             </a:r>
           </a:p>
@@ -10282,11 +9807,14 @@
                 <a:spcPts val="800"/>
               </a:spcAft>
             </a:pPr>
-            <a:endParaRPr sz="2200">
-              <a:solidFill>
-                <a:srgbClr val="212121"/>
-              </a:solidFill>
-            </a:endParaRPr>
+            <a:r>
+              <a:rPr sz="2400">
+                <a:solidFill>
+                  <a:srgbClr val="212121"/>
+                </a:solidFill>
+              </a:rPr>
+              <a:t/>
+            </a:r>
           </a:p>
           <a:p>
             <a:pPr>
@@ -10314,7 +9842,7 @@
 </file>
 
 <file path=ppt/slides/slide37.xml><?xml version="1.0" encoding="utf-8"?>
-<p:sld xmlns:a="http://schemas.openxmlformats.org/drawingml/2006/main" xmlns:r="http://schemas.openxmlformats.org/officeDocument/2006/relationships" xmlns:p="http://schemas.openxmlformats.org/presentationml/2006/main">
+<p:sld xmlns:a="http://schemas.openxmlformats.org/drawingml/2006/main" xmlns:p="http://schemas.openxmlformats.org/presentationml/2006/main" xmlns:r="http://schemas.openxmlformats.org/officeDocument/2006/relationships">
   <p:cSld>
     <p:spTree>
       <p:nvGrpSpPr>
@@ -10322,14 +9850,7 @@
         <p:cNvGrpSpPr/>
         <p:nvPr/>
       </p:nvGrpSpPr>
-      <p:grpSpPr>
-        <a:xfrm>
-          <a:off x="0" y="0"/>
-          <a:ext cx="0" cy="0"/>
-          <a:chOff x="0" y="0"/>
-          <a:chExt cx="0" cy="0"/>
-        </a:xfrm>
-      </p:grpSpPr>
+      <p:grpSpPr/>
       <p:sp>
         <p:nvSpPr>
           <p:cNvPr id="2" name="TextBox 1"/>
@@ -10373,7 +9894,7 @@
         </p:nvGraphicFramePr>
         <p:xfrm>
           <a:off x="731520" y="1554480"/>
-          <a:ext cx="10698480" cy="1889760"/>
+          <a:ext cx="10698480" cy="1463040"/>
         </p:xfrm>
         <a:graphic>
           <a:graphicData uri="http://schemas.openxmlformats.org/drawingml/2006/table">
@@ -10382,20 +9903,8 @@
                 <a:tableStyleId>{5C22544A-7EE6-4342-B048-85BDC9FD1C3A}</a:tableStyleId>
               </a:tblPr>
               <a:tblGrid>
-                <a:gridCol w="4572000">
-                  <a:extLst>
-                    <a:ext uri="{9D8B030D-6E8A-4147-A177-3AD203B41FA5}">
-                      <a16:colId xmlns:a16="http://schemas.microsoft.com/office/drawing/2014/main" val="20000"/>
-                    </a:ext>
-                  </a:extLst>
-                </a:gridCol>
-                <a:gridCol w="6126480">
-                  <a:extLst>
-                    <a:ext uri="{9D8B030D-6E8A-4147-A177-3AD203B41FA5}">
-                      <a16:colId xmlns:a16="http://schemas.microsoft.com/office/drawing/2014/main" val="20001"/>
-                    </a:ext>
-                  </a:extLst>
-                </a:gridCol>
+                <a:gridCol w="4572000"/>
+                <a:gridCol w="6126480"/>
               </a:tblGrid>
               <a:tr h="365760">
                 <a:tc>
@@ -10424,11 +9933,6 @@
                   </a:txBody>
                   <a:tcPr/>
                 </a:tc>
-                <a:extLst>
-                  <a:ext uri="{0D108BD9-81ED-4DB2-BD59-A6C34878D82A}">
-                    <a16:rowId xmlns:a16="http://schemas.microsoft.com/office/drawing/2014/main" val="10000"/>
-                  </a:ext>
-                </a:extLst>
               </a:tr>
               <a:tr h="365760">
                 <a:tc>
@@ -10457,11 +9961,6 @@
                   </a:txBody>
                   <a:tcPr/>
                 </a:tc>
-                <a:extLst>
-                  <a:ext uri="{0D108BD9-81ED-4DB2-BD59-A6C34878D82A}">
-                    <a16:rowId xmlns:a16="http://schemas.microsoft.com/office/drawing/2014/main" val="10001"/>
-                  </a:ext>
-                </a:extLst>
               </a:tr>
               <a:tr h="365760">
                 <a:tc>
@@ -10490,11 +9989,6 @@
                   </a:txBody>
                   <a:tcPr/>
                 </a:tc>
-                <a:extLst>
-                  <a:ext uri="{0D108BD9-81ED-4DB2-BD59-A6C34878D82A}">
-                    <a16:rowId xmlns:a16="http://schemas.microsoft.com/office/drawing/2014/main" val="10002"/>
-                  </a:ext>
-                </a:extLst>
               </a:tr>
               <a:tr h="365760">
                 <a:tc>
@@ -10523,11 +10017,6 @@
                   </a:txBody>
                   <a:tcPr/>
                 </a:tc>
-                <a:extLst>
-                  <a:ext uri="{0D108BD9-81ED-4DB2-BD59-A6C34878D82A}">
-                    <a16:rowId xmlns:a16="http://schemas.microsoft.com/office/drawing/2014/main" val="10003"/>
-                  </a:ext>
-                </a:extLst>
               </a:tr>
             </a:tbl>
           </a:graphicData>
@@ -10595,7 +10084,7 @@
 </file>
 
 <file path=ppt/slides/slide38.xml><?xml version="1.0" encoding="utf-8"?>
-<p:sld xmlns:a="http://schemas.openxmlformats.org/drawingml/2006/main" xmlns:r="http://schemas.openxmlformats.org/officeDocument/2006/relationships" xmlns:p="http://schemas.openxmlformats.org/presentationml/2006/main">
+<p:sld xmlns:a="http://schemas.openxmlformats.org/drawingml/2006/main" xmlns:p="http://schemas.openxmlformats.org/presentationml/2006/main" xmlns:r="http://schemas.openxmlformats.org/officeDocument/2006/relationships">
   <p:cSld>
     <p:spTree>
       <p:nvGrpSpPr>
@@ -10603,14 +10092,7 @@
         <p:cNvGrpSpPr/>
         <p:nvPr/>
       </p:nvGrpSpPr>
-      <p:grpSpPr>
-        <a:xfrm>
-          <a:off x="0" y="0"/>
-          <a:ext cx="0" cy="0"/>
-          <a:chOff x="0" y="0"/>
-          <a:chExt cx="0" cy="0"/>
-        </a:xfrm>
-      </p:grpSpPr>
+      <p:grpSpPr/>
       <p:sp>
         <p:nvSpPr>
           <p:cNvPr id="2" name="TextBox 1"/>
@@ -10719,12 +10201,14 @@
                 <a:spcPts val="800"/>
               </a:spcAft>
             </a:pPr>
-            <a:endParaRPr sz="2000">
-              <a:solidFill>
-                <a:srgbClr val="212121"/>
-              </a:solidFill>
-              <a:latin typeface="Courier New"/>
-            </a:endParaRPr>
+            <a:r>
+              <a:rPr sz="2400">
+                <a:solidFill>
+                  <a:srgbClr val="212121"/>
+                </a:solidFill>
+              </a:rPr>
+              <a:t/>
+            </a:r>
           </a:p>
           <a:p>
             <a:pPr>
@@ -10767,7 +10251,7 @@
 </file>
 
 <file path=ppt/slides/slide39.xml><?xml version="1.0" encoding="utf-8"?>
-<p:sld xmlns:a="http://schemas.openxmlformats.org/drawingml/2006/main" xmlns:r="http://schemas.openxmlformats.org/officeDocument/2006/relationships" xmlns:p="http://schemas.openxmlformats.org/presentationml/2006/main">
+<p:sld xmlns:a="http://schemas.openxmlformats.org/drawingml/2006/main" xmlns:p="http://schemas.openxmlformats.org/presentationml/2006/main" xmlns:r="http://schemas.openxmlformats.org/officeDocument/2006/relationships">
   <p:cSld>
     <p:spTree>
       <p:nvGrpSpPr>
@@ -10775,14 +10259,7 @@
         <p:cNvGrpSpPr/>
         <p:nvPr/>
       </p:nvGrpSpPr>
-      <p:grpSpPr>
-        <a:xfrm>
-          <a:off x="0" y="0"/>
-          <a:ext cx="0" cy="0"/>
-          <a:chOff x="0" y="0"/>
-          <a:chExt cx="0" cy="0"/>
-        </a:xfrm>
-      </p:grpSpPr>
+      <p:grpSpPr/>
       <p:sp>
         <p:nvSpPr>
           <p:cNvPr id="2" name="TextBox 1"/>
@@ -10859,25 +10336,27 @@
                 <a:spcPts val="800"/>
               </a:spcAft>
             </a:pPr>
-            <a:endParaRPr sz="2200">
-              <a:solidFill>
-                <a:srgbClr val="212121"/>
-              </a:solidFill>
-              <a:latin typeface="Courier New"/>
-            </a:endParaRPr>
-          </a:p>
-          <a:p>
-            <a:pPr>
-              <a:spcAft>
-                <a:spcPts val="800"/>
-              </a:spcAft>
-            </a:pPr>
             <a:r>
               <a:rPr sz="2600">
                 <a:solidFill>
                   <a:srgbClr val="212121"/>
                 </a:solidFill>
               </a:rPr>
+              <a:t/>
+            </a:r>
+          </a:p>
+          <a:p>
+            <a:pPr>
+              <a:spcAft>
+                <a:spcPts val="800"/>
+              </a:spcAft>
+            </a:pPr>
+            <a:r>
+              <a:rPr sz="2600">
+                <a:solidFill>
+                  <a:srgbClr val="212121"/>
+                </a:solidFill>
+              </a:rPr>
               <a:t>sat — the model assigns every input and every choice: replayed in program order, that is the counterexample trace.</a:t>
             </a:r>
           </a:p>
@@ -10902,11 +10381,14 @@
                 <a:spcPts val="800"/>
               </a:spcAft>
             </a:pPr>
-            <a:endParaRPr sz="2600">
-              <a:solidFill>
-                <a:srgbClr val="212121"/>
-              </a:solidFill>
-            </a:endParaRPr>
+            <a:r>
+              <a:rPr sz="2600">
+                <a:solidFill>
+                  <a:srgbClr val="212121"/>
+                </a:solidFill>
+              </a:rPr>
+              <a:t/>
+            </a:r>
           </a:p>
           <a:p>
             <a:pPr>
@@ -10934,7 +10416,7 @@
 </file>
 
 <file path=ppt/slides/slide4.xml><?xml version="1.0" encoding="utf-8"?>
-<p:sld xmlns:a="http://schemas.openxmlformats.org/drawingml/2006/main" xmlns:r="http://schemas.openxmlformats.org/officeDocument/2006/relationships" xmlns:p="http://schemas.openxmlformats.org/presentationml/2006/main">
+<p:sld xmlns:a="http://schemas.openxmlformats.org/drawingml/2006/main" xmlns:p="http://schemas.openxmlformats.org/presentationml/2006/main" xmlns:r="http://schemas.openxmlformats.org/officeDocument/2006/relationships">
   <p:cSld>
     <p:spTree>
       <p:nvGrpSpPr>
@@ -10942,14 +10424,7 @@
         <p:cNvGrpSpPr/>
         <p:nvPr/>
       </p:nvGrpSpPr>
-      <p:grpSpPr>
-        <a:xfrm>
-          <a:off x="0" y="0"/>
-          <a:ext cx="0" cy="0"/>
-          <a:chOff x="0" y="0"/>
-          <a:chExt cx="0" cy="0"/>
-        </a:xfrm>
-      </p:grpSpPr>
+      <p:grpSpPr/>
       <p:sp>
         <p:nvSpPr>
           <p:cNvPr id="2" name="TextBox 1"/>
@@ -11100,11 +10575,14 @@
                 <a:spcPts val="800"/>
               </a:spcAft>
             </a:pPr>
-            <a:endParaRPr sz="2000">
-              <a:solidFill>
-                <a:srgbClr val="212121"/>
-              </a:solidFill>
-            </a:endParaRPr>
+            <a:r>
+              <a:rPr sz="2200">
+                <a:solidFill>
+                  <a:srgbClr val="212121"/>
+                </a:solidFill>
+              </a:rPr>
+              <a:t/>
+            </a:r>
           </a:p>
           <a:p>
             <a:pPr>
@@ -11132,7 +10610,7 @@
 </file>
 
 <file path=ppt/slides/slide40.xml><?xml version="1.0" encoding="utf-8"?>
-<p:sld xmlns:a="http://schemas.openxmlformats.org/drawingml/2006/main" xmlns:r="http://schemas.openxmlformats.org/officeDocument/2006/relationships" xmlns:p="http://schemas.openxmlformats.org/presentationml/2006/main">
+<p:sld xmlns:a="http://schemas.openxmlformats.org/drawingml/2006/main" xmlns:p="http://schemas.openxmlformats.org/presentationml/2006/main" xmlns:r="http://schemas.openxmlformats.org/officeDocument/2006/relationships">
   <p:cSld>
     <p:spTree>
       <p:nvGrpSpPr>
@@ -11140,14 +10618,7 @@
         <p:cNvGrpSpPr/>
         <p:nvPr/>
       </p:nvGrpSpPr>
-      <p:grpSpPr>
-        <a:xfrm>
-          <a:off x="0" y="0"/>
-          <a:ext cx="0" cy="0"/>
-          <a:chOff x="0" y="0"/>
-          <a:chExt cx="0" cy="0"/>
-        </a:xfrm>
-      </p:grpSpPr>
+      <p:grpSpPr/>
       <p:sp>
         <p:nvSpPr>
           <p:cNvPr id="2" name="TextBox 1"/>
@@ -11304,12 +10775,14 @@
                 <a:spcPts val="800"/>
               </a:spcAft>
             </a:pPr>
-            <a:endParaRPr sz="1800">
-              <a:solidFill>
-                <a:srgbClr val="212121"/>
-              </a:solidFill>
-              <a:latin typeface="Courier New"/>
-            </a:endParaRPr>
+            <a:r>
+              <a:rPr sz="2200">
+                <a:solidFill>
+                  <a:srgbClr val="212121"/>
+                </a:solidFill>
+              </a:rPr>
+              <a:t/>
+            </a:r>
           </a:p>
           <a:p>
             <a:pPr>
@@ -11352,7 +10825,7 @@
 </file>
 
 <file path=ppt/slides/slide41.xml><?xml version="1.0" encoding="utf-8"?>
-<p:sld xmlns:a="http://schemas.openxmlformats.org/drawingml/2006/main" xmlns:r="http://schemas.openxmlformats.org/officeDocument/2006/relationships" xmlns:p="http://schemas.openxmlformats.org/presentationml/2006/main">
+<p:sld xmlns:a="http://schemas.openxmlformats.org/drawingml/2006/main" xmlns:p="http://schemas.openxmlformats.org/presentationml/2006/main" xmlns:r="http://schemas.openxmlformats.org/officeDocument/2006/relationships">
   <p:cSld>
     <p:spTree>
       <p:nvGrpSpPr>
@@ -11360,14 +10833,7 @@
         <p:cNvGrpSpPr/>
         <p:nvPr/>
       </p:nvGrpSpPr>
-      <p:grpSpPr>
-        <a:xfrm>
-          <a:off x="0" y="0"/>
-          <a:ext cx="0" cy="0"/>
-          <a:chOff x="0" y="0"/>
-          <a:chExt cx="0" cy="0"/>
-        </a:xfrm>
-      </p:grpSpPr>
+      <p:grpSpPr/>
       <p:sp>
         <p:nvSpPr>
           <p:cNvPr id="2" name="TextBox 1"/>
@@ -11524,12 +10990,15 @@
                 <a:spcPts val="0"/>
               </a:spcAft>
             </a:pPr>
-            <a:endParaRPr sz="1800">
-              <a:solidFill>
-                <a:srgbClr val="212121"/>
-              </a:solidFill>
-              <a:latin typeface="Courier New"/>
-            </a:endParaRPr>
+            <a:r>
+              <a:rPr sz="1800">
+                <a:solidFill>
+                  <a:srgbClr val="212121"/>
+                </a:solidFill>
+                <a:latin typeface="Courier New"/>
+              </a:rPr>
+              <a:t/>
+            </a:r>
           </a:p>
           <a:p>
             <a:pPr>
@@ -11553,12 +11022,14 @@
                 <a:spcPts val="800"/>
               </a:spcAft>
             </a:pPr>
-            <a:endParaRPr sz="1800">
-              <a:solidFill>
-                <a:srgbClr val="212121"/>
-              </a:solidFill>
-              <a:latin typeface="Courier New"/>
-            </a:endParaRPr>
+            <a:r>
+              <a:rPr sz="2200">
+                <a:solidFill>
+                  <a:srgbClr val="212121"/>
+                </a:solidFill>
+              </a:rPr>
+              <a:t/>
+            </a:r>
           </a:p>
           <a:p>
             <a:pPr>
@@ -11601,7 +11072,7 @@
 </file>
 
 <file path=ppt/slides/slide42.xml><?xml version="1.0" encoding="utf-8"?>
-<p:sld xmlns:a="http://schemas.openxmlformats.org/drawingml/2006/main" xmlns:r="http://schemas.openxmlformats.org/officeDocument/2006/relationships" xmlns:p="http://schemas.openxmlformats.org/presentationml/2006/main">
+<p:sld xmlns:a="http://schemas.openxmlformats.org/drawingml/2006/main" xmlns:p="http://schemas.openxmlformats.org/presentationml/2006/main" xmlns:r="http://schemas.openxmlformats.org/officeDocument/2006/relationships">
   <p:cSld>
     <p:spTree>
       <p:nvGrpSpPr>
@@ -11609,14 +11080,7 @@
         <p:cNvGrpSpPr/>
         <p:nvPr/>
       </p:nvGrpSpPr>
-      <p:grpSpPr>
-        <a:xfrm>
-          <a:off x="0" y="0"/>
-          <a:ext cx="0" cy="0"/>
-          <a:chOff x="0" y="0"/>
-          <a:chExt cx="0" cy="0"/>
-        </a:xfrm>
-      </p:grpSpPr>
+      <p:grpSpPr/>
       <p:sp>
         <p:nvSpPr>
           <p:cNvPr id="2" name="TextBox 1"/>
@@ -11725,12 +11189,14 @@
                 <a:spcPts val="800"/>
               </a:spcAft>
             </a:pPr>
-            <a:endParaRPr sz="1800">
-              <a:solidFill>
-                <a:srgbClr val="212121"/>
-              </a:solidFill>
-              <a:latin typeface="Courier New"/>
-            </a:endParaRPr>
+            <a:r>
+              <a:rPr sz="2200">
+                <a:solidFill>
+                  <a:srgbClr val="212121"/>
+                </a:solidFill>
+              </a:rPr>
+              <a:t/>
+            </a:r>
           </a:p>
           <a:p>
             <a:pPr>
@@ -11773,7 +11239,7 @@
 </file>
 
 <file path=ppt/slides/slide43.xml><?xml version="1.0" encoding="utf-8"?>
-<p:sld xmlns:a="http://schemas.openxmlformats.org/drawingml/2006/main" xmlns:r="http://schemas.openxmlformats.org/officeDocument/2006/relationships" xmlns:p="http://schemas.openxmlformats.org/presentationml/2006/main">
+<p:sld xmlns:a="http://schemas.openxmlformats.org/drawingml/2006/main" xmlns:p="http://schemas.openxmlformats.org/presentationml/2006/main" xmlns:r="http://schemas.openxmlformats.org/officeDocument/2006/relationships">
   <p:cSld>
     <p:spTree>
       <p:nvGrpSpPr>
@@ -11781,14 +11247,7 @@
         <p:cNvGrpSpPr/>
         <p:nvPr/>
       </p:nvGrpSpPr>
-      <p:grpSpPr>
-        <a:xfrm>
-          <a:off x="0" y="0"/>
-          <a:ext cx="0" cy="0"/>
-          <a:chOff x="0" y="0"/>
-          <a:chExt cx="0" cy="0"/>
-        </a:xfrm>
-      </p:grpSpPr>
+      <p:grpSpPr/>
       <p:sp>
         <p:nvSpPr>
           <p:cNvPr id="2" name="TextBox 1"/>
@@ -11894,11 +11353,14 @@
                 <a:spcPts val="800"/>
               </a:spcAft>
             </a:pPr>
-            <a:endParaRPr sz="2400">
-              <a:solidFill>
-                <a:srgbClr val="212121"/>
-              </a:solidFill>
-            </a:endParaRPr>
+            <a:r>
+              <a:rPr sz="2400">
+                <a:solidFill>
+                  <a:srgbClr val="212121"/>
+                </a:solidFill>
+              </a:rPr>
+              <a:t/>
+            </a:r>
           </a:p>
           <a:p>
             <a:pPr>
@@ -11926,7 +11388,7 @@
 </file>
 
 <file path=ppt/slides/slide44.xml><?xml version="1.0" encoding="utf-8"?>
-<p:sld xmlns:a="http://schemas.openxmlformats.org/drawingml/2006/main" xmlns:r="http://schemas.openxmlformats.org/officeDocument/2006/relationships" xmlns:p="http://schemas.openxmlformats.org/presentationml/2006/main">
+<p:sld xmlns:a="http://schemas.openxmlformats.org/drawingml/2006/main" xmlns:p="http://schemas.openxmlformats.org/presentationml/2006/main" xmlns:r="http://schemas.openxmlformats.org/officeDocument/2006/relationships">
   <p:cSld>
     <p:spTree>
       <p:nvGrpSpPr>
@@ -11934,14 +11396,7 @@
         <p:cNvGrpSpPr/>
         <p:nvPr/>
       </p:nvGrpSpPr>
-      <p:grpSpPr>
-        <a:xfrm>
-          <a:off x="0" y="0"/>
-          <a:ext cx="0" cy="0"/>
-          <a:chOff x="0" y="0"/>
-          <a:chExt cx="0" cy="0"/>
-        </a:xfrm>
-      </p:grpSpPr>
+      <p:grpSpPr/>
       <p:sp>
         <p:nvSpPr>
           <p:cNvPr id="2" name="TextBox 1"/>
@@ -12034,25 +11489,27 @@
                 <a:spcPts val="800"/>
               </a:spcAft>
             </a:pPr>
-            <a:endParaRPr sz="2200">
-              <a:solidFill>
-                <a:srgbClr val="212121"/>
-              </a:solidFill>
-              <a:latin typeface="Courier New"/>
-            </a:endParaRPr>
-          </a:p>
-          <a:p>
-            <a:pPr>
-              <a:spcAft>
-                <a:spcPts val="800"/>
-              </a:spcAft>
-            </a:pPr>
             <a:r>
               <a:rPr sz="2600">
                 <a:solidFill>
                   <a:srgbClr val="212121"/>
                 </a:solidFill>
               </a:rPr>
+              <a:t/>
+            </a:r>
+          </a:p>
+          <a:p>
+            <a:pPr>
+              <a:spcAft>
+                <a:spcPts val="800"/>
+              </a:spcAft>
+            </a:pPr>
+            <a:r>
+              <a:rPr sz="2600">
+                <a:solidFill>
+                  <a:srgbClr val="212121"/>
+                </a:solidFill>
+              </a:rPr>
               <a:t>FAILED or SUCCESSFUL?</a:t>
             </a:r>
           </a:p>
@@ -12062,11 +11519,14 @@
                 <a:spcPts val="800"/>
               </a:spcAft>
             </a:pPr>
-            <a:endParaRPr sz="2600">
-              <a:solidFill>
-                <a:srgbClr val="212121"/>
-              </a:solidFill>
-            </a:endParaRPr>
+            <a:r>
+              <a:rPr sz="2600">
+                <a:solidFill>
+                  <a:srgbClr val="212121"/>
+                </a:solidFill>
+              </a:rPr>
+              <a:t/>
+            </a:r>
           </a:p>
           <a:p>
             <a:pPr>
@@ -12109,7 +11569,7 @@
 </file>
 
 <file path=ppt/slides/slide45.xml><?xml version="1.0" encoding="utf-8"?>
-<p:sld xmlns:a="http://schemas.openxmlformats.org/drawingml/2006/main" xmlns:r="http://schemas.openxmlformats.org/officeDocument/2006/relationships" xmlns:p="http://schemas.openxmlformats.org/presentationml/2006/main">
+<p:sld xmlns:a="http://schemas.openxmlformats.org/drawingml/2006/main" xmlns:p="http://schemas.openxmlformats.org/presentationml/2006/main" xmlns:r="http://schemas.openxmlformats.org/officeDocument/2006/relationships">
   <p:cSld>
     <p:spTree>
       <p:nvGrpSpPr>
@@ -12117,14 +11577,7 @@
         <p:cNvGrpSpPr/>
         <p:nvPr/>
       </p:nvGrpSpPr>
-      <p:grpSpPr>
-        <a:xfrm>
-          <a:off x="0" y="0"/>
-          <a:ext cx="0" cy="0"/>
-          <a:chOff x="0" y="0"/>
-          <a:chExt cx="0" cy="0"/>
-        </a:xfrm>
-      </p:grpSpPr>
+      <p:grpSpPr/>
       <p:sp>
         <p:nvSpPr>
           <p:cNvPr id="2" name="TextBox 1"/>
@@ -12265,7 +11718,7 @@
 </file>
 
 <file path=ppt/slides/slide46.xml><?xml version="1.0" encoding="utf-8"?>
-<p:sld xmlns:a="http://schemas.openxmlformats.org/drawingml/2006/main" xmlns:r="http://schemas.openxmlformats.org/officeDocument/2006/relationships" xmlns:p="http://schemas.openxmlformats.org/presentationml/2006/main">
+<p:sld xmlns:a="http://schemas.openxmlformats.org/drawingml/2006/main" xmlns:p="http://schemas.openxmlformats.org/presentationml/2006/main" xmlns:r="http://schemas.openxmlformats.org/officeDocument/2006/relationships">
   <p:cSld>
     <p:spTree>
       <p:nvGrpSpPr>
@@ -12273,14 +11726,7 @@
         <p:cNvGrpSpPr/>
         <p:nvPr/>
       </p:nvGrpSpPr>
-      <p:grpSpPr>
-        <a:xfrm>
-          <a:off x="0" y="0"/>
-          <a:ext cx="0" cy="0"/>
-          <a:chOff x="0" y="0"/>
-          <a:chExt cx="0" cy="0"/>
-        </a:xfrm>
-      </p:grpSpPr>
+      <p:grpSpPr/>
       <p:sp>
         <p:nvSpPr>
           <p:cNvPr id="2" name="TextBox 1"/>
@@ -12391,7 +11837,7 @@
 </file>
 
 <file path=ppt/slides/slide47.xml><?xml version="1.0" encoding="utf-8"?>
-<p:sld xmlns:a="http://schemas.openxmlformats.org/drawingml/2006/main" xmlns:r="http://schemas.openxmlformats.org/officeDocument/2006/relationships" xmlns:p="http://schemas.openxmlformats.org/presentationml/2006/main">
+<p:sld xmlns:a="http://schemas.openxmlformats.org/drawingml/2006/main" xmlns:p="http://schemas.openxmlformats.org/presentationml/2006/main" xmlns:r="http://schemas.openxmlformats.org/officeDocument/2006/relationships">
   <p:cSld>
     <p:spTree>
       <p:nvGrpSpPr>
@@ -12399,14 +11845,7 @@
         <p:cNvGrpSpPr/>
         <p:nvPr/>
       </p:nvGrpSpPr>
-      <p:grpSpPr>
-        <a:xfrm>
-          <a:off x="0" y="0"/>
-          <a:ext cx="0" cy="0"/>
-          <a:chOff x="0" y="0"/>
-          <a:chExt cx="0" cy="0"/>
-        </a:xfrm>
-      </p:grpSpPr>
+      <p:grpSpPr/>
       <p:sp>
         <p:nvSpPr>
           <p:cNvPr id="2" name="TextBox 1"/>
@@ -12532,7 +11971,7 @@
 </file>
 
 <file path=ppt/slides/slide48.xml><?xml version="1.0" encoding="utf-8"?>
-<p:sld xmlns:a="http://schemas.openxmlformats.org/drawingml/2006/main" xmlns:r="http://schemas.openxmlformats.org/officeDocument/2006/relationships" xmlns:p="http://schemas.openxmlformats.org/presentationml/2006/main">
+<p:sld xmlns:a="http://schemas.openxmlformats.org/drawingml/2006/main" xmlns:p="http://schemas.openxmlformats.org/presentationml/2006/main" xmlns:r="http://schemas.openxmlformats.org/officeDocument/2006/relationships">
   <p:cSld>
     <p:spTree>
       <p:nvGrpSpPr>
@@ -12540,14 +11979,7 @@
         <p:cNvGrpSpPr/>
         <p:nvPr/>
       </p:nvGrpSpPr>
-      <p:grpSpPr>
-        <a:xfrm>
-          <a:off x="0" y="0"/>
-          <a:ext cx="0" cy="0"/>
-          <a:chOff x="0" y="0"/>
-          <a:chExt cx="0" cy="0"/>
-        </a:xfrm>
-      </p:grpSpPr>
+      <p:grpSpPr/>
       <p:sp>
         <p:nvSpPr>
           <p:cNvPr id="2" name="TextBox 1"/>
@@ -12590,7 +12022,7 @@
         <p:spPr>
           <a:xfrm>
             <a:off x="731520" y="1463040"/>
-            <a:ext cx="10789920" cy="4042132"/>
+            <a:ext cx="10789920" cy="5120640"/>
           </a:xfrm>
           <a:prstGeom prst="rect">
             <a:avLst/>
@@ -12609,41 +12041,28 @@
               </a:spcAft>
             </a:pPr>
             <a:r>
-              <a:rPr sz="2000" dirty="0">
-                <a:solidFill>
-                  <a:srgbClr val="212121"/>
-                </a:solidFill>
-              </a:rPr>
-              <a:t>The BMC pipeline you just saw hunts a counterexample (or proves up to a bound). Abstract interpretation proves P the other way</a:t>
-            </a:r>
-            <a:r>
-              <a:rPr lang="en-GB" sz="2000" dirty="0">
-                <a:solidFill>
-                  <a:srgbClr val="212121"/>
-                </a:solidFill>
-              </a:rPr>
-              <a:t>;</a:t>
-            </a:r>
-            <a:r>
-              <a:rPr sz="2000" dirty="0">
-                <a:solidFill>
-                  <a:srgbClr val="212121"/>
-                </a:solidFill>
-              </a:rPr>
-              <a:t> over-approximate every run at once: no inputs, no paths, no bound.</a:t>
-            </a:r>
-          </a:p>
-          <a:p>
-            <a:pPr>
-              <a:spcAft>
-                <a:spcPts val="800"/>
-              </a:spcAft>
-            </a:pPr>
-            <a:endParaRPr sz="2000" dirty="0">
-              <a:solidFill>
-                <a:srgbClr val="212121"/>
-              </a:solidFill>
-            </a:endParaRPr>
+              <a:rPr sz="2000">
+                <a:solidFill>
+                  <a:srgbClr val="212121"/>
+                </a:solidFill>
+              </a:rPr>
+              <a:t>The BMC pipeline you just saw hunts a counterexample (or proves up to a bound). Abstract interpretation proves P the other way — over-approximate every run at once: no inputs, no paths, no bound.</a:t>
+            </a:r>
+          </a:p>
+          <a:p>
+            <a:pPr>
+              <a:spcAft>
+                <a:spcPts val="800"/>
+              </a:spcAft>
+            </a:pPr>
+            <a:r>
+              <a:rPr sz="2000">
+                <a:solidFill>
+                  <a:srgbClr val="212121"/>
+                </a:solidFill>
+              </a:rPr>
+              <a:t/>
+            </a:r>
           </a:p>
           <a:p>
             <a:pPr>
@@ -12652,7 +12071,7 @@
               </a:spcAft>
             </a:pPr>
             <a:r>
-              <a:rPr sz="1600" dirty="0">
+              <a:rPr sz="1600">
                 <a:solidFill>
                   <a:srgbClr val="212121"/>
                 </a:solidFill>
@@ -12668,7 +12087,7 @@
               </a:spcAft>
             </a:pPr>
             <a:r>
-              <a:rPr sz="1600" dirty="0">
+              <a:rPr sz="1600">
                 <a:solidFill>
                   <a:srgbClr val="212121"/>
                 </a:solidFill>
@@ -12684,7 +12103,7 @@
               </a:spcAft>
             </a:pPr>
             <a:r>
-              <a:rPr sz="1600" dirty="0">
+              <a:rPr sz="1600">
                 <a:solidFill>
                   <a:srgbClr val="212121"/>
                 </a:solidFill>
@@ -12700,7 +12119,7 @@
               </a:spcAft>
             </a:pPr>
             <a:r>
-              <a:rPr sz="1600" dirty="0">
+              <a:rPr sz="1600">
                 <a:solidFill>
                   <a:srgbClr val="212121"/>
                 </a:solidFill>
@@ -12716,7 +12135,7 @@
               </a:spcAft>
             </a:pPr>
             <a:r>
-              <a:rPr sz="1600" dirty="0">
+              <a:rPr sz="1600">
                 <a:solidFill>
                   <a:srgbClr val="212121"/>
                 </a:solidFill>
@@ -12731,12 +12150,14 @@
                 <a:spcPts val="800"/>
               </a:spcAft>
             </a:pPr>
-            <a:endParaRPr sz="1600" dirty="0">
-              <a:solidFill>
-                <a:srgbClr val="212121"/>
-              </a:solidFill>
-              <a:latin typeface="Courier New"/>
-            </a:endParaRPr>
+            <a:r>
+              <a:rPr sz="2000">
+                <a:solidFill>
+                  <a:srgbClr val="212121"/>
+                </a:solidFill>
+              </a:rPr>
+              <a:t/>
+            </a:r>
           </a:p>
           <a:p>
             <a:pPr lvl="1">
@@ -12745,28 +12166,12 @@
               </a:spcAft>
             </a:pPr>
             <a:r>
-              <a:rPr sz="1800" dirty="0">
-                <a:solidFill>
-                  <a:srgbClr val="212121"/>
-                </a:solidFill>
-              </a:rPr>
-              <a:t>Compute the tightest fact the loop can't escape (a fixpoint); if it implies P, P holds for every run</a:t>
-            </a:r>
-            <a:r>
-              <a:rPr lang="en-GB" sz="1800" dirty="0">
-                <a:solidFill>
-                  <a:srgbClr val="212121"/>
-                </a:solidFill>
-              </a:rPr>
-              <a:t>;</a:t>
-            </a:r>
-            <a:r>
-              <a:rPr sz="1800" dirty="0">
-                <a:solidFill>
-                  <a:srgbClr val="212121"/>
-                </a:solidFill>
-              </a:rPr>
-              <a:t> no unrolling.</a:t>
+              <a:rPr sz="1800">
+                <a:solidFill>
+                  <a:srgbClr val="212121"/>
+                </a:solidFill>
+              </a:rPr>
+              <a:t>Compute the tightest fact the loop can't escape (a fixpoint); if it implies P, P holds for every run — no unrolling.</a:t>
             </a:r>
           </a:p>
           <a:p>
@@ -12776,28 +12181,50 @@
               </a:spcAft>
             </a:pPr>
             <a:r>
-              <a:rPr sz="1800" dirty="0">
-                <a:solidFill>
-                  <a:srgbClr val="212121"/>
-                </a:solidFill>
-              </a:rPr>
-              <a:t>Sound, not complete: too coarse → a false alarm. (Astrée proved the A340/A380 fly-by-wire this way</a:t>
-            </a:r>
-            <a:r>
-              <a:rPr lang="en-GB" sz="1800" dirty="0">
-                <a:solidFill>
-                  <a:srgbClr val="212121"/>
-                </a:solidFill>
-              </a:rPr>
-              <a:t>;</a:t>
-            </a:r>
-            <a:r>
-              <a:rPr sz="1800" dirty="0">
-                <a:solidFill>
-                  <a:srgbClr val="212121"/>
-                </a:solidFill>
-              </a:rPr>
-              <a:t> next slide.)</a:t>
+              <a:rPr sz="1800">
+                <a:solidFill>
+                  <a:srgbClr val="212121"/>
+                </a:solidFill>
+              </a:rPr>
+              <a:t>Sound, not complete: too coarse → a false alarm. (Astrée proved the A340/A380 fly-by-wire this way — next slide.)</a:t>
+            </a:r>
+          </a:p>
+        </p:txBody>
+      </p:sp>
+      <p:sp>
+        <p:nvSpPr>
+          <p:cNvPr id="4" name="TextBox 3"/>
+          <p:cNvSpPr txBox="1"/>
+          <p:nvPr/>
+        </p:nvSpPr>
+        <p:spPr>
+          <a:xfrm>
+            <a:off x="731520" y="6400800"/>
+            <a:ext cx="10789920" cy="182880"/>
+          </a:xfrm>
+          <a:prstGeom prst="rect">
+            <a:avLst/>
+          </a:prstGeom>
+          <a:noFill/>
+        </p:spPr>
+        <p:txBody>
+          <a:bodyPr wrap="square">
+            <a:spAutoFit/>
+          </a:bodyPr>
+          <a:lstStyle/>
+          <a:p>
+            <a:pPr>
+              <a:spcAft>
+                <a:spcPts val="800"/>
+              </a:spcAft>
+            </a:pPr>
+            <a:r>
+              <a:rPr sz="1400">
+                <a:solidFill>
+                  <a:srgbClr val="212121"/>
+                </a:solidFill>
+              </a:rPr>
+              <a:t>Sound over-approximation: Cousot &amp; Cousot, POPL 1977 (doi:10.1145/512950.512973)</a:t>
             </a:r>
           </a:p>
         </p:txBody>
@@ -12811,7 +12238,7 @@
 </file>
 
 <file path=ppt/slides/slide49.xml><?xml version="1.0" encoding="utf-8"?>
-<p:sld xmlns:a="http://schemas.openxmlformats.org/drawingml/2006/main" xmlns:r="http://schemas.openxmlformats.org/officeDocument/2006/relationships" xmlns:p="http://schemas.openxmlformats.org/presentationml/2006/main">
+<p:sld xmlns:a="http://schemas.openxmlformats.org/drawingml/2006/main" xmlns:p="http://schemas.openxmlformats.org/presentationml/2006/main" xmlns:r="http://schemas.openxmlformats.org/officeDocument/2006/relationships">
   <p:cSld>
     <p:spTree>
       <p:nvGrpSpPr>
@@ -12819,14 +12246,7 @@
         <p:cNvGrpSpPr/>
         <p:nvPr/>
       </p:nvGrpSpPr>
-      <p:grpSpPr>
-        <a:xfrm>
-          <a:off x="0" y="0"/>
-          <a:ext cx="0" cy="0"/>
-          <a:chOff x="0" y="0"/>
-          <a:chExt cx="0" cy="0"/>
-        </a:xfrm>
-      </p:grpSpPr>
+      <p:grpSpPr/>
       <p:sp>
         <p:nvSpPr>
           <p:cNvPr id="2" name="TextBox 1"/>
@@ -12869,7 +12289,7 @@
         <p:spPr>
           <a:xfrm>
             <a:off x="731520" y="1463040"/>
-            <a:ext cx="10789920" cy="4093428"/>
+            <a:ext cx="10789920" cy="5120640"/>
           </a:xfrm>
           <a:prstGeom prst="rect">
             <a:avLst/>
@@ -12888,57 +12308,28 @@
               </a:spcAft>
             </a:pPr>
             <a:r>
-              <a:rPr sz="1800" dirty="0">
-                <a:solidFill>
-                  <a:srgbClr val="212121"/>
-                </a:solidFill>
-              </a:rPr>
-              <a:t>Abstract domain — the facts you track instead of exact values. Intervals x ∈ [a, b]; richer ones add relationships (octagons ±x ±y ≤ c, </a:t>
-            </a:r>
-            <a:r>
-              <a:rPr sz="1800" dirty="0" err="1">
-                <a:solidFill>
-                  <a:srgbClr val="212121"/>
-                </a:solidFill>
-              </a:rPr>
-              <a:t>polyhedra</a:t>
-            </a:r>
-            <a:r>
-              <a:rPr sz="1800" dirty="0">
-                <a:solidFill>
-                  <a:srgbClr val="212121"/>
-                </a:solidFill>
-              </a:rPr>
-              <a:t>). At a branch you join the two sides</a:t>
-            </a:r>
-            <a:r>
-              <a:rPr lang="en-GB" sz="1800" dirty="0">
-                <a:solidFill>
-                  <a:srgbClr val="212121"/>
-                </a:solidFill>
-              </a:rPr>
-              <a:t>;</a:t>
-            </a:r>
-            <a:r>
-              <a:rPr sz="1800" dirty="0">
-                <a:solidFill>
-                  <a:srgbClr val="212121"/>
-                </a:solidFill>
-              </a:rPr>
-              <a:t> richer domain → more precise, but more costly.</a:t>
-            </a:r>
-          </a:p>
-          <a:p>
-            <a:pPr>
-              <a:spcAft>
-                <a:spcPts val="800"/>
-              </a:spcAft>
-            </a:pPr>
-            <a:endParaRPr sz="1800" dirty="0">
-              <a:solidFill>
-                <a:srgbClr val="212121"/>
-              </a:solidFill>
-            </a:endParaRPr>
+              <a:rPr sz="1800">
+                <a:solidFill>
+                  <a:srgbClr val="212121"/>
+                </a:solidFill>
+              </a:rPr>
+              <a:t>Abstract domain — the facts you track instead of exact values. Intervals x ∈ [a, b]; richer ones add relationships (octagons ±x ±y ≤ c, polyhedra). At a branch you join the two sides — richer domain → more precise, but more costly.</a:t>
+            </a:r>
+          </a:p>
+          <a:p>
+            <a:pPr>
+              <a:spcAft>
+                <a:spcPts val="800"/>
+              </a:spcAft>
+            </a:pPr>
+            <a:r>
+              <a:rPr sz="2000">
+                <a:solidFill>
+                  <a:srgbClr val="212121"/>
+                </a:solidFill>
+              </a:rPr>
+              <a:t/>
+            </a:r>
           </a:p>
           <a:p>
             <a:pPr lvl="1">
@@ -12947,7 +12338,7 @@
               </a:spcAft>
             </a:pPr>
             <a:r>
-              <a:rPr sz="1800" dirty="0">
+              <a:rPr sz="1800">
                 <a:solidFill>
                   <a:srgbClr val="212121"/>
                 </a:solidFill>
@@ -12961,11 +12352,14 @@
                 <a:spcPts val="800"/>
               </a:spcAft>
             </a:pPr>
-            <a:endParaRPr sz="1800" dirty="0">
-              <a:solidFill>
-                <a:srgbClr val="212121"/>
-              </a:solidFill>
-            </a:endParaRPr>
+            <a:r>
+              <a:rPr sz="2000">
+                <a:solidFill>
+                  <a:srgbClr val="212121"/>
+                </a:solidFill>
+              </a:rPr>
+              <a:t/>
+            </a:r>
           </a:p>
           <a:p>
             <a:pPr lvl="1">
@@ -12974,71 +12368,42 @@
               </a:spcAft>
             </a:pPr>
             <a:r>
-              <a:rPr sz="1800" dirty="0">
-                <a:solidFill>
-                  <a:srgbClr val="212121"/>
-                </a:solidFill>
-              </a:rPr>
-              <a:t>Narrowing (</a:t>
-            </a:r>
-            <a:r>
-              <a:rPr sz="1800" dirty="0" err="1">
-                <a:solidFill>
-                  <a:srgbClr val="212121"/>
-                </a:solidFill>
-              </a:rPr>
-              <a:t>Δ</a:t>
-            </a:r>
-            <a:r>
-              <a:rPr sz="1800" dirty="0">
-                <a:solidFill>
-                  <a:srgbClr val="212121"/>
-                </a:solidFill>
-              </a:rPr>
-              <a:t>) — recovers what widening overshot. Re-reading the guard x &lt; 100 pulls [0, +∞) back to [0, 100]: precision restored, still terminating.</a:t>
-            </a:r>
-          </a:p>
-          <a:p>
-            <a:pPr>
-              <a:spcAft>
-                <a:spcPts val="800"/>
-              </a:spcAft>
-            </a:pPr>
-            <a:endParaRPr sz="1800" dirty="0">
-              <a:solidFill>
-                <a:srgbClr val="212121"/>
-              </a:solidFill>
-            </a:endParaRPr>
-          </a:p>
-          <a:p>
-            <a:pPr>
-              <a:spcAft>
-                <a:spcPts val="800"/>
-              </a:spcAft>
-            </a:pPr>
-            <a:r>
-              <a:rPr sz="2000" dirty="0">
-                <a:solidFill>
-                  <a:srgbClr val="212121"/>
-                </a:solidFill>
-              </a:rPr>
-              <a:t>ESBMC ships it too</a:t>
-            </a:r>
-            <a:r>
-              <a:rPr lang="en-GB" sz="2000" dirty="0">
-                <a:solidFill>
-                  <a:srgbClr val="212121"/>
-                </a:solidFill>
-              </a:rPr>
-              <a:t>:</a:t>
-            </a:r>
-            <a:r>
-              <a:rPr sz="2000" dirty="0">
-                <a:solidFill>
-                  <a:srgbClr val="212121"/>
-                </a:solidFill>
-              </a:rPr>
-              <a:t> --interval-analysis — and can supply the invariant k-induction needs (Session 2, Lab 3).</a:t>
+              <a:rPr sz="1800">
+                <a:solidFill>
+                  <a:srgbClr val="212121"/>
+                </a:solidFill>
+              </a:rPr>
+              <a:t>Narrowing (Δ) — recovers what widening overshot. Re-reading the guard x &lt; 100 pulls [0, +∞) back to [0, 100]: precision restored, still terminating.</a:t>
+            </a:r>
+          </a:p>
+          <a:p>
+            <a:pPr>
+              <a:spcAft>
+                <a:spcPts val="800"/>
+              </a:spcAft>
+            </a:pPr>
+            <a:r>
+              <a:rPr sz="2000">
+                <a:solidFill>
+                  <a:srgbClr val="212121"/>
+                </a:solidFill>
+              </a:rPr>
+              <a:t/>
+            </a:r>
+          </a:p>
+          <a:p>
+            <a:pPr>
+              <a:spcAft>
+                <a:spcPts val="800"/>
+              </a:spcAft>
+            </a:pPr>
+            <a:r>
+              <a:rPr sz="2000">
+                <a:solidFill>
+                  <a:srgbClr val="212121"/>
+                </a:solidFill>
+              </a:rPr>
+              <a:t>ESBMC ships it too — --interval-analysis — and can supply the invariant k-induction needs (Session 2, Lab 3).</a:t>
             </a:r>
           </a:p>
         </p:txBody>
@@ -13052,7 +12417,7 @@
 </file>
 
 <file path=ppt/slides/slide5.xml><?xml version="1.0" encoding="utf-8"?>
-<p:sld xmlns:a="http://schemas.openxmlformats.org/drawingml/2006/main" xmlns:r="http://schemas.openxmlformats.org/officeDocument/2006/relationships" xmlns:p="http://schemas.openxmlformats.org/presentationml/2006/main">
+<p:sld xmlns:a="http://schemas.openxmlformats.org/drawingml/2006/main" xmlns:p="http://schemas.openxmlformats.org/presentationml/2006/main" xmlns:r="http://schemas.openxmlformats.org/officeDocument/2006/relationships">
   <p:cSld>
     <p:spTree>
       <p:nvGrpSpPr>
@@ -13060,14 +12425,7 @@
         <p:cNvGrpSpPr/>
         <p:nvPr/>
       </p:nvGrpSpPr>
-      <p:grpSpPr>
-        <a:xfrm>
-          <a:off x="0" y="0"/>
-          <a:ext cx="0" cy="0"/>
-          <a:chOff x="0" y="0"/>
-          <a:chExt cx="0" cy="0"/>
-        </a:xfrm>
-      </p:grpSpPr>
+      <p:grpSpPr/>
       <p:sp>
         <p:nvSpPr>
           <p:cNvPr id="2" name="TextBox 1"/>
@@ -13144,12 +12502,15 @@
                 <a:spcPts val="0"/>
               </a:spcAft>
             </a:pPr>
-            <a:endParaRPr sz="2000">
-              <a:solidFill>
-                <a:srgbClr val="212121"/>
-              </a:solidFill>
-              <a:latin typeface="Courier New"/>
-            </a:endParaRPr>
+            <a:r>
+              <a:rPr sz="2000">
+                <a:solidFill>
+                  <a:srgbClr val="212121"/>
+                </a:solidFill>
+                <a:latin typeface="Courier New"/>
+              </a:rPr>
+              <a:t/>
+            </a:r>
           </a:p>
           <a:p>
             <a:pPr>
@@ -13253,12 +12614,15 @@
                 <a:spcPts val="0"/>
               </a:spcAft>
             </a:pPr>
-            <a:endParaRPr sz="2000">
-              <a:solidFill>
-                <a:srgbClr val="212121"/>
-              </a:solidFill>
-              <a:latin typeface="Courier New"/>
-            </a:endParaRPr>
+            <a:r>
+              <a:rPr sz="2000">
+                <a:solidFill>
+                  <a:srgbClr val="212121"/>
+                </a:solidFill>
+                <a:latin typeface="Courier New"/>
+              </a:rPr>
+              <a:t/>
+            </a:r>
           </a:p>
           <a:p>
             <a:pPr>
@@ -13282,12 +12646,14 @@
                 <a:spcPts val="800"/>
               </a:spcAft>
             </a:pPr>
-            <a:endParaRPr sz="2000">
-              <a:solidFill>
-                <a:srgbClr val="212121"/>
-              </a:solidFill>
-              <a:latin typeface="Courier New"/>
-            </a:endParaRPr>
+            <a:r>
+              <a:rPr sz="2400">
+                <a:solidFill>
+                  <a:srgbClr val="212121"/>
+                </a:solidFill>
+              </a:rPr>
+              <a:t/>
+            </a:r>
           </a:p>
           <a:p>
             <a:pPr>
@@ -13315,7 +12681,7 @@
 </file>
 
 <file path=ppt/slides/slide50.xml><?xml version="1.0" encoding="utf-8"?>
-<p:sld xmlns:a="http://schemas.openxmlformats.org/drawingml/2006/main" xmlns:r="http://schemas.openxmlformats.org/officeDocument/2006/relationships" xmlns:p="http://schemas.openxmlformats.org/presentationml/2006/main">
+<p:sld xmlns:a="http://schemas.openxmlformats.org/drawingml/2006/main" xmlns:p="http://schemas.openxmlformats.org/presentationml/2006/main" xmlns:r="http://schemas.openxmlformats.org/officeDocument/2006/relationships">
   <p:cSld>
     <p:spTree>
       <p:nvGrpSpPr>
@@ -13323,14 +12689,7 @@
         <p:cNvGrpSpPr/>
         <p:nvPr/>
       </p:nvGrpSpPr>
-      <p:grpSpPr>
-        <a:xfrm>
-          <a:off x="0" y="0"/>
-          <a:ext cx="0" cy="0"/>
-          <a:chOff x="0" y="0"/>
-          <a:chExt cx="0" cy="0"/>
-        </a:xfrm>
-      </p:grpSpPr>
+      <p:grpSpPr/>
       <p:sp>
         <p:nvSpPr>
           <p:cNvPr id="2" name="TextBox 1"/>
@@ -13441,7 +12800,7 @@
 </file>
 
 <file path=ppt/slides/slide51.xml><?xml version="1.0" encoding="utf-8"?>
-<p:sld xmlns:a="http://schemas.openxmlformats.org/drawingml/2006/main" xmlns:r="http://schemas.openxmlformats.org/officeDocument/2006/relationships" xmlns:p="http://schemas.openxmlformats.org/presentationml/2006/main">
+<p:sld xmlns:a="http://schemas.openxmlformats.org/drawingml/2006/main" xmlns:p="http://schemas.openxmlformats.org/presentationml/2006/main" xmlns:r="http://schemas.openxmlformats.org/officeDocument/2006/relationships">
   <p:cSld>
     <p:spTree>
       <p:nvGrpSpPr>
@@ -13449,14 +12808,7 @@
         <p:cNvGrpSpPr/>
         <p:nvPr/>
       </p:nvGrpSpPr>
-      <p:grpSpPr>
-        <a:xfrm>
-          <a:off x="0" y="0"/>
-          <a:ext cx="0" cy="0"/>
-          <a:chOff x="0" y="0"/>
-          <a:chExt cx="0" cy="0"/>
-        </a:xfrm>
-      </p:grpSpPr>
+      <p:grpSpPr/>
       <p:sp>
         <p:nvSpPr>
           <p:cNvPr id="2" name="TextBox 1"/>
@@ -13567,7 +12919,7 @@
 </file>
 
 <file path=ppt/slides/slide52.xml><?xml version="1.0" encoding="utf-8"?>
-<p:sld xmlns:a="http://schemas.openxmlformats.org/drawingml/2006/main" xmlns:r="http://schemas.openxmlformats.org/officeDocument/2006/relationships" xmlns:p="http://schemas.openxmlformats.org/presentationml/2006/main">
+<p:sld xmlns:a="http://schemas.openxmlformats.org/drawingml/2006/main" xmlns:p="http://schemas.openxmlformats.org/presentationml/2006/main" xmlns:r="http://schemas.openxmlformats.org/officeDocument/2006/relationships">
   <p:cSld>
     <p:spTree>
       <p:nvGrpSpPr>
@@ -13575,14 +12927,7 @@
         <p:cNvGrpSpPr/>
         <p:nvPr/>
       </p:nvGrpSpPr>
-      <p:grpSpPr>
-        <a:xfrm>
-          <a:off x="0" y="0"/>
-          <a:ext cx="0" cy="0"/>
-          <a:chOff x="0" y="0"/>
-          <a:chExt cx="0" cy="0"/>
-        </a:xfrm>
-      </p:grpSpPr>
+      <p:grpSpPr/>
       <p:sp>
         <p:nvSpPr>
           <p:cNvPr id="2" name="TextBox 1"/>
@@ -13673,24 +13018,27 @@
                 <a:spcPts val="800"/>
               </a:spcAft>
             </a:pPr>
-            <a:endParaRPr sz="2000">
-              <a:solidFill>
-                <a:srgbClr val="212121"/>
-              </a:solidFill>
-            </a:endParaRPr>
-          </a:p>
-          <a:p>
-            <a:pPr>
-              <a:spcAft>
-                <a:spcPts val="800"/>
-              </a:spcAft>
-            </a:pPr>
             <a:r>
               <a:rPr sz="2200">
                 <a:solidFill>
                   <a:srgbClr val="212121"/>
                 </a:solidFill>
               </a:rPr>
+              <a:t/>
+            </a:r>
+          </a:p>
+          <a:p>
+            <a:pPr>
+              <a:spcAft>
+                <a:spcPts val="800"/>
+              </a:spcAft>
+            </a:pPr>
+            <a:r>
+              <a:rPr sz="2200">
+                <a:solidFill>
+                  <a:srgbClr val="212121"/>
+                </a:solidFill>
+              </a:rPr>
               <a:t>irep2 is the typed, reference-counted representation everything lowers to and every backend consumes.</a:t>
             </a:r>
           </a:p>
@@ -13731,12 +13079,14 @@
                 <a:spcPts val="800"/>
               </a:spcAft>
             </a:pPr>
-            <a:endParaRPr sz="1800">
-              <a:solidFill>
-                <a:srgbClr val="212121"/>
-              </a:solidFill>
-              <a:latin typeface="Courier New"/>
-            </a:endParaRPr>
+            <a:r>
+              <a:rPr sz="2200">
+                <a:solidFill>
+                  <a:srgbClr val="212121"/>
+                </a:solidFill>
+              </a:rPr>
+              <a:t/>
+            </a:r>
           </a:p>
           <a:p>
             <a:pPr>
@@ -13803,7 +13153,7 @@
 </file>
 
 <file path=ppt/slides/slide53.xml><?xml version="1.0" encoding="utf-8"?>
-<p:sld xmlns:a="http://schemas.openxmlformats.org/drawingml/2006/main" xmlns:r="http://schemas.openxmlformats.org/officeDocument/2006/relationships" xmlns:p="http://schemas.openxmlformats.org/presentationml/2006/main">
+<p:sld xmlns:a="http://schemas.openxmlformats.org/drawingml/2006/main" xmlns:p="http://schemas.openxmlformats.org/presentationml/2006/main" xmlns:r="http://schemas.openxmlformats.org/officeDocument/2006/relationships">
   <p:cSld>
     <p:spTree>
       <p:nvGrpSpPr>
@@ -13811,14 +13161,7 @@
         <p:cNvGrpSpPr/>
         <p:nvPr/>
       </p:nvGrpSpPr>
-      <p:grpSpPr>
-        <a:xfrm>
-          <a:off x="0" y="0"/>
-          <a:ext cx="0" cy="0"/>
-          <a:chOff x="0" y="0"/>
-          <a:chExt cx="0" cy="0"/>
-        </a:xfrm>
-      </p:grpSpPr>
+      <p:grpSpPr/>
       <p:sp>
         <p:nvSpPr>
           <p:cNvPr id="2" name="TextBox 1"/>
@@ -13959,7 +13302,7 @@
 </file>
 
 <file path=ppt/slides/slide54.xml><?xml version="1.0" encoding="utf-8"?>
-<p:sld xmlns:a="http://schemas.openxmlformats.org/drawingml/2006/main" xmlns:r="http://schemas.openxmlformats.org/officeDocument/2006/relationships" xmlns:p="http://schemas.openxmlformats.org/presentationml/2006/main">
+<p:sld xmlns:a="http://schemas.openxmlformats.org/drawingml/2006/main" xmlns:p="http://schemas.openxmlformats.org/presentationml/2006/main" xmlns:r="http://schemas.openxmlformats.org/officeDocument/2006/relationships">
   <p:cSld>
     <p:spTree>
       <p:nvGrpSpPr>
@@ -13967,14 +13310,7 @@
         <p:cNvGrpSpPr/>
         <p:nvPr/>
       </p:nvGrpSpPr>
-      <p:grpSpPr>
-        <a:xfrm>
-          <a:off x="0" y="0"/>
-          <a:ext cx="0" cy="0"/>
-          <a:chOff x="0" y="0"/>
-          <a:chExt cx="0" cy="0"/>
-        </a:xfrm>
-      </p:grpSpPr>
+      <p:grpSpPr/>
       <p:sp>
         <p:nvSpPr>
           <p:cNvPr id="2" name="TextBox 1"/>
@@ -14134,7 +13470,7 @@
 </file>
 
 <file path=ppt/slides/slide6.xml><?xml version="1.0" encoding="utf-8"?>
-<p:sld xmlns:a="http://schemas.openxmlformats.org/drawingml/2006/main" xmlns:r="http://schemas.openxmlformats.org/officeDocument/2006/relationships" xmlns:p="http://schemas.openxmlformats.org/presentationml/2006/main">
+<p:sld xmlns:a="http://schemas.openxmlformats.org/drawingml/2006/main" xmlns:p="http://schemas.openxmlformats.org/presentationml/2006/main" xmlns:r="http://schemas.openxmlformats.org/officeDocument/2006/relationships">
   <p:cSld>
     <p:spTree>
       <p:nvGrpSpPr>
@@ -14142,14 +13478,7 @@
         <p:cNvGrpSpPr/>
         <p:nvPr/>
       </p:nvGrpSpPr>
-      <p:grpSpPr>
-        <a:xfrm>
-          <a:off x="0" y="0"/>
-          <a:ext cx="0" cy="0"/>
-          <a:chOff x="0" y="0"/>
-          <a:chExt cx="0" cy="0"/>
-        </a:xfrm>
-      </p:grpSpPr>
+      <p:grpSpPr/>
       <p:sp>
         <p:nvSpPr>
           <p:cNvPr id="2" name="TextBox 1"/>
@@ -14193,7 +13522,7 @@
         </p:nvGraphicFramePr>
         <p:xfrm>
           <a:off x="731520" y="1463040"/>
-          <a:ext cx="10698480" cy="1584960"/>
+          <a:ext cx="10698480" cy="1463040"/>
         </p:xfrm>
         <a:graphic>
           <a:graphicData uri="http://schemas.openxmlformats.org/drawingml/2006/table">
@@ -14202,20 +13531,8 @@
                 <a:tableStyleId>{5C22544A-7EE6-4342-B048-85BDC9FD1C3A}</a:tableStyleId>
               </a:tblPr>
               <a:tblGrid>
-                <a:gridCol w="3840480">
-                  <a:extLst>
-                    <a:ext uri="{9D8B030D-6E8A-4147-A177-3AD203B41FA5}">
-                      <a16:colId xmlns:a16="http://schemas.microsoft.com/office/drawing/2014/main" val="20000"/>
-                    </a:ext>
-                  </a:extLst>
-                </a:gridCol>
-                <a:gridCol w="6858000">
-                  <a:extLst>
-                    <a:ext uri="{9D8B030D-6E8A-4147-A177-3AD203B41FA5}">
-                      <a16:colId xmlns:a16="http://schemas.microsoft.com/office/drawing/2014/main" val="20001"/>
-                    </a:ext>
-                  </a:extLst>
-                </a:gridCol>
+                <a:gridCol w="3840480"/>
+                <a:gridCol w="6858000"/>
               </a:tblGrid>
               <a:tr h="365760">
                 <a:tc>
@@ -14235,17 +13552,10 @@
                   <a:txBody>
                     <a:bodyPr/>
                     <a:lstStyle/>
-                    <a:p>
-                      <a:endParaRPr/>
-                    </a:p>
+                    <a:p/>
                   </a:txBody>
                   <a:tcPr/>
                 </a:tc>
-                <a:extLst>
-                  <a:ext uri="{0D108BD9-81ED-4DB2-BD59-A6C34878D82A}">
-                    <a16:rowId xmlns:a16="http://schemas.microsoft.com/office/drawing/2014/main" val="10000"/>
-                  </a:ext>
-                </a:extLst>
               </a:tr>
               <a:tr h="365760">
                 <a:tc>
@@ -14274,11 +13584,6 @@
                   </a:txBody>
                   <a:tcPr/>
                 </a:tc>
-                <a:extLst>
-                  <a:ext uri="{0D108BD9-81ED-4DB2-BD59-A6C34878D82A}">
-                    <a16:rowId xmlns:a16="http://schemas.microsoft.com/office/drawing/2014/main" val="10001"/>
-                  </a:ext>
-                </a:extLst>
               </a:tr>
               <a:tr h="365760">
                 <a:tc>
@@ -14307,11 +13612,6 @@
                   </a:txBody>
                   <a:tcPr/>
                 </a:tc>
-                <a:extLst>
-                  <a:ext uri="{0D108BD9-81ED-4DB2-BD59-A6C34878D82A}">
-                    <a16:rowId xmlns:a16="http://schemas.microsoft.com/office/drawing/2014/main" val="10002"/>
-                  </a:ext>
-                </a:extLst>
               </a:tr>
               <a:tr h="365760">
                 <a:tc>
@@ -14340,11 +13640,6 @@
                   </a:txBody>
                   <a:tcPr/>
                 </a:tc>
-                <a:extLst>
-                  <a:ext uri="{0D108BD9-81ED-4DB2-BD59-A6C34878D82A}">
-                    <a16:rowId xmlns:a16="http://schemas.microsoft.com/office/drawing/2014/main" val="10003"/>
-                  </a:ext>
-                </a:extLst>
               </a:tr>
             </a:tbl>
           </a:graphicData>
@@ -14442,7 +13737,7 @@
 </file>
 
 <file path=ppt/slides/slide7.xml><?xml version="1.0" encoding="utf-8"?>
-<p:sld xmlns:a="http://schemas.openxmlformats.org/drawingml/2006/main" xmlns:r="http://schemas.openxmlformats.org/officeDocument/2006/relationships" xmlns:p="http://schemas.openxmlformats.org/presentationml/2006/main">
+<p:sld xmlns:a="http://schemas.openxmlformats.org/drawingml/2006/main" xmlns:p="http://schemas.openxmlformats.org/presentationml/2006/main" xmlns:r="http://schemas.openxmlformats.org/officeDocument/2006/relationships">
   <p:cSld>
     <p:spTree>
       <p:nvGrpSpPr>
@@ -14450,14 +13745,7 @@
         <p:cNvGrpSpPr/>
         <p:nvPr/>
       </p:nvGrpSpPr>
-      <p:grpSpPr>
-        <a:xfrm>
-          <a:off x="0" y="0"/>
-          <a:ext cx="0" cy="0"/>
-          <a:chOff x="0" y="0"/>
-          <a:chExt cx="0" cy="0"/>
-        </a:xfrm>
-      </p:grpSpPr>
+      <p:grpSpPr/>
       <p:sp>
         <p:nvSpPr>
           <p:cNvPr id="2" name="TextBox 1"/>
@@ -14534,12 +13822,15 @@
                 <a:spcPts val="0"/>
               </a:spcAft>
             </a:pPr>
-            <a:endParaRPr sz="1800">
-              <a:solidFill>
-                <a:srgbClr val="212121"/>
-              </a:solidFill>
-              <a:latin typeface="Courier New"/>
-            </a:endParaRPr>
+            <a:r>
+              <a:rPr sz="1800">
+                <a:solidFill>
+                  <a:srgbClr val="212121"/>
+                </a:solidFill>
+                <a:latin typeface="Courier New"/>
+              </a:rPr>
+              <a:t/>
+            </a:r>
           </a:p>
           <a:p>
             <a:pPr>
@@ -14627,12 +13918,15 @@
                 <a:spcPts val="0"/>
               </a:spcAft>
             </a:pPr>
-            <a:endParaRPr sz="1800">
-              <a:solidFill>
-                <a:srgbClr val="212121"/>
-              </a:solidFill>
-              <a:latin typeface="Courier New"/>
-            </a:endParaRPr>
+            <a:r>
+              <a:rPr sz="1800">
+                <a:solidFill>
+                  <a:srgbClr val="212121"/>
+                </a:solidFill>
+                <a:latin typeface="Courier New"/>
+              </a:rPr>
+              <a:t/>
+            </a:r>
           </a:p>
           <a:p>
             <a:pPr>
@@ -14656,12 +13950,14 @@
                 <a:spcPts val="800"/>
               </a:spcAft>
             </a:pPr>
-            <a:endParaRPr sz="1800">
-              <a:solidFill>
-                <a:srgbClr val="212121"/>
-              </a:solidFill>
-              <a:latin typeface="Courier New"/>
-            </a:endParaRPr>
+            <a:r>
+              <a:rPr sz="2200">
+                <a:solidFill>
+                  <a:srgbClr val="212121"/>
+                </a:solidFill>
+              </a:rPr>
+              <a:t/>
+            </a:r>
           </a:p>
           <a:p>
             <a:pPr>
@@ -14689,7 +13985,7 @@
 </file>
 
 <file path=ppt/slides/slide8.xml><?xml version="1.0" encoding="utf-8"?>
-<p:sld xmlns:a="http://schemas.openxmlformats.org/drawingml/2006/main" xmlns:r="http://schemas.openxmlformats.org/officeDocument/2006/relationships" xmlns:p="http://schemas.openxmlformats.org/presentationml/2006/main">
+<p:sld xmlns:a="http://schemas.openxmlformats.org/drawingml/2006/main" xmlns:p="http://schemas.openxmlformats.org/presentationml/2006/main" xmlns:r="http://schemas.openxmlformats.org/officeDocument/2006/relationships">
   <p:cSld>
     <p:spTree>
       <p:nvGrpSpPr>
@@ -14697,14 +13993,7 @@
         <p:cNvGrpSpPr/>
         <p:nvPr/>
       </p:nvGrpSpPr>
-      <p:grpSpPr>
-        <a:xfrm>
-          <a:off x="0" y="0"/>
-          <a:ext cx="0" cy="0"/>
-          <a:chOff x="0" y="0"/>
-          <a:chExt cx="0" cy="0"/>
-        </a:xfrm>
-      </p:grpSpPr>
+      <p:grpSpPr/>
       <p:sp>
         <p:nvSpPr>
           <p:cNvPr id="2" name="TextBox 1"/>
@@ -14860,12 +14149,15 @@
                 <a:spcPts val="0"/>
               </a:spcAft>
             </a:pPr>
-            <a:endParaRPr sz="1600">
-              <a:solidFill>
-                <a:srgbClr val="212121"/>
-              </a:solidFill>
-              <a:latin typeface="Courier New"/>
-            </a:endParaRPr>
+            <a:r>
+              <a:rPr sz="1600">
+                <a:solidFill>
+                  <a:srgbClr val="212121"/>
+                </a:solidFill>
+                <a:latin typeface="Courier New"/>
+              </a:rPr>
+              <a:t/>
+            </a:r>
           </a:p>
           <a:p>
             <a:pPr>
@@ -14905,12 +14197,15 @@
                 <a:spcPts val="0"/>
               </a:spcAft>
             </a:pPr>
-            <a:endParaRPr sz="1600">
-              <a:solidFill>
-                <a:srgbClr val="212121"/>
-              </a:solidFill>
-              <a:latin typeface="Courier New"/>
-            </a:endParaRPr>
+            <a:r>
+              <a:rPr sz="1600">
+                <a:solidFill>
+                  <a:srgbClr val="212121"/>
+                </a:solidFill>
+                <a:latin typeface="Courier New"/>
+              </a:rPr>
+              <a:t/>
+            </a:r>
           </a:p>
           <a:p>
             <a:pPr>
@@ -14982,12 +14277,14 @@
                 <a:spcPts val="800"/>
               </a:spcAft>
             </a:pPr>
-            <a:endParaRPr sz="1600">
-              <a:solidFill>
-                <a:srgbClr val="212121"/>
-              </a:solidFill>
-              <a:latin typeface="Courier New"/>
-            </a:endParaRPr>
+            <a:r>
+              <a:rPr sz="2000">
+                <a:solidFill>
+                  <a:srgbClr val="212121"/>
+                </a:solidFill>
+              </a:rPr>
+              <a:t/>
+            </a:r>
           </a:p>
           <a:p>
             <a:pPr>
@@ -15054,7 +14351,7 @@
 </file>
 
 <file path=ppt/slides/slide9.xml><?xml version="1.0" encoding="utf-8"?>
-<p:sld xmlns:a="http://schemas.openxmlformats.org/drawingml/2006/main" xmlns:r="http://schemas.openxmlformats.org/officeDocument/2006/relationships" xmlns:p="http://schemas.openxmlformats.org/presentationml/2006/main">
+<p:sld xmlns:a="http://schemas.openxmlformats.org/drawingml/2006/main" xmlns:p="http://schemas.openxmlformats.org/presentationml/2006/main" xmlns:r="http://schemas.openxmlformats.org/officeDocument/2006/relationships">
   <p:cSld>
     <p:spTree>
       <p:nvGrpSpPr>
@@ -15062,14 +14359,7 @@
         <p:cNvGrpSpPr/>
         <p:nvPr/>
       </p:nvGrpSpPr>
-      <p:grpSpPr>
-        <a:xfrm>
-          <a:off x="0" y="0"/>
-          <a:ext cx="0" cy="0"/>
-          <a:chOff x="0" y="0"/>
-          <a:chExt cx="0" cy="0"/>
-        </a:xfrm>
-      </p:grpSpPr>
+      <p:grpSpPr/>
       <p:sp>
         <p:nvSpPr>
           <p:cNvPr id="2" name="TextBox 1"/>
@@ -15193,12 +14483,15 @@
                 <a:spcPts val="0"/>
               </a:spcAft>
             </a:pPr>
-            <a:endParaRPr sz="1600">
-              <a:solidFill>
-                <a:srgbClr val="212121"/>
-              </a:solidFill>
-              <a:latin typeface="Courier New"/>
-            </a:endParaRPr>
+            <a:r>
+              <a:rPr sz="1600">
+                <a:solidFill>
+                  <a:srgbClr val="212121"/>
+                </a:solidFill>
+                <a:latin typeface="Courier New"/>
+              </a:rPr>
+              <a:t/>
+            </a:r>
           </a:p>
           <a:p>
             <a:pPr>
@@ -15238,12 +14531,15 @@
                 <a:spcPts val="0"/>
               </a:spcAft>
             </a:pPr>
-            <a:endParaRPr sz="1600">
-              <a:solidFill>
-                <a:srgbClr val="212121"/>
-              </a:solidFill>
-              <a:latin typeface="Courier New"/>
-            </a:endParaRPr>
+            <a:r>
+              <a:rPr sz="1600">
+                <a:solidFill>
+                  <a:srgbClr val="212121"/>
+                </a:solidFill>
+                <a:latin typeface="Courier New"/>
+              </a:rPr>
+              <a:t/>
+            </a:r>
           </a:p>
           <a:p>
             <a:pPr>
@@ -15299,12 +14595,14 @@
                 <a:spcPts val="800"/>
               </a:spcAft>
             </a:pPr>
-            <a:endParaRPr sz="1600">
-              <a:solidFill>
-                <a:srgbClr val="212121"/>
-              </a:solidFill>
-              <a:latin typeface="Courier New"/>
-            </a:endParaRPr>
+            <a:r>
+              <a:rPr sz="2000">
+                <a:solidFill>
+                  <a:srgbClr val="212121"/>
+                </a:solidFill>
+              </a:rPr>
+              <a:t/>
+            </a:r>
           </a:p>
           <a:p>
             <a:pPr>

</xml_diff>

<commit_message>
Add function contracts: Lab 3 exercise + Session 1 foundation
New labs/lab3/contract.c (clamp with a seeded ensures bug) teaches function
contracts: --enforce-contract finds the violation, the fix verifies, and
--replace-call-with-contract demonstrates modular reasoning (all verified on
ESBMC 8.3.0). Add a Session 2 Lab 3 slide and a Session 1 foundation slide
(Hoare triples + design-by-contract), README Part 3, and ledger rows.

Citations on the S1 slide verified via citation-verifier against DBLP:
Hoare, CACM 1969 (doi:10.1145/363235.363259); Meyer, IEEE Computer 1992
(doi:10.1109/2.161279).
</commit_message>
<xml_diff>
--- a/slides/session1/01-session1-fundamentals.pptx
+++ b/slides/session1/01-session1-fundamentals.pptx
@@ -59,6 +59,7 @@
     <p:sldId id="307" r:id="rId58"/>
     <p:sldId id="308" r:id="rId59"/>
     <p:sldId id="309" r:id="rId60"/>
+    <p:sldId id="310" r:id="rId61"/>
   </p:sldIdLst>
   <p:sldSz cx="12191695" cy="6858000" type="screen4x3"/>
   <p:notesSz cx="6858000" cy="9144000"/>
@@ -11276,7 +11277,7 @@
                   <a:srgbClr val="5A0A7A"/>
                 </a:solidFill>
               </a:rPr>
-              <a:t>Beyond one thread</a:t>
+              <a:t>Specifying functions: contracts (pre/post)</a:t>
             </a:r>
           </a:p>
         </p:txBody>
@@ -11289,8 +11290,8 @@
         </p:nvSpPr>
         <p:spPr>
           <a:xfrm>
-            <a:off x="731520" y="1645920"/>
-            <a:ext cx="10789920" cy="4937760"/>
+            <a:off x="731520" y="1463040"/>
+            <a:ext cx="10789920" cy="5120640"/>
           </a:xfrm>
           <a:prstGeom prst="rect">
             <a:avLst/>
@@ -11309,52 +11310,52 @@
               </a:spcAft>
             </a:pPr>
             <a:r>
-              <a:rPr sz="2400">
-                <a:solidFill>
-                  <a:srgbClr val="212121"/>
-                </a:solidFill>
-              </a:rPr>
-              <a:t>Two threads of two and one statements already have three interleavings. Real code has billions.</a:t>
-            </a:r>
-          </a:p>
-          <a:p>
-            <a:pPr>
-              <a:spcAft>
-                <a:spcPts val="800"/>
-              </a:spcAft>
-            </a:pPr>
-            <a:r>
-              <a:rPr sz="2400">
-                <a:solidFill>
-                  <a:srgbClr val="212121"/>
-                </a:solidFill>
-              </a:rPr>
-              <a:t>Run the program a million times and the bad interleaving may never show up — Therac-25's bug hid exactly this way.</a:t>
-            </a:r>
-          </a:p>
-          <a:p>
-            <a:pPr>
-              <a:spcAft>
-                <a:spcPts val="800"/>
-              </a:spcAft>
-            </a:pPr>
-            <a:r>
-              <a:rPr sz="2400">
-                <a:solidFill>
-                  <a:srgbClr val="212121"/>
-                </a:solidFill>
-              </a:rPr>
-              <a:t>A model checker enumerates every interleaving up to a bound, including the one that kills your assertion.</a:t>
-            </a:r>
-          </a:p>
-          <a:p>
-            <a:pPr>
-              <a:spcAft>
-                <a:spcPts val="800"/>
-              </a:spcAft>
-            </a:pPr>
-            <a:r>
-              <a:rPr sz="2400">
+              <a:rPr sz="2000">
+                <a:solidFill>
+                  <a:srgbClr val="212121"/>
+                </a:solidFill>
+              </a:rPr>
+              <a:t>A Hoare triple {P} S {Q}: if precondition P holds before S, postcondition Q holds after. Design-by-contract splits the duty:</a:t>
+            </a:r>
+          </a:p>
+          <a:p>
+            <a:pPr lvl="1">
+              <a:spcAft>
+                <a:spcPts val="800"/>
+              </a:spcAft>
+            </a:pPr>
+            <a:r>
+              <a:rPr sz="1800">
+                <a:solidFill>
+                  <a:srgbClr val="212121"/>
+                </a:solidFill>
+              </a:rPr>
+              <a:t>requires (precondition) — the caller's duty before the call.</a:t>
+            </a:r>
+          </a:p>
+          <a:p>
+            <a:pPr lvl="1">
+              <a:spcAft>
+                <a:spcPts val="800"/>
+              </a:spcAft>
+            </a:pPr>
+            <a:r>
+              <a:rPr sz="1800">
+                <a:solidFill>
+                  <a:srgbClr val="212121"/>
+                </a:solidFill>
+              </a:rPr>
+              <a:t>ensures (postcondition) — the function's promise on return.</a:t>
+            </a:r>
+          </a:p>
+          <a:p>
+            <a:pPr>
+              <a:spcAft>
+                <a:spcPts val="800"/>
+              </a:spcAft>
+            </a:pPr>
+            <a:r>
+              <a:rPr sz="2000">
                 <a:solidFill>
                   <a:srgbClr val="212121"/>
                 </a:solidFill>
@@ -11369,12 +11370,80 @@
               </a:spcAft>
             </a:pPr>
             <a:r>
-              <a:rPr sz="2400">
-                <a:solidFill>
-                  <a:srgbClr val="212121"/>
-                </a:solidFill>
-              </a:rPr>
-              <a:t>Session 2, Lab 4: you write down the killer interleaving before the tool finds it.</a:t>
+              <a:rPr sz="2000">
+                <a:solidFill>
+                  <a:srgbClr val="212121"/>
+                </a:solidFill>
+              </a:rPr>
+              <a:t>Why it matters: verify each function once against its contract, then callers trust the contract — not the body. That is modular (assume-guarantee) verification, and it is how proof scales.</a:t>
+            </a:r>
+          </a:p>
+          <a:p>
+            <a:pPr>
+              <a:spcAft>
+                <a:spcPts val="800"/>
+              </a:spcAft>
+            </a:pPr>
+            <a:r>
+              <a:rPr sz="2000">
+                <a:solidFill>
+                  <a:srgbClr val="212121"/>
+                </a:solidFill>
+              </a:rPr>
+              <a:t/>
+            </a:r>
+          </a:p>
+          <a:p>
+            <a:pPr>
+              <a:spcAft>
+                <a:spcPts val="800"/>
+              </a:spcAft>
+            </a:pPr>
+            <a:r>
+              <a:rPr sz="2000">
+                <a:solidFill>
+                  <a:srgbClr val="212121"/>
+                </a:solidFill>
+              </a:rPr>
+              <a:t>The engine of the deductive-verification row (Dafny, Frama-C/WP, SPARK). ESBMC has it too: __ESBMC_requires / __ESBMC_ensures, with --enforce-contract vs --replace-call-with-contract (Session 2, Lab 3).</a:t>
+            </a:r>
+          </a:p>
+        </p:txBody>
+      </p:sp>
+      <p:sp>
+        <p:nvSpPr>
+          <p:cNvPr id="4" name="TextBox 3"/>
+          <p:cNvSpPr txBox="1"/>
+          <p:nvPr/>
+        </p:nvSpPr>
+        <p:spPr>
+          <a:xfrm>
+            <a:off x="731520" y="6400800"/>
+            <a:ext cx="10789920" cy="182880"/>
+          </a:xfrm>
+          <a:prstGeom prst="rect">
+            <a:avLst/>
+          </a:prstGeom>
+          <a:noFill/>
+        </p:spPr>
+        <p:txBody>
+          <a:bodyPr wrap="square">
+            <a:spAutoFit/>
+          </a:bodyPr>
+          <a:lstStyle/>
+          <a:p>
+            <a:pPr>
+              <a:spcAft>
+                <a:spcPts val="800"/>
+              </a:spcAft>
+            </a:pPr>
+            <a:r>
+              <a:rPr sz="1400">
+                <a:solidFill>
+                  <a:srgbClr val="212121"/>
+                </a:solidFill>
+              </a:rPr>
+              <a:t>Hoare, CACM 1969 (doi:10.1145/363235.363259) · Meyer, IEEE Computer 1992 (doi:10.1109/2.161279)</a:t>
             </a:r>
           </a:p>
         </p:txBody>
@@ -11425,7 +11494,7 @@
                   <a:srgbClr val="5A0A7A"/>
                 </a:solidFill>
               </a:rPr>
-              <a:t>Homework for your intuition</a:t>
+              <a:t>Beyond one thread</a:t>
             </a:r>
           </a:p>
         </p:txBody>
@@ -11438,8 +11507,8 @@
         </p:nvSpPr>
         <p:spPr>
           <a:xfrm>
-            <a:off x="731520" y="1828800"/>
-            <a:ext cx="10789920" cy="4754880"/>
+            <a:off x="731520" y="1645920"/>
+            <a:ext cx="10789920" cy="4937760"/>
           </a:xfrm>
           <a:prstGeom prst="rect">
             <a:avLst/>
@@ -11454,43 +11523,56 @@
           <a:p>
             <a:pPr>
               <a:spcAft>
-                <a:spcPts val="0"/>
-              </a:spcAft>
-            </a:pPr>
-            <a:r>
-              <a:rPr sz="2200">
-                <a:solidFill>
-                  <a:srgbClr val="212121"/>
-                </a:solidFill>
-                <a:latin typeface="Courier New"/>
-              </a:rPr>
-              <a:t>double w = 0.1 + 0.2;</a:t>
-            </a:r>
-          </a:p>
-          <a:p>
-            <a:pPr>
-              <a:spcAft>
-                <a:spcPts val="0"/>
-              </a:spcAft>
-            </a:pPr>
-            <a:r>
-              <a:rPr sz="2200">
-                <a:solidFill>
-                  <a:srgbClr val="212121"/>
-                </a:solidFill>
-                <a:latin typeface="Courier New"/>
-              </a:rPr>
-              <a:t>assert(w == 0.3);</a:t>
-            </a:r>
-          </a:p>
-          <a:p>
-            <a:pPr>
-              <a:spcAft>
-                <a:spcPts val="800"/>
-              </a:spcAft>
-            </a:pPr>
-            <a:r>
-              <a:rPr sz="2600">
+                <a:spcPts val="800"/>
+              </a:spcAft>
+            </a:pPr>
+            <a:r>
+              <a:rPr sz="2400">
+                <a:solidFill>
+                  <a:srgbClr val="212121"/>
+                </a:solidFill>
+              </a:rPr>
+              <a:t>Two threads of two and one statements already have three interleavings. Real code has billions.</a:t>
+            </a:r>
+          </a:p>
+          <a:p>
+            <a:pPr>
+              <a:spcAft>
+                <a:spcPts val="800"/>
+              </a:spcAft>
+            </a:pPr>
+            <a:r>
+              <a:rPr sz="2400">
+                <a:solidFill>
+                  <a:srgbClr val="212121"/>
+                </a:solidFill>
+              </a:rPr>
+              <a:t>Run the program a million times and the bad interleaving may never show up — Therac-25's bug hid exactly this way.</a:t>
+            </a:r>
+          </a:p>
+          <a:p>
+            <a:pPr>
+              <a:spcAft>
+                <a:spcPts val="800"/>
+              </a:spcAft>
+            </a:pPr>
+            <a:r>
+              <a:rPr sz="2400">
+                <a:solidFill>
+                  <a:srgbClr val="212121"/>
+                </a:solidFill>
+              </a:rPr>
+              <a:t>A model checker enumerates every interleaving up to a bound, including the one that kills your assertion.</a:t>
+            </a:r>
+          </a:p>
+          <a:p>
+            <a:pPr>
+              <a:spcAft>
+                <a:spcPts val="800"/>
+              </a:spcAft>
+            </a:pPr>
+            <a:r>
+              <a:rPr sz="2400">
                 <a:solidFill>
                   <a:srgbClr val="212121"/>
                 </a:solidFill>
@@ -11505,57 +11587,12 @@
               </a:spcAft>
             </a:pPr>
             <a:r>
-              <a:rPr sz="2600">
-                <a:solidFill>
-                  <a:srgbClr val="212121"/>
-                </a:solidFill>
-              </a:rPr>
-              <a:t>FAILED or SUCCESSFUL?</a:t>
-            </a:r>
-          </a:p>
-          <a:p>
-            <a:pPr>
-              <a:spcAft>
-                <a:spcPts val="800"/>
-              </a:spcAft>
-            </a:pPr>
-            <a:r>
-              <a:rPr sz="2600">
-                <a:solidFill>
-                  <a:srgbClr val="212121"/>
-                </a:solidFill>
-              </a:rPr>
-              <a:t/>
-            </a:r>
-          </a:p>
-          <a:p>
-            <a:pPr>
-              <a:spcAft>
-                <a:spcPts val="800"/>
-              </a:spcAft>
-            </a:pPr>
-            <a:r>
-              <a:rPr sz="2600">
-                <a:solidFill>
-                  <a:srgbClr val="212121"/>
-                </a:solidFill>
-              </a:rPr>
-              <a:t>Bring your answer to Session 2 — Lab 4 settles it with a solver that does exact IEEE-754 arithmetic.</a:t>
-            </a:r>
-          </a:p>
-          <a:p>
-            <a:pPr lvl="1">
-              <a:spcAft>
-                <a:spcPts val="800"/>
-              </a:spcAft>
-            </a:pPr>
-            <a:r>
               <a:rPr sz="2400">
                 <a:solidFill>
                   <a:srgbClr val="212121"/>
                 </a:solidFill>
               </a:rPr>
-              <a:t>Hint: 0.1 in binary is like 1/3 in decimal.</a:t>
+              <a:t>Session 2, Lab 4: you write down the killer interleaving before the tool finds it.</a:t>
             </a:r>
           </a:p>
         </p:txBody>
@@ -11606,7 +11643,7 @@
                   <a:srgbClr val="5A0A7A"/>
                 </a:solidFill>
               </a:rPr>
-              <a:t>Exercise 2 — Predict the Verdict (15 min)</a:t>
+              <a:t>Homework for your intuition</a:t>
             </a:r>
           </a:p>
         </p:txBody>
@@ -11619,8 +11656,8 @@
         </p:nvSpPr>
         <p:spPr>
           <a:xfrm>
-            <a:off x="731520" y="1463040"/>
-            <a:ext cx="10789920" cy="5120640"/>
+            <a:off x="731520" y="1828800"/>
+            <a:ext cx="10789920" cy="4754880"/>
           </a:xfrm>
           <a:prstGeom prst="rect">
             <a:avLst/>
@@ -11635,7 +11672,7 @@
           <a:p>
             <a:pPr>
               <a:spcAft>
-                <a:spcPts val="800"/>
+                <a:spcPts val="0"/>
               </a:spcAft>
             </a:pPr>
             <a:r>
@@ -11643,14 +11680,15 @@
                 <a:solidFill>
                   <a:srgbClr val="212121"/>
                 </a:solidFill>
-              </a:rPr>
-              <a:t>Groups of 3–4. Three short C programs on the handout (predict1.c, predict2.c, predict3.c).</a:t>
-            </a:r>
-          </a:p>
-          <a:p>
-            <a:pPr>
-              <a:spcAft>
-                <a:spcPts val="800"/>
+                <a:latin typeface="Courier New"/>
+              </a:rPr>
+              <a:t>double w = 0.1 + 0.2;</a:t>
+            </a:r>
+          </a:p>
+          <a:p>
+            <a:pPr>
+              <a:spcAft>
+                <a:spcPts val="0"/>
               </a:spcAft>
             </a:pPr>
             <a:r>
@@ -11658,8 +11696,69 @@
                 <a:solidFill>
                   <a:srgbClr val="212121"/>
                 </a:solidFill>
-              </a:rPr>
-              <a:t>For each program, write down BEFORE we run anything:</a:t>
+                <a:latin typeface="Courier New"/>
+              </a:rPr>
+              <a:t>assert(w == 0.3);</a:t>
+            </a:r>
+          </a:p>
+          <a:p>
+            <a:pPr>
+              <a:spcAft>
+                <a:spcPts val="800"/>
+              </a:spcAft>
+            </a:pPr>
+            <a:r>
+              <a:rPr sz="2600">
+                <a:solidFill>
+                  <a:srgbClr val="212121"/>
+                </a:solidFill>
+              </a:rPr>
+              <a:t/>
+            </a:r>
+          </a:p>
+          <a:p>
+            <a:pPr>
+              <a:spcAft>
+                <a:spcPts val="800"/>
+              </a:spcAft>
+            </a:pPr>
+            <a:r>
+              <a:rPr sz="2600">
+                <a:solidFill>
+                  <a:srgbClr val="212121"/>
+                </a:solidFill>
+              </a:rPr>
+              <a:t>FAILED or SUCCESSFUL?</a:t>
+            </a:r>
+          </a:p>
+          <a:p>
+            <a:pPr>
+              <a:spcAft>
+                <a:spcPts val="800"/>
+              </a:spcAft>
+            </a:pPr>
+            <a:r>
+              <a:rPr sz="2600">
+                <a:solidFill>
+                  <a:srgbClr val="212121"/>
+                </a:solidFill>
+              </a:rPr>
+              <a:t/>
+            </a:r>
+          </a:p>
+          <a:p>
+            <a:pPr>
+              <a:spcAft>
+                <a:spcPts val="800"/>
+              </a:spcAft>
+            </a:pPr>
+            <a:r>
+              <a:rPr sz="2600">
+                <a:solidFill>
+                  <a:srgbClr val="212121"/>
+                </a:solidFill>
+              </a:rPr>
+              <a:t>Bring your answer to Session 2 — Lab 4 settles it with a solver that does exact IEEE-754 arithmetic.</a:t>
             </a:r>
           </a:p>
           <a:p>
@@ -11669,42 +11768,12 @@
               </a:spcAft>
             </a:pPr>
             <a:r>
-              <a:rPr sz="2000">
-                <a:solidFill>
-                  <a:srgbClr val="212121"/>
-                </a:solidFill>
-              </a:rPr>
-              <a:t>Will the model checker say VERIFICATION FAILED or SUCCESSFUL?</a:t>
-            </a:r>
-          </a:p>
-          <a:p>
-            <a:pPr lvl="1">
-              <a:spcAft>
-                <a:spcPts val="800"/>
-              </a:spcAft>
-            </a:pPr>
-            <a:r>
-              <a:rPr sz="2000">
-                <a:solidFill>
-                  <a:srgbClr val="212121"/>
-                </a:solidFill>
-              </a:rPr>
-              <a:t>If FAILED — which line is the culprit?</a:t>
-            </a:r>
-          </a:p>
-          <a:p>
-            <a:pPr>
-              <a:spcAft>
-                <a:spcPts val="800"/>
-              </a:spcAft>
-            </a:pPr>
-            <a:r>
-              <a:rPr sz="2200">
-                <a:solidFill>
-                  <a:srgbClr val="212121"/>
-                </a:solidFill>
-              </a:rPr>
-              <a:t>Then we run ESBMC live and settle every bet.</a:t>
+              <a:rPr sz="2400">
+                <a:solidFill>
+                  <a:srgbClr val="212121"/>
+                </a:solidFill>
+              </a:rPr>
+              <a:t>Hint: 0.1 in binary is like 1/3 in decimal.</a:t>
             </a:r>
           </a:p>
         </p:txBody>
@@ -11755,7 +11824,7 @@
                   <a:srgbClr val="5A0A7A"/>
                 </a:solidFill>
               </a:rPr>
-              <a:t>Who uses this? — Model checking</a:t>
+              <a:t>Exercise 2 — Predict the Verdict (15 min)</a:t>
             </a:r>
           </a:p>
         </p:txBody>
@@ -11793,7 +11862,7 @@
                   <a:srgbClr val="212121"/>
                 </a:solidFill>
               </a:rPr>
-              <a:t>Amazon Web Services — CBMC proves memory safety of the TLS library s2n; bounded proofs run in CI on every commit</a:t>
+              <a:t>Groups of 3–4. Three short C programs on the handout (predict1.c, predict2.c, predict3.c).</a:t>
             </a:r>
           </a:p>
           <a:p>
@@ -11808,7 +11877,37 @@
                   <a:srgbClr val="212121"/>
                 </a:solidFill>
               </a:rPr>
-              <a:t>ESBMC / CBMC — the tools from tonight's demos; compete yearly in SV-COMP on tens of thousands of benchmarks</a:t>
+              <a:t>For each program, write down BEFORE we run anything:</a:t>
+            </a:r>
+          </a:p>
+          <a:p>
+            <a:pPr lvl="1">
+              <a:spcAft>
+                <a:spcPts val="800"/>
+              </a:spcAft>
+            </a:pPr>
+            <a:r>
+              <a:rPr sz="2000">
+                <a:solidFill>
+                  <a:srgbClr val="212121"/>
+                </a:solidFill>
+              </a:rPr>
+              <a:t>Will the model checker say VERIFICATION FAILED or SUCCESSFUL?</a:t>
+            </a:r>
+          </a:p>
+          <a:p>
+            <a:pPr lvl="1">
+              <a:spcAft>
+                <a:spcPts val="800"/>
+              </a:spcAft>
+            </a:pPr>
+            <a:r>
+              <a:rPr sz="2000">
+                <a:solidFill>
+                  <a:srgbClr val="212121"/>
+                </a:solidFill>
+              </a:rPr>
+              <a:t>If FAILED — which line is the culprit?</a:t>
             </a:r>
           </a:p>
           <a:p>
@@ -11823,7 +11922,7 @@
                   <a:srgbClr val="212121"/>
                 </a:solidFill>
               </a:rPr>
-              <a:t>The counterexample you saw for getpassword.c is the same artefact AWS engineers read when a proof fails</a:t>
+              <a:t>Then we run ESBMC live and settle every bet.</a:t>
             </a:r>
           </a:p>
         </p:txBody>
@@ -11874,7 +11973,7 @@
                   <a:srgbClr val="5A0A7A"/>
                 </a:solidFill>
               </a:rPr>
-              <a:t>Who uses this? — Symbolic execution &amp; fuzzing</a:t>
+              <a:t>Who uses this? — Model checking</a:t>
             </a:r>
           </a:p>
         </p:txBody>
@@ -11912,7 +12011,7 @@
                   <a:srgbClr val="212121"/>
                 </a:solidFill>
               </a:rPr>
-              <a:t>KLEE found 56 serious bugs in coreutils, busybox and Minix — including three in coreutils that had survived 15 years of testing</a:t>
+              <a:t>Amazon Web Services — CBMC proves memory safety of the TLS library s2n; bounded proofs run in CI on every commit</a:t>
             </a:r>
           </a:p>
           <a:p>
@@ -11927,7 +12026,7 @@
                   <a:srgbClr val="212121"/>
                 </a:solidFill>
               </a:rPr>
-              <a:t>Microsoft SAGE fuzzed Windows file parsers with symbolic execution; it found ~1/3 of all bugs caught by file fuzzing during Windows 7 development — running last, after every other tool</a:t>
+              <a:t>ESBMC / CBMC — the tools from tonight's demos; compete yearly in SV-COMP on tens of thousands of benchmarks</a:t>
             </a:r>
           </a:p>
           <a:p>
@@ -11942,22 +12041,7 @@
                   <a:srgbClr val="212121"/>
                 </a:solidFill>
               </a:rPr>
-              <a:t>AFL / OSS-Fuzz — Google fuzzes ~1,000 open-source projects continuously; tens of thousands of bugs found</a:t>
-            </a:r>
-          </a:p>
-          <a:p>
-            <a:pPr>
-              <a:spcAft>
-                <a:spcPts val="800"/>
-              </a:spcAft>
-            </a:pPr>
-            <a:r>
-              <a:rPr sz="2200">
-                <a:solidFill>
-                  <a:srgbClr val="212121"/>
-                </a:solidFill>
-              </a:rPr>
-              <a:t>The pragmatic cousin of verification: no proofs, ruthless effectiveness</a:t>
+              <a:t>The counterexample you saw for getpassword.c is the same artefact AWS engineers read when a proof fails</a:t>
             </a:r>
           </a:p>
         </p:txBody>
@@ -12008,7 +12092,7 @@
                   <a:srgbClr val="5A0A7A"/>
                 </a:solidFill>
               </a:rPr>
-              <a:t>Another route to a proof: abstract interpretation</a:t>
+              <a:t>Who uses this? — Symbolic execution &amp; fuzzing</a:t>
             </a:r>
           </a:p>
         </p:txBody>
@@ -12041,190 +12125,57 @@
               </a:spcAft>
             </a:pPr>
             <a:r>
-              <a:rPr sz="2000">
-                <a:solidFill>
-                  <a:srgbClr val="212121"/>
-                </a:solidFill>
-              </a:rPr>
-              <a:t>The BMC pipeline you just saw hunts a counterexample (or proves up to a bound). Abstract interpretation proves P the other way — over-approximate every run at once: no inputs, no paths, no bound.</a:t>
-            </a:r>
-          </a:p>
-          <a:p>
-            <a:pPr>
-              <a:spcAft>
-                <a:spcPts val="800"/>
-              </a:spcAft>
-            </a:pPr>
-            <a:r>
-              <a:rPr sz="2000">
-                <a:solidFill>
-                  <a:srgbClr val="212121"/>
-                </a:solidFill>
-              </a:rPr>
-              <a:t/>
-            </a:r>
-          </a:p>
-          <a:p>
-            <a:pPr>
-              <a:spcAft>
-                <a:spcPts val="0"/>
-              </a:spcAft>
-            </a:pPr>
-            <a:r>
-              <a:rPr sz="1600">
-                <a:solidFill>
-                  <a:srgbClr val="212121"/>
-                </a:solidFill>
-                <a:latin typeface="Courier New"/>
-              </a:rPr>
-              <a:t>x = 0                 # x ∈ [0, 0]</a:t>
-            </a:r>
-          </a:p>
-          <a:p>
-            <a:pPr>
-              <a:spcAft>
-                <a:spcPts val="0"/>
-              </a:spcAft>
-            </a:pPr>
-            <a:r>
-              <a:rPr sz="1600">
-                <a:solidFill>
-                  <a:srgbClr val="212121"/>
-                </a:solidFill>
-                <a:latin typeface="Courier New"/>
-              </a:rPr>
-              <a:t>while x &lt; 100:</a:t>
-            </a:r>
-          </a:p>
-          <a:p>
-            <a:pPr>
-              <a:spcAft>
-                <a:spcPts val="0"/>
-              </a:spcAft>
-            </a:pPr>
-            <a:r>
-              <a:rPr sz="1600">
-                <a:solidFill>
-                  <a:srgbClr val="212121"/>
-                </a:solidFill>
-                <a:latin typeface="Courier New"/>
-              </a:rPr>
-              <a:t>    x = x + 1         # x ∈ [1, 100]</a:t>
-            </a:r>
-          </a:p>
-          <a:p>
-            <a:pPr>
-              <a:spcAft>
-                <a:spcPts val="0"/>
-              </a:spcAft>
-            </a:pPr>
-            <a:r>
-              <a:rPr sz="1600">
-                <a:solidFill>
-                  <a:srgbClr val="212121"/>
-                </a:solidFill>
-                <a:latin typeface="Courier New"/>
-              </a:rPr>
-              <a:t># fixpoint invariant:  x ∈ [0, 100]</a:t>
-            </a:r>
-          </a:p>
-          <a:p>
-            <a:pPr>
-              <a:spcAft>
-                <a:spcPts val="0"/>
-              </a:spcAft>
-            </a:pPr>
-            <a:r>
-              <a:rPr sz="1600">
-                <a:solidFill>
-                  <a:srgbClr val="212121"/>
-                </a:solidFill>
-                <a:latin typeface="Courier New"/>
-              </a:rPr>
-              <a:t>assert 0 &lt;= x &lt;= 100  # implied by the invariant → PROVED</a:t>
-            </a:r>
-          </a:p>
-          <a:p>
-            <a:pPr>
-              <a:spcAft>
-                <a:spcPts val="800"/>
-              </a:spcAft>
-            </a:pPr>
-            <a:r>
-              <a:rPr sz="2000">
-                <a:solidFill>
-                  <a:srgbClr val="212121"/>
-                </a:solidFill>
-              </a:rPr>
-              <a:t/>
-            </a:r>
-          </a:p>
-          <a:p>
-            <a:pPr lvl="1">
-              <a:spcAft>
-                <a:spcPts val="800"/>
-              </a:spcAft>
-            </a:pPr>
-            <a:r>
-              <a:rPr sz="1800">
-                <a:solidFill>
-                  <a:srgbClr val="212121"/>
-                </a:solidFill>
-              </a:rPr>
-              <a:t>Compute the tightest fact the loop can't escape (a fixpoint); if it implies P, P holds for every run — no unrolling.</a:t>
-            </a:r>
-          </a:p>
-          <a:p>
-            <a:pPr lvl="1">
-              <a:spcAft>
-                <a:spcPts val="800"/>
-              </a:spcAft>
-            </a:pPr>
-            <a:r>
-              <a:rPr sz="1800">
-                <a:solidFill>
-                  <a:srgbClr val="212121"/>
-                </a:solidFill>
-              </a:rPr>
-              <a:t>Sound, not complete: too coarse → a false alarm. (Astrée proved the A340/A380 fly-by-wire this way — next slide.)</a:t>
-            </a:r>
-          </a:p>
-        </p:txBody>
-      </p:sp>
-      <p:sp>
-        <p:nvSpPr>
-          <p:cNvPr id="4" name="TextBox 3"/>
-          <p:cNvSpPr txBox="1"/>
-          <p:nvPr/>
-        </p:nvSpPr>
-        <p:spPr>
-          <a:xfrm>
-            <a:off x="731520" y="6400800"/>
-            <a:ext cx="10789920" cy="182880"/>
-          </a:xfrm>
-          <a:prstGeom prst="rect">
-            <a:avLst/>
-          </a:prstGeom>
-          <a:noFill/>
-        </p:spPr>
-        <p:txBody>
-          <a:bodyPr wrap="square">
-            <a:spAutoFit/>
-          </a:bodyPr>
-          <a:lstStyle/>
-          <a:p>
-            <a:pPr>
-              <a:spcAft>
-                <a:spcPts val="800"/>
-              </a:spcAft>
-            </a:pPr>
-            <a:r>
-              <a:rPr sz="1400">
-                <a:solidFill>
-                  <a:srgbClr val="212121"/>
-                </a:solidFill>
-              </a:rPr>
-              <a:t>Sound over-approximation: Cousot &amp; Cousot, POPL 1977 (doi:10.1145/512950.512973)</a:t>
+              <a:rPr sz="2200">
+                <a:solidFill>
+                  <a:srgbClr val="212121"/>
+                </a:solidFill>
+              </a:rPr>
+              <a:t>KLEE found 56 serious bugs in coreutils, busybox and Minix — including three in coreutils that had survived 15 years of testing</a:t>
+            </a:r>
+          </a:p>
+          <a:p>
+            <a:pPr>
+              <a:spcAft>
+                <a:spcPts val="800"/>
+              </a:spcAft>
+            </a:pPr>
+            <a:r>
+              <a:rPr sz="2200">
+                <a:solidFill>
+                  <a:srgbClr val="212121"/>
+                </a:solidFill>
+              </a:rPr>
+              <a:t>Microsoft SAGE fuzzed Windows file parsers with symbolic execution; it found ~1/3 of all bugs caught by file fuzzing during Windows 7 development — running last, after every other tool</a:t>
+            </a:r>
+          </a:p>
+          <a:p>
+            <a:pPr>
+              <a:spcAft>
+                <a:spcPts val="800"/>
+              </a:spcAft>
+            </a:pPr>
+            <a:r>
+              <a:rPr sz="2200">
+                <a:solidFill>
+                  <a:srgbClr val="212121"/>
+                </a:solidFill>
+              </a:rPr>
+              <a:t>AFL / OSS-Fuzz — Google fuzzes ~1,000 open-source projects continuously; tens of thousands of bugs found</a:t>
+            </a:r>
+          </a:p>
+          <a:p>
+            <a:pPr>
+              <a:spcAft>
+                <a:spcPts val="800"/>
+              </a:spcAft>
+            </a:pPr>
+            <a:r>
+              <a:rPr sz="2200">
+                <a:solidFill>
+                  <a:srgbClr val="212121"/>
+                </a:solidFill>
+              </a:rPr>
+              <a:t>The pragmatic cousin of verification: no proofs, ruthless effectiveness</a:t>
             </a:r>
           </a:p>
         </p:txBody>
@@ -12275,7 +12226,7 @@
                   <a:srgbClr val="5A0A7A"/>
                 </a:solidFill>
               </a:rPr>
-              <a:t>Abstract interpretation: domain, widening, narrowing</a:t>
+              <a:t>Another route to a proof: abstract interpretation</a:t>
             </a:r>
           </a:p>
         </p:txBody>
@@ -12302,6 +12253,131 @@
           </a:bodyPr>
           <a:lstStyle/>
           <a:p>
+            <a:pPr>
+              <a:spcAft>
+                <a:spcPts val="800"/>
+              </a:spcAft>
+            </a:pPr>
+            <a:r>
+              <a:rPr sz="2000">
+                <a:solidFill>
+                  <a:srgbClr val="212121"/>
+                </a:solidFill>
+              </a:rPr>
+              <a:t>The BMC pipeline you just saw hunts a counterexample (or proves up to a bound). Abstract interpretation proves P the other way — over-approximate every run at once: no inputs, no paths, no bound.</a:t>
+            </a:r>
+          </a:p>
+          <a:p>
+            <a:pPr>
+              <a:spcAft>
+                <a:spcPts val="800"/>
+              </a:spcAft>
+            </a:pPr>
+            <a:r>
+              <a:rPr sz="2000">
+                <a:solidFill>
+                  <a:srgbClr val="212121"/>
+                </a:solidFill>
+              </a:rPr>
+              <a:t/>
+            </a:r>
+          </a:p>
+          <a:p>
+            <a:pPr>
+              <a:spcAft>
+                <a:spcPts val="0"/>
+              </a:spcAft>
+            </a:pPr>
+            <a:r>
+              <a:rPr sz="1600">
+                <a:solidFill>
+                  <a:srgbClr val="212121"/>
+                </a:solidFill>
+                <a:latin typeface="Courier New"/>
+              </a:rPr>
+              <a:t>x = 0                 # x ∈ [0, 0]</a:t>
+            </a:r>
+          </a:p>
+          <a:p>
+            <a:pPr>
+              <a:spcAft>
+                <a:spcPts val="0"/>
+              </a:spcAft>
+            </a:pPr>
+            <a:r>
+              <a:rPr sz="1600">
+                <a:solidFill>
+                  <a:srgbClr val="212121"/>
+                </a:solidFill>
+                <a:latin typeface="Courier New"/>
+              </a:rPr>
+              <a:t>while x &lt; 100:</a:t>
+            </a:r>
+          </a:p>
+          <a:p>
+            <a:pPr>
+              <a:spcAft>
+                <a:spcPts val="0"/>
+              </a:spcAft>
+            </a:pPr>
+            <a:r>
+              <a:rPr sz="1600">
+                <a:solidFill>
+                  <a:srgbClr val="212121"/>
+                </a:solidFill>
+                <a:latin typeface="Courier New"/>
+              </a:rPr>
+              <a:t>    x = x + 1         # x ∈ [1, 100]</a:t>
+            </a:r>
+          </a:p>
+          <a:p>
+            <a:pPr>
+              <a:spcAft>
+                <a:spcPts val="0"/>
+              </a:spcAft>
+            </a:pPr>
+            <a:r>
+              <a:rPr sz="1600">
+                <a:solidFill>
+                  <a:srgbClr val="212121"/>
+                </a:solidFill>
+                <a:latin typeface="Courier New"/>
+              </a:rPr>
+              <a:t># fixpoint invariant:  x ∈ [0, 100]</a:t>
+            </a:r>
+          </a:p>
+          <a:p>
+            <a:pPr>
+              <a:spcAft>
+                <a:spcPts val="0"/>
+              </a:spcAft>
+            </a:pPr>
+            <a:r>
+              <a:rPr sz="1600">
+                <a:solidFill>
+                  <a:srgbClr val="212121"/>
+                </a:solidFill>
+                <a:latin typeface="Courier New"/>
+              </a:rPr>
+              <a:t>assert 0 &lt;= x &lt;= 100  # implied by the invariant → PROVED</a:t>
+            </a:r>
+          </a:p>
+          <a:p>
+            <a:pPr>
+              <a:spcAft>
+                <a:spcPts val="800"/>
+              </a:spcAft>
+            </a:pPr>
+            <a:r>
+              <a:rPr sz="2000">
+                <a:solidFill>
+                  <a:srgbClr val="212121"/>
+                </a:solidFill>
+              </a:rPr>
+              <a:t/>
+            </a:r>
+          </a:p>
+          <a:p>
             <a:pPr lvl="1">
               <a:spcAft>
                 <a:spcPts val="800"/>
@@ -12313,22 +12389,7 @@
                   <a:srgbClr val="212121"/>
                 </a:solidFill>
               </a:rPr>
-              <a:t>Abstract domain — the facts you track instead of exact values. Intervals x ∈ [a, b]; richer ones add relationships (octagons ±x ±y ≤ c, polyhedra). At a branch you join the two sides — richer domain → more precise, but more costly.</a:t>
-            </a:r>
-          </a:p>
-          <a:p>
-            <a:pPr>
-              <a:spcAft>
-                <a:spcPts val="800"/>
-              </a:spcAft>
-            </a:pPr>
-            <a:r>
-              <a:rPr sz="2000">
-                <a:solidFill>
-                  <a:srgbClr val="212121"/>
-                </a:solidFill>
-              </a:rPr>
-              <a:t/>
+              <a:t>Compute the tightest fact the loop can't escape (a fixpoint); if it implies P, P holds for every run — no unrolling.</a:t>
             </a:r>
           </a:p>
           <a:p>
@@ -12343,67 +12404,45 @@
                   <a:srgbClr val="212121"/>
                 </a:solidFill>
               </a:rPr>
-              <a:t>Widening (∇) — forces loops to converge. The loop ascends [0,0] → [0,1] → [0,2] → … and may never stop; widening sees the bound climbing and extrapolates it to [0, +∞). Termination, at the cost of precision.</a:t>
-            </a:r>
-          </a:p>
-          <a:p>
-            <a:pPr>
-              <a:spcAft>
-                <a:spcPts val="800"/>
-              </a:spcAft>
-            </a:pPr>
-            <a:r>
-              <a:rPr sz="2000">
-                <a:solidFill>
-                  <a:srgbClr val="212121"/>
-                </a:solidFill>
-              </a:rPr>
-              <a:t/>
-            </a:r>
-          </a:p>
-          <a:p>
-            <a:pPr lvl="1">
-              <a:spcAft>
-                <a:spcPts val="800"/>
-              </a:spcAft>
-            </a:pPr>
-            <a:r>
-              <a:rPr sz="1800">
-                <a:solidFill>
-                  <a:srgbClr val="212121"/>
-                </a:solidFill>
-              </a:rPr>
-              <a:t>Narrowing (Δ) — recovers what widening overshot. Re-reading the guard x &lt; 100 pulls [0, +∞) back to [0, 100]: precision restored, still terminating.</a:t>
-            </a:r>
-          </a:p>
-          <a:p>
-            <a:pPr>
-              <a:spcAft>
-                <a:spcPts val="800"/>
-              </a:spcAft>
-            </a:pPr>
-            <a:r>
-              <a:rPr sz="2000">
-                <a:solidFill>
-                  <a:srgbClr val="212121"/>
-                </a:solidFill>
-              </a:rPr>
-              <a:t/>
-            </a:r>
-          </a:p>
-          <a:p>
-            <a:pPr>
-              <a:spcAft>
-                <a:spcPts val="800"/>
-              </a:spcAft>
-            </a:pPr>
-            <a:r>
-              <a:rPr sz="2000">
-                <a:solidFill>
-                  <a:srgbClr val="212121"/>
-                </a:solidFill>
-              </a:rPr>
-              <a:t>ESBMC ships it too — --interval-analysis — and can supply the invariant k-induction needs (Session 2, Lab 3).</a:t>
+              <a:t>Sound, not complete: too coarse → a false alarm. (Astrée proved the A340/A380 fly-by-wire this way — next slide.)</a:t>
+            </a:r>
+          </a:p>
+        </p:txBody>
+      </p:sp>
+      <p:sp>
+        <p:nvSpPr>
+          <p:cNvPr id="4" name="TextBox 3"/>
+          <p:cNvSpPr txBox="1"/>
+          <p:nvPr/>
+        </p:nvSpPr>
+        <p:spPr>
+          <a:xfrm>
+            <a:off x="731520" y="6400800"/>
+            <a:ext cx="10789920" cy="182880"/>
+          </a:xfrm>
+          <a:prstGeom prst="rect">
+            <a:avLst/>
+          </a:prstGeom>
+          <a:noFill/>
+        </p:spPr>
+        <p:txBody>
+          <a:bodyPr wrap="square">
+            <a:spAutoFit/>
+          </a:bodyPr>
+          <a:lstStyle/>
+          <a:p>
+            <a:pPr>
+              <a:spcAft>
+                <a:spcPts val="800"/>
+              </a:spcAft>
+            </a:pPr>
+            <a:r>
+              <a:rPr sz="1400">
+                <a:solidFill>
+                  <a:srgbClr val="212121"/>
+                </a:solidFill>
+              </a:rPr>
+              <a:t>Sound over-approximation: Cousot &amp; Cousot, POPL 1977 (doi:10.1145/512950.512973)</a:t>
             </a:r>
           </a:p>
         </p:txBody>
@@ -12718,7 +12757,7 @@
                   <a:srgbClr val="5A0A7A"/>
                 </a:solidFill>
               </a:rPr>
-              <a:t>Who uses this? — Proofs all the way up</a:t>
+              <a:t>Abstract interpretation: domain, widening, narrowing</a:t>
             </a:r>
           </a:p>
         </p:txBody>
@@ -12745,48 +12784,108 @@
           </a:bodyPr>
           <a:lstStyle/>
           <a:p>
-            <a:pPr>
-              <a:spcAft>
-                <a:spcPts val="800"/>
-              </a:spcAft>
-            </a:pPr>
-            <a:r>
-              <a:rPr sz="2200">
-                <a:solidFill>
-                  <a:srgbClr val="212121"/>
-                </a:solidFill>
-              </a:rPr>
-              <a:t>Astrée (abstract interpretation) proved absence of runtime errors in the Airbus A340 fly-by-wire code — 132,000 lines of C — and was then applied to the A380</a:t>
-            </a:r>
-          </a:p>
-          <a:p>
-            <a:pPr>
-              <a:spcAft>
-                <a:spcPts val="800"/>
-              </a:spcAft>
-            </a:pPr>
-            <a:r>
-              <a:rPr sz="2200">
-                <a:solidFill>
-                  <a:srgbClr val="212121"/>
-                </a:solidFill>
-              </a:rPr>
-              <a:t>seL4 — an OS microkernel with a machine-checked proof of functional correctness</a:t>
-            </a:r>
-          </a:p>
-          <a:p>
-            <a:pPr>
-              <a:spcAft>
-                <a:spcPts val="800"/>
-              </a:spcAft>
-            </a:pPr>
-            <a:r>
-              <a:rPr sz="2200">
-                <a:solidFill>
-                  <a:srgbClr val="212121"/>
-                </a:solidFill>
-              </a:rPr>
-              <a:t>CompCert — a C compiler with a proof that compilation preserves semantics; six CPU-years of fuzzing found no wrong-code bugs in its verified core, while every other compiler tested failed</a:t>
+            <a:pPr lvl="1">
+              <a:spcAft>
+                <a:spcPts val="800"/>
+              </a:spcAft>
+            </a:pPr>
+            <a:r>
+              <a:rPr sz="1800">
+                <a:solidFill>
+                  <a:srgbClr val="212121"/>
+                </a:solidFill>
+              </a:rPr>
+              <a:t>Abstract domain — the facts you track instead of exact values. Intervals x ∈ [a, b]; richer ones add relationships (octagons ±x ±y ≤ c, polyhedra). At a branch you join the two sides — richer domain → more precise, but more costly.</a:t>
+            </a:r>
+          </a:p>
+          <a:p>
+            <a:pPr>
+              <a:spcAft>
+                <a:spcPts val="800"/>
+              </a:spcAft>
+            </a:pPr>
+            <a:r>
+              <a:rPr sz="2000">
+                <a:solidFill>
+                  <a:srgbClr val="212121"/>
+                </a:solidFill>
+              </a:rPr>
+              <a:t/>
+            </a:r>
+          </a:p>
+          <a:p>
+            <a:pPr lvl="1">
+              <a:spcAft>
+                <a:spcPts val="800"/>
+              </a:spcAft>
+            </a:pPr>
+            <a:r>
+              <a:rPr sz="1800">
+                <a:solidFill>
+                  <a:srgbClr val="212121"/>
+                </a:solidFill>
+              </a:rPr>
+              <a:t>Widening (∇) — forces loops to converge. The loop ascends [0,0] → [0,1] → [0,2] → … and may never stop; widening sees the bound climbing and extrapolates it to [0, +∞). Termination, at the cost of precision.</a:t>
+            </a:r>
+          </a:p>
+          <a:p>
+            <a:pPr>
+              <a:spcAft>
+                <a:spcPts val="800"/>
+              </a:spcAft>
+            </a:pPr>
+            <a:r>
+              <a:rPr sz="2000">
+                <a:solidFill>
+                  <a:srgbClr val="212121"/>
+                </a:solidFill>
+              </a:rPr>
+              <a:t/>
+            </a:r>
+          </a:p>
+          <a:p>
+            <a:pPr lvl="1">
+              <a:spcAft>
+                <a:spcPts val="800"/>
+              </a:spcAft>
+            </a:pPr>
+            <a:r>
+              <a:rPr sz="1800">
+                <a:solidFill>
+                  <a:srgbClr val="212121"/>
+                </a:solidFill>
+              </a:rPr>
+              <a:t>Narrowing (Δ) — recovers what widening overshot. Re-reading the guard x &lt; 100 pulls [0, +∞) back to [0, 100]: precision restored, still terminating.</a:t>
+            </a:r>
+          </a:p>
+          <a:p>
+            <a:pPr>
+              <a:spcAft>
+                <a:spcPts val="800"/>
+              </a:spcAft>
+            </a:pPr>
+            <a:r>
+              <a:rPr sz="2000">
+                <a:solidFill>
+                  <a:srgbClr val="212121"/>
+                </a:solidFill>
+              </a:rPr>
+              <a:t/>
+            </a:r>
+          </a:p>
+          <a:p>
+            <a:pPr>
+              <a:spcAft>
+                <a:spcPts val="800"/>
+              </a:spcAft>
+            </a:pPr>
+            <a:r>
+              <a:rPr sz="2000">
+                <a:solidFill>
+                  <a:srgbClr val="212121"/>
+                </a:solidFill>
+              </a:rPr>
+              <a:t>ESBMC ships it too — --interval-analysis — and can supply the invariant k-induction needs (Session 2, Lab 3).</a:t>
             </a:r>
           </a:p>
         </p:txBody>
@@ -12837,7 +12936,7 @@
                   <a:srgbClr val="5A0A7A"/>
                 </a:solidFill>
               </a:rPr>
-              <a:t>Discussion</a:t>
+              <a:t>Who uses this? — Proofs all the way up</a:t>
             </a:r>
           </a:p>
         </p:txBody>
@@ -12850,8 +12949,8 @@
         </p:nvSpPr>
         <p:spPr>
           <a:xfrm>
-            <a:off x="731520" y="2194560"/>
-            <a:ext cx="10789920" cy="4389120"/>
+            <a:off x="731520" y="1463040"/>
+            <a:ext cx="10789920" cy="5120640"/>
           </a:xfrm>
           <a:prstGeom prst="rect">
             <a:avLst/>
@@ -12870,42 +12969,42 @@
               </a:spcAft>
             </a:pPr>
             <a:r>
-              <a:rPr sz="2800">
-                <a:solidFill>
-                  <a:srgbClr val="212121"/>
-                </a:solidFill>
-              </a:rPr>
-              <a:t>If verification can prove the absence of bugs…</a:t>
-            </a:r>
-          </a:p>
-          <a:p>
-            <a:pPr>
-              <a:spcAft>
-                <a:spcPts val="800"/>
-              </a:spcAft>
-            </a:pPr>
-            <a:r>
-              <a:rPr sz="2800">
-                <a:solidFill>
-                  <a:srgbClr val="212121"/>
-                </a:solidFill>
-              </a:rPr>
-              <a:t>why isn't all software verified?</a:t>
-            </a:r>
-          </a:p>
-          <a:p>
-            <a:pPr>
-              <a:spcAft>
-                <a:spcPts val="800"/>
-              </a:spcAft>
-            </a:pPr>
-            <a:r>
-              <a:rPr sz="2800">
-                <a:solidFill>
-                  <a:srgbClr val="212121"/>
-                </a:solidFill>
-              </a:rPr>
-              <a:t>(Let's collect reasons — then I'll tell you which ones the industry actually cites.)</a:t>
+              <a:rPr sz="2200">
+                <a:solidFill>
+                  <a:srgbClr val="212121"/>
+                </a:solidFill>
+              </a:rPr>
+              <a:t>Astrée (abstract interpretation) proved absence of runtime errors in the Airbus A340 fly-by-wire code — 132,000 lines of C — and was then applied to the A380</a:t>
+            </a:r>
+          </a:p>
+          <a:p>
+            <a:pPr>
+              <a:spcAft>
+                <a:spcPts val="800"/>
+              </a:spcAft>
+            </a:pPr>
+            <a:r>
+              <a:rPr sz="2200">
+                <a:solidFill>
+                  <a:srgbClr val="212121"/>
+                </a:solidFill>
+              </a:rPr>
+              <a:t>seL4 — an OS microkernel with a machine-checked proof of functional correctness</a:t>
+            </a:r>
+          </a:p>
+          <a:p>
+            <a:pPr>
+              <a:spcAft>
+                <a:spcPts val="800"/>
+              </a:spcAft>
+            </a:pPr>
+            <a:r>
+              <a:rPr sz="2200">
+                <a:solidFill>
+                  <a:srgbClr val="212121"/>
+                </a:solidFill>
+              </a:rPr>
+              <a:t>CompCert — a C compiler with a proof that compilation preserves semantics; six CPU-years of fuzzing found no wrong-code bugs in its verified core, while every other compiler tested failed</a:t>
             </a:r>
           </a:p>
         </p:txBody>
@@ -12956,7 +13055,7 @@
                   <a:srgbClr val="5A0A7A"/>
                 </a:solidFill>
               </a:rPr>
-              <a:t>Under the hood — and how to hack on it</a:t>
+              <a:t>Discussion</a:t>
             </a:r>
           </a:p>
         </p:txBody>
@@ -12969,8 +13068,8 @@
         </p:nvSpPr>
         <p:spPr>
           <a:xfrm>
-            <a:off x="731520" y="1463040"/>
-            <a:ext cx="10789920" cy="5120640"/>
+            <a:off x="731520" y="2194560"/>
+            <a:ext cx="10789920" cy="4389120"/>
           </a:xfrm>
           <a:prstGeom prst="rect">
             <a:avLst/>
@@ -12989,157 +13088,42 @@
               </a:spcAft>
             </a:pPr>
             <a:r>
-              <a:rPr sz="2200">
-                <a:solidFill>
-                  <a:srgbClr val="212121"/>
-                </a:solidFill>
-              </a:rPr>
-              <a:t>Tonight's pipeline was the conceptual one. ESBMC's real pipeline:</a:t>
-            </a:r>
-          </a:p>
-          <a:p>
-            <a:pPr lvl="1">
-              <a:spcAft>
-                <a:spcPts val="800"/>
-              </a:spcAft>
-            </a:pPr>
-            <a:r>
-              <a:rPr sz="2000">
-                <a:solidFill>
-                  <a:srgbClr val="212121"/>
-                </a:solidFill>
-              </a:rPr>
-              <a:t>Clang frontend → irep2 (typed IR) → GOTO program → symbolic execution (unwind, SSA) → SMT backends (Z3, Bitwuzla, cvc5)</a:t>
-            </a:r>
-          </a:p>
-          <a:p>
-            <a:pPr>
-              <a:spcAft>
-                <a:spcPts val="800"/>
-              </a:spcAft>
-            </a:pPr>
-            <a:r>
-              <a:rPr sz="2200">
-                <a:solidFill>
-                  <a:srgbClr val="212121"/>
-                </a:solidFill>
-              </a:rPr>
-              <a:t/>
-            </a:r>
-          </a:p>
-          <a:p>
-            <a:pPr>
-              <a:spcAft>
-                <a:spcPts val="800"/>
-              </a:spcAft>
-            </a:pPr>
-            <a:r>
-              <a:rPr sz="2200">
-                <a:solidFill>
-                  <a:srgbClr val="212121"/>
-                </a:solidFill>
-              </a:rPr>
-              <a:t>irep2 is the typed, reference-counted representation everything lowers to and every backend consumes.</a:t>
-            </a:r>
-          </a:p>
-          <a:p>
-            <a:pPr>
-              <a:spcAft>
-                <a:spcPts val="800"/>
-              </a:spcAft>
-            </a:pPr>
-            <a:r>
-              <a:rPr sz="2200">
-                <a:solidFill>
-                  <a:srgbClr val="212121"/>
-                </a:solidFill>
-              </a:rPr>
-              <a:t>Want to add a check, a frontend, or a new node type? Start here:</a:t>
-            </a:r>
-          </a:p>
-          <a:p>
-            <a:pPr lvl="1">
-              <a:spcAft>
-                <a:spcPts val="0"/>
-              </a:spcAft>
-            </a:pPr>
-            <a:r>
-              <a:rPr sz="1800">
-                <a:solidFill>
-                  <a:srgbClr val="212121"/>
-                </a:solidFill>
-                <a:latin typeface="Courier New"/>
-              </a:rPr>
-              <a:t>github.com/esbmc/esbmc  →  src/irep2/README.md</a:t>
-            </a:r>
-          </a:p>
-          <a:p>
-            <a:pPr>
-              <a:spcAft>
-                <a:spcPts val="800"/>
-              </a:spcAft>
-            </a:pPr>
-            <a:r>
-              <a:rPr sz="2200">
-                <a:solidFill>
-                  <a:srgbClr val="212121"/>
-                </a:solidFill>
-              </a:rPr>
-              <a:t/>
-            </a:r>
-          </a:p>
-          <a:p>
-            <a:pPr>
-              <a:spcAft>
-                <a:spcPts val="800"/>
-              </a:spcAft>
-            </a:pPr>
-            <a:r>
-              <a:rPr sz="2200">
-                <a:solidFill>
-                  <a:srgbClr val="212121"/>
-                </a:solidFill>
-              </a:rPr>
-              <a:t>For the curious — and anyone who wants to contribute.</a:t>
-            </a:r>
-          </a:p>
-        </p:txBody>
-      </p:sp>
-      <p:sp>
-        <p:nvSpPr>
-          <p:cNvPr id="4" name="TextBox 3"/>
-          <p:cNvSpPr txBox="1"/>
-          <p:nvPr/>
-        </p:nvSpPr>
-        <p:spPr>
-          <a:xfrm>
-            <a:off x="731520" y="6400800"/>
-            <a:ext cx="10789920" cy="182880"/>
-          </a:xfrm>
-          <a:prstGeom prst="rect">
-            <a:avLst/>
-          </a:prstGeom>
-          <a:noFill/>
-        </p:spPr>
-        <p:txBody>
-          <a:bodyPr wrap="square">
-            <a:spAutoFit/>
-          </a:bodyPr>
-          <a:lstStyle/>
-          <a:p>
-            <a:pPr>
-              <a:spcAft>
-                <a:spcPts val="800"/>
-              </a:spcAft>
-            </a:pPr>
-            <a:r>
-              <a:rPr sz="1400">
-                <a:solidFill>
-                  <a:srgbClr val="212121"/>
-                </a:solidFill>
-                <a:hlinkClick r:id="rId2"/>
-              </a:rPr>
-              <a:t>src/irep2/README.md</a:t>
+              <a:rPr sz="2800">
+                <a:solidFill>
+                  <a:srgbClr val="212121"/>
+                </a:solidFill>
+              </a:rPr>
+              <a:t>If verification can prove the absence of bugs…</a:t>
+            </a:r>
+          </a:p>
+          <a:p>
+            <a:pPr>
+              <a:spcAft>
+                <a:spcPts val="800"/>
+              </a:spcAft>
+            </a:pPr>
+            <a:r>
+              <a:rPr sz="2800">
+                <a:solidFill>
+                  <a:srgbClr val="212121"/>
+                </a:solidFill>
+              </a:rPr>
+              <a:t>why isn't all software verified?</a:t>
+            </a:r>
+          </a:p>
+          <a:p>
+            <a:pPr>
+              <a:spcAft>
+                <a:spcPts val="800"/>
+              </a:spcAft>
+            </a:pPr>
+            <a:r>
+              <a:rPr sz="2800">
+                <a:solidFill>
+                  <a:srgbClr val="212121"/>
+                </a:solidFill>
+              </a:rPr>
+              <a:t>(Let's collect reasons — then I'll tell you which ones the industry actually cites.)</a:t>
             </a:r>
           </a:p>
         </p:txBody>
@@ -13190,7 +13174,7 @@
                   <a:srgbClr val="5A0A7A"/>
                 </a:solidFill>
               </a:rPr>
-              <a:t>Closing quiz</a:t>
+              <a:t>Under the hood — and how to hack on it</a:t>
             </a:r>
           </a:p>
         </p:txBody>
@@ -13223,72 +13207,157 @@
               </a:spcAft>
             </a:pPr>
             <a:r>
-              <a:rPr sz="2400">
-                <a:solidFill>
-                  <a:srgbClr val="212121"/>
-                </a:solidFill>
-              </a:rPr>
-              <a:t>1. A tool that never raises a false alarm is called …?</a:t>
-            </a:r>
-          </a:p>
-          <a:p>
-            <a:pPr>
-              <a:spcAft>
-                <a:spcPts val="800"/>
-              </a:spcAft>
-            </a:pPr>
-            <a:r>
-              <a:rPr sz="2400">
-                <a:solidFill>
-                  <a:srgbClr val="212121"/>
-                </a:solidFill>
-              </a:rPr>
-              <a:t>2. ESBMC returns UNSAT for C ∧ ¬P at --unwind 10. What do we know?</a:t>
-            </a:r>
-          </a:p>
-          <a:p>
-            <a:pPr>
-              <a:spcAft>
-                <a:spcPts val="800"/>
-              </a:spcAft>
-            </a:pPr>
-            <a:r>
-              <a:rPr sz="2400">
-                <a:solidFill>
-                  <a:srgbClr val="212121"/>
-                </a:solidFill>
-              </a:rPr>
-              <a:t>3. What's inside a counterexample?</a:t>
-            </a:r>
-          </a:p>
-          <a:p>
-            <a:pPr>
-              <a:spcAft>
-                <a:spcPts val="800"/>
-              </a:spcAft>
-            </a:pPr>
-            <a:r>
-              <a:rPr sz="2400">
-                <a:solidFill>
-                  <a:srgbClr val="212121"/>
-                </a:solidFill>
-              </a:rPr>
-              <a:t>4. Which technique proved the A340 flight-control code free of runtime errors?</a:t>
-            </a:r>
-          </a:p>
-          <a:p>
-            <a:pPr>
-              <a:spcAft>
-                <a:spcPts val="800"/>
-              </a:spcAft>
-            </a:pPr>
-            <a:r>
-              <a:rPr sz="2400">
-                <a:solidFill>
-                  <a:srgbClr val="212121"/>
-                </a:solidFill>
-              </a:rPr>
-              <a:t>5. Why can't testing prove the getPassword program safe?</a:t>
+              <a:rPr sz="2200">
+                <a:solidFill>
+                  <a:srgbClr val="212121"/>
+                </a:solidFill>
+              </a:rPr>
+              <a:t>Tonight's pipeline was the conceptual one. ESBMC's real pipeline:</a:t>
+            </a:r>
+          </a:p>
+          <a:p>
+            <a:pPr lvl="1">
+              <a:spcAft>
+                <a:spcPts val="800"/>
+              </a:spcAft>
+            </a:pPr>
+            <a:r>
+              <a:rPr sz="2000">
+                <a:solidFill>
+                  <a:srgbClr val="212121"/>
+                </a:solidFill>
+              </a:rPr>
+              <a:t>Clang frontend → irep2 (typed IR) → GOTO program → symbolic execution (unwind, SSA) → SMT backends (Z3, Bitwuzla, cvc5)</a:t>
+            </a:r>
+          </a:p>
+          <a:p>
+            <a:pPr>
+              <a:spcAft>
+                <a:spcPts val="800"/>
+              </a:spcAft>
+            </a:pPr>
+            <a:r>
+              <a:rPr sz="2200">
+                <a:solidFill>
+                  <a:srgbClr val="212121"/>
+                </a:solidFill>
+              </a:rPr>
+              <a:t/>
+            </a:r>
+          </a:p>
+          <a:p>
+            <a:pPr>
+              <a:spcAft>
+                <a:spcPts val="800"/>
+              </a:spcAft>
+            </a:pPr>
+            <a:r>
+              <a:rPr sz="2200">
+                <a:solidFill>
+                  <a:srgbClr val="212121"/>
+                </a:solidFill>
+              </a:rPr>
+              <a:t>irep2 is the typed, reference-counted representation everything lowers to and every backend consumes.</a:t>
+            </a:r>
+          </a:p>
+          <a:p>
+            <a:pPr>
+              <a:spcAft>
+                <a:spcPts val="800"/>
+              </a:spcAft>
+            </a:pPr>
+            <a:r>
+              <a:rPr sz="2200">
+                <a:solidFill>
+                  <a:srgbClr val="212121"/>
+                </a:solidFill>
+              </a:rPr>
+              <a:t>Want to add a check, a frontend, or a new node type? Start here:</a:t>
+            </a:r>
+          </a:p>
+          <a:p>
+            <a:pPr lvl="1">
+              <a:spcAft>
+                <a:spcPts val="0"/>
+              </a:spcAft>
+            </a:pPr>
+            <a:r>
+              <a:rPr sz="1800">
+                <a:solidFill>
+                  <a:srgbClr val="212121"/>
+                </a:solidFill>
+                <a:latin typeface="Courier New"/>
+              </a:rPr>
+              <a:t>github.com/esbmc/esbmc  →  src/irep2/README.md</a:t>
+            </a:r>
+          </a:p>
+          <a:p>
+            <a:pPr>
+              <a:spcAft>
+                <a:spcPts val="800"/>
+              </a:spcAft>
+            </a:pPr>
+            <a:r>
+              <a:rPr sz="2200">
+                <a:solidFill>
+                  <a:srgbClr val="212121"/>
+                </a:solidFill>
+              </a:rPr>
+              <a:t/>
+            </a:r>
+          </a:p>
+          <a:p>
+            <a:pPr>
+              <a:spcAft>
+                <a:spcPts val="800"/>
+              </a:spcAft>
+            </a:pPr>
+            <a:r>
+              <a:rPr sz="2200">
+                <a:solidFill>
+                  <a:srgbClr val="212121"/>
+                </a:solidFill>
+              </a:rPr>
+              <a:t>For the curious — and anyone who wants to contribute.</a:t>
+            </a:r>
+          </a:p>
+        </p:txBody>
+      </p:sp>
+      <p:sp>
+        <p:nvSpPr>
+          <p:cNvPr id="4" name="TextBox 3"/>
+          <p:cNvSpPr txBox="1"/>
+          <p:nvPr/>
+        </p:nvSpPr>
+        <p:spPr>
+          <a:xfrm>
+            <a:off x="731520" y="6400800"/>
+            <a:ext cx="10789920" cy="182880"/>
+          </a:xfrm>
+          <a:prstGeom prst="rect">
+            <a:avLst/>
+          </a:prstGeom>
+          <a:noFill/>
+        </p:spPr>
+        <p:txBody>
+          <a:bodyPr wrap="square">
+            <a:spAutoFit/>
+          </a:bodyPr>
+          <a:lstStyle/>
+          <a:p>
+            <a:pPr>
+              <a:spcAft>
+                <a:spcPts val="800"/>
+              </a:spcAft>
+            </a:pPr>
+            <a:r>
+              <a:rPr sz="1400">
+                <a:solidFill>
+                  <a:srgbClr val="212121"/>
+                </a:solidFill>
+                <a:hlinkClick r:id="rId2"/>
+              </a:rPr>
+              <a:t>src/irep2/README.md</a:t>
             </a:r>
           </a:p>
         </p:txBody>
@@ -13302,6 +13371,155 @@
 </file>
 
 <file path=ppt/slides/slide54.xml><?xml version="1.0" encoding="utf-8"?>
+<p:sld xmlns:a="http://schemas.openxmlformats.org/drawingml/2006/main" xmlns:p="http://schemas.openxmlformats.org/presentationml/2006/main" xmlns:r="http://schemas.openxmlformats.org/officeDocument/2006/relationships">
+  <p:cSld>
+    <p:spTree>
+      <p:nvGrpSpPr>
+        <p:cNvPr id="1" name=""/>
+        <p:cNvGrpSpPr/>
+        <p:nvPr/>
+      </p:nvGrpSpPr>
+      <p:grpSpPr/>
+      <p:sp>
+        <p:nvSpPr>
+          <p:cNvPr id="2" name="TextBox 1"/>
+          <p:cNvSpPr txBox="1"/>
+          <p:nvPr/>
+        </p:nvSpPr>
+        <p:spPr>
+          <a:xfrm>
+            <a:off x="548640" y="365760"/>
+            <a:ext cx="11064240" cy="1005840"/>
+          </a:xfrm>
+          <a:prstGeom prst="rect">
+            <a:avLst/>
+          </a:prstGeom>
+          <a:noFill/>
+        </p:spPr>
+        <p:txBody>
+          <a:bodyPr wrap="square">
+            <a:spAutoFit/>
+          </a:bodyPr>
+          <a:lstStyle/>
+          <a:p>
+            <a:r>
+              <a:rPr sz="3600" b="1">
+                <a:solidFill>
+                  <a:srgbClr val="5A0A7A"/>
+                </a:solidFill>
+              </a:rPr>
+              <a:t>Closing quiz</a:t>
+            </a:r>
+          </a:p>
+        </p:txBody>
+      </p:sp>
+      <p:sp>
+        <p:nvSpPr>
+          <p:cNvPr id="3" name="TextBox 2"/>
+          <p:cNvSpPr txBox="1"/>
+          <p:nvPr/>
+        </p:nvSpPr>
+        <p:spPr>
+          <a:xfrm>
+            <a:off x="731520" y="1463040"/>
+            <a:ext cx="10789920" cy="5120640"/>
+          </a:xfrm>
+          <a:prstGeom prst="rect">
+            <a:avLst/>
+          </a:prstGeom>
+          <a:noFill/>
+        </p:spPr>
+        <p:txBody>
+          <a:bodyPr wrap="square">
+            <a:spAutoFit/>
+          </a:bodyPr>
+          <a:lstStyle/>
+          <a:p>
+            <a:pPr>
+              <a:spcAft>
+                <a:spcPts val="800"/>
+              </a:spcAft>
+            </a:pPr>
+            <a:r>
+              <a:rPr sz="2400">
+                <a:solidFill>
+                  <a:srgbClr val="212121"/>
+                </a:solidFill>
+              </a:rPr>
+              <a:t>1. A tool that never raises a false alarm is called …?</a:t>
+            </a:r>
+          </a:p>
+          <a:p>
+            <a:pPr>
+              <a:spcAft>
+                <a:spcPts val="800"/>
+              </a:spcAft>
+            </a:pPr>
+            <a:r>
+              <a:rPr sz="2400">
+                <a:solidFill>
+                  <a:srgbClr val="212121"/>
+                </a:solidFill>
+              </a:rPr>
+              <a:t>2. ESBMC returns UNSAT for C ∧ ¬P at --unwind 10. What do we know?</a:t>
+            </a:r>
+          </a:p>
+          <a:p>
+            <a:pPr>
+              <a:spcAft>
+                <a:spcPts val="800"/>
+              </a:spcAft>
+            </a:pPr>
+            <a:r>
+              <a:rPr sz="2400">
+                <a:solidFill>
+                  <a:srgbClr val="212121"/>
+                </a:solidFill>
+              </a:rPr>
+              <a:t>3. What's inside a counterexample?</a:t>
+            </a:r>
+          </a:p>
+          <a:p>
+            <a:pPr>
+              <a:spcAft>
+                <a:spcPts val="800"/>
+              </a:spcAft>
+            </a:pPr>
+            <a:r>
+              <a:rPr sz="2400">
+                <a:solidFill>
+                  <a:srgbClr val="212121"/>
+                </a:solidFill>
+              </a:rPr>
+              <a:t>4. Which technique proved the A340 flight-control code free of runtime errors?</a:t>
+            </a:r>
+          </a:p>
+          <a:p>
+            <a:pPr>
+              <a:spcAft>
+                <a:spcPts val="800"/>
+              </a:spcAft>
+            </a:pPr>
+            <a:r>
+              <a:rPr sz="2400">
+                <a:solidFill>
+                  <a:srgbClr val="212121"/>
+                </a:solidFill>
+              </a:rPr>
+              <a:t>5. Why can't testing prove the getPassword program safe?</a:t>
+            </a:r>
+          </a:p>
+        </p:txBody>
+      </p:sp>
+    </p:spTree>
+  </p:cSld>
+  <p:clrMapOvr>
+    <a:masterClrMapping/>
+  </p:clrMapOvr>
+</p:sld>
+</file>
+
+<file path=ppt/slides/slide55.xml><?xml version="1.0" encoding="utf-8"?>
 <p:sld xmlns:a="http://schemas.openxmlformats.org/drawingml/2006/main" xmlns:p="http://schemas.openxmlformats.org/presentationml/2006/main" xmlns:r="http://schemas.openxmlformats.org/officeDocument/2006/relationships">
   <p:cSld>
     <p:spTree>

</xml_diff>